<commit_message>
Add auto-filter mechanism and update PPT with new slide
- src/auto_filter.py: group-level noise detection, drops feature groups with avg AUC < 0.52
- PPT slide 14c: auto-filter results across 3 datasets (SemEval AUC 0.84→0.98)
- Updated feature_complementarity.md Section 5.4 with auto-filter analysis

Co-Authored-By: Claude Opus 4.6 <noreply@anthropic.com>
</commit_message>
<xml_diff>
--- a/reports/AIGC_Detection_Presentation.pptx
+++ b/reports/AIGC_Detection_Presentation.pptx
@@ -28,6 +28,7 @@
     <p:sldId id="276" r:id="rId27"/>
     <p:sldId id="277" r:id="rId28"/>
     <p:sldId id="278" r:id="rId29"/>
+    <p:sldId id="279" r:id="rId30"/>
   </p:sldIdLst>
   <p:sldSz cx="12191695" cy="6858000" type="screen4x3"/>
   <p:notesSz cx="6858000" cy="9144000"/>
@@ -8870,7 +8871,7 @@
         <p:spPr>
           <a:xfrm>
             <a:off x="731520" y="365760"/>
-            <a:ext cx="9144000" cy="731520"/>
+            <a:ext cx="10972800" cy="731520"/>
           </a:xfrm>
           <a:prstGeom prst="rect">
             <a:avLst/>
@@ -8886,13 +8887,13 @@
             <a:pPr algn="l">
               <a:defRPr sz="3200" b="1">
                 <a:solidFill>
-                  <a:srgbClr val="00D2FF"/>
-                </a:solidFill>
-                <a:latin typeface="Calibri"/>
-              </a:defRPr>
-            </a:pPr>
-            <a:r>
-              <a:t>RAID vs HC3: 特征组消融对比</a:t>
+                  <a:srgbClr val="4ECB71"/>
+                </a:solidFill>
+                <a:latin typeface="Calibri"/>
+              </a:defRPr>
+            </a:pPr>
+            <a:r>
+              <a:t>解决方案: Auto-Filter 噪声特征自动过滤</a:t>
             </a:r>
           </a:p>
         </p:txBody>
@@ -8906,7 +8907,7 @@
         <p:spPr>
           <a:xfrm>
             <a:off x="731520" y="1005840"/>
-            <a:ext cx="5486400" cy="38100"/>
+            <a:ext cx="7315200" cy="38100"/>
           </a:xfrm>
           <a:prstGeom prst="rect">
             <a:avLst/>
@@ -8948,22 +8949,226 @@
         </p:nvSpPr>
         <p:spPr>
           <a:xfrm>
-            <a:off x="914400" y="1371600"/>
-            <a:ext cx="2286000" cy="457200"/>
-          </a:xfrm>
-          <a:prstGeom prst="rect">
-            <a:avLst/>
-          </a:prstGeom>
-          <a:noFill/>
-        </p:spPr>
-        <p:txBody>
-          <a:bodyPr wrap="square">
-            <a:spAutoFit/>
-          </a:bodyPr>
-          <a:lstStyle/>
-          <a:p>
-            <a:pPr algn="l">
-              <a:defRPr sz="1800" b="1">
+            <a:off x="731520" y="1280160"/>
+            <a:ext cx="5029200" cy="548640"/>
+          </a:xfrm>
+          <a:prstGeom prst="rect">
+            <a:avLst/>
+          </a:prstGeom>
+          <a:noFill/>
+        </p:spPr>
+        <p:txBody>
+          <a:bodyPr wrap="square">
+            <a:spAutoFit/>
+          </a:bodyPr>
+          <a:lstStyle/>
+          <a:p>
+            <a:pPr algn="l">
+              <a:defRPr sz="2000" b="1">
+                <a:solidFill>
+                  <a:srgbClr val="FFFFFF"/>
+                </a:solidFill>
+                <a:latin typeface="Calibri"/>
+              </a:defRPr>
+            </a:pPr>
+            <a:r>
+              <a:t>机制: 组级信号强度检测</a:t>
+            </a:r>
+          </a:p>
+        </p:txBody>
+      </p:sp>
+      <p:sp>
+        <p:nvSpPr>
+          <p:cNvPr id="5" name="TextBox 4"/>
+          <p:cNvSpPr txBox="1"/>
+          <p:nvPr/>
+        </p:nvSpPr>
+        <p:spPr>
+          <a:xfrm>
+            <a:off x="731520" y="1828800"/>
+            <a:ext cx="5029200" cy="2286000"/>
+          </a:xfrm>
+          <a:prstGeom prst="rect">
+            <a:avLst/>
+          </a:prstGeom>
+          <a:noFill/>
+        </p:spPr>
+        <p:txBody>
+          <a:bodyPr wrap="square">
+            <a:spAutoFit/>
+          </a:bodyPr>
+          <a:lstStyle/>
+          <a:p>
+            <a:pPr>
+              <a:spcAft>
+                <a:spcPts val="900"/>
+              </a:spcAft>
+              <a:defRPr sz="1500">
+                <a:solidFill>
+                  <a:srgbClr val="E0E0E0"/>
+                </a:solidFill>
+                <a:latin typeface="Calibri"/>
+              </a:defRPr>
+            </a:pPr>
+            <a:r>
+              <a:t>对每组特征计算平均单特征 AUC</a:t>
+            </a:r>
+          </a:p>
+          <a:p>
+            <a:pPr>
+              <a:spcAft>
+                <a:spcPts val="900"/>
+              </a:spcAft>
+              <a:defRPr sz="1500">
+                <a:solidFill>
+                  <a:srgbClr val="E0E0E0"/>
+                </a:solidFill>
+                <a:latin typeface="Calibri"/>
+              </a:defRPr>
+            </a:pPr>
+            <a:r>
+              <a:t>  avg_AUC = mean(max(AUC_i, 1-AUC_i))</a:t>
+            </a:r>
+          </a:p>
+          <a:p>
+            <a:pPr>
+              <a:spcAft>
+                <a:spcPts val="900"/>
+              </a:spcAft>
+              <a:defRPr sz="1500">
+                <a:solidFill>
+                  <a:srgbClr val="E0E0E0"/>
+                </a:solidFill>
+                <a:latin typeface="Calibri"/>
+              </a:defRPr>
+            </a:pPr>
+            <a:r>
+              <a:t>丢弃 avg AUC &lt; 0.52 的组 (近随机)</a:t>
+            </a:r>
+          </a:p>
+          <a:p>
+            <a:pPr>
+              <a:spcAft>
+                <a:spcPts val="900"/>
+              </a:spcAft>
+              <a:defRPr sz="1500">
+                <a:solidFill>
+                  <a:srgbClr val="E0E0E0"/>
+                </a:solidFill>
+                <a:latin typeface="Calibri"/>
+              </a:defRPr>
+            </a:pPr>
+            <a:r>
+              <a:t>余下特征 + 30 token → 组合训练</a:t>
+            </a:r>
+          </a:p>
+          <a:p>
+            <a:pPr>
+              <a:spcAft>
+                <a:spcPts val="900"/>
+              </a:spcAft>
+              <a:defRPr sz="1500">
+                <a:solidFill>
+                  <a:srgbClr val="E0E0E0"/>
+                </a:solidFill>
+                <a:latin typeface="Calibri"/>
+              </a:defRPr>
+            </a:pPr>
+          </a:p>
+          <a:p>
+            <a:pPr>
+              <a:spcAft>
+                <a:spcPts val="900"/>
+              </a:spcAft>
+              <a:defRPr sz="1500">
+                <a:solidFill>
+                  <a:srgbClr val="E0E0E0"/>
+                </a:solidFill>
+                <a:latin typeface="Calibri"/>
+              </a:defRPr>
+            </a:pPr>
+            <a:r>
+              <a:t>只用训练集评估 → 不泄露测试信息</a:t>
+            </a:r>
+          </a:p>
+          <a:p>
+            <a:pPr>
+              <a:spcAft>
+                <a:spcPts val="900"/>
+              </a:spcAft>
+              <a:defRPr sz="1500">
+                <a:solidFill>
+                  <a:srgbClr val="E0E0E0"/>
+                </a:solidFill>
+                <a:latin typeface="Calibri"/>
+              </a:defRPr>
+            </a:pPr>
+            <a:r>
+              <a:t>O(n·p) 开销 → 几秒完成</a:t>
+            </a:r>
+          </a:p>
+        </p:txBody>
+      </p:sp>
+      <p:sp>
+        <p:nvSpPr>
+          <p:cNvPr id="6" name="TextBox 5"/>
+          <p:cNvSpPr txBox="1"/>
+          <p:nvPr/>
+        </p:nvSpPr>
+        <p:spPr>
+          <a:xfrm>
+            <a:off x="6400800" y="1280160"/>
+            <a:ext cx="5029200" cy="548640"/>
+          </a:xfrm>
+          <a:prstGeom prst="rect">
+            <a:avLst/>
+          </a:prstGeom>
+          <a:noFill/>
+        </p:spPr>
+        <p:txBody>
+          <a:bodyPr wrap="square">
+            <a:spAutoFit/>
+          </a:bodyPr>
+          <a:lstStyle/>
+          <a:p>
+            <a:pPr algn="l">
+              <a:defRPr sz="2000" b="1">
+                <a:solidFill>
+                  <a:srgbClr val="FFFFFF"/>
+                </a:solidFill>
+                <a:latin typeface="Calibri"/>
+              </a:defRPr>
+            </a:pPr>
+            <a:r>
+              <a:t>跨数据集 Auto-Filter 结果</a:t>
+            </a:r>
+          </a:p>
+        </p:txBody>
+      </p:sp>
+      <p:sp>
+        <p:nvSpPr>
+          <p:cNvPr id="7" name="TextBox 6"/>
+          <p:cNvSpPr txBox="1"/>
+          <p:nvPr/>
+        </p:nvSpPr>
+        <p:spPr>
+          <a:xfrm>
+            <a:off x="6400800" y="1828800"/>
+            <a:ext cx="2011680" cy="365760"/>
+          </a:xfrm>
+          <a:prstGeom prst="rect">
+            <a:avLst/>
+          </a:prstGeom>
+          <a:noFill/>
+        </p:spPr>
+        <p:txBody>
+          <a:bodyPr wrap="square">
+            <a:spAutoFit/>
+          </a:bodyPr>
+          <a:lstStyle/>
+          <a:p>
+            <a:pPr algn="l">
+              <a:defRPr sz="1500" b="1">
                 <a:solidFill>
                   <a:srgbClr val="00D2FF"/>
                 </a:solidFill>
@@ -8971,35 +9176,35 @@
               </a:defRPr>
             </a:pPr>
             <a:r>
-              <a:t>特征组</a:t>
-            </a:r>
-          </a:p>
-        </p:txBody>
-      </p:sp>
-      <p:sp>
-        <p:nvSpPr>
-          <p:cNvPr id="5" name="TextBox 4"/>
-          <p:cNvSpPr txBox="1"/>
-          <p:nvPr/>
-        </p:nvSpPr>
-        <p:spPr>
-          <a:xfrm>
-            <a:off x="4114800" y="1371600"/>
-            <a:ext cx="2286000" cy="457200"/>
-          </a:xfrm>
-          <a:prstGeom prst="rect">
-            <a:avLst/>
-          </a:prstGeom>
-          <a:noFill/>
-        </p:spPr>
-        <p:txBody>
-          <a:bodyPr wrap="square">
-            <a:spAutoFit/>
-          </a:bodyPr>
-          <a:lstStyle/>
-          <a:p>
-            <a:pPr algn="l">
-              <a:defRPr sz="1800" b="1">
+              <a:t>Dataset</a:t>
+            </a:r>
+          </a:p>
+        </p:txBody>
+      </p:sp>
+      <p:sp>
+        <p:nvSpPr>
+          <p:cNvPr id="8" name="TextBox 7"/>
+          <p:cNvSpPr txBox="1"/>
+          <p:nvPr/>
+        </p:nvSpPr>
+        <p:spPr>
+          <a:xfrm>
+            <a:off x="8503920" y="1828800"/>
+            <a:ext cx="1188720" cy="365760"/>
+          </a:xfrm>
+          <a:prstGeom prst="rect">
+            <a:avLst/>
+          </a:prstGeom>
+          <a:noFill/>
+        </p:spPr>
+        <p:txBody>
+          <a:bodyPr wrap="square">
+            <a:spAutoFit/>
+          </a:bodyPr>
+          <a:lstStyle/>
+          <a:p>
+            <a:pPr algn="l">
+              <a:defRPr sz="1500" b="1">
                 <a:solidFill>
                   <a:srgbClr val="00D2FF"/>
                 </a:solidFill>
@@ -9007,35 +9212,35 @@
               </a:defRPr>
             </a:pPr>
             <a:r>
-              <a:t>RAID AUC</a:t>
-            </a:r>
-          </a:p>
-        </p:txBody>
-      </p:sp>
-      <p:sp>
-        <p:nvSpPr>
-          <p:cNvPr id="6" name="TextBox 5"/>
-          <p:cNvSpPr txBox="1"/>
-          <p:nvPr/>
-        </p:nvSpPr>
-        <p:spPr>
-          <a:xfrm>
-            <a:off x="6400800" y="1371600"/>
-            <a:ext cx="2286000" cy="457200"/>
-          </a:xfrm>
-          <a:prstGeom prst="rect">
-            <a:avLst/>
-          </a:prstGeom>
-          <a:noFill/>
-        </p:spPr>
-        <p:txBody>
-          <a:bodyPr wrap="square">
-            <a:spAutoFit/>
-          </a:bodyPr>
-          <a:lstStyle/>
-          <a:p>
-            <a:pPr algn="l">
-              <a:defRPr sz="1800" b="1">
+              <a:t>Before</a:t>
+            </a:r>
+          </a:p>
+        </p:txBody>
+      </p:sp>
+      <p:sp>
+        <p:nvSpPr>
+          <p:cNvPr id="9" name="TextBox 8"/>
+          <p:cNvSpPr txBox="1"/>
+          <p:nvPr/>
+        </p:nvSpPr>
+        <p:spPr>
+          <a:xfrm>
+            <a:off x="9784080" y="1828800"/>
+            <a:ext cx="1188720" cy="365760"/>
+          </a:xfrm>
+          <a:prstGeom prst="rect">
+            <a:avLst/>
+          </a:prstGeom>
+          <a:noFill/>
+        </p:spPr>
+        <p:txBody>
+          <a:bodyPr wrap="square">
+            <a:spAutoFit/>
+          </a:bodyPr>
+          <a:lstStyle/>
+          <a:p>
+            <a:pPr algn="l">
+              <a:defRPr sz="1500" b="1">
                 <a:solidFill>
                   <a:srgbClr val="00D2FF"/>
                 </a:solidFill>
@@ -9043,71 +9248,71 @@
               </a:defRPr>
             </a:pPr>
             <a:r>
-              <a:t>HC3 AUC</a:t>
-            </a:r>
-          </a:p>
-        </p:txBody>
-      </p:sp>
-      <p:sp>
-        <p:nvSpPr>
-          <p:cNvPr id="7" name="TextBox 6"/>
-          <p:cNvSpPr txBox="1"/>
-          <p:nvPr/>
-        </p:nvSpPr>
-        <p:spPr>
-          <a:xfrm>
-            <a:off x="8686800" y="1371600"/>
-            <a:ext cx="2286000" cy="457200"/>
-          </a:xfrm>
-          <a:prstGeom prst="rect">
-            <a:avLst/>
-          </a:prstGeom>
-          <a:noFill/>
-        </p:spPr>
-        <p:txBody>
-          <a:bodyPr wrap="square">
-            <a:spAutoFit/>
-          </a:bodyPr>
-          <a:lstStyle/>
-          <a:p>
-            <a:pPr algn="l">
-              <a:defRPr sz="1800" b="1">
-                <a:solidFill>
-                  <a:srgbClr val="00D2FF"/>
-                </a:solidFill>
-                <a:latin typeface="Calibri"/>
-              </a:defRPr>
-            </a:pPr>
-            <a:r>
-              <a:t>启示</a:t>
-            </a:r>
-          </a:p>
-        </p:txBody>
-      </p:sp>
-      <p:sp>
-        <p:nvSpPr>
-          <p:cNvPr id="8" name="TextBox 7"/>
-          <p:cNvSpPr txBox="1"/>
-          <p:nvPr/>
-        </p:nvSpPr>
-        <p:spPr>
-          <a:xfrm>
-            <a:off x="914400" y="2011680"/>
-            <a:ext cx="2743200" cy="457200"/>
-          </a:xfrm>
-          <a:prstGeom prst="rect">
-            <a:avLst/>
-          </a:prstGeom>
-          <a:noFill/>
-        </p:spPr>
-        <p:txBody>
-          <a:bodyPr wrap="square">
-            <a:spAutoFit/>
-          </a:bodyPr>
-          <a:lstStyle/>
-          <a:p>
-            <a:pPr algn="l">
-              <a:defRPr sz="1600" b="0">
+              <a:t>After</a:t>
+            </a:r>
+          </a:p>
+        </p:txBody>
+      </p:sp>
+      <p:sp>
+        <p:nvSpPr>
+          <p:cNvPr id="10" name="TextBox 9"/>
+          <p:cNvSpPr txBox="1"/>
+          <p:nvPr/>
+        </p:nvSpPr>
+        <p:spPr>
+          <a:xfrm>
+            <a:off x="6400800" y="2377440"/>
+            <a:ext cx="2011680" cy="365760"/>
+          </a:xfrm>
+          <a:prstGeom prst="rect">
+            <a:avLst/>
+          </a:prstGeom>
+          <a:noFill/>
+        </p:spPr>
+        <p:txBody>
+          <a:bodyPr wrap="square">
+            <a:spAutoFit/>
+          </a:bodyPr>
+          <a:lstStyle/>
+          <a:p>
+            <a:pPr algn="l">
+              <a:defRPr sz="1400" b="0">
+                <a:solidFill>
+                  <a:srgbClr val="E0E0E0"/>
+                </a:solidFill>
+                <a:latin typeface="Calibri"/>
+              </a:defRPr>
+            </a:pPr>
+            <a:r>
+              <a:t>RAID</a:t>
+            </a:r>
+          </a:p>
+        </p:txBody>
+      </p:sp>
+      <p:sp>
+        <p:nvSpPr>
+          <p:cNvPr id="11" name="TextBox 10"/>
+          <p:cNvSpPr txBox="1"/>
+          <p:nvPr/>
+        </p:nvSpPr>
+        <p:spPr>
+          <a:xfrm>
+            <a:off x="8503920" y="2377440"/>
+            <a:ext cx="1188720" cy="365760"/>
+          </a:xfrm>
+          <a:prstGeom prst="rect">
+            <a:avLst/>
+          </a:prstGeom>
+          <a:noFill/>
+        </p:spPr>
+        <p:txBody>
+          <a:bodyPr wrap="square">
+            <a:spAutoFit/>
+          </a:bodyPr>
+          <a:lstStyle/>
+          <a:p>
+            <a:pPr algn="l">
+              <a:defRPr sz="1400" b="0">
                 <a:solidFill>
                   <a:srgbClr val="FFFFFF"/>
                 </a:solidFill>
@@ -9115,35 +9320,35 @@
               </a:defRPr>
             </a:pPr>
             <a:r>
-              <a:t>basic_counts</a:t>
-            </a:r>
-          </a:p>
-        </p:txBody>
-      </p:sp>
-      <p:sp>
-        <p:nvSpPr>
-          <p:cNvPr id="9" name="TextBox 8"/>
-          <p:cNvSpPr txBox="1"/>
-          <p:nvPr/>
-        </p:nvSpPr>
-        <p:spPr>
-          <a:xfrm>
-            <a:off x="4114800" y="2011680"/>
-            <a:ext cx="1828800" cy="457200"/>
-          </a:xfrm>
-          <a:prstGeom prst="rect">
-            <a:avLst/>
-          </a:prstGeom>
-          <a:noFill/>
-        </p:spPr>
-        <p:txBody>
-          <a:bodyPr wrap="square">
-            <a:spAutoFit/>
-          </a:bodyPr>
-          <a:lstStyle/>
-          <a:p>
-            <a:pPr algn="l">
-              <a:defRPr sz="1600" b="0">
+              <a:t>0.9992</a:t>
+            </a:r>
+          </a:p>
+        </p:txBody>
+      </p:sp>
+      <p:sp>
+        <p:nvSpPr>
+          <p:cNvPr id="12" name="TextBox 11"/>
+          <p:cNvSpPr txBox="1"/>
+          <p:nvPr/>
+        </p:nvSpPr>
+        <p:spPr>
+          <a:xfrm>
+            <a:off x="9784080" y="2377440"/>
+            <a:ext cx="1188720" cy="365760"/>
+          </a:xfrm>
+          <a:prstGeom prst="rect">
+            <a:avLst/>
+          </a:prstGeom>
+          <a:noFill/>
+        </p:spPr>
+        <p:txBody>
+          <a:bodyPr wrap="square">
+            <a:spAutoFit/>
+          </a:bodyPr>
+          <a:lstStyle/>
+          <a:p>
+            <a:pPr algn="l">
+              <a:defRPr sz="1400" b="0">
                 <a:solidFill>
                   <a:srgbClr val="FFFFFF"/>
                 </a:solidFill>
@@ -9151,35 +9356,71 @@
               </a:defRPr>
             </a:pPr>
             <a:r>
-              <a:t>0.9700</a:t>
-            </a:r>
-          </a:p>
-        </p:txBody>
-      </p:sp>
-      <p:sp>
-        <p:nvSpPr>
-          <p:cNvPr id="10" name="TextBox 9"/>
-          <p:cNvSpPr txBox="1"/>
-          <p:nvPr/>
-        </p:nvSpPr>
-        <p:spPr>
-          <a:xfrm>
-            <a:off x="6400800" y="2011680"/>
-            <a:ext cx="1828800" cy="457200"/>
-          </a:xfrm>
-          <a:prstGeom prst="rect">
-            <a:avLst/>
-          </a:prstGeom>
-          <a:noFill/>
-        </p:spPr>
-        <p:txBody>
-          <a:bodyPr wrap="square">
-            <a:spAutoFit/>
-          </a:bodyPr>
-          <a:lstStyle/>
-          <a:p>
-            <a:pPr algn="l">
-              <a:defRPr sz="1600" b="0">
+              <a:t>0.9992</a:t>
+            </a:r>
+          </a:p>
+        </p:txBody>
+      </p:sp>
+      <p:sp>
+        <p:nvSpPr>
+          <p:cNvPr id="13" name="TextBox 12"/>
+          <p:cNvSpPr txBox="1"/>
+          <p:nvPr/>
+        </p:nvSpPr>
+        <p:spPr>
+          <a:xfrm>
+            <a:off x="6400800" y="2971800"/>
+            <a:ext cx="2011680" cy="365760"/>
+          </a:xfrm>
+          <a:prstGeom prst="rect">
+            <a:avLst/>
+          </a:prstGeom>
+          <a:noFill/>
+        </p:spPr>
+        <p:txBody>
+          <a:bodyPr wrap="square">
+            <a:spAutoFit/>
+          </a:bodyPr>
+          <a:lstStyle/>
+          <a:p>
+            <a:pPr algn="l">
+              <a:defRPr sz="1400" b="0">
+                <a:solidFill>
+                  <a:srgbClr val="4ECB71"/>
+                </a:solidFill>
+                <a:latin typeface="Calibri"/>
+              </a:defRPr>
+            </a:pPr>
+            <a:r>
+              <a:t>SemEval</a:t>
+            </a:r>
+          </a:p>
+        </p:txBody>
+      </p:sp>
+      <p:sp>
+        <p:nvSpPr>
+          <p:cNvPr id="14" name="TextBox 13"/>
+          <p:cNvSpPr txBox="1"/>
+          <p:nvPr/>
+        </p:nvSpPr>
+        <p:spPr>
+          <a:xfrm>
+            <a:off x="8503920" y="2971800"/>
+            <a:ext cx="1188720" cy="365760"/>
+          </a:xfrm>
+          <a:prstGeom prst="rect">
+            <a:avLst/>
+          </a:prstGeom>
+          <a:noFill/>
+        </p:spPr>
+        <p:txBody>
+          <a:bodyPr wrap="square">
+            <a:spAutoFit/>
+          </a:bodyPr>
+          <a:lstStyle/>
+          <a:p>
+            <a:pPr algn="l">
+              <a:defRPr sz="1400" b="0">
                 <a:solidFill>
                   <a:srgbClr val="FFFFFF"/>
                 </a:solidFill>
@@ -9187,35 +9428,107 @@
               </a:defRPr>
             </a:pPr>
             <a:r>
-              <a:t>0.9204</a:t>
-            </a:r>
-          </a:p>
-        </p:txBody>
-      </p:sp>
-      <p:sp>
-        <p:nvSpPr>
-          <p:cNvPr id="11" name="TextBox 10"/>
-          <p:cNvSpPr txBox="1"/>
-          <p:nvPr/>
-        </p:nvSpPr>
-        <p:spPr>
-          <a:xfrm>
-            <a:off x="8686800" y="2011680"/>
-            <a:ext cx="2743200" cy="457200"/>
-          </a:xfrm>
-          <a:prstGeom prst="rect">
-            <a:avLst/>
-          </a:prstGeom>
-          <a:noFill/>
-        </p:spPr>
-        <p:txBody>
-          <a:bodyPr wrap="square">
-            <a:spAutoFit/>
-          </a:bodyPr>
-          <a:lstStyle/>
-          <a:p>
-            <a:pPr algn="l">
-              <a:defRPr sz="1600" b="0">
+              <a:t>0.8443</a:t>
+            </a:r>
+          </a:p>
+        </p:txBody>
+      </p:sp>
+      <p:sp>
+        <p:nvSpPr>
+          <p:cNvPr id="15" name="TextBox 14"/>
+          <p:cNvSpPr txBox="1"/>
+          <p:nvPr/>
+        </p:nvSpPr>
+        <p:spPr>
+          <a:xfrm>
+            <a:off x="9784080" y="2971800"/>
+            <a:ext cx="1188720" cy="365760"/>
+          </a:xfrm>
+          <a:prstGeom prst="rect">
+            <a:avLst/>
+          </a:prstGeom>
+          <a:noFill/>
+        </p:spPr>
+        <p:txBody>
+          <a:bodyPr wrap="square">
+            <a:spAutoFit/>
+          </a:bodyPr>
+          <a:lstStyle/>
+          <a:p>
+            <a:pPr algn="l">
+              <a:defRPr sz="1400" b="0">
+                <a:solidFill>
+                  <a:srgbClr val="4ECB71"/>
+                </a:solidFill>
+                <a:latin typeface="Calibri"/>
+              </a:defRPr>
+            </a:pPr>
+            <a:r>
+              <a:t>0.9763</a:t>
+            </a:r>
+          </a:p>
+        </p:txBody>
+      </p:sp>
+      <p:sp>
+        <p:nvSpPr>
+          <p:cNvPr id="16" name="TextBox 15"/>
+          <p:cNvSpPr txBox="1"/>
+          <p:nvPr/>
+        </p:nvSpPr>
+        <p:spPr>
+          <a:xfrm>
+            <a:off x="6400800" y="3566160"/>
+            <a:ext cx="2011680" cy="365760"/>
+          </a:xfrm>
+          <a:prstGeom prst="rect">
+            <a:avLst/>
+          </a:prstGeom>
+          <a:noFill/>
+        </p:spPr>
+        <p:txBody>
+          <a:bodyPr wrap="square">
+            <a:spAutoFit/>
+          </a:bodyPr>
+          <a:lstStyle/>
+          <a:p>
+            <a:pPr algn="l">
+              <a:defRPr sz="1400" b="0">
+                <a:solidFill>
+                  <a:srgbClr val="E0E0E0"/>
+                </a:solidFill>
+                <a:latin typeface="Calibri"/>
+              </a:defRPr>
+            </a:pPr>
+            <a:r>
+              <a:t>TuringBench</a:t>
+            </a:r>
+          </a:p>
+        </p:txBody>
+      </p:sp>
+      <p:sp>
+        <p:nvSpPr>
+          <p:cNvPr id="17" name="TextBox 16"/>
+          <p:cNvSpPr txBox="1"/>
+          <p:nvPr/>
+        </p:nvSpPr>
+        <p:spPr>
+          <a:xfrm>
+            <a:off x="8503920" y="3566160"/>
+            <a:ext cx="1188720" cy="365760"/>
+          </a:xfrm>
+          <a:prstGeom prst="rect">
+            <a:avLst/>
+          </a:prstGeom>
+          <a:noFill/>
+        </p:spPr>
+        <p:txBody>
+          <a:bodyPr wrap="square">
+            <a:spAutoFit/>
+          </a:bodyPr>
+          <a:lstStyle/>
+          <a:p>
+            <a:pPr algn="l">
+              <a:defRPr sz="1400" b="0">
                 <a:solidFill>
                   <a:srgbClr val="FFFFFF"/>
                 </a:solidFill>
@@ -9223,35 +9536,35 @@
               </a:defRPr>
             </a:pPr>
             <a:r>
-              <a:t>RAID 更强</a:t>
-            </a:r>
-          </a:p>
-        </p:txBody>
-      </p:sp>
-      <p:sp>
-        <p:nvSpPr>
-          <p:cNvPr id="12" name="TextBox 11"/>
-          <p:cNvSpPr txBox="1"/>
-          <p:nvPr/>
-        </p:nvSpPr>
-        <p:spPr>
-          <a:xfrm>
-            <a:off x="914400" y="2651760"/>
-            <a:ext cx="2743200" cy="457200"/>
-          </a:xfrm>
-          <a:prstGeom prst="rect">
-            <a:avLst/>
-          </a:prstGeom>
-          <a:noFill/>
-        </p:spPr>
-        <p:txBody>
-          <a:bodyPr wrap="square">
-            <a:spAutoFit/>
-          </a:bodyPr>
-          <a:lstStyle/>
-          <a:p>
-            <a:pPr algn="l">
-              <a:defRPr sz="1600" b="0">
+              <a:t>0.9847</a:t>
+            </a:r>
+          </a:p>
+        </p:txBody>
+      </p:sp>
+      <p:sp>
+        <p:nvSpPr>
+          <p:cNvPr id="18" name="TextBox 17"/>
+          <p:cNvSpPr txBox="1"/>
+          <p:nvPr/>
+        </p:nvSpPr>
+        <p:spPr>
+          <a:xfrm>
+            <a:off x="9784080" y="3566160"/>
+            <a:ext cx="1188720" cy="365760"/>
+          </a:xfrm>
+          <a:prstGeom prst="rect">
+            <a:avLst/>
+          </a:prstGeom>
+          <a:noFill/>
+        </p:spPr>
+        <p:txBody>
+          <a:bodyPr wrap="square">
+            <a:spAutoFit/>
+          </a:bodyPr>
+          <a:lstStyle/>
+          <a:p>
+            <a:pPr algn="l">
+              <a:defRPr sz="1400" b="0">
                 <a:solidFill>
                   <a:srgbClr val="FFFFFF"/>
                 </a:solidFill>
@@ -9259,295 +9572,76 @@
               </a:defRPr>
             </a:pPr>
             <a:r>
-              <a:t>averages</a:t>
-            </a:r>
-          </a:p>
-        </p:txBody>
-      </p:sp>
-      <p:sp>
-        <p:nvSpPr>
-          <p:cNvPr id="13" name="TextBox 12"/>
-          <p:cNvSpPr txBox="1"/>
-          <p:nvPr/>
-        </p:nvSpPr>
-        <p:spPr>
-          <a:xfrm>
-            <a:off x="4114800" y="2651760"/>
-            <a:ext cx="1828800" cy="457200"/>
-          </a:xfrm>
-          <a:prstGeom prst="rect">
-            <a:avLst/>
-          </a:prstGeom>
-          <a:noFill/>
-        </p:spPr>
-        <p:txBody>
-          <a:bodyPr wrap="square">
-            <a:spAutoFit/>
-          </a:bodyPr>
-          <a:lstStyle/>
-          <a:p>
-            <a:pPr algn="l">
-              <a:defRPr sz="1600" b="0">
-                <a:solidFill>
-                  <a:srgbClr val="FFFFFF"/>
-                </a:solidFill>
-                <a:latin typeface="Calibri"/>
-              </a:defRPr>
-            </a:pPr>
-            <a:r>
-              <a:t>0.9425</a:t>
-            </a:r>
-          </a:p>
-        </p:txBody>
-      </p:sp>
-      <p:sp>
-        <p:nvSpPr>
-          <p:cNvPr id="14" name="TextBox 13"/>
+              <a:t>0.9847</a:t>
+            </a:r>
+          </a:p>
+        </p:txBody>
+      </p:sp>
+      <p:sp>
+        <p:nvSpPr>
+          <p:cNvPr id="19" name="TextBox 18"/>
+          <p:cNvSpPr txBox="1"/>
+          <p:nvPr/>
+        </p:nvSpPr>
+        <p:spPr>
+          <a:xfrm>
+            <a:off x="6400800" y="4389120"/>
+            <a:ext cx="5029200" cy="365760"/>
+          </a:xfrm>
+          <a:prstGeom prst="rect">
+            <a:avLst/>
+          </a:prstGeom>
+          <a:noFill/>
+        </p:spPr>
+        <p:txBody>
+          <a:bodyPr wrap="square">
+            <a:spAutoFit/>
+          </a:bodyPr>
+          <a:lstStyle/>
+          <a:p>
+            <a:pPr algn="l">
+              <a:defRPr sz="1200" b="0">
+                <a:solidFill>
+                  <a:srgbClr val="AAAAAA"/>
+                </a:solidFill>
+                <a:latin typeface="Calibri"/>
+              </a:defRPr>
+            </a:pPr>
+          </a:p>
+        </p:txBody>
+      </p:sp>
+      <p:sp>
+        <p:nvSpPr>
+          <p:cNvPr id="20" name="TextBox 19"/>
           <p:cNvSpPr txBox="1"/>
           <p:nvPr/>
         </p:nvSpPr>
         <p:spPr>
           <a:xfrm>
             <a:off x="6400800" y="2651760"/>
-            <a:ext cx="1828800" cy="457200"/>
-          </a:xfrm>
-          <a:prstGeom prst="rect">
-            <a:avLst/>
-          </a:prstGeom>
-          <a:noFill/>
-        </p:spPr>
-        <p:txBody>
-          <a:bodyPr wrap="square">
-            <a:spAutoFit/>
-          </a:bodyPr>
-          <a:lstStyle/>
-          <a:p>
-            <a:pPr algn="l">
-              <a:defRPr sz="1600" b="0">
-                <a:solidFill>
-                  <a:srgbClr val="FFFFFF"/>
-                </a:solidFill>
-                <a:latin typeface="Calibri"/>
-              </a:defRPr>
-            </a:pPr>
-            <a:r>
-              <a:t>0.9021</a:t>
-            </a:r>
-          </a:p>
-        </p:txBody>
-      </p:sp>
-      <p:sp>
-        <p:nvSpPr>
-          <p:cNvPr id="15" name="TextBox 14"/>
-          <p:cNvSpPr txBox="1"/>
-          <p:nvPr/>
-        </p:nvSpPr>
-        <p:spPr>
-          <a:xfrm>
-            <a:off x="8686800" y="2651760"/>
-            <a:ext cx="2743200" cy="457200"/>
-          </a:xfrm>
-          <a:prstGeom prst="rect">
-            <a:avLst/>
-          </a:prstGeom>
-          <a:noFill/>
-        </p:spPr>
-        <p:txBody>
-          <a:bodyPr wrap="square">
-            <a:spAutoFit/>
-          </a:bodyPr>
-          <a:lstStyle/>
-          <a:p>
-            <a:pPr algn="l">
-              <a:defRPr sz="1600" b="0">
-                <a:solidFill>
-                  <a:srgbClr val="FFFFFF"/>
-                </a:solidFill>
-                <a:latin typeface="Calibri"/>
-              </a:defRPr>
-            </a:pPr>
-            <a:r>
-              <a:t>RAID 更强</a:t>
-            </a:r>
-          </a:p>
-        </p:txBody>
-      </p:sp>
-      <p:sp>
-        <p:nvSpPr>
-          <p:cNvPr id="16" name="TextBox 15"/>
-          <p:cNvSpPr txBox="1"/>
-          <p:nvPr/>
-        </p:nvSpPr>
-        <p:spPr>
-          <a:xfrm>
-            <a:off x="914400" y="3291840"/>
-            <a:ext cx="2743200" cy="457200"/>
-          </a:xfrm>
-          <a:prstGeom prst="rect">
-            <a:avLst/>
-          </a:prstGeom>
-          <a:noFill/>
-        </p:spPr>
-        <p:txBody>
-          <a:bodyPr wrap="square">
-            <a:spAutoFit/>
-          </a:bodyPr>
-          <a:lstStyle/>
-          <a:p>
-            <a:pPr algn="l">
-              <a:defRPr sz="1600" b="0">
-                <a:solidFill>
-                  <a:srgbClr val="FFFFFF"/>
-                </a:solidFill>
-                <a:latin typeface="Calibri"/>
-              </a:defRPr>
-            </a:pPr>
-            <a:r>
-              <a:t>lexical_richness</a:t>
-            </a:r>
-          </a:p>
-        </p:txBody>
-      </p:sp>
-      <p:sp>
-        <p:nvSpPr>
-          <p:cNvPr id="17" name="TextBox 16"/>
-          <p:cNvSpPr txBox="1"/>
-          <p:nvPr/>
-        </p:nvSpPr>
-        <p:spPr>
-          <a:xfrm>
-            <a:off x="4114800" y="3291840"/>
-            <a:ext cx="1828800" cy="457200"/>
-          </a:xfrm>
-          <a:prstGeom prst="rect">
-            <a:avLst/>
-          </a:prstGeom>
-          <a:noFill/>
-        </p:spPr>
-        <p:txBody>
-          <a:bodyPr wrap="square">
-            <a:spAutoFit/>
-          </a:bodyPr>
-          <a:lstStyle/>
-          <a:p>
-            <a:pPr algn="l">
-              <a:defRPr sz="1600" b="0">
-                <a:solidFill>
-                  <a:srgbClr val="FFFFFF"/>
-                </a:solidFill>
-                <a:latin typeface="Calibri"/>
-              </a:defRPr>
-            </a:pPr>
-            <a:r>
-              <a:t>0.8861</a:t>
-            </a:r>
-          </a:p>
-        </p:txBody>
-      </p:sp>
-      <p:sp>
-        <p:nvSpPr>
-          <p:cNvPr id="18" name="TextBox 17"/>
-          <p:cNvSpPr txBox="1"/>
-          <p:nvPr/>
-        </p:nvSpPr>
-        <p:spPr>
-          <a:xfrm>
-            <a:off x="6400800" y="3291840"/>
-            <a:ext cx="1828800" cy="457200"/>
-          </a:xfrm>
-          <a:prstGeom prst="rect">
-            <a:avLst/>
-          </a:prstGeom>
-          <a:noFill/>
-        </p:spPr>
-        <p:txBody>
-          <a:bodyPr wrap="square">
-            <a:spAutoFit/>
-          </a:bodyPr>
-          <a:lstStyle/>
-          <a:p>
-            <a:pPr algn="l">
-              <a:defRPr sz="1600" b="0">
-                <a:solidFill>
-                  <a:srgbClr val="FFFFFF"/>
-                </a:solidFill>
-                <a:latin typeface="Calibri"/>
-              </a:defRPr>
-            </a:pPr>
-            <a:r>
-              <a:t>0.9367</a:t>
-            </a:r>
-          </a:p>
-        </p:txBody>
-      </p:sp>
-      <p:sp>
-        <p:nvSpPr>
-          <p:cNvPr id="19" name="TextBox 18"/>
-          <p:cNvSpPr txBox="1"/>
-          <p:nvPr/>
-        </p:nvSpPr>
-        <p:spPr>
-          <a:xfrm>
-            <a:off x="8686800" y="3291840"/>
-            <a:ext cx="2743200" cy="457200"/>
-          </a:xfrm>
-          <a:prstGeom prst="rect">
-            <a:avLst/>
-          </a:prstGeom>
-          <a:noFill/>
-        </p:spPr>
-        <p:txBody>
-          <a:bodyPr wrap="square">
-            <a:spAutoFit/>
-          </a:bodyPr>
-          <a:lstStyle/>
-          <a:p>
-            <a:pPr algn="l">
-              <a:defRPr sz="1600" b="0">
-                <a:solidFill>
-                  <a:srgbClr val="FFFFFF"/>
-                </a:solidFill>
-                <a:latin typeface="Calibri"/>
-              </a:defRPr>
-            </a:pPr>
-            <a:r>
-              <a:t>HC3 更强</a:t>
-            </a:r>
-          </a:p>
-        </p:txBody>
-      </p:sp>
-      <p:sp>
-        <p:nvSpPr>
-          <p:cNvPr id="20" name="TextBox 19"/>
-          <p:cNvSpPr txBox="1"/>
-          <p:nvPr/>
-        </p:nvSpPr>
-        <p:spPr>
-          <a:xfrm>
-            <a:off x="914400" y="3931920"/>
-            <a:ext cx="2743200" cy="457200"/>
-          </a:xfrm>
-          <a:prstGeom prst="rect">
-            <a:avLst/>
-          </a:prstGeom>
-          <a:noFill/>
-        </p:spPr>
-        <p:txBody>
-          <a:bodyPr wrap="square">
-            <a:spAutoFit/>
-          </a:bodyPr>
-          <a:lstStyle/>
-          <a:p>
-            <a:pPr algn="l">
-              <a:defRPr sz="1600" b="0">
-                <a:solidFill>
-                  <a:srgbClr val="FFFFFF"/>
-                </a:solidFill>
-                <a:latin typeface="Calibri"/>
-              </a:defRPr>
-            </a:pPr>
-            <a:r>
-              <a:t>readability</a:t>
+            <a:ext cx="5029200" cy="274320"/>
+          </a:xfrm>
+          <a:prstGeom prst="rect">
+            <a:avLst/>
+          </a:prstGeom>
+          <a:noFill/>
+        </p:spPr>
+        <p:txBody>
+          <a:bodyPr wrap="square">
+            <a:spAutoFit/>
+          </a:bodyPr>
+          <a:lstStyle/>
+          <a:p>
+            <a:pPr algn="l">
+              <a:defRPr sz="1100" b="0">
+                <a:solidFill>
+                  <a:srgbClr val="AAAAAA"/>
+                </a:solidFill>
+                <a:latin typeface="Calibri"/>
+              </a:defRPr>
+            </a:pPr>
+            <a:r>
+              <a:t>drop 2 组 (无影响)</a:t>
             </a:r>
           </a:p>
         </p:txBody>
@@ -9560,30 +9654,30 @@
         </p:nvSpPr>
         <p:spPr>
           <a:xfrm>
-            <a:off x="4114800" y="3931920"/>
-            <a:ext cx="1828800" cy="457200"/>
-          </a:xfrm>
-          <a:prstGeom prst="rect">
-            <a:avLst/>
-          </a:prstGeom>
-          <a:noFill/>
-        </p:spPr>
-        <p:txBody>
-          <a:bodyPr wrap="square">
-            <a:spAutoFit/>
-          </a:bodyPr>
-          <a:lstStyle/>
-          <a:p>
-            <a:pPr algn="l">
-              <a:defRPr sz="1600" b="0">
-                <a:solidFill>
-                  <a:srgbClr val="FFFFFF"/>
-                </a:solidFill>
-                <a:latin typeface="Calibri"/>
-              </a:defRPr>
-            </a:pPr>
-            <a:r>
-              <a:t>0.8500</a:t>
+            <a:off x="6400800" y="3246120"/>
+            <a:ext cx="5029200" cy="274320"/>
+          </a:xfrm>
+          <a:prstGeom prst="rect">
+            <a:avLst/>
+          </a:prstGeom>
+          <a:noFill/>
+        </p:spPr>
+        <p:txBody>
+          <a:bodyPr wrap="square">
+            <a:spAutoFit/>
+          </a:bodyPr>
+          <a:lstStyle/>
+          <a:p>
+            <a:pPr algn="l">
+              <a:defRPr sz="1100" b="0">
+                <a:solidFill>
+                  <a:srgbClr val="AAAAAA"/>
+                </a:solidFill>
+                <a:latin typeface="Calibri"/>
+              </a:defRPr>
+            </a:pPr>
+            <a:r>
+              <a:t>drop 全部9组 → tok-only</a:t>
             </a:r>
           </a:p>
         </p:txBody>
@@ -9596,30 +9690,30 @@
         </p:nvSpPr>
         <p:spPr>
           <a:xfrm>
-            <a:off x="6400800" y="3931920"/>
-            <a:ext cx="1828800" cy="457200"/>
-          </a:xfrm>
-          <a:prstGeom prst="rect">
-            <a:avLst/>
-          </a:prstGeom>
-          <a:noFill/>
-        </p:spPr>
-        <p:txBody>
-          <a:bodyPr wrap="square">
-            <a:spAutoFit/>
-          </a:bodyPr>
-          <a:lstStyle/>
-          <a:p>
-            <a:pPr algn="l">
-              <a:defRPr sz="1600" b="0">
-                <a:solidFill>
-                  <a:srgbClr val="FFFFFF"/>
-                </a:solidFill>
-                <a:latin typeface="Calibri"/>
-              </a:defRPr>
-            </a:pPr>
-            <a:r>
-              <a:t>0.9741</a:t>
+            <a:off x="6400800" y="3840480"/>
+            <a:ext cx="5029200" cy="274320"/>
+          </a:xfrm>
+          <a:prstGeom prst="rect">
+            <a:avLst/>
+          </a:prstGeom>
+          <a:noFill/>
+        </p:spPr>
+        <p:txBody>
+          <a:bodyPr wrap="square">
+            <a:spAutoFit/>
+          </a:bodyPr>
+          <a:lstStyle/>
+          <a:p>
+            <a:pPr algn="l">
+              <a:defRPr sz="1100" b="0">
+                <a:solidFill>
+                  <a:srgbClr val="AAAAAA"/>
+                </a:solidFill>
+                <a:latin typeface="Calibri"/>
+              </a:defRPr>
+            </a:pPr>
+            <a:r>
+              <a:t>drop 0 组 (无影响)</a:t>
             </a:r>
           </a:p>
         </p:txBody>
@@ -9632,332 +9726,8 @@
         </p:nvSpPr>
         <p:spPr>
           <a:xfrm>
-            <a:off x="8686800" y="3931920"/>
-            <a:ext cx="2743200" cy="457200"/>
-          </a:xfrm>
-          <a:prstGeom prst="rect">
-            <a:avLst/>
-          </a:prstGeom>
-          <a:noFill/>
-        </p:spPr>
-        <p:txBody>
-          <a:bodyPr wrap="square">
-            <a:spAutoFit/>
-          </a:bodyPr>
-          <a:lstStyle/>
-          <a:p>
-            <a:pPr algn="l">
-              <a:defRPr sz="1600" b="0">
-                <a:solidFill>
-                  <a:srgbClr val="FFFFFF"/>
-                </a:solidFill>
-                <a:latin typeface="Calibri"/>
-              </a:defRPr>
-            </a:pPr>
-            <a:r>
-              <a:t>HC3 远优</a:t>
-            </a:r>
-          </a:p>
-        </p:txBody>
-      </p:sp>
-      <p:sp>
-        <p:nvSpPr>
-          <p:cNvPr id="24" name="TextBox 23"/>
-          <p:cNvSpPr txBox="1"/>
-          <p:nvPr/>
-        </p:nvSpPr>
-        <p:spPr>
-          <a:xfrm>
-            <a:off x="914400" y="4572000"/>
-            <a:ext cx="2743200" cy="457200"/>
-          </a:xfrm>
-          <a:prstGeom prst="rect">
-            <a:avLst/>
-          </a:prstGeom>
-          <a:noFill/>
-        </p:spPr>
-        <p:txBody>
-          <a:bodyPr wrap="square">
-            <a:spAutoFit/>
-          </a:bodyPr>
-          <a:lstStyle/>
-          <a:p>
-            <a:pPr algn="l">
-              <a:defRPr sz="1600" b="0">
-                <a:solidFill>
-                  <a:srgbClr val="FF6B6B"/>
-                </a:solidFill>
-                <a:latin typeface="Calibri"/>
-              </a:defRPr>
-            </a:pPr>
-            <a:r>
-              <a:t>perplexity</a:t>
-            </a:r>
-          </a:p>
-        </p:txBody>
-      </p:sp>
-      <p:sp>
-        <p:nvSpPr>
-          <p:cNvPr id="25" name="TextBox 24"/>
-          <p:cNvSpPr txBox="1"/>
-          <p:nvPr/>
-        </p:nvSpPr>
-        <p:spPr>
-          <a:xfrm>
-            <a:off x="4114800" y="4572000"/>
-            <a:ext cx="1828800" cy="457200"/>
-          </a:xfrm>
-          <a:prstGeom prst="rect">
-            <a:avLst/>
-          </a:prstGeom>
-          <a:noFill/>
-        </p:spPr>
-        <p:txBody>
-          <a:bodyPr wrap="square">
-            <a:spAutoFit/>
-          </a:bodyPr>
-          <a:lstStyle/>
-          <a:p>
-            <a:pPr algn="l">
-              <a:defRPr sz="1600" b="0">
-                <a:solidFill>
-                  <a:srgbClr val="FF6B6B"/>
-                </a:solidFill>
-                <a:latin typeface="Calibri"/>
-              </a:defRPr>
-            </a:pPr>
-            <a:r>
-              <a:t>0.4920</a:t>
-            </a:r>
-          </a:p>
-        </p:txBody>
-      </p:sp>
-      <p:sp>
-        <p:nvSpPr>
-          <p:cNvPr id="26" name="TextBox 25"/>
-          <p:cNvSpPr txBox="1"/>
-          <p:nvPr/>
-        </p:nvSpPr>
-        <p:spPr>
-          <a:xfrm>
-            <a:off x="6400800" y="4572000"/>
-            <a:ext cx="1828800" cy="457200"/>
-          </a:xfrm>
-          <a:prstGeom prst="rect">
-            <a:avLst/>
-          </a:prstGeom>
-          <a:noFill/>
-        </p:spPr>
-        <p:txBody>
-          <a:bodyPr wrap="square">
-            <a:spAutoFit/>
-          </a:bodyPr>
-          <a:lstStyle/>
-          <a:p>
-            <a:pPr algn="l">
-              <a:defRPr sz="1600" b="0">
-                <a:solidFill>
-                  <a:srgbClr val="FF6B6B"/>
-                </a:solidFill>
-                <a:latin typeface="Calibri"/>
-              </a:defRPr>
-            </a:pPr>
-            <a:r>
-              <a:t>0.9912</a:t>
-            </a:r>
-          </a:p>
-        </p:txBody>
-      </p:sp>
-      <p:sp>
-        <p:nvSpPr>
-          <p:cNvPr id="27" name="TextBox 26"/>
-          <p:cNvSpPr txBox="1"/>
-          <p:nvPr/>
-        </p:nvSpPr>
-        <p:spPr>
-          <a:xfrm>
-            <a:off x="8686800" y="4572000"/>
-            <a:ext cx="2743200" cy="457200"/>
-          </a:xfrm>
-          <a:prstGeom prst="rect">
-            <a:avLst/>
-          </a:prstGeom>
-          <a:noFill/>
-        </p:spPr>
-        <p:txBody>
-          <a:bodyPr wrap="square">
-            <a:spAutoFit/>
-          </a:bodyPr>
-          <a:lstStyle/>
-          <a:p>
-            <a:pPr algn="l">
-              <a:defRPr sz="1600" b="0">
-                <a:solidFill>
-                  <a:srgbClr val="FF6B6B"/>
-                </a:solidFill>
-                <a:latin typeface="Calibri"/>
-              </a:defRPr>
-            </a:pPr>
-            <a:r>
-              <a:t>完全反转!</a:t>
-            </a:r>
-          </a:p>
-        </p:txBody>
-      </p:sp>
-      <p:sp>
-        <p:nvSpPr>
-          <p:cNvPr id="28" name="TextBox 27"/>
-          <p:cNvSpPr txBox="1"/>
-          <p:nvPr/>
-        </p:nvSpPr>
-        <p:spPr>
-          <a:xfrm>
-            <a:off x="914400" y="5212080"/>
-            <a:ext cx="2743200" cy="457200"/>
-          </a:xfrm>
-          <a:prstGeom prst="rect">
-            <a:avLst/>
-          </a:prstGeom>
-          <a:noFill/>
-        </p:spPr>
-        <p:txBody>
-          <a:bodyPr wrap="square">
-            <a:spAutoFit/>
-          </a:bodyPr>
-          <a:lstStyle/>
-          <a:p>
-            <a:pPr algn="l">
-              <a:defRPr sz="1600" b="0">
-                <a:solidFill>
-                  <a:srgbClr val="FFFFFF"/>
-                </a:solidFill>
-                <a:latin typeface="Calibri"/>
-              </a:defRPr>
-            </a:pPr>
-            <a:r>
-              <a:t>embedding_pca</a:t>
-            </a:r>
-          </a:p>
-        </p:txBody>
-      </p:sp>
-      <p:sp>
-        <p:nvSpPr>
-          <p:cNvPr id="29" name="TextBox 28"/>
-          <p:cNvSpPr txBox="1"/>
-          <p:nvPr/>
-        </p:nvSpPr>
-        <p:spPr>
-          <a:xfrm>
-            <a:off x="4114800" y="5212080"/>
-            <a:ext cx="1828800" cy="457200"/>
-          </a:xfrm>
-          <a:prstGeom prst="rect">
-            <a:avLst/>
-          </a:prstGeom>
-          <a:noFill/>
-        </p:spPr>
-        <p:txBody>
-          <a:bodyPr wrap="square">
-            <a:spAutoFit/>
-          </a:bodyPr>
-          <a:lstStyle/>
-          <a:p>
-            <a:pPr algn="l">
-              <a:defRPr sz="1600" b="0">
-                <a:solidFill>
-                  <a:srgbClr val="FFFFFF"/>
-                </a:solidFill>
-                <a:latin typeface="Calibri"/>
-              </a:defRPr>
-            </a:pPr>
-            <a:r>
-              <a:t>0.9357</a:t>
-            </a:r>
-          </a:p>
-        </p:txBody>
-      </p:sp>
-      <p:sp>
-        <p:nvSpPr>
-          <p:cNvPr id="30" name="TextBox 29"/>
-          <p:cNvSpPr txBox="1"/>
-          <p:nvPr/>
-        </p:nvSpPr>
-        <p:spPr>
-          <a:xfrm>
-            <a:off x="6400800" y="5212080"/>
-            <a:ext cx="1828800" cy="457200"/>
-          </a:xfrm>
-          <a:prstGeom prst="rect">
-            <a:avLst/>
-          </a:prstGeom>
-          <a:noFill/>
-        </p:spPr>
-        <p:txBody>
-          <a:bodyPr wrap="square">
-            <a:spAutoFit/>
-          </a:bodyPr>
-          <a:lstStyle/>
-          <a:p>
-            <a:pPr algn="l">
-              <a:defRPr sz="1600" b="0">
-                <a:solidFill>
-                  <a:srgbClr val="FFFFFF"/>
-                </a:solidFill>
-                <a:latin typeface="Calibri"/>
-              </a:defRPr>
-            </a:pPr>
-            <a:r>
-              <a:t>0.8972</a:t>
-            </a:r>
-          </a:p>
-        </p:txBody>
-      </p:sp>
-      <p:sp>
-        <p:nvSpPr>
-          <p:cNvPr id="31" name="TextBox 30"/>
-          <p:cNvSpPr txBox="1"/>
-          <p:nvPr/>
-        </p:nvSpPr>
-        <p:spPr>
-          <a:xfrm>
-            <a:off x="8686800" y="5212080"/>
-            <a:ext cx="2743200" cy="457200"/>
-          </a:xfrm>
-          <a:prstGeom prst="rect">
-            <a:avLst/>
-          </a:prstGeom>
-          <a:noFill/>
-        </p:spPr>
-        <p:txBody>
-          <a:bodyPr wrap="square">
-            <a:spAutoFit/>
-          </a:bodyPr>
-          <a:lstStyle/>
-          <a:p>
-            <a:pPr algn="l">
-              <a:defRPr sz="1600" b="0">
-                <a:solidFill>
-                  <a:srgbClr val="FFFFFF"/>
-                </a:solidFill>
-                <a:latin typeface="Calibri"/>
-              </a:defRPr>
-            </a:pPr>
-            <a:r>
-              <a:t>接近</a:t>
-            </a:r>
-          </a:p>
-        </p:txBody>
-      </p:sp>
-      <p:sp>
-        <p:nvSpPr>
-          <p:cNvPr id="32" name="TextBox 31"/>
-          <p:cNvSpPr txBox="1"/>
-          <p:nvPr/>
-        </p:nvSpPr>
-        <p:spPr>
-          <a:xfrm>
-            <a:off x="731520" y="5760720"/>
-            <a:ext cx="10515600" cy="731520"/>
+            <a:off x="731520" y="5029200"/>
+            <a:ext cx="10972800" cy="731520"/>
           </a:xfrm>
           <a:prstGeom prst="rect">
             <a:avLst/>
@@ -9979,7 +9749,11 @@
               </a:defRPr>
             </a:pPr>
             <a:r>
-              <a:t>核心启示: 多模型检测不能依赖单一语言模型的困惑度 — 需要模型无关的统计特征作为稳定基线</a:t>
+              <a:t>Auto-Filter 是"只赚不赔"策略: RAID/TuringBench 性能不变, SemEval AUC 从 0.84 恢复到 0.98</a:t>
+            </a:r>
+            <a:br/>
+            <a:r>
+              <a:t>已集成到项目 pipeline: src/auto_filter.py</a:t>
             </a:r>
           </a:p>
         </p:txBody>
@@ -10033,7 +9807,7 @@
           <a:lstStyle/>
           <a:p>
             <a:pPr algn="l">
-              <a:defRPr sz="3600" b="1">
+              <a:defRPr sz="3200" b="1">
                 <a:solidFill>
                   <a:srgbClr val="00D2FF"/>
                 </a:solidFill>
@@ -10041,7 +9815,7 @@
               </a:defRPr>
             </a:pPr>
             <a:r>
-              <a:t>结论</a:t>
+              <a:t>RAID vs HC3: 特征组消融对比</a:t>
             </a:r>
           </a:p>
         </p:txBody>
@@ -10055,7 +9829,7 @@
         <p:spPr>
           <a:xfrm>
             <a:off x="731520" y="1005840"/>
-            <a:ext cx="3657600" cy="38100"/>
+            <a:ext cx="5486400" cy="38100"/>
           </a:xfrm>
           <a:prstGeom prst="rect">
             <a:avLst/>
@@ -10097,229 +9871,1038 @@
         </p:nvSpPr>
         <p:spPr>
           <a:xfrm>
-            <a:off x="731520" y="1371600"/>
-            <a:ext cx="10058400" cy="5029200"/>
-          </a:xfrm>
-          <a:prstGeom prst="rect">
-            <a:avLst/>
-          </a:prstGeom>
-          <a:noFill/>
-        </p:spPr>
-        <p:txBody>
-          <a:bodyPr wrap="square">
-            <a:spAutoFit/>
-          </a:bodyPr>
-          <a:lstStyle/>
-          <a:p>
-            <a:pPr>
-              <a:spcAft>
-                <a:spcPts val="720"/>
-              </a:spcAft>
-              <a:defRPr sz="1800">
-                <a:solidFill>
-                  <a:srgbClr val="E0E0E0"/>
-                </a:solidFill>
-                <a:latin typeface="Calibri"/>
-              </a:defRPr>
-            </a:pPr>
-            <a:r>
-              <a:t>1. XGBoost + 120 维组合特征在 RAID 上达到 AUC 0.9992</a:t>
-            </a:r>
-          </a:p>
-          <a:p>
-            <a:pPr>
-              <a:spcAft>
-                <a:spcPts val="720"/>
-              </a:spcAft>
-              <a:defRPr sz="1800">
-                <a:solidFill>
-                  <a:srgbClr val="E0E0E0"/>
-                </a:solidFill>
-                <a:latin typeface="Calibri"/>
-              </a:defRPr>
-            </a:pPr>
-            <a:r>
-              <a:t>    完全可解释，超越零样本方法 Fast-DetectGPT (0.7815)</a:t>
-            </a:r>
-          </a:p>
-          <a:p>
-            <a:pPr>
-              <a:spcAft>
-                <a:spcPts val="720"/>
-              </a:spcAft>
-              <a:defRPr sz="1800">
-                <a:solidFill>
-                  <a:srgbClr val="E0E0E0"/>
-                </a:solidFill>
-                <a:latin typeface="Calibri"/>
-              </a:defRPr>
-            </a:pPr>
-          </a:p>
-          <a:p>
-            <a:pPr>
-              <a:spcAft>
-                <a:spcPts val="720"/>
-              </a:spcAft>
-              <a:defRPr sz="1800">
-                <a:solidFill>
-                  <a:srgbClr val="E0E0E0"/>
-                </a:solidFill>
-                <a:latin typeface="Calibri"/>
-              </a:defRPr>
-            </a:pPr>
-            <a:r>
-              <a:t>2. 两类特征视角正交，互补覆盖盲区</a:t>
-            </a:r>
-          </a:p>
-          <a:p>
-            <a:pPr>
-              <a:spcAft>
-                <a:spcPts val="720"/>
-              </a:spcAft>
-              <a:defRPr sz="1800">
-                <a:solidFill>
-                  <a:srgbClr val="E0E0E0"/>
-                </a:solidFill>
-                <a:latin typeface="Calibri"/>
-              </a:defRPr>
-            </a:pPr>
-            <a:r>
-              <a:t>    手工特征看"文本外表"，Token 特征看"AI 内在"</a:t>
-            </a:r>
-          </a:p>
-          <a:p>
-            <a:pPr>
-              <a:spcAft>
-                <a:spcPts val="720"/>
-              </a:spcAft>
-              <a:defRPr sz="1800">
-                <a:solidFill>
-                  <a:srgbClr val="E0E0E0"/>
-                </a:solidFill>
-                <a:latin typeface="Calibri"/>
-              </a:defRPr>
-            </a:pPr>
-          </a:p>
-          <a:p>
-            <a:pPr>
-              <a:spcAft>
-                <a:spcPts val="720"/>
-              </a:spcAft>
-              <a:defRPr sz="1800">
-                <a:solidFill>
-                  <a:srgbClr val="E0E0E0"/>
-                </a:solidFill>
-                <a:latin typeface="Calibri"/>
-              </a:defRPr>
-            </a:pPr>
-            <a:r>
-              <a:t>3. GPT-2 困惑度的 Paradox 是重要发现</a:t>
-            </a:r>
-          </a:p>
-          <a:p>
-            <a:pPr>
-              <a:spcAft>
-                <a:spcPts val="720"/>
-              </a:spcAft>
-              <a:defRPr sz="1800">
-                <a:solidFill>
-                  <a:srgbClr val="E0E0E0"/>
-                </a:solidFill>
-                <a:latin typeface="Calibri"/>
-              </a:defRPr>
-            </a:pPr>
-            <a:r>
-              <a:t>    HC3 最强 (0.99) → RAID 完全失效 (0.49)</a:t>
-            </a:r>
-          </a:p>
-          <a:p>
-            <a:pPr>
-              <a:spcAft>
-                <a:spcPts val="720"/>
-              </a:spcAft>
-              <a:defRPr sz="1800">
-                <a:solidFill>
-                  <a:srgbClr val="E0E0E0"/>
-                </a:solidFill>
-                <a:latin typeface="Calibri"/>
-              </a:defRPr>
-            </a:pPr>
-          </a:p>
-          <a:p>
-            <a:pPr>
-              <a:spcAft>
-                <a:spcPts val="720"/>
-              </a:spcAft>
-              <a:defRPr sz="1800">
-                <a:solidFill>
-                  <a:srgbClr val="E0E0E0"/>
-                </a:solidFill>
-                <a:latin typeface="Calibri"/>
-              </a:defRPr>
-            </a:pPr>
-            <a:r>
-              <a:t>4. 统计特征对 10/11 种对抗攻击天然鲁棒</a:t>
-            </a:r>
-          </a:p>
-          <a:p>
-            <a:pPr>
-              <a:spcAft>
-                <a:spcPts val="720"/>
-              </a:spcAft>
-              <a:defRPr sz="1800">
-                <a:solidFill>
-                  <a:srgbClr val="E0E0E0"/>
-                </a:solidFill>
-                <a:latin typeface="Calibri"/>
-              </a:defRPr>
-            </a:pPr>
-            <a:r>
-              <a:t>    只有释义攻击能显著降低检测效果</a:t>
-            </a:r>
-          </a:p>
-          <a:p>
-            <a:pPr>
-              <a:spcAft>
-                <a:spcPts val="720"/>
-              </a:spcAft>
-              <a:defRPr sz="1800">
-                <a:solidFill>
-                  <a:srgbClr val="E0E0E0"/>
-                </a:solidFill>
-                <a:latin typeface="Calibri"/>
-              </a:defRPr>
-            </a:pPr>
-          </a:p>
-          <a:p>
-            <a:pPr>
-              <a:spcAft>
-                <a:spcPts val="720"/>
-              </a:spcAft>
-              <a:defRPr sz="1800">
-                <a:solidFill>
-                  <a:srgbClr val="E0E0E0"/>
-                </a:solidFill>
-                <a:latin typeface="Calibri"/>
-              </a:defRPr>
-            </a:pPr>
-            <a:r>
-              <a:t>5. Token 概率特征有"时代窗口"</a:t>
-            </a:r>
-          </a:p>
-          <a:p>
-            <a:pPr>
-              <a:spcAft>
-                <a:spcPts val="720"/>
-              </a:spcAft>
-              <a:defRPr sz="1800">
-                <a:solidFill>
-                  <a:srgbClr val="E0E0E0"/>
-                </a:solidFill>
-                <a:latin typeface="Calibri"/>
-              </a:defRPr>
-            </a:pPr>
-            <a:r>
-              <a:t>    观察者模型需要与目标生成器同代</a:t>
+            <a:off x="914400" y="1371600"/>
+            <a:ext cx="2286000" cy="457200"/>
+          </a:xfrm>
+          <a:prstGeom prst="rect">
+            <a:avLst/>
+          </a:prstGeom>
+          <a:noFill/>
+        </p:spPr>
+        <p:txBody>
+          <a:bodyPr wrap="square">
+            <a:spAutoFit/>
+          </a:bodyPr>
+          <a:lstStyle/>
+          <a:p>
+            <a:pPr algn="l">
+              <a:defRPr sz="1800" b="1">
+                <a:solidFill>
+                  <a:srgbClr val="00D2FF"/>
+                </a:solidFill>
+                <a:latin typeface="Calibri"/>
+              </a:defRPr>
+            </a:pPr>
+            <a:r>
+              <a:t>特征组</a:t>
+            </a:r>
+          </a:p>
+        </p:txBody>
+      </p:sp>
+      <p:sp>
+        <p:nvSpPr>
+          <p:cNvPr id="5" name="TextBox 4"/>
+          <p:cNvSpPr txBox="1"/>
+          <p:nvPr/>
+        </p:nvSpPr>
+        <p:spPr>
+          <a:xfrm>
+            <a:off x="4114800" y="1371600"/>
+            <a:ext cx="2286000" cy="457200"/>
+          </a:xfrm>
+          <a:prstGeom prst="rect">
+            <a:avLst/>
+          </a:prstGeom>
+          <a:noFill/>
+        </p:spPr>
+        <p:txBody>
+          <a:bodyPr wrap="square">
+            <a:spAutoFit/>
+          </a:bodyPr>
+          <a:lstStyle/>
+          <a:p>
+            <a:pPr algn="l">
+              <a:defRPr sz="1800" b="1">
+                <a:solidFill>
+                  <a:srgbClr val="00D2FF"/>
+                </a:solidFill>
+                <a:latin typeface="Calibri"/>
+              </a:defRPr>
+            </a:pPr>
+            <a:r>
+              <a:t>RAID AUC</a:t>
+            </a:r>
+          </a:p>
+        </p:txBody>
+      </p:sp>
+      <p:sp>
+        <p:nvSpPr>
+          <p:cNvPr id="6" name="TextBox 5"/>
+          <p:cNvSpPr txBox="1"/>
+          <p:nvPr/>
+        </p:nvSpPr>
+        <p:spPr>
+          <a:xfrm>
+            <a:off x="6400800" y="1371600"/>
+            <a:ext cx="2286000" cy="457200"/>
+          </a:xfrm>
+          <a:prstGeom prst="rect">
+            <a:avLst/>
+          </a:prstGeom>
+          <a:noFill/>
+        </p:spPr>
+        <p:txBody>
+          <a:bodyPr wrap="square">
+            <a:spAutoFit/>
+          </a:bodyPr>
+          <a:lstStyle/>
+          <a:p>
+            <a:pPr algn="l">
+              <a:defRPr sz="1800" b="1">
+                <a:solidFill>
+                  <a:srgbClr val="00D2FF"/>
+                </a:solidFill>
+                <a:latin typeface="Calibri"/>
+              </a:defRPr>
+            </a:pPr>
+            <a:r>
+              <a:t>HC3 AUC</a:t>
+            </a:r>
+          </a:p>
+        </p:txBody>
+      </p:sp>
+      <p:sp>
+        <p:nvSpPr>
+          <p:cNvPr id="7" name="TextBox 6"/>
+          <p:cNvSpPr txBox="1"/>
+          <p:nvPr/>
+        </p:nvSpPr>
+        <p:spPr>
+          <a:xfrm>
+            <a:off x="8686800" y="1371600"/>
+            <a:ext cx="2286000" cy="457200"/>
+          </a:xfrm>
+          <a:prstGeom prst="rect">
+            <a:avLst/>
+          </a:prstGeom>
+          <a:noFill/>
+        </p:spPr>
+        <p:txBody>
+          <a:bodyPr wrap="square">
+            <a:spAutoFit/>
+          </a:bodyPr>
+          <a:lstStyle/>
+          <a:p>
+            <a:pPr algn="l">
+              <a:defRPr sz="1800" b="1">
+                <a:solidFill>
+                  <a:srgbClr val="00D2FF"/>
+                </a:solidFill>
+                <a:latin typeface="Calibri"/>
+              </a:defRPr>
+            </a:pPr>
+            <a:r>
+              <a:t>启示</a:t>
+            </a:r>
+          </a:p>
+        </p:txBody>
+      </p:sp>
+      <p:sp>
+        <p:nvSpPr>
+          <p:cNvPr id="8" name="TextBox 7"/>
+          <p:cNvSpPr txBox="1"/>
+          <p:nvPr/>
+        </p:nvSpPr>
+        <p:spPr>
+          <a:xfrm>
+            <a:off x="914400" y="2011680"/>
+            <a:ext cx="2743200" cy="457200"/>
+          </a:xfrm>
+          <a:prstGeom prst="rect">
+            <a:avLst/>
+          </a:prstGeom>
+          <a:noFill/>
+        </p:spPr>
+        <p:txBody>
+          <a:bodyPr wrap="square">
+            <a:spAutoFit/>
+          </a:bodyPr>
+          <a:lstStyle/>
+          <a:p>
+            <a:pPr algn="l">
+              <a:defRPr sz="1600" b="0">
+                <a:solidFill>
+                  <a:srgbClr val="FFFFFF"/>
+                </a:solidFill>
+                <a:latin typeface="Calibri"/>
+              </a:defRPr>
+            </a:pPr>
+            <a:r>
+              <a:t>basic_counts</a:t>
+            </a:r>
+          </a:p>
+        </p:txBody>
+      </p:sp>
+      <p:sp>
+        <p:nvSpPr>
+          <p:cNvPr id="9" name="TextBox 8"/>
+          <p:cNvSpPr txBox="1"/>
+          <p:nvPr/>
+        </p:nvSpPr>
+        <p:spPr>
+          <a:xfrm>
+            <a:off x="4114800" y="2011680"/>
+            <a:ext cx="1828800" cy="457200"/>
+          </a:xfrm>
+          <a:prstGeom prst="rect">
+            <a:avLst/>
+          </a:prstGeom>
+          <a:noFill/>
+        </p:spPr>
+        <p:txBody>
+          <a:bodyPr wrap="square">
+            <a:spAutoFit/>
+          </a:bodyPr>
+          <a:lstStyle/>
+          <a:p>
+            <a:pPr algn="l">
+              <a:defRPr sz="1600" b="0">
+                <a:solidFill>
+                  <a:srgbClr val="FFFFFF"/>
+                </a:solidFill>
+                <a:latin typeface="Calibri"/>
+              </a:defRPr>
+            </a:pPr>
+            <a:r>
+              <a:t>0.9700</a:t>
+            </a:r>
+          </a:p>
+        </p:txBody>
+      </p:sp>
+      <p:sp>
+        <p:nvSpPr>
+          <p:cNvPr id="10" name="TextBox 9"/>
+          <p:cNvSpPr txBox="1"/>
+          <p:nvPr/>
+        </p:nvSpPr>
+        <p:spPr>
+          <a:xfrm>
+            <a:off x="6400800" y="2011680"/>
+            <a:ext cx="1828800" cy="457200"/>
+          </a:xfrm>
+          <a:prstGeom prst="rect">
+            <a:avLst/>
+          </a:prstGeom>
+          <a:noFill/>
+        </p:spPr>
+        <p:txBody>
+          <a:bodyPr wrap="square">
+            <a:spAutoFit/>
+          </a:bodyPr>
+          <a:lstStyle/>
+          <a:p>
+            <a:pPr algn="l">
+              <a:defRPr sz="1600" b="0">
+                <a:solidFill>
+                  <a:srgbClr val="FFFFFF"/>
+                </a:solidFill>
+                <a:latin typeface="Calibri"/>
+              </a:defRPr>
+            </a:pPr>
+            <a:r>
+              <a:t>0.9204</a:t>
+            </a:r>
+          </a:p>
+        </p:txBody>
+      </p:sp>
+      <p:sp>
+        <p:nvSpPr>
+          <p:cNvPr id="11" name="TextBox 10"/>
+          <p:cNvSpPr txBox="1"/>
+          <p:nvPr/>
+        </p:nvSpPr>
+        <p:spPr>
+          <a:xfrm>
+            <a:off x="8686800" y="2011680"/>
+            <a:ext cx="2743200" cy="457200"/>
+          </a:xfrm>
+          <a:prstGeom prst="rect">
+            <a:avLst/>
+          </a:prstGeom>
+          <a:noFill/>
+        </p:spPr>
+        <p:txBody>
+          <a:bodyPr wrap="square">
+            <a:spAutoFit/>
+          </a:bodyPr>
+          <a:lstStyle/>
+          <a:p>
+            <a:pPr algn="l">
+              <a:defRPr sz="1600" b="0">
+                <a:solidFill>
+                  <a:srgbClr val="FFFFFF"/>
+                </a:solidFill>
+                <a:latin typeface="Calibri"/>
+              </a:defRPr>
+            </a:pPr>
+            <a:r>
+              <a:t>RAID 更强</a:t>
+            </a:r>
+          </a:p>
+        </p:txBody>
+      </p:sp>
+      <p:sp>
+        <p:nvSpPr>
+          <p:cNvPr id="12" name="TextBox 11"/>
+          <p:cNvSpPr txBox="1"/>
+          <p:nvPr/>
+        </p:nvSpPr>
+        <p:spPr>
+          <a:xfrm>
+            <a:off x="914400" y="2651760"/>
+            <a:ext cx="2743200" cy="457200"/>
+          </a:xfrm>
+          <a:prstGeom prst="rect">
+            <a:avLst/>
+          </a:prstGeom>
+          <a:noFill/>
+        </p:spPr>
+        <p:txBody>
+          <a:bodyPr wrap="square">
+            <a:spAutoFit/>
+          </a:bodyPr>
+          <a:lstStyle/>
+          <a:p>
+            <a:pPr algn="l">
+              <a:defRPr sz="1600" b="0">
+                <a:solidFill>
+                  <a:srgbClr val="FFFFFF"/>
+                </a:solidFill>
+                <a:latin typeface="Calibri"/>
+              </a:defRPr>
+            </a:pPr>
+            <a:r>
+              <a:t>averages</a:t>
+            </a:r>
+          </a:p>
+        </p:txBody>
+      </p:sp>
+      <p:sp>
+        <p:nvSpPr>
+          <p:cNvPr id="13" name="TextBox 12"/>
+          <p:cNvSpPr txBox="1"/>
+          <p:nvPr/>
+        </p:nvSpPr>
+        <p:spPr>
+          <a:xfrm>
+            <a:off x="4114800" y="2651760"/>
+            <a:ext cx="1828800" cy="457200"/>
+          </a:xfrm>
+          <a:prstGeom prst="rect">
+            <a:avLst/>
+          </a:prstGeom>
+          <a:noFill/>
+        </p:spPr>
+        <p:txBody>
+          <a:bodyPr wrap="square">
+            <a:spAutoFit/>
+          </a:bodyPr>
+          <a:lstStyle/>
+          <a:p>
+            <a:pPr algn="l">
+              <a:defRPr sz="1600" b="0">
+                <a:solidFill>
+                  <a:srgbClr val="FFFFFF"/>
+                </a:solidFill>
+                <a:latin typeface="Calibri"/>
+              </a:defRPr>
+            </a:pPr>
+            <a:r>
+              <a:t>0.9425</a:t>
+            </a:r>
+          </a:p>
+        </p:txBody>
+      </p:sp>
+      <p:sp>
+        <p:nvSpPr>
+          <p:cNvPr id="14" name="TextBox 13"/>
+          <p:cNvSpPr txBox="1"/>
+          <p:nvPr/>
+        </p:nvSpPr>
+        <p:spPr>
+          <a:xfrm>
+            <a:off x="6400800" y="2651760"/>
+            <a:ext cx="1828800" cy="457200"/>
+          </a:xfrm>
+          <a:prstGeom prst="rect">
+            <a:avLst/>
+          </a:prstGeom>
+          <a:noFill/>
+        </p:spPr>
+        <p:txBody>
+          <a:bodyPr wrap="square">
+            <a:spAutoFit/>
+          </a:bodyPr>
+          <a:lstStyle/>
+          <a:p>
+            <a:pPr algn="l">
+              <a:defRPr sz="1600" b="0">
+                <a:solidFill>
+                  <a:srgbClr val="FFFFFF"/>
+                </a:solidFill>
+                <a:latin typeface="Calibri"/>
+              </a:defRPr>
+            </a:pPr>
+            <a:r>
+              <a:t>0.9021</a:t>
+            </a:r>
+          </a:p>
+        </p:txBody>
+      </p:sp>
+      <p:sp>
+        <p:nvSpPr>
+          <p:cNvPr id="15" name="TextBox 14"/>
+          <p:cNvSpPr txBox="1"/>
+          <p:nvPr/>
+        </p:nvSpPr>
+        <p:spPr>
+          <a:xfrm>
+            <a:off x="8686800" y="2651760"/>
+            <a:ext cx="2743200" cy="457200"/>
+          </a:xfrm>
+          <a:prstGeom prst="rect">
+            <a:avLst/>
+          </a:prstGeom>
+          <a:noFill/>
+        </p:spPr>
+        <p:txBody>
+          <a:bodyPr wrap="square">
+            <a:spAutoFit/>
+          </a:bodyPr>
+          <a:lstStyle/>
+          <a:p>
+            <a:pPr algn="l">
+              <a:defRPr sz="1600" b="0">
+                <a:solidFill>
+                  <a:srgbClr val="FFFFFF"/>
+                </a:solidFill>
+                <a:latin typeface="Calibri"/>
+              </a:defRPr>
+            </a:pPr>
+            <a:r>
+              <a:t>RAID 更强</a:t>
+            </a:r>
+          </a:p>
+        </p:txBody>
+      </p:sp>
+      <p:sp>
+        <p:nvSpPr>
+          <p:cNvPr id="16" name="TextBox 15"/>
+          <p:cNvSpPr txBox="1"/>
+          <p:nvPr/>
+        </p:nvSpPr>
+        <p:spPr>
+          <a:xfrm>
+            <a:off x="914400" y="3291840"/>
+            <a:ext cx="2743200" cy="457200"/>
+          </a:xfrm>
+          <a:prstGeom prst="rect">
+            <a:avLst/>
+          </a:prstGeom>
+          <a:noFill/>
+        </p:spPr>
+        <p:txBody>
+          <a:bodyPr wrap="square">
+            <a:spAutoFit/>
+          </a:bodyPr>
+          <a:lstStyle/>
+          <a:p>
+            <a:pPr algn="l">
+              <a:defRPr sz="1600" b="0">
+                <a:solidFill>
+                  <a:srgbClr val="FFFFFF"/>
+                </a:solidFill>
+                <a:latin typeface="Calibri"/>
+              </a:defRPr>
+            </a:pPr>
+            <a:r>
+              <a:t>lexical_richness</a:t>
+            </a:r>
+          </a:p>
+        </p:txBody>
+      </p:sp>
+      <p:sp>
+        <p:nvSpPr>
+          <p:cNvPr id="17" name="TextBox 16"/>
+          <p:cNvSpPr txBox="1"/>
+          <p:nvPr/>
+        </p:nvSpPr>
+        <p:spPr>
+          <a:xfrm>
+            <a:off x="4114800" y="3291840"/>
+            <a:ext cx="1828800" cy="457200"/>
+          </a:xfrm>
+          <a:prstGeom prst="rect">
+            <a:avLst/>
+          </a:prstGeom>
+          <a:noFill/>
+        </p:spPr>
+        <p:txBody>
+          <a:bodyPr wrap="square">
+            <a:spAutoFit/>
+          </a:bodyPr>
+          <a:lstStyle/>
+          <a:p>
+            <a:pPr algn="l">
+              <a:defRPr sz="1600" b="0">
+                <a:solidFill>
+                  <a:srgbClr val="FFFFFF"/>
+                </a:solidFill>
+                <a:latin typeface="Calibri"/>
+              </a:defRPr>
+            </a:pPr>
+            <a:r>
+              <a:t>0.8861</a:t>
+            </a:r>
+          </a:p>
+        </p:txBody>
+      </p:sp>
+      <p:sp>
+        <p:nvSpPr>
+          <p:cNvPr id="18" name="TextBox 17"/>
+          <p:cNvSpPr txBox="1"/>
+          <p:nvPr/>
+        </p:nvSpPr>
+        <p:spPr>
+          <a:xfrm>
+            <a:off x="6400800" y="3291840"/>
+            <a:ext cx="1828800" cy="457200"/>
+          </a:xfrm>
+          <a:prstGeom prst="rect">
+            <a:avLst/>
+          </a:prstGeom>
+          <a:noFill/>
+        </p:spPr>
+        <p:txBody>
+          <a:bodyPr wrap="square">
+            <a:spAutoFit/>
+          </a:bodyPr>
+          <a:lstStyle/>
+          <a:p>
+            <a:pPr algn="l">
+              <a:defRPr sz="1600" b="0">
+                <a:solidFill>
+                  <a:srgbClr val="FFFFFF"/>
+                </a:solidFill>
+                <a:latin typeface="Calibri"/>
+              </a:defRPr>
+            </a:pPr>
+            <a:r>
+              <a:t>0.9367</a:t>
+            </a:r>
+          </a:p>
+        </p:txBody>
+      </p:sp>
+      <p:sp>
+        <p:nvSpPr>
+          <p:cNvPr id="19" name="TextBox 18"/>
+          <p:cNvSpPr txBox="1"/>
+          <p:nvPr/>
+        </p:nvSpPr>
+        <p:spPr>
+          <a:xfrm>
+            <a:off x="8686800" y="3291840"/>
+            <a:ext cx="2743200" cy="457200"/>
+          </a:xfrm>
+          <a:prstGeom prst="rect">
+            <a:avLst/>
+          </a:prstGeom>
+          <a:noFill/>
+        </p:spPr>
+        <p:txBody>
+          <a:bodyPr wrap="square">
+            <a:spAutoFit/>
+          </a:bodyPr>
+          <a:lstStyle/>
+          <a:p>
+            <a:pPr algn="l">
+              <a:defRPr sz="1600" b="0">
+                <a:solidFill>
+                  <a:srgbClr val="FFFFFF"/>
+                </a:solidFill>
+                <a:latin typeface="Calibri"/>
+              </a:defRPr>
+            </a:pPr>
+            <a:r>
+              <a:t>HC3 更强</a:t>
+            </a:r>
+          </a:p>
+        </p:txBody>
+      </p:sp>
+      <p:sp>
+        <p:nvSpPr>
+          <p:cNvPr id="20" name="TextBox 19"/>
+          <p:cNvSpPr txBox="1"/>
+          <p:nvPr/>
+        </p:nvSpPr>
+        <p:spPr>
+          <a:xfrm>
+            <a:off x="914400" y="3931920"/>
+            <a:ext cx="2743200" cy="457200"/>
+          </a:xfrm>
+          <a:prstGeom prst="rect">
+            <a:avLst/>
+          </a:prstGeom>
+          <a:noFill/>
+        </p:spPr>
+        <p:txBody>
+          <a:bodyPr wrap="square">
+            <a:spAutoFit/>
+          </a:bodyPr>
+          <a:lstStyle/>
+          <a:p>
+            <a:pPr algn="l">
+              <a:defRPr sz="1600" b="0">
+                <a:solidFill>
+                  <a:srgbClr val="FFFFFF"/>
+                </a:solidFill>
+                <a:latin typeface="Calibri"/>
+              </a:defRPr>
+            </a:pPr>
+            <a:r>
+              <a:t>readability</a:t>
+            </a:r>
+          </a:p>
+        </p:txBody>
+      </p:sp>
+      <p:sp>
+        <p:nvSpPr>
+          <p:cNvPr id="21" name="TextBox 20"/>
+          <p:cNvSpPr txBox="1"/>
+          <p:nvPr/>
+        </p:nvSpPr>
+        <p:spPr>
+          <a:xfrm>
+            <a:off x="4114800" y="3931920"/>
+            <a:ext cx="1828800" cy="457200"/>
+          </a:xfrm>
+          <a:prstGeom prst="rect">
+            <a:avLst/>
+          </a:prstGeom>
+          <a:noFill/>
+        </p:spPr>
+        <p:txBody>
+          <a:bodyPr wrap="square">
+            <a:spAutoFit/>
+          </a:bodyPr>
+          <a:lstStyle/>
+          <a:p>
+            <a:pPr algn="l">
+              <a:defRPr sz="1600" b="0">
+                <a:solidFill>
+                  <a:srgbClr val="FFFFFF"/>
+                </a:solidFill>
+                <a:latin typeface="Calibri"/>
+              </a:defRPr>
+            </a:pPr>
+            <a:r>
+              <a:t>0.8500</a:t>
+            </a:r>
+          </a:p>
+        </p:txBody>
+      </p:sp>
+      <p:sp>
+        <p:nvSpPr>
+          <p:cNvPr id="22" name="TextBox 21"/>
+          <p:cNvSpPr txBox="1"/>
+          <p:nvPr/>
+        </p:nvSpPr>
+        <p:spPr>
+          <a:xfrm>
+            <a:off x="6400800" y="3931920"/>
+            <a:ext cx="1828800" cy="457200"/>
+          </a:xfrm>
+          <a:prstGeom prst="rect">
+            <a:avLst/>
+          </a:prstGeom>
+          <a:noFill/>
+        </p:spPr>
+        <p:txBody>
+          <a:bodyPr wrap="square">
+            <a:spAutoFit/>
+          </a:bodyPr>
+          <a:lstStyle/>
+          <a:p>
+            <a:pPr algn="l">
+              <a:defRPr sz="1600" b="0">
+                <a:solidFill>
+                  <a:srgbClr val="FFFFFF"/>
+                </a:solidFill>
+                <a:latin typeface="Calibri"/>
+              </a:defRPr>
+            </a:pPr>
+            <a:r>
+              <a:t>0.9741</a:t>
+            </a:r>
+          </a:p>
+        </p:txBody>
+      </p:sp>
+      <p:sp>
+        <p:nvSpPr>
+          <p:cNvPr id="23" name="TextBox 22"/>
+          <p:cNvSpPr txBox="1"/>
+          <p:nvPr/>
+        </p:nvSpPr>
+        <p:spPr>
+          <a:xfrm>
+            <a:off x="8686800" y="3931920"/>
+            <a:ext cx="2743200" cy="457200"/>
+          </a:xfrm>
+          <a:prstGeom prst="rect">
+            <a:avLst/>
+          </a:prstGeom>
+          <a:noFill/>
+        </p:spPr>
+        <p:txBody>
+          <a:bodyPr wrap="square">
+            <a:spAutoFit/>
+          </a:bodyPr>
+          <a:lstStyle/>
+          <a:p>
+            <a:pPr algn="l">
+              <a:defRPr sz="1600" b="0">
+                <a:solidFill>
+                  <a:srgbClr val="FFFFFF"/>
+                </a:solidFill>
+                <a:latin typeface="Calibri"/>
+              </a:defRPr>
+            </a:pPr>
+            <a:r>
+              <a:t>HC3 远优</a:t>
+            </a:r>
+          </a:p>
+        </p:txBody>
+      </p:sp>
+      <p:sp>
+        <p:nvSpPr>
+          <p:cNvPr id="24" name="TextBox 23"/>
+          <p:cNvSpPr txBox="1"/>
+          <p:nvPr/>
+        </p:nvSpPr>
+        <p:spPr>
+          <a:xfrm>
+            <a:off x="914400" y="4572000"/>
+            <a:ext cx="2743200" cy="457200"/>
+          </a:xfrm>
+          <a:prstGeom prst="rect">
+            <a:avLst/>
+          </a:prstGeom>
+          <a:noFill/>
+        </p:spPr>
+        <p:txBody>
+          <a:bodyPr wrap="square">
+            <a:spAutoFit/>
+          </a:bodyPr>
+          <a:lstStyle/>
+          <a:p>
+            <a:pPr algn="l">
+              <a:defRPr sz="1600" b="0">
+                <a:solidFill>
+                  <a:srgbClr val="FF6B6B"/>
+                </a:solidFill>
+                <a:latin typeface="Calibri"/>
+              </a:defRPr>
+            </a:pPr>
+            <a:r>
+              <a:t>perplexity</a:t>
+            </a:r>
+          </a:p>
+        </p:txBody>
+      </p:sp>
+      <p:sp>
+        <p:nvSpPr>
+          <p:cNvPr id="25" name="TextBox 24"/>
+          <p:cNvSpPr txBox="1"/>
+          <p:nvPr/>
+        </p:nvSpPr>
+        <p:spPr>
+          <a:xfrm>
+            <a:off x="4114800" y="4572000"/>
+            <a:ext cx="1828800" cy="457200"/>
+          </a:xfrm>
+          <a:prstGeom prst="rect">
+            <a:avLst/>
+          </a:prstGeom>
+          <a:noFill/>
+        </p:spPr>
+        <p:txBody>
+          <a:bodyPr wrap="square">
+            <a:spAutoFit/>
+          </a:bodyPr>
+          <a:lstStyle/>
+          <a:p>
+            <a:pPr algn="l">
+              <a:defRPr sz="1600" b="0">
+                <a:solidFill>
+                  <a:srgbClr val="FF6B6B"/>
+                </a:solidFill>
+                <a:latin typeface="Calibri"/>
+              </a:defRPr>
+            </a:pPr>
+            <a:r>
+              <a:t>0.4920</a:t>
+            </a:r>
+          </a:p>
+        </p:txBody>
+      </p:sp>
+      <p:sp>
+        <p:nvSpPr>
+          <p:cNvPr id="26" name="TextBox 25"/>
+          <p:cNvSpPr txBox="1"/>
+          <p:nvPr/>
+        </p:nvSpPr>
+        <p:spPr>
+          <a:xfrm>
+            <a:off x="6400800" y="4572000"/>
+            <a:ext cx="1828800" cy="457200"/>
+          </a:xfrm>
+          <a:prstGeom prst="rect">
+            <a:avLst/>
+          </a:prstGeom>
+          <a:noFill/>
+        </p:spPr>
+        <p:txBody>
+          <a:bodyPr wrap="square">
+            <a:spAutoFit/>
+          </a:bodyPr>
+          <a:lstStyle/>
+          <a:p>
+            <a:pPr algn="l">
+              <a:defRPr sz="1600" b="0">
+                <a:solidFill>
+                  <a:srgbClr val="FF6B6B"/>
+                </a:solidFill>
+                <a:latin typeface="Calibri"/>
+              </a:defRPr>
+            </a:pPr>
+            <a:r>
+              <a:t>0.9912</a:t>
+            </a:r>
+          </a:p>
+        </p:txBody>
+      </p:sp>
+      <p:sp>
+        <p:nvSpPr>
+          <p:cNvPr id="27" name="TextBox 26"/>
+          <p:cNvSpPr txBox="1"/>
+          <p:nvPr/>
+        </p:nvSpPr>
+        <p:spPr>
+          <a:xfrm>
+            <a:off x="8686800" y="4572000"/>
+            <a:ext cx="2743200" cy="457200"/>
+          </a:xfrm>
+          <a:prstGeom prst="rect">
+            <a:avLst/>
+          </a:prstGeom>
+          <a:noFill/>
+        </p:spPr>
+        <p:txBody>
+          <a:bodyPr wrap="square">
+            <a:spAutoFit/>
+          </a:bodyPr>
+          <a:lstStyle/>
+          <a:p>
+            <a:pPr algn="l">
+              <a:defRPr sz="1600" b="0">
+                <a:solidFill>
+                  <a:srgbClr val="FF6B6B"/>
+                </a:solidFill>
+                <a:latin typeface="Calibri"/>
+              </a:defRPr>
+            </a:pPr>
+            <a:r>
+              <a:t>完全反转!</a:t>
+            </a:r>
+          </a:p>
+        </p:txBody>
+      </p:sp>
+      <p:sp>
+        <p:nvSpPr>
+          <p:cNvPr id="28" name="TextBox 27"/>
+          <p:cNvSpPr txBox="1"/>
+          <p:nvPr/>
+        </p:nvSpPr>
+        <p:spPr>
+          <a:xfrm>
+            <a:off x="914400" y="5212080"/>
+            <a:ext cx="2743200" cy="457200"/>
+          </a:xfrm>
+          <a:prstGeom prst="rect">
+            <a:avLst/>
+          </a:prstGeom>
+          <a:noFill/>
+        </p:spPr>
+        <p:txBody>
+          <a:bodyPr wrap="square">
+            <a:spAutoFit/>
+          </a:bodyPr>
+          <a:lstStyle/>
+          <a:p>
+            <a:pPr algn="l">
+              <a:defRPr sz="1600" b="0">
+                <a:solidFill>
+                  <a:srgbClr val="FFFFFF"/>
+                </a:solidFill>
+                <a:latin typeface="Calibri"/>
+              </a:defRPr>
+            </a:pPr>
+            <a:r>
+              <a:t>embedding_pca</a:t>
+            </a:r>
+          </a:p>
+        </p:txBody>
+      </p:sp>
+      <p:sp>
+        <p:nvSpPr>
+          <p:cNvPr id="29" name="TextBox 28"/>
+          <p:cNvSpPr txBox="1"/>
+          <p:nvPr/>
+        </p:nvSpPr>
+        <p:spPr>
+          <a:xfrm>
+            <a:off x="4114800" y="5212080"/>
+            <a:ext cx="1828800" cy="457200"/>
+          </a:xfrm>
+          <a:prstGeom prst="rect">
+            <a:avLst/>
+          </a:prstGeom>
+          <a:noFill/>
+        </p:spPr>
+        <p:txBody>
+          <a:bodyPr wrap="square">
+            <a:spAutoFit/>
+          </a:bodyPr>
+          <a:lstStyle/>
+          <a:p>
+            <a:pPr algn="l">
+              <a:defRPr sz="1600" b="0">
+                <a:solidFill>
+                  <a:srgbClr val="FFFFFF"/>
+                </a:solidFill>
+                <a:latin typeface="Calibri"/>
+              </a:defRPr>
+            </a:pPr>
+            <a:r>
+              <a:t>0.9357</a:t>
+            </a:r>
+          </a:p>
+        </p:txBody>
+      </p:sp>
+      <p:sp>
+        <p:nvSpPr>
+          <p:cNvPr id="30" name="TextBox 29"/>
+          <p:cNvSpPr txBox="1"/>
+          <p:nvPr/>
+        </p:nvSpPr>
+        <p:spPr>
+          <a:xfrm>
+            <a:off x="6400800" y="5212080"/>
+            <a:ext cx="1828800" cy="457200"/>
+          </a:xfrm>
+          <a:prstGeom prst="rect">
+            <a:avLst/>
+          </a:prstGeom>
+          <a:noFill/>
+        </p:spPr>
+        <p:txBody>
+          <a:bodyPr wrap="square">
+            <a:spAutoFit/>
+          </a:bodyPr>
+          <a:lstStyle/>
+          <a:p>
+            <a:pPr algn="l">
+              <a:defRPr sz="1600" b="0">
+                <a:solidFill>
+                  <a:srgbClr val="FFFFFF"/>
+                </a:solidFill>
+                <a:latin typeface="Calibri"/>
+              </a:defRPr>
+            </a:pPr>
+            <a:r>
+              <a:t>0.8972</a:t>
+            </a:r>
+          </a:p>
+        </p:txBody>
+      </p:sp>
+      <p:sp>
+        <p:nvSpPr>
+          <p:cNvPr id="31" name="TextBox 30"/>
+          <p:cNvSpPr txBox="1"/>
+          <p:nvPr/>
+        </p:nvSpPr>
+        <p:spPr>
+          <a:xfrm>
+            <a:off x="8686800" y="5212080"/>
+            <a:ext cx="2743200" cy="457200"/>
+          </a:xfrm>
+          <a:prstGeom prst="rect">
+            <a:avLst/>
+          </a:prstGeom>
+          <a:noFill/>
+        </p:spPr>
+        <p:txBody>
+          <a:bodyPr wrap="square">
+            <a:spAutoFit/>
+          </a:bodyPr>
+          <a:lstStyle/>
+          <a:p>
+            <a:pPr algn="l">
+              <a:defRPr sz="1600" b="0">
+                <a:solidFill>
+                  <a:srgbClr val="FFFFFF"/>
+                </a:solidFill>
+                <a:latin typeface="Calibri"/>
+              </a:defRPr>
+            </a:pPr>
+            <a:r>
+              <a:t>接近</a:t>
+            </a:r>
+          </a:p>
+        </p:txBody>
+      </p:sp>
+      <p:sp>
+        <p:nvSpPr>
+          <p:cNvPr id="32" name="TextBox 31"/>
+          <p:cNvSpPr txBox="1"/>
+          <p:nvPr/>
+        </p:nvSpPr>
+        <p:spPr>
+          <a:xfrm>
+            <a:off x="731520" y="5760720"/>
+            <a:ext cx="10515600" cy="731520"/>
+          </a:xfrm>
+          <a:prstGeom prst="rect">
+            <a:avLst/>
+          </a:prstGeom>
+          <a:noFill/>
+        </p:spPr>
+        <p:txBody>
+          <a:bodyPr wrap="square">
+            <a:spAutoFit/>
+          </a:bodyPr>
+          <a:lstStyle/>
+          <a:p>
+            <a:pPr algn="ctr">
+              <a:defRPr sz="1600" b="0">
+                <a:solidFill>
+                  <a:srgbClr val="00D2FF"/>
+                </a:solidFill>
+                <a:latin typeface="Calibri"/>
+              </a:defRPr>
+            </a:pPr>
+            <a:r>
+              <a:t>核心启示: 多模型检测不能依赖单一语言模型的困惑度 — 需要模型无关的统计特征作为稳定基线</a:t>
             </a:r>
           </a:p>
         </p:txBody>
@@ -10381,7 +10964,7 @@
               </a:defRPr>
             </a:pPr>
             <a:r>
-              <a:t>未来方向与部署建议</a:t>
+              <a:t>结论</a:t>
             </a:r>
           </a:p>
         </p:txBody>
@@ -10438,311 +11021,228 @@
         <p:spPr>
           <a:xfrm>
             <a:off x="731520" y="1371600"/>
-            <a:ext cx="5029200" cy="548640"/>
-          </a:xfrm>
-          <a:prstGeom prst="rect">
-            <a:avLst/>
-          </a:prstGeom>
-          <a:noFill/>
-        </p:spPr>
-        <p:txBody>
-          <a:bodyPr wrap="square">
-            <a:spAutoFit/>
-          </a:bodyPr>
-          <a:lstStyle/>
-          <a:p>
-            <a:pPr algn="l">
-              <a:defRPr sz="2200" b="1">
-                <a:solidFill>
-                  <a:srgbClr val="4ECB71"/>
-                </a:solidFill>
-                <a:latin typeface="Calibri"/>
-              </a:defRPr>
-            </a:pPr>
-            <a:r>
-              <a:t>未来工作</a:t>
-            </a:r>
-          </a:p>
-        </p:txBody>
-      </p:sp>
-      <p:sp>
-        <p:nvSpPr>
-          <p:cNvPr id="5" name="TextBox 4"/>
-          <p:cNvSpPr txBox="1"/>
-          <p:nvPr/>
-        </p:nvSpPr>
-        <p:spPr>
-          <a:xfrm>
-            <a:off x="731520" y="2011680"/>
-            <a:ext cx="5029200" cy="2743200"/>
-          </a:xfrm>
-          <a:prstGeom prst="rect">
-            <a:avLst/>
-          </a:prstGeom>
-          <a:noFill/>
-        </p:spPr>
-        <p:txBody>
-          <a:bodyPr wrap="square">
-            <a:spAutoFit/>
-          </a:bodyPr>
-          <a:lstStyle/>
-          <a:p>
-            <a:pPr>
-              <a:spcAft>
-                <a:spcPts val="960"/>
-              </a:spcAft>
-              <a:defRPr sz="1600">
-                <a:solidFill>
-                  <a:srgbClr val="E0E0E0"/>
-                </a:solidFill>
-                <a:latin typeface="Calibri"/>
-              </a:defRPr>
-            </a:pPr>
-            <a:r>
-              <a:t>引入语义相似度特征防御释义攻击</a:t>
-            </a:r>
-          </a:p>
-          <a:p>
-            <a:pPr>
-              <a:spcAft>
-                <a:spcPts val="960"/>
-              </a:spcAft>
-              <a:defRPr sz="1600">
-                <a:solidFill>
-                  <a:srgbClr val="E0E0E0"/>
-                </a:solidFill>
-                <a:latin typeface="Calibri"/>
-              </a:defRPr>
-            </a:pPr>
-            <a:r>
-              <a:t>多观察者模型集成 (Mistral + Qwen + Llama)</a:t>
-            </a:r>
-          </a:p>
-          <a:p>
-            <a:pPr>
-              <a:spcAft>
-                <a:spcPts val="960"/>
-              </a:spcAft>
-              <a:defRPr sz="1600">
-                <a:solidFill>
-                  <a:srgbClr val="E0E0E0"/>
-                </a:solidFill>
-                <a:latin typeface="Calibri"/>
-              </a:defRPr>
-            </a:pPr>
-            <a:r>
-              <a:t>动态特征选择: 根据文本领域自动调整</a:t>
-            </a:r>
-          </a:p>
-          <a:p>
-            <a:pPr>
-              <a:spcAft>
-                <a:spcPts val="960"/>
-              </a:spcAft>
-              <a:defRPr sz="1600">
-                <a:solidFill>
-                  <a:srgbClr val="E0E0E0"/>
-                </a:solidFill>
-                <a:latin typeface="Calibri"/>
-              </a:defRPr>
-            </a:pPr>
-            <a:r>
-              <a:t>探索更多 token 统计: burstiness, curvature</a:t>
-            </a:r>
-          </a:p>
-          <a:p>
-            <a:pPr>
-              <a:spcAft>
-                <a:spcPts val="960"/>
-              </a:spcAft>
-              <a:defRPr sz="1600">
-                <a:solidFill>
-                  <a:srgbClr val="E0E0E0"/>
-                </a:solidFill>
-                <a:latin typeface="Calibri"/>
-              </a:defRPr>
-            </a:pPr>
-            <a:r>
-              <a:t>在 SemEval/TuringBench 全量数据验证</a:t>
-            </a:r>
-          </a:p>
-        </p:txBody>
-      </p:sp>
-      <p:sp>
-        <p:nvSpPr>
-          <p:cNvPr id="6" name="TextBox 5"/>
-          <p:cNvSpPr txBox="1"/>
-          <p:nvPr/>
-        </p:nvSpPr>
-        <p:spPr>
-          <a:xfrm>
-            <a:off x="6400800" y="1371600"/>
-            <a:ext cx="5029200" cy="548640"/>
-          </a:xfrm>
-          <a:prstGeom prst="rect">
-            <a:avLst/>
-          </a:prstGeom>
-          <a:noFill/>
-        </p:spPr>
-        <p:txBody>
-          <a:bodyPr wrap="square">
-            <a:spAutoFit/>
-          </a:bodyPr>
-          <a:lstStyle/>
-          <a:p>
-            <a:pPr algn="l">
-              <a:defRPr sz="2200" b="1">
-                <a:solidFill>
-                  <a:srgbClr val="FF6B6B"/>
-                </a:solidFill>
-                <a:latin typeface="Calibri"/>
-              </a:defRPr>
-            </a:pPr>
-            <a:r>
-              <a:t>部署建议</a:t>
-            </a:r>
-          </a:p>
-        </p:txBody>
-      </p:sp>
-      <p:sp>
-        <p:nvSpPr>
-          <p:cNvPr id="7" name="TextBox 6"/>
-          <p:cNvSpPr txBox="1"/>
-          <p:nvPr/>
-        </p:nvSpPr>
-        <p:spPr>
-          <a:xfrm>
-            <a:off x="6400800" y="2011680"/>
-            <a:ext cx="5029200" cy="2743200"/>
-          </a:xfrm>
-          <a:prstGeom prst="rect">
-            <a:avLst/>
-          </a:prstGeom>
-          <a:noFill/>
-        </p:spPr>
-        <p:txBody>
-          <a:bodyPr wrap="square">
-            <a:spAutoFit/>
-          </a:bodyPr>
-          <a:lstStyle/>
-          <a:p>
-            <a:pPr>
-              <a:spcAft>
-                <a:spcPts val="960"/>
-              </a:spcAft>
-              <a:defRPr sz="1600">
-                <a:solidFill>
-                  <a:srgbClr val="E0E0E0"/>
-                </a:solidFill>
-                <a:latin typeface="Calibri"/>
-              </a:defRPr>
-            </a:pPr>
-            <a:r>
-              <a:t>以模型无关的手工特征作为稳定基线</a:t>
-            </a:r>
-          </a:p>
-          <a:p>
-            <a:pPr>
-              <a:spcAft>
-                <a:spcPts val="960"/>
-              </a:spcAft>
-              <a:defRPr sz="1600">
-                <a:solidFill>
-                  <a:srgbClr val="E0E0E0"/>
-                </a:solidFill>
-                <a:latin typeface="Calibri"/>
-              </a:defRPr>
-            </a:pPr>
-            <a:r>
-              <a:t>辅以同代 LLM token 特征覆盖新生成器</a:t>
-            </a:r>
-          </a:p>
-          <a:p>
-            <a:pPr>
-              <a:spcAft>
-                <a:spcPts val="960"/>
-              </a:spcAft>
-              <a:defRPr sz="1600">
-                <a:solidFill>
-                  <a:srgbClr val="E0E0E0"/>
-                </a:solidFill>
-                <a:latin typeface="Calibri"/>
-              </a:defRPr>
-            </a:pPr>
-            <a:r>
-              <a:t>观察者模型需要定期更新 (半年一次)</a:t>
-            </a:r>
-          </a:p>
-          <a:p>
-            <a:pPr>
-              <a:spcAft>
-                <a:spcPts val="960"/>
-              </a:spcAft>
-              <a:defRPr sz="1600">
-                <a:solidFill>
-                  <a:srgbClr val="E0E0E0"/>
-                </a:solidFill>
-                <a:latin typeface="Calibri"/>
-              </a:defRPr>
-            </a:pPr>
-            <a:r>
-              <a:t>跨域部署需注意领域差异 (诗歌 vs 新闻)</a:t>
-            </a:r>
-          </a:p>
-          <a:p>
-            <a:pPr>
-              <a:spcAft>
-                <a:spcPts val="960"/>
-              </a:spcAft>
-              <a:defRPr sz="1600">
-                <a:solidFill>
-                  <a:srgbClr val="E0E0E0"/>
-                </a:solidFill>
-                <a:latin typeface="Calibri"/>
-              </a:defRPr>
-            </a:pPr>
-            <a:r>
-              <a:t>提供 SHAP 解释以增强用户信任</a:t>
-            </a:r>
-          </a:p>
-        </p:txBody>
-      </p:sp>
-      <p:sp>
-        <p:nvSpPr>
-          <p:cNvPr id="8" name="TextBox 7"/>
-          <p:cNvSpPr txBox="1"/>
-          <p:nvPr/>
-        </p:nvSpPr>
-        <p:spPr>
-          <a:xfrm>
-            <a:off x="731520" y="5029200"/>
-            <a:ext cx="10515600" cy="1097280"/>
-          </a:xfrm>
-          <a:prstGeom prst="rect">
-            <a:avLst/>
-          </a:prstGeom>
-          <a:noFill/>
-        </p:spPr>
-        <p:txBody>
-          <a:bodyPr wrap="square">
-            <a:spAutoFit/>
-          </a:bodyPr>
-          <a:lstStyle/>
-          <a:p>
-            <a:pPr algn="ctr">
-              <a:defRPr sz="2000" b="0">
-                <a:solidFill>
-                  <a:srgbClr val="00D2FF"/>
-                </a:solidFill>
-                <a:latin typeface="Calibri"/>
-              </a:defRPr>
-            </a:pPr>
-            <a:r>
-              <a:t>"手工特征看文本的外表，Token 概率特征看文本在 AI 眼中的内在。</a:t>
-            </a:r>
-            <a:br/>
-            <a:r>
-              <a:t>当一个视角被欺骗时，另一个视角往往能看穿。这就是 120 维组合的力量。"</a:t>
+            <a:ext cx="10058400" cy="5029200"/>
+          </a:xfrm>
+          <a:prstGeom prst="rect">
+            <a:avLst/>
+          </a:prstGeom>
+          <a:noFill/>
+        </p:spPr>
+        <p:txBody>
+          <a:bodyPr wrap="square">
+            <a:spAutoFit/>
+          </a:bodyPr>
+          <a:lstStyle/>
+          <a:p>
+            <a:pPr>
+              <a:spcAft>
+                <a:spcPts val="720"/>
+              </a:spcAft>
+              <a:defRPr sz="1800">
+                <a:solidFill>
+                  <a:srgbClr val="E0E0E0"/>
+                </a:solidFill>
+                <a:latin typeface="Calibri"/>
+              </a:defRPr>
+            </a:pPr>
+            <a:r>
+              <a:t>1. XGBoost + 120 维组合特征在 RAID 上达到 AUC 0.9992</a:t>
+            </a:r>
+          </a:p>
+          <a:p>
+            <a:pPr>
+              <a:spcAft>
+                <a:spcPts val="720"/>
+              </a:spcAft>
+              <a:defRPr sz="1800">
+                <a:solidFill>
+                  <a:srgbClr val="E0E0E0"/>
+                </a:solidFill>
+                <a:latin typeface="Calibri"/>
+              </a:defRPr>
+            </a:pPr>
+            <a:r>
+              <a:t>    完全可解释，超越零样本方法 Fast-DetectGPT (0.7815)</a:t>
+            </a:r>
+          </a:p>
+          <a:p>
+            <a:pPr>
+              <a:spcAft>
+                <a:spcPts val="720"/>
+              </a:spcAft>
+              <a:defRPr sz="1800">
+                <a:solidFill>
+                  <a:srgbClr val="E0E0E0"/>
+                </a:solidFill>
+                <a:latin typeface="Calibri"/>
+              </a:defRPr>
+            </a:pPr>
+          </a:p>
+          <a:p>
+            <a:pPr>
+              <a:spcAft>
+                <a:spcPts val="720"/>
+              </a:spcAft>
+              <a:defRPr sz="1800">
+                <a:solidFill>
+                  <a:srgbClr val="E0E0E0"/>
+                </a:solidFill>
+                <a:latin typeface="Calibri"/>
+              </a:defRPr>
+            </a:pPr>
+            <a:r>
+              <a:t>2. 两类特征视角正交，互补覆盖盲区</a:t>
+            </a:r>
+          </a:p>
+          <a:p>
+            <a:pPr>
+              <a:spcAft>
+                <a:spcPts val="720"/>
+              </a:spcAft>
+              <a:defRPr sz="1800">
+                <a:solidFill>
+                  <a:srgbClr val="E0E0E0"/>
+                </a:solidFill>
+                <a:latin typeface="Calibri"/>
+              </a:defRPr>
+            </a:pPr>
+            <a:r>
+              <a:t>    手工特征看"文本外表"，Token 特征看"AI 内在"</a:t>
+            </a:r>
+          </a:p>
+          <a:p>
+            <a:pPr>
+              <a:spcAft>
+                <a:spcPts val="720"/>
+              </a:spcAft>
+              <a:defRPr sz="1800">
+                <a:solidFill>
+                  <a:srgbClr val="E0E0E0"/>
+                </a:solidFill>
+                <a:latin typeface="Calibri"/>
+              </a:defRPr>
+            </a:pPr>
+          </a:p>
+          <a:p>
+            <a:pPr>
+              <a:spcAft>
+                <a:spcPts val="720"/>
+              </a:spcAft>
+              <a:defRPr sz="1800">
+                <a:solidFill>
+                  <a:srgbClr val="E0E0E0"/>
+                </a:solidFill>
+                <a:latin typeface="Calibri"/>
+              </a:defRPr>
+            </a:pPr>
+            <a:r>
+              <a:t>3. GPT-2 困惑度的 Paradox 是重要发现</a:t>
+            </a:r>
+          </a:p>
+          <a:p>
+            <a:pPr>
+              <a:spcAft>
+                <a:spcPts val="720"/>
+              </a:spcAft>
+              <a:defRPr sz="1800">
+                <a:solidFill>
+                  <a:srgbClr val="E0E0E0"/>
+                </a:solidFill>
+                <a:latin typeface="Calibri"/>
+              </a:defRPr>
+            </a:pPr>
+            <a:r>
+              <a:t>    HC3 最强 (0.99) → RAID 完全失效 (0.49)</a:t>
+            </a:r>
+          </a:p>
+          <a:p>
+            <a:pPr>
+              <a:spcAft>
+                <a:spcPts val="720"/>
+              </a:spcAft>
+              <a:defRPr sz="1800">
+                <a:solidFill>
+                  <a:srgbClr val="E0E0E0"/>
+                </a:solidFill>
+                <a:latin typeface="Calibri"/>
+              </a:defRPr>
+            </a:pPr>
+          </a:p>
+          <a:p>
+            <a:pPr>
+              <a:spcAft>
+                <a:spcPts val="720"/>
+              </a:spcAft>
+              <a:defRPr sz="1800">
+                <a:solidFill>
+                  <a:srgbClr val="E0E0E0"/>
+                </a:solidFill>
+                <a:latin typeface="Calibri"/>
+              </a:defRPr>
+            </a:pPr>
+            <a:r>
+              <a:t>4. 统计特征对 10/11 种对抗攻击天然鲁棒</a:t>
+            </a:r>
+          </a:p>
+          <a:p>
+            <a:pPr>
+              <a:spcAft>
+                <a:spcPts val="720"/>
+              </a:spcAft>
+              <a:defRPr sz="1800">
+                <a:solidFill>
+                  <a:srgbClr val="E0E0E0"/>
+                </a:solidFill>
+                <a:latin typeface="Calibri"/>
+              </a:defRPr>
+            </a:pPr>
+            <a:r>
+              <a:t>    只有释义攻击能显著降低检测效果</a:t>
+            </a:r>
+          </a:p>
+          <a:p>
+            <a:pPr>
+              <a:spcAft>
+                <a:spcPts val="720"/>
+              </a:spcAft>
+              <a:defRPr sz="1800">
+                <a:solidFill>
+                  <a:srgbClr val="E0E0E0"/>
+                </a:solidFill>
+                <a:latin typeface="Calibri"/>
+              </a:defRPr>
+            </a:pPr>
+          </a:p>
+          <a:p>
+            <a:pPr>
+              <a:spcAft>
+                <a:spcPts val="720"/>
+              </a:spcAft>
+              <a:defRPr sz="1800">
+                <a:solidFill>
+                  <a:srgbClr val="E0E0E0"/>
+                </a:solidFill>
+                <a:latin typeface="Calibri"/>
+              </a:defRPr>
+            </a:pPr>
+            <a:r>
+              <a:t>5. Token 概率特征有"时代窗口"</a:t>
+            </a:r>
+          </a:p>
+          <a:p>
+            <a:pPr>
+              <a:spcAft>
+                <a:spcPts val="720"/>
+              </a:spcAft>
+              <a:defRPr sz="1800">
+                <a:solidFill>
+                  <a:srgbClr val="E0E0E0"/>
+                </a:solidFill>
+                <a:latin typeface="Calibri"/>
+              </a:defRPr>
+            </a:pPr>
+            <a:r>
+              <a:t>    观察者模型需要与目标生成器同代</a:t>
             </a:r>
           </a:p>
         </p:txBody>
@@ -10756,6 +11256,429 @@
 </file>
 
 <file path=ppt/slides/slide23.xml><?xml version="1.0" encoding="utf-8"?>
+<p:sld xmlns:a="http://schemas.openxmlformats.org/drawingml/2006/main" xmlns:p="http://schemas.openxmlformats.org/presentationml/2006/main" xmlns:r="http://schemas.openxmlformats.org/officeDocument/2006/relationships">
+  <p:cSld>
+    <p:bg>
+      <p:bgPr>
+        <a:solidFill>
+          <a:srgbClr val="1A1A2E"/>
+        </a:solidFill>
+        <a:effectLst/>
+      </p:bgPr>
+    </p:bg>
+    <p:spTree>
+      <p:nvGrpSpPr>
+        <p:cNvPr id="1" name=""/>
+        <p:cNvGrpSpPr/>
+        <p:nvPr/>
+      </p:nvGrpSpPr>
+      <p:grpSpPr/>
+      <p:sp>
+        <p:nvSpPr>
+          <p:cNvPr id="2" name="TextBox 1"/>
+          <p:cNvSpPr txBox="1"/>
+          <p:nvPr/>
+        </p:nvSpPr>
+        <p:spPr>
+          <a:xfrm>
+            <a:off x="731520" y="365760"/>
+            <a:ext cx="9144000" cy="731520"/>
+          </a:xfrm>
+          <a:prstGeom prst="rect">
+            <a:avLst/>
+          </a:prstGeom>
+          <a:noFill/>
+        </p:spPr>
+        <p:txBody>
+          <a:bodyPr wrap="square">
+            <a:spAutoFit/>
+          </a:bodyPr>
+          <a:lstStyle/>
+          <a:p>
+            <a:pPr algn="l">
+              <a:defRPr sz="3600" b="1">
+                <a:solidFill>
+                  <a:srgbClr val="00D2FF"/>
+                </a:solidFill>
+                <a:latin typeface="Calibri"/>
+              </a:defRPr>
+            </a:pPr>
+            <a:r>
+              <a:t>未来方向与部署建议</a:t>
+            </a:r>
+          </a:p>
+        </p:txBody>
+      </p:sp>
+      <p:sp>
+        <p:nvSpPr>
+          <p:cNvPr id="3" name="Rectangle 2"/>
+          <p:cNvSpPr/>
+          <p:nvPr/>
+        </p:nvSpPr>
+        <p:spPr>
+          <a:xfrm>
+            <a:off x="731520" y="1005840"/>
+            <a:ext cx="3657600" cy="38100"/>
+          </a:xfrm>
+          <a:prstGeom prst="rect">
+            <a:avLst/>
+          </a:prstGeom>
+          <a:solidFill>
+            <a:srgbClr val="00D2FF"/>
+          </a:solidFill>
+          <a:ln>
+            <a:noFill/>
+          </a:ln>
+        </p:spPr>
+        <p:style>
+          <a:lnRef idx="1">
+            <a:schemeClr val="accent1"/>
+          </a:lnRef>
+          <a:fillRef idx="3">
+            <a:schemeClr val="accent1"/>
+          </a:fillRef>
+          <a:effectRef idx="2">
+            <a:schemeClr val="accent1"/>
+          </a:effectRef>
+          <a:fontRef idx="minor">
+            <a:schemeClr val="lt1"/>
+          </a:fontRef>
+        </p:style>
+        <p:txBody>
+          <a:bodyPr rtlCol="0" anchor="ctr"/>
+          <a:lstStyle/>
+          <a:p>
+            <a:pPr algn="ctr"/>
+          </a:p>
+        </p:txBody>
+      </p:sp>
+      <p:sp>
+        <p:nvSpPr>
+          <p:cNvPr id="4" name="TextBox 3"/>
+          <p:cNvSpPr txBox="1"/>
+          <p:nvPr/>
+        </p:nvSpPr>
+        <p:spPr>
+          <a:xfrm>
+            <a:off x="731520" y="1371600"/>
+            <a:ext cx="5029200" cy="548640"/>
+          </a:xfrm>
+          <a:prstGeom prst="rect">
+            <a:avLst/>
+          </a:prstGeom>
+          <a:noFill/>
+        </p:spPr>
+        <p:txBody>
+          <a:bodyPr wrap="square">
+            <a:spAutoFit/>
+          </a:bodyPr>
+          <a:lstStyle/>
+          <a:p>
+            <a:pPr algn="l">
+              <a:defRPr sz="2200" b="1">
+                <a:solidFill>
+                  <a:srgbClr val="4ECB71"/>
+                </a:solidFill>
+                <a:latin typeface="Calibri"/>
+              </a:defRPr>
+            </a:pPr>
+            <a:r>
+              <a:t>未来工作</a:t>
+            </a:r>
+          </a:p>
+        </p:txBody>
+      </p:sp>
+      <p:sp>
+        <p:nvSpPr>
+          <p:cNvPr id="5" name="TextBox 4"/>
+          <p:cNvSpPr txBox="1"/>
+          <p:nvPr/>
+        </p:nvSpPr>
+        <p:spPr>
+          <a:xfrm>
+            <a:off x="731520" y="2011680"/>
+            <a:ext cx="5029200" cy="2743200"/>
+          </a:xfrm>
+          <a:prstGeom prst="rect">
+            <a:avLst/>
+          </a:prstGeom>
+          <a:noFill/>
+        </p:spPr>
+        <p:txBody>
+          <a:bodyPr wrap="square">
+            <a:spAutoFit/>
+          </a:bodyPr>
+          <a:lstStyle/>
+          <a:p>
+            <a:pPr>
+              <a:spcAft>
+                <a:spcPts val="960"/>
+              </a:spcAft>
+              <a:defRPr sz="1600">
+                <a:solidFill>
+                  <a:srgbClr val="E0E0E0"/>
+                </a:solidFill>
+                <a:latin typeface="Calibri"/>
+              </a:defRPr>
+            </a:pPr>
+            <a:r>
+              <a:t>引入语义相似度特征防御释义攻击</a:t>
+            </a:r>
+          </a:p>
+          <a:p>
+            <a:pPr>
+              <a:spcAft>
+                <a:spcPts val="960"/>
+              </a:spcAft>
+              <a:defRPr sz="1600">
+                <a:solidFill>
+                  <a:srgbClr val="E0E0E0"/>
+                </a:solidFill>
+                <a:latin typeface="Calibri"/>
+              </a:defRPr>
+            </a:pPr>
+            <a:r>
+              <a:t>多观察者模型集成 (Mistral + Qwen + Llama)</a:t>
+            </a:r>
+          </a:p>
+          <a:p>
+            <a:pPr>
+              <a:spcAft>
+                <a:spcPts val="960"/>
+              </a:spcAft>
+              <a:defRPr sz="1600">
+                <a:solidFill>
+                  <a:srgbClr val="E0E0E0"/>
+                </a:solidFill>
+                <a:latin typeface="Calibri"/>
+              </a:defRPr>
+            </a:pPr>
+            <a:r>
+              <a:t>动态特征选择: 根据文本领域自动调整</a:t>
+            </a:r>
+          </a:p>
+          <a:p>
+            <a:pPr>
+              <a:spcAft>
+                <a:spcPts val="960"/>
+              </a:spcAft>
+              <a:defRPr sz="1600">
+                <a:solidFill>
+                  <a:srgbClr val="E0E0E0"/>
+                </a:solidFill>
+                <a:latin typeface="Calibri"/>
+              </a:defRPr>
+            </a:pPr>
+            <a:r>
+              <a:t>探索更多 token 统计: burstiness, curvature</a:t>
+            </a:r>
+          </a:p>
+          <a:p>
+            <a:pPr>
+              <a:spcAft>
+                <a:spcPts val="960"/>
+              </a:spcAft>
+              <a:defRPr sz="1600">
+                <a:solidFill>
+                  <a:srgbClr val="E0E0E0"/>
+                </a:solidFill>
+                <a:latin typeface="Calibri"/>
+              </a:defRPr>
+            </a:pPr>
+            <a:r>
+              <a:t>在 SemEval/TuringBench 全量数据验证</a:t>
+            </a:r>
+          </a:p>
+        </p:txBody>
+      </p:sp>
+      <p:sp>
+        <p:nvSpPr>
+          <p:cNvPr id="6" name="TextBox 5"/>
+          <p:cNvSpPr txBox="1"/>
+          <p:nvPr/>
+        </p:nvSpPr>
+        <p:spPr>
+          <a:xfrm>
+            <a:off x="6400800" y="1371600"/>
+            <a:ext cx="5029200" cy="548640"/>
+          </a:xfrm>
+          <a:prstGeom prst="rect">
+            <a:avLst/>
+          </a:prstGeom>
+          <a:noFill/>
+        </p:spPr>
+        <p:txBody>
+          <a:bodyPr wrap="square">
+            <a:spAutoFit/>
+          </a:bodyPr>
+          <a:lstStyle/>
+          <a:p>
+            <a:pPr algn="l">
+              <a:defRPr sz="2200" b="1">
+                <a:solidFill>
+                  <a:srgbClr val="FF6B6B"/>
+                </a:solidFill>
+                <a:latin typeface="Calibri"/>
+              </a:defRPr>
+            </a:pPr>
+            <a:r>
+              <a:t>部署建议</a:t>
+            </a:r>
+          </a:p>
+        </p:txBody>
+      </p:sp>
+      <p:sp>
+        <p:nvSpPr>
+          <p:cNvPr id="7" name="TextBox 6"/>
+          <p:cNvSpPr txBox="1"/>
+          <p:nvPr/>
+        </p:nvSpPr>
+        <p:spPr>
+          <a:xfrm>
+            <a:off x="6400800" y="2011680"/>
+            <a:ext cx="5029200" cy="2743200"/>
+          </a:xfrm>
+          <a:prstGeom prst="rect">
+            <a:avLst/>
+          </a:prstGeom>
+          <a:noFill/>
+        </p:spPr>
+        <p:txBody>
+          <a:bodyPr wrap="square">
+            <a:spAutoFit/>
+          </a:bodyPr>
+          <a:lstStyle/>
+          <a:p>
+            <a:pPr>
+              <a:spcAft>
+                <a:spcPts val="960"/>
+              </a:spcAft>
+              <a:defRPr sz="1600">
+                <a:solidFill>
+                  <a:srgbClr val="E0E0E0"/>
+                </a:solidFill>
+                <a:latin typeface="Calibri"/>
+              </a:defRPr>
+            </a:pPr>
+            <a:r>
+              <a:t>以模型无关的手工特征作为稳定基线</a:t>
+            </a:r>
+          </a:p>
+          <a:p>
+            <a:pPr>
+              <a:spcAft>
+                <a:spcPts val="960"/>
+              </a:spcAft>
+              <a:defRPr sz="1600">
+                <a:solidFill>
+                  <a:srgbClr val="E0E0E0"/>
+                </a:solidFill>
+                <a:latin typeface="Calibri"/>
+              </a:defRPr>
+            </a:pPr>
+            <a:r>
+              <a:t>辅以同代 LLM token 特征覆盖新生成器</a:t>
+            </a:r>
+          </a:p>
+          <a:p>
+            <a:pPr>
+              <a:spcAft>
+                <a:spcPts val="960"/>
+              </a:spcAft>
+              <a:defRPr sz="1600">
+                <a:solidFill>
+                  <a:srgbClr val="E0E0E0"/>
+                </a:solidFill>
+                <a:latin typeface="Calibri"/>
+              </a:defRPr>
+            </a:pPr>
+            <a:r>
+              <a:t>观察者模型需要定期更新 (半年一次)</a:t>
+            </a:r>
+          </a:p>
+          <a:p>
+            <a:pPr>
+              <a:spcAft>
+                <a:spcPts val="960"/>
+              </a:spcAft>
+              <a:defRPr sz="1600">
+                <a:solidFill>
+                  <a:srgbClr val="E0E0E0"/>
+                </a:solidFill>
+                <a:latin typeface="Calibri"/>
+              </a:defRPr>
+            </a:pPr>
+            <a:r>
+              <a:t>跨域部署需注意领域差异 (诗歌 vs 新闻)</a:t>
+            </a:r>
+          </a:p>
+          <a:p>
+            <a:pPr>
+              <a:spcAft>
+                <a:spcPts val="960"/>
+              </a:spcAft>
+              <a:defRPr sz="1600">
+                <a:solidFill>
+                  <a:srgbClr val="E0E0E0"/>
+                </a:solidFill>
+                <a:latin typeface="Calibri"/>
+              </a:defRPr>
+            </a:pPr>
+            <a:r>
+              <a:t>提供 SHAP 解释以增强用户信任</a:t>
+            </a:r>
+          </a:p>
+        </p:txBody>
+      </p:sp>
+      <p:sp>
+        <p:nvSpPr>
+          <p:cNvPr id="8" name="TextBox 7"/>
+          <p:cNvSpPr txBox="1"/>
+          <p:nvPr/>
+        </p:nvSpPr>
+        <p:spPr>
+          <a:xfrm>
+            <a:off x="731520" y="5029200"/>
+            <a:ext cx="10515600" cy="1097280"/>
+          </a:xfrm>
+          <a:prstGeom prst="rect">
+            <a:avLst/>
+          </a:prstGeom>
+          <a:noFill/>
+        </p:spPr>
+        <p:txBody>
+          <a:bodyPr wrap="square">
+            <a:spAutoFit/>
+          </a:bodyPr>
+          <a:lstStyle/>
+          <a:p>
+            <a:pPr algn="ctr">
+              <a:defRPr sz="2000" b="0">
+                <a:solidFill>
+                  <a:srgbClr val="00D2FF"/>
+                </a:solidFill>
+                <a:latin typeface="Calibri"/>
+              </a:defRPr>
+            </a:pPr>
+            <a:r>
+              <a:t>"手工特征看文本的外表，Token 概率特征看文本在 AI 眼中的内在。</a:t>
+            </a:r>
+            <a:br/>
+            <a:r>
+              <a:t>当一个视角被欺骗时，另一个视角往往能看穿。这就是 120 维组合的力量。"</a:t>
+            </a:r>
+          </a:p>
+        </p:txBody>
+      </p:sp>
+    </p:spTree>
+  </p:cSld>
+  <p:clrMapOvr>
+    <a:masterClrMapping/>
+  </p:clrMapOvr>
+</p:sld>
+</file>
+
+<file path=ppt/slides/slide24.xml><?xml version="1.0" encoding="utf-8"?>
 <p:sld xmlns:a="http://schemas.openxmlformats.org/drawingml/2006/main" xmlns:p="http://schemas.openxmlformats.org/presentationml/2006/main" xmlns:r="http://schemas.openxmlformats.org/officeDocument/2006/relationships">
   <p:cSld>
     <p:bg>

</xml_diff>

<commit_message>
Restructure features into 3-layer taxonomy in PPT
- Slide 4: 90+30 → three columns (Statistical ~36 / Model-derived 52 / Token-level 30)
- Slide 4c: rename to "模型衍生特征详解", distinguish from pure statistical features
- Properly classifies BERT embedding PCA and GPT-2 perplexity as model-derived

Co-Authored-By: Claude Opus 4.6 <noreply@anthropic.com>
</commit_message>
<xml_diff>
--- a/reports/AIGC_Detection_Presentation.pptx
+++ b/reports/AIGC_Detection_Presentation.pptx
@@ -12743,7 +12743,7 @@
         <p:spPr>
           <a:xfrm>
             <a:off x="731520" y="365760"/>
-            <a:ext cx="9144000" cy="731520"/>
+            <a:ext cx="10972800" cy="731520"/>
           </a:xfrm>
           <a:prstGeom prst="rect">
             <a:avLst/>
@@ -12765,7 +12765,7 @@
               </a:defRPr>
             </a:pPr>
             <a:r>
-              <a:t>方法概览：120 维可解释特征 + XGBoost</a:t>
+              <a:t>方法概览：三层 120 维特征体系 + XGBoost</a:t>
             </a:r>
           </a:p>
         </p:txBody>
@@ -12821,22 +12821,22 @@
         </p:nvSpPr>
         <p:spPr>
           <a:xfrm>
-            <a:off x="731520" y="1371600"/>
-            <a:ext cx="4572000" cy="548640"/>
-          </a:xfrm>
-          <a:prstGeom prst="rect">
-            <a:avLst/>
-          </a:prstGeom>
-          <a:noFill/>
-        </p:spPr>
-        <p:txBody>
-          <a:bodyPr wrap="square">
-            <a:spAutoFit/>
-          </a:bodyPr>
-          <a:lstStyle/>
-          <a:p>
-            <a:pPr algn="l">
-              <a:defRPr sz="2200" b="1">
+            <a:off x="274320" y="1280160"/>
+            <a:ext cx="3474720" cy="457200"/>
+          </a:xfrm>
+          <a:prstGeom prst="rect">
+            <a:avLst/>
+          </a:prstGeom>
+          <a:noFill/>
+        </p:spPr>
+        <p:txBody>
+          <a:bodyPr wrap="square">
+            <a:spAutoFit/>
+          </a:bodyPr>
+          <a:lstStyle/>
+          <a:p>
+            <a:pPr algn="l">
+              <a:defRPr sz="1800" b="1">
                 <a:solidFill>
                   <a:srgbClr val="FF6B6B"/>
                 </a:solidFill>
@@ -12844,7 +12844,7 @@
               </a:defRPr>
             </a:pPr>
             <a:r>
-              <a:t>90 维手工统计特征</a:t>
+              <a:t>Layer 1: 纯统计特征 (~36维)</a:t>
             </a:r>
           </a:p>
         </p:txBody>
@@ -12857,57 +12857,57 @@
         </p:nvSpPr>
         <p:spPr>
           <a:xfrm>
-            <a:off x="731520" y="1920240"/>
-            <a:ext cx="4572000" cy="3200400"/>
-          </a:xfrm>
-          <a:prstGeom prst="rect">
-            <a:avLst/>
-          </a:prstGeom>
-          <a:noFill/>
-        </p:spPr>
-        <p:txBody>
-          <a:bodyPr wrap="square">
-            <a:spAutoFit/>
-          </a:bodyPr>
-          <a:lstStyle/>
-          <a:p>
-            <a:pPr>
-              <a:spcAft>
-                <a:spcPts val="840"/>
-              </a:spcAft>
-              <a:defRPr sz="1400">
-                <a:solidFill>
-                  <a:srgbClr val="E0E0E0"/>
-                </a:solidFill>
-                <a:latin typeface="Calibri"/>
-              </a:defRPr>
-            </a:pPr>
-            <a:r>
-              <a:t>basic_counts (4): 词数、字符数、句数、段数</a:t>
-            </a:r>
-          </a:p>
-          <a:p>
-            <a:pPr>
-              <a:spcAft>
-                <a:spcPts val="840"/>
-              </a:spcAft>
-              <a:defRPr sz="1400">
-                <a:solidFill>
-                  <a:srgbClr val="E0E0E0"/>
-                </a:solidFill>
-                <a:latin typeface="Calibri"/>
-              </a:defRPr>
-            </a:pPr>
-            <a:r>
-              <a:t>averages (4): 平均词长、句长、段落长度</a:t>
-            </a:r>
-          </a:p>
-          <a:p>
-            <a:pPr>
-              <a:spcAft>
-                <a:spcPts val="840"/>
-              </a:spcAft>
-              <a:defRPr sz="1400">
+            <a:off x="274320" y="1737360"/>
+            <a:ext cx="3474720" cy="2926080"/>
+          </a:xfrm>
+          <a:prstGeom prst="rect">
+            <a:avLst/>
+          </a:prstGeom>
+          <a:noFill/>
+        </p:spPr>
+        <p:txBody>
+          <a:bodyPr wrap="square">
+            <a:spAutoFit/>
+          </a:bodyPr>
+          <a:lstStyle/>
+          <a:p>
+            <a:pPr>
+              <a:spcAft>
+                <a:spcPts val="719"/>
+              </a:spcAft>
+              <a:defRPr sz="1200">
+                <a:solidFill>
+                  <a:srgbClr val="E0E0E0"/>
+                </a:solidFill>
+                <a:latin typeface="Calibri"/>
+              </a:defRPr>
+            </a:pPr>
+            <a:r>
+              <a:t>basic_counts (4): 词/字符/句/段数</a:t>
+            </a:r>
+          </a:p>
+          <a:p>
+            <a:pPr>
+              <a:spcAft>
+                <a:spcPts val="719"/>
+              </a:spcAft>
+              <a:defRPr sz="1200">
+                <a:solidFill>
+                  <a:srgbClr val="E0E0E0"/>
+                </a:solidFill>
+                <a:latin typeface="Calibri"/>
+              </a:defRPr>
+            </a:pPr>
+            <a:r>
+              <a:t>averages (4): 平均词长/句长/段长</a:t>
+            </a:r>
+          </a:p>
+          <a:p>
+            <a:pPr>
+              <a:spcAft>
+                <a:spcPts val="719"/>
+              </a:spcAft>
+              <a:defRPr sz="1200">
                 <a:solidFill>
                   <a:srgbClr val="E0E0E0"/>
                 </a:solidFill>
@@ -12921,57 +12921,57 @@
           <a:p>
             <a:pPr>
               <a:spcAft>
-                <a:spcPts val="840"/>
-              </a:spcAft>
-              <a:defRPr sz="1400">
-                <a:solidFill>
-                  <a:srgbClr val="E0E0E0"/>
-                </a:solidFill>
-                <a:latin typeface="Calibri"/>
-              </a:defRPr>
-            </a:pPr>
-            <a:r>
-              <a:t>lexical_richness (7): TTR, Hapax, Yule's K...</a:t>
-            </a:r>
-          </a:p>
-          <a:p>
-            <a:pPr>
-              <a:spcAft>
-                <a:spcPts val="840"/>
-              </a:spcAft>
-              <a:defRPr sz="1400">
-                <a:solidFill>
-                  <a:srgbClr val="E0E0E0"/>
-                </a:solidFill>
-                <a:latin typeface="Calibri"/>
-              </a:defRPr>
-            </a:pPr>
-            <a:r>
-              <a:t>punctuation (11): 标点使用率 + 大写/数字/空格比</a:t>
-            </a:r>
-          </a:p>
-          <a:p>
-            <a:pPr>
-              <a:spcAft>
-                <a:spcPts val="840"/>
-              </a:spcAft>
-              <a:defRPr sz="1400">
-                <a:solidFill>
-                  <a:srgbClr val="E0E0E0"/>
-                </a:solidFill>
-                <a:latin typeface="Calibri"/>
-              </a:defRPr>
-            </a:pPr>
-            <a:r>
-              <a:t>readability (7): Flesch, Gunning Fog, SMOG...</a:t>
-            </a:r>
-          </a:p>
-          <a:p>
-            <a:pPr>
-              <a:spcAft>
-                <a:spcPts val="840"/>
-              </a:spcAft>
-              <a:defRPr sz="1400">
+                <a:spcPts val="719"/>
+              </a:spcAft>
+              <a:defRPr sz="1200">
+                <a:solidFill>
+                  <a:srgbClr val="E0E0E0"/>
+                </a:solidFill>
+                <a:latin typeface="Calibri"/>
+              </a:defRPr>
+            </a:pPr>
+            <a:r>
+              <a:t>lexical_richness (7): TTR, Hapax...</a:t>
+            </a:r>
+          </a:p>
+          <a:p>
+            <a:pPr>
+              <a:spcAft>
+                <a:spcPts val="719"/>
+              </a:spcAft>
+              <a:defRPr sz="1200">
+                <a:solidFill>
+                  <a:srgbClr val="E0E0E0"/>
+                </a:solidFill>
+                <a:latin typeface="Calibri"/>
+              </a:defRPr>
+            </a:pPr>
+            <a:r>
+              <a:t>punctuation (11): 标点 + 大写/数字比</a:t>
+            </a:r>
+          </a:p>
+          <a:p>
+            <a:pPr>
+              <a:spcAft>
+                <a:spcPts val="719"/>
+              </a:spcAft>
+              <a:defRPr sz="1200">
+                <a:solidFill>
+                  <a:srgbClr val="E0E0E0"/>
+                </a:solidFill>
+                <a:latin typeface="Calibri"/>
+              </a:defRPr>
+            </a:pPr>
+            <a:r>
+              <a:t>readability (7): Flesch, SMOG...</a:t>
+            </a:r>
+          </a:p>
+          <a:p>
+            <a:pPr>
+              <a:spcAft>
+                <a:spcPts val="719"/>
+              </a:spcAft>
+              <a:defRPr sz="1200">
                 <a:solidFill>
                   <a:srgbClr val="E0E0E0"/>
                 </a:solidFill>
@@ -12985,33 +12985,30 @@
           <a:p>
             <a:pPr>
               <a:spcAft>
-                <a:spcPts val="840"/>
-              </a:spcAft>
-              <a:defRPr sz="1400">
-                <a:solidFill>
-                  <a:srgbClr val="E0E0E0"/>
-                </a:solidFill>
-                <a:latin typeface="Calibri"/>
-              </a:defRPr>
-            </a:pPr>
-            <a:r>
-              <a:t>embedding_pca (50): BERT 句嵌入 PCA</a:t>
-            </a:r>
-          </a:p>
-          <a:p>
-            <a:pPr>
-              <a:spcAft>
-                <a:spcPts val="840"/>
-              </a:spcAft>
-              <a:defRPr sz="1400">
-                <a:solidFill>
-                  <a:srgbClr val="E0E0E0"/>
-                </a:solidFill>
-                <a:latin typeface="Calibri"/>
-              </a:defRPr>
-            </a:pPr>
-            <a:r>
-              <a:t>perplexity (2): GPT-2 困惑度</a:t>
+                <a:spcPts val="719"/>
+              </a:spcAft>
+              <a:defRPr sz="1200">
+                <a:solidFill>
+                  <a:srgbClr val="E0E0E0"/>
+                </a:solidFill>
+                <a:latin typeface="Calibri"/>
+              </a:defRPr>
+            </a:pPr>
+          </a:p>
+          <a:p>
+            <a:pPr>
+              <a:spcAft>
+                <a:spcPts val="719"/>
+              </a:spcAft>
+              <a:defRPr sz="1200">
+                <a:solidFill>
+                  <a:srgbClr val="E0E0E0"/>
+                </a:solidFill>
+                <a:latin typeface="Calibri"/>
+              </a:defRPr>
+            </a:pPr>
+            <a:r>
+              <a:t>不依赖任何神经网络, 纯公式计算</a:t>
             </a:r>
           </a:p>
         </p:txBody>
@@ -13024,22 +13021,222 @@
         </p:nvSpPr>
         <p:spPr>
           <a:xfrm>
-            <a:off x="6400800" y="1371600"/>
-            <a:ext cx="4572000" cy="548640"/>
-          </a:xfrm>
-          <a:prstGeom prst="rect">
-            <a:avLst/>
-          </a:prstGeom>
-          <a:noFill/>
-        </p:spPr>
-        <p:txBody>
-          <a:bodyPr wrap="square">
-            <a:spAutoFit/>
-          </a:bodyPr>
-          <a:lstStyle/>
-          <a:p>
-            <a:pPr algn="l">
-              <a:defRPr sz="2200" b="1">
+            <a:off x="4114800" y="1280160"/>
+            <a:ext cx="3657600" cy="457200"/>
+          </a:xfrm>
+          <a:prstGeom prst="rect">
+            <a:avLst/>
+          </a:prstGeom>
+          <a:noFill/>
+        </p:spPr>
+        <p:txBody>
+          <a:bodyPr wrap="square">
+            <a:spAutoFit/>
+          </a:bodyPr>
+          <a:lstStyle/>
+          <a:p>
+            <a:pPr algn="l">
+              <a:defRPr sz="1800" b="1">
+                <a:solidFill>
+                  <a:srgbClr val="FFA500"/>
+                </a:solidFill>
+                <a:latin typeface="Calibri"/>
+              </a:defRPr>
+            </a:pPr>
+            <a:r>
+              <a:t>Layer 2: 模型衍生特征 (52维)</a:t>
+            </a:r>
+          </a:p>
+        </p:txBody>
+      </p:sp>
+      <p:sp>
+        <p:nvSpPr>
+          <p:cNvPr id="7" name="TextBox 6"/>
+          <p:cNvSpPr txBox="1"/>
+          <p:nvPr/>
+        </p:nvSpPr>
+        <p:spPr>
+          <a:xfrm>
+            <a:off x="4114800" y="1737360"/>
+            <a:ext cx="3657600" cy="2926080"/>
+          </a:xfrm>
+          <a:prstGeom prst="rect">
+            <a:avLst/>
+          </a:prstGeom>
+          <a:noFill/>
+        </p:spPr>
+        <p:txBody>
+          <a:bodyPr wrap="square">
+            <a:spAutoFit/>
+          </a:bodyPr>
+          <a:lstStyle/>
+          <a:p>
+            <a:pPr>
+              <a:spcAft>
+                <a:spcPts val="719"/>
+              </a:spcAft>
+              <a:defRPr sz="1200">
+                <a:solidFill>
+                  <a:srgbClr val="E0E0E0"/>
+                </a:solidFill>
+                <a:latin typeface="Calibri"/>
+              </a:defRPr>
+            </a:pPr>
+            <a:r>
+              <a:t>BERT embedding → PCA (50维)</a:t>
+            </a:r>
+          </a:p>
+          <a:p>
+            <a:pPr>
+              <a:spcAft>
+                <a:spcPts val="719"/>
+              </a:spcAft>
+              <a:defRPr sz="1200">
+                <a:solidFill>
+                  <a:srgbClr val="E0E0E0"/>
+                </a:solidFill>
+                <a:latin typeface="Calibri"/>
+              </a:defRPr>
+            </a:pPr>
+            <a:r>
+              <a:t>  将文本映射到语义空间</a:t>
+            </a:r>
+          </a:p>
+          <a:p>
+            <a:pPr>
+              <a:spcAft>
+                <a:spcPts val="719"/>
+              </a:spcAft>
+              <a:defRPr sz="1200">
+                <a:solidFill>
+                  <a:srgbClr val="E0E0E0"/>
+                </a:solidFill>
+                <a:latin typeface="Calibri"/>
+              </a:defRPr>
+            </a:pPr>
+            <a:r>
+              <a:t>  AI 文本语义分布更集中</a:t>
+            </a:r>
+          </a:p>
+          <a:p>
+            <a:pPr>
+              <a:spcAft>
+                <a:spcPts val="719"/>
+              </a:spcAft>
+              <a:defRPr sz="1200">
+                <a:solidFill>
+                  <a:srgbClr val="E0E0E0"/>
+                </a:solidFill>
+                <a:latin typeface="Calibri"/>
+              </a:defRPr>
+            </a:pPr>
+          </a:p>
+          <a:p>
+            <a:pPr>
+              <a:spcAft>
+                <a:spcPts val="719"/>
+              </a:spcAft>
+              <a:defRPr sz="1200">
+                <a:solidFill>
+                  <a:srgbClr val="E0E0E0"/>
+                </a:solidFill>
+                <a:latin typeface="Calibri"/>
+              </a:defRPr>
+            </a:pPr>
+            <a:r>
+              <a:t>GPT-2 perplexity (2维)</a:t>
+            </a:r>
+          </a:p>
+          <a:p>
+            <a:pPr>
+              <a:spcAft>
+                <a:spcPts val="719"/>
+              </a:spcAft>
+              <a:defRPr sz="1200">
+                <a:solidFill>
+                  <a:srgbClr val="E0E0E0"/>
+                </a:solidFill>
+                <a:latin typeface="Calibri"/>
+              </a:defRPr>
+            </a:pPr>
+            <a:r>
+              <a:t>  文本级别的困惑度汇总</a:t>
+            </a:r>
+          </a:p>
+          <a:p>
+            <a:pPr>
+              <a:spcAft>
+                <a:spcPts val="719"/>
+              </a:spcAft>
+              <a:defRPr sz="1200">
+                <a:solidFill>
+                  <a:srgbClr val="E0E0E0"/>
+                </a:solidFill>
+                <a:latin typeface="Calibri"/>
+              </a:defRPr>
+            </a:pPr>
+            <a:r>
+              <a:t>  HC3 最强特征 (AUC 0.99)</a:t>
+            </a:r>
+          </a:p>
+          <a:p>
+            <a:pPr>
+              <a:spcAft>
+                <a:spcPts val="719"/>
+              </a:spcAft>
+              <a:defRPr sz="1200">
+                <a:solidFill>
+                  <a:srgbClr val="E0E0E0"/>
+                </a:solidFill>
+                <a:latin typeface="Calibri"/>
+              </a:defRPr>
+            </a:pPr>
+            <a:r>
+              <a:t>  RAID 完全失效 (AUC 0.49)</a:t>
+            </a:r>
+          </a:p>
+          <a:p>
+            <a:pPr>
+              <a:spcAft>
+                <a:spcPts val="719"/>
+              </a:spcAft>
+              <a:defRPr sz="1200">
+                <a:solidFill>
+                  <a:srgbClr val="E0E0E0"/>
+                </a:solidFill>
+                <a:latin typeface="Calibri"/>
+              </a:defRPr>
+            </a:pPr>
+            <a:r>
+              <a:t>  → 模型依赖性是其本质属性</a:t>
+            </a:r>
+          </a:p>
+        </p:txBody>
+      </p:sp>
+      <p:sp>
+        <p:nvSpPr>
+          <p:cNvPr id="8" name="TextBox 7"/>
+          <p:cNvSpPr txBox="1"/>
+          <p:nvPr/>
+        </p:nvSpPr>
+        <p:spPr>
+          <a:xfrm>
+            <a:off x="8046720" y="1280160"/>
+            <a:ext cx="3840480" cy="457200"/>
+          </a:xfrm>
+          <a:prstGeom prst="rect">
+            <a:avLst/>
+          </a:prstGeom>
+          <a:noFill/>
+        </p:spPr>
+        <p:txBody>
+          <a:bodyPr wrap="square">
+            <a:spAutoFit/>
+          </a:bodyPr>
+          <a:lstStyle/>
+          <a:p>
+            <a:pPr algn="l">
+              <a:defRPr sz="1800" b="1">
                 <a:solidFill>
                   <a:srgbClr val="4ECB71"/>
                 </a:solidFill>
@@ -13047,147 +13244,115 @@
               </a:defRPr>
             </a:pPr>
             <a:r>
-              <a:t>30 维 Token 概率特征</a:t>
-            </a:r>
-          </a:p>
-        </p:txBody>
-      </p:sp>
-      <p:sp>
-        <p:nvSpPr>
-          <p:cNvPr id="7" name="TextBox 6"/>
-          <p:cNvSpPr txBox="1"/>
-          <p:nvPr/>
-        </p:nvSpPr>
-        <p:spPr>
-          <a:xfrm>
-            <a:off x="6400800" y="1920240"/>
-            <a:ext cx="5029200" cy="3200400"/>
-          </a:xfrm>
-          <a:prstGeom prst="rect">
-            <a:avLst/>
-          </a:prstGeom>
-          <a:noFill/>
-        </p:spPr>
-        <p:txBody>
-          <a:bodyPr wrap="square">
-            <a:spAutoFit/>
-          </a:bodyPr>
-          <a:lstStyle/>
-          <a:p>
-            <a:pPr>
-              <a:spcAft>
-                <a:spcPts val="840"/>
-              </a:spcAft>
-              <a:defRPr sz="1400">
-                <a:solidFill>
-                  <a:srgbClr val="E0E0E0"/>
-                </a:solidFill>
-                <a:latin typeface="Calibri"/>
-              </a:defRPr>
-            </a:pPr>
-            <a:r>
-              <a:t>观察者模型: Mistral-7B-Instruct</a:t>
-            </a:r>
-          </a:p>
-          <a:p>
-            <a:pPr>
-              <a:spcAft>
-                <a:spcPts val="840"/>
-              </a:spcAft>
-              <a:defRPr sz="1400">
-                <a:solidFill>
-                  <a:srgbClr val="E0E0E0"/>
-                </a:solidFill>
-                <a:latin typeface="Calibri"/>
-              </a:defRPr>
-            </a:pPr>
-          </a:p>
-          <a:p>
-            <a:pPr>
-              <a:spcAft>
-                <a:spcPts val="840"/>
-              </a:spcAft>
-              <a:defRPr sz="1400">
-                <a:solidFill>
-                  <a:srgbClr val="E0E0E0"/>
-                </a:solidFill>
-                <a:latin typeface="Calibri"/>
-              </a:defRPr>
-            </a:pPr>
-            <a:r>
-              <a:t>Log-probability (10 统计量):</a:t>
-            </a:r>
-          </a:p>
-          <a:p>
-            <a:pPr>
-              <a:spcAft>
-                <a:spcPts val="840"/>
-              </a:spcAft>
-              <a:defRPr sz="1400">
-                <a:solidFill>
-                  <a:srgbClr val="E0E0E0"/>
-                </a:solidFill>
-                <a:latin typeface="Calibri"/>
-              </a:defRPr>
-            </a:pPr>
-            <a:r>
-              <a:t>  mean, std, min, max, median, q10, q90,</a:t>
-            </a:r>
-          </a:p>
-          <a:p>
-            <a:pPr>
-              <a:spcAft>
-                <a:spcPts val="840"/>
-              </a:spcAft>
-              <a:defRPr sz="1400">
-                <a:solidFill>
-                  <a:srgbClr val="E0E0E0"/>
-                </a:solidFill>
-                <a:latin typeface="Calibri"/>
-              </a:defRPr>
-            </a:pPr>
-            <a:r>
-              <a:t>  skew, kurtosis, diff_mean</a:t>
-            </a:r>
-          </a:p>
-          <a:p>
-            <a:pPr>
-              <a:spcAft>
-                <a:spcPts val="840"/>
-              </a:spcAft>
-              <a:defRPr sz="1400">
-                <a:solidFill>
-                  <a:srgbClr val="E0E0E0"/>
-                </a:solidFill>
-                <a:latin typeface="Calibri"/>
-              </a:defRPr>
-            </a:pPr>
-            <a:r>
-              <a:t>Token Rank (8 统计量):</a:t>
-            </a:r>
-          </a:p>
-          <a:p>
-            <a:pPr>
-              <a:spcAft>
-                <a:spcPts val="840"/>
-              </a:spcAft>
-              <a:defRPr sz="1400">
-                <a:solidFill>
-                  <a:srgbClr val="E0E0E0"/>
-                </a:solidFill>
-                <a:latin typeface="Calibri"/>
-              </a:defRPr>
-            </a:pPr>
-            <a:r>
-              <a:t>  mean, std, median, q90,</a:t>
-            </a:r>
-          </a:p>
-          <a:p>
-            <a:pPr>
-              <a:spcAft>
-                <a:spcPts val="840"/>
-              </a:spcAft>
-              <a:defRPr sz="1400">
+              <a:t>Layer 3: Token 概率特征 (30维)</a:t>
+            </a:r>
+          </a:p>
+        </p:txBody>
+      </p:sp>
+      <p:sp>
+        <p:nvSpPr>
+          <p:cNvPr id="9" name="TextBox 8"/>
+          <p:cNvSpPr txBox="1"/>
+          <p:nvPr/>
+        </p:nvSpPr>
+        <p:spPr>
+          <a:xfrm>
+            <a:off x="8046720" y="1737360"/>
+            <a:ext cx="3840480" cy="2926080"/>
+          </a:xfrm>
+          <a:prstGeom prst="rect">
+            <a:avLst/>
+          </a:prstGeom>
+          <a:noFill/>
+        </p:spPr>
+        <p:txBody>
+          <a:bodyPr wrap="square">
+            <a:spAutoFit/>
+          </a:bodyPr>
+          <a:lstStyle/>
+          <a:p>
+            <a:pPr>
+              <a:spcAft>
+                <a:spcPts val="719"/>
+              </a:spcAft>
+              <a:defRPr sz="1200">
+                <a:solidFill>
+                  <a:srgbClr val="E0E0E0"/>
+                </a:solidFill>
+                <a:latin typeface="Calibri"/>
+              </a:defRPr>
+            </a:pPr>
+            <a:r>
+              <a:t>观察者: Mistral-7B-Instruct</a:t>
+            </a:r>
+          </a:p>
+          <a:p>
+            <a:pPr>
+              <a:spcAft>
+                <a:spcPts val="719"/>
+              </a:spcAft>
+              <a:defRPr sz="1200">
+                <a:solidFill>
+                  <a:srgbClr val="E0E0E0"/>
+                </a:solidFill>
+                <a:latin typeface="Calibri"/>
+              </a:defRPr>
+            </a:pPr>
+          </a:p>
+          <a:p>
+            <a:pPr>
+              <a:spcAft>
+                <a:spcPts val="719"/>
+              </a:spcAft>
+              <a:defRPr sz="1200">
+                <a:solidFill>
+                  <a:srgbClr val="E0E0E0"/>
+                </a:solidFill>
+                <a:latin typeface="Calibri"/>
+              </a:defRPr>
+            </a:pPr>
+            <a:r>
+              <a:t>Log-prob (10): mean, std, min,</a:t>
+            </a:r>
+          </a:p>
+          <a:p>
+            <a:pPr>
+              <a:spcAft>
+                <a:spcPts val="719"/>
+              </a:spcAft>
+              <a:defRPr sz="1200">
+                <a:solidFill>
+                  <a:srgbClr val="E0E0E0"/>
+                </a:solidFill>
+                <a:latin typeface="Calibri"/>
+              </a:defRPr>
+            </a:pPr>
+            <a:r>
+              <a:t>  max, median, q10, q90, skew...</a:t>
+            </a:r>
+          </a:p>
+          <a:p>
+            <a:pPr>
+              <a:spcAft>
+                <a:spcPts val="719"/>
+              </a:spcAft>
+              <a:defRPr sz="1200">
+                <a:solidFill>
+                  <a:srgbClr val="E0E0E0"/>
+                </a:solidFill>
+                <a:latin typeface="Calibri"/>
+              </a:defRPr>
+            </a:pPr>
+            <a:r>
+              <a:t>Rank (8): mean, std, median,</a:t>
+            </a:r>
+          </a:p>
+          <a:p>
+            <a:pPr>
+              <a:spcAft>
+                <a:spcPts val="719"/>
+              </a:spcAft>
+              <a:defRPr sz="1200">
                 <a:solidFill>
                   <a:srgbClr val="E0E0E0"/>
                 </a:solidFill>
@@ -13201,47 +13366,112 @@
           <a:p>
             <a:pPr>
               <a:spcAft>
-                <a:spcPts val="840"/>
-              </a:spcAft>
-              <a:defRPr sz="1400">
-                <a:solidFill>
-                  <a:srgbClr val="E0E0E0"/>
-                </a:solidFill>
-                <a:latin typeface="Calibri"/>
-              </a:defRPr>
-            </a:pPr>
-            <a:r>
-              <a:t>Entropy (6 统计量):</a:t>
-            </a:r>
-          </a:p>
-          <a:p>
-            <a:pPr>
-              <a:spcAft>
-                <a:spcPts val="840"/>
-              </a:spcAft>
-              <a:defRPr sz="1400">
-                <a:solidFill>
-                  <a:srgbClr val="E0E0E0"/>
-                </a:solidFill>
-                <a:latin typeface="Calibri"/>
-              </a:defRPr>
-            </a:pPr>
-            <a:r>
-              <a:t>  mean, std, min, max, median, skew</a:t>
-            </a:r>
-          </a:p>
-        </p:txBody>
-      </p:sp>
-      <p:sp>
-        <p:nvSpPr>
-          <p:cNvPr id="8" name="TextBox 7"/>
+                <a:spcPts val="719"/>
+              </a:spcAft>
+              <a:defRPr sz="1200">
+                <a:solidFill>
+                  <a:srgbClr val="E0E0E0"/>
+                </a:solidFill>
+                <a:latin typeface="Calibri"/>
+              </a:defRPr>
+            </a:pPr>
+            <a:r>
+              <a:t>Entropy (6): mean, std, min,</a:t>
+            </a:r>
+          </a:p>
+          <a:p>
+            <a:pPr>
+              <a:spcAft>
+                <a:spcPts val="719"/>
+              </a:spcAft>
+              <a:defRPr sz="1200">
+                <a:solidFill>
+                  <a:srgbClr val="E0E0E0"/>
+                </a:solidFill>
+                <a:latin typeface="Calibri"/>
+              </a:defRPr>
+            </a:pPr>
+            <a:r>
+              <a:t>  max, median, skew</a:t>
+            </a:r>
+          </a:p>
+          <a:p>
+            <a:pPr>
+              <a:spcAft>
+                <a:spcPts val="719"/>
+              </a:spcAft>
+              <a:defRPr sz="1200">
+                <a:solidFill>
+                  <a:srgbClr val="E0E0E0"/>
+                </a:solidFill>
+                <a:latin typeface="Calibri"/>
+              </a:defRPr>
+            </a:pPr>
+          </a:p>
+          <a:p>
+            <a:pPr>
+              <a:spcAft>
+                <a:spcPts val="719"/>
+              </a:spcAft>
+              <a:defRPr sz="1200">
+                <a:solidFill>
+                  <a:srgbClr val="E0E0E0"/>
+                </a:solidFill>
+                <a:latin typeface="Calibri"/>
+              </a:defRPr>
+            </a:pPr>
+            <a:r>
+              <a:t>逐 token 粒度, 看 AI 的"选词指纹"</a:t>
+            </a:r>
+          </a:p>
+        </p:txBody>
+      </p:sp>
+      <p:sp>
+        <p:nvSpPr>
+          <p:cNvPr id="10" name="TextBox 9"/>
+          <p:cNvSpPr txBox="1"/>
+          <p:nvPr/>
+        </p:nvSpPr>
+        <p:spPr>
+          <a:xfrm>
+            <a:off x="457200" y="4846320"/>
+            <a:ext cx="10972800" cy="457200"/>
+          </a:xfrm>
+          <a:prstGeom prst="rect">
+            <a:avLst/>
+          </a:prstGeom>
+          <a:noFill/>
+        </p:spPr>
+        <p:txBody>
+          <a:bodyPr wrap="square">
+            <a:spAutoFit/>
+          </a:bodyPr>
+          <a:lstStyle/>
+          <a:p>
+            <a:pPr algn="ctr">
+              <a:defRPr sz="1800" b="1">
+                <a:solidFill>
+                  <a:srgbClr val="FFFFFF"/>
+                </a:solidFill>
+                <a:latin typeface="Calibri"/>
+              </a:defRPr>
+            </a:pPr>
+            <a:r>
+              <a:t>纯统计 (36维)  +  模型衍生 (52维)  +  Token级 (30维)  =  118维 (去重后)</a:t>
+            </a:r>
+          </a:p>
+        </p:txBody>
+      </p:sp>
+      <p:sp>
+        <p:nvSpPr>
+          <p:cNvPr id="11" name="TextBox 10"/>
           <p:cNvSpPr txBox="1"/>
           <p:nvPr/>
         </p:nvSpPr>
         <p:spPr>
           <a:xfrm>
             <a:off x="1828800" y="5303520"/>
-            <a:ext cx="8229600" cy="731520"/>
+            <a:ext cx="8229600" cy="548640"/>
           </a:xfrm>
           <a:prstGeom prst="rect">
             <a:avLst/>
@@ -13255,7 +13485,7 @@
           <a:lstStyle/>
           <a:p>
             <a:pPr algn="ctr">
-              <a:defRPr sz="2000" b="1">
+              <a:defRPr sz="1800" b="1">
                 <a:solidFill>
                   <a:srgbClr val="FFFFFF"/>
                 </a:solidFill>
@@ -13263,14 +13493,14 @@
               </a:defRPr>
             </a:pPr>
             <a:r>
-              <a:t>→  合并为 118 维 (去重后)  →  XGBoost (500 trees, depth 8)  →  SHAP 可解释分析</a:t>
-            </a:r>
-          </a:p>
-        </p:txBody>
-      </p:sp>
-      <p:sp>
-        <p:nvSpPr>
-          <p:cNvPr id="9" name="TextBox 8"/>
+              <a:t>→  Auto-Filter (丢噪声组)  →  XGBoost (500 trees, depth 8)  →  SHAP 可解释分析</a:t>
+            </a:r>
+          </a:p>
+        </p:txBody>
+      </p:sp>
+      <p:sp>
+        <p:nvSpPr>
+          <p:cNvPr id="12" name="TextBox 11"/>
           <p:cNvSpPr txBox="1"/>
           <p:nvPr/>
         </p:nvSpPr>
@@ -13299,7 +13529,7 @@
               </a:defRPr>
             </a:pPr>
             <a:r>
-              <a:t>核心理念：手工特征看"文本的外表"，Token 特征看"文本在 AI 眼中的内在"</a:t>
+              <a:t>三层特征从不同粒度和视角刻画文本: 表面统计 → 语义嵌入 → Token 概率</a:t>
             </a:r>
           </a:p>
         </p:txBody>
@@ -14047,7 +14277,7 @@
               </a:defRPr>
             </a:pPr>
             <a:r>
-              <a:t>手工特征详解：结构 &amp; 标点 &amp; 嵌入</a:t>
+              <a:t>模型衍生特征详解：语义嵌入 &amp; 困惑度</a:t>
             </a:r>
           </a:p>
         </p:txBody>
@@ -14126,7 +14356,7 @@
               </a:defRPr>
             </a:pPr>
             <a:r>
-              <a:t>结构 &amp; 标点特征 — 16 维</a:t>
+              <a:t>结构 &amp; 标点 (纯统计特征) — 16 维</a:t>
             </a:r>
           </a:p>
         </p:txBody>
@@ -14349,13 +14579,13 @@
             <a:pPr algn="l">
               <a:defRPr sz="2000" b="1">
                 <a:solidFill>
-                  <a:srgbClr val="4ECB71"/>
-                </a:solidFill>
-                <a:latin typeface="Calibri"/>
-              </a:defRPr>
-            </a:pPr>
-            <a:r>
-              <a:t>语义嵌入 &amp; 困惑度 — 52 维</a:t>
+                  <a:srgbClr val="FFA500"/>
+                </a:solidFill>
+                <a:latin typeface="Calibri"/>
+              </a:defRPr>
+            </a:pPr>
+            <a:r>
+              <a:t>模型衍生特征 (Layer 2) — 52 维</a:t>
             </a:r>
           </a:p>
         </p:txBody>

</xml_diff>

<commit_message>
Three-layer ablation experiment + full deliverable updates
Experiment:
- src/run_three_layer_ablation.py: 7 configs × 5 datasets ablation
- Key finding: each layer has distinct shelf life
  RAID: stat+token complementary (0.999)
  SemEval: model+token (0.961) > all (0.847), stat is noise
  TuringBench: model dominates (0.975), BERT captures old AI

Deliverables:
- PPT: new slide 14d (three-layer heatmap), updated auto-filter
- Notebook: Section 9.6 (three-layer ablation) + auto-filter demo
- ACM report: three-layer taxonomy, ablation table, noise dilution

Co-Authored-By: Claude Opus 4.6 <noreply@anthropic.com>
</commit_message>
<xml_diff>
--- a/reports/AIGC_Detection_Presentation.pptx
+++ b/reports/AIGC_Detection_Presentation.pptx
@@ -29,6 +29,7 @@
     <p:sldId id="277" r:id="rId28"/>
     <p:sldId id="278" r:id="rId29"/>
     <p:sldId id="279" r:id="rId30"/>
+    <p:sldId id="280" r:id="rId31"/>
   </p:sldIdLst>
   <p:sldSz cx="12191695" cy="6858000" type="screen4x3"/>
   <p:notesSz cx="6858000" cy="9144000"/>
@@ -9320,7 +9321,7 @@
               </a:defRPr>
             </a:pPr>
             <a:r>
-              <a:t>0.9992</a:t>
+              <a:t>0.9991</a:t>
             </a:r>
           </a:p>
         </p:txBody>
@@ -9350,7 +9351,7 @@
             <a:pPr algn="l">
               <a:defRPr sz="1400" b="0">
                 <a:solidFill>
-                  <a:srgbClr val="FFFFFF"/>
+                  <a:srgbClr val="4ECB71"/>
                 </a:solidFill>
                 <a:latin typeface="Calibri"/>
               </a:defRPr>
@@ -9386,13 +9387,13 @@
             <a:pPr algn="l">
               <a:defRPr sz="1400" b="0">
                 <a:solidFill>
-                  <a:srgbClr val="4ECB71"/>
-                </a:solidFill>
-                <a:latin typeface="Calibri"/>
-              </a:defRPr>
-            </a:pPr>
-            <a:r>
-              <a:t>SemEval</a:t>
+                  <a:srgbClr val="E0E0E0"/>
+                </a:solidFill>
+                <a:latin typeface="Calibri"/>
+              </a:defRPr>
+            </a:pPr>
+            <a:r>
+              <a:t>HC3</a:t>
             </a:r>
           </a:p>
         </p:txBody>
@@ -9428,7 +9429,7 @@
               </a:defRPr>
             </a:pPr>
             <a:r>
-              <a:t>0.8443</a:t>
+              <a:t>0.9995</a:t>
             </a:r>
           </a:p>
         </p:txBody>
@@ -9464,7 +9465,7 @@
               </a:defRPr>
             </a:pPr>
             <a:r>
-              <a:t>0.9763</a:t>
+              <a:t>0.9996</a:t>
             </a:r>
           </a:p>
         </p:txBody>
@@ -9494,13 +9495,13 @@
             <a:pPr algn="l">
               <a:defRPr sz="1400" b="0">
                 <a:solidFill>
-                  <a:srgbClr val="E0E0E0"/>
-                </a:solidFill>
-                <a:latin typeface="Calibri"/>
-              </a:defRPr>
-            </a:pPr>
-            <a:r>
-              <a:t>TuringBench</a:t>
+                  <a:srgbClr val="FF6B6B"/>
+                </a:solidFill>
+                <a:latin typeface="Calibri"/>
+              </a:defRPr>
+            </a:pPr>
+            <a:r>
+              <a:t>SemEval</a:t>
             </a:r>
           </a:p>
         </p:txBody>
@@ -9536,7 +9537,7 @@
               </a:defRPr>
             </a:pPr>
             <a:r>
-              <a:t>0.9847</a:t>
+              <a:t>0.8468</a:t>
             </a:r>
           </a:p>
         </p:txBody>
@@ -9566,20 +9567,236 @@
             <a:pPr algn="l">
               <a:defRPr sz="1400" b="0">
                 <a:solidFill>
+                  <a:srgbClr val="4ECB71"/>
+                </a:solidFill>
+                <a:latin typeface="Calibri"/>
+              </a:defRPr>
+            </a:pPr>
+            <a:r>
+              <a:t>0.8371</a:t>
+            </a:r>
+          </a:p>
+        </p:txBody>
+      </p:sp>
+      <p:sp>
+        <p:nvSpPr>
+          <p:cNvPr id="19" name="TextBox 18"/>
+          <p:cNvSpPr txBox="1"/>
+          <p:nvPr/>
+        </p:nvSpPr>
+        <p:spPr>
+          <a:xfrm>
+            <a:off x="6400800" y="4160520"/>
+            <a:ext cx="2011680" cy="365760"/>
+          </a:xfrm>
+          <a:prstGeom prst="rect">
+            <a:avLst/>
+          </a:prstGeom>
+          <a:noFill/>
+        </p:spPr>
+        <p:txBody>
+          <a:bodyPr wrap="square">
+            <a:spAutoFit/>
+          </a:bodyPr>
+          <a:lstStyle/>
+          <a:p>
+            <a:pPr algn="l">
+              <a:defRPr sz="1400" b="0">
+                <a:solidFill>
+                  <a:srgbClr val="FF6B6B"/>
+                </a:solidFill>
+                <a:latin typeface="Calibri"/>
+              </a:defRPr>
+            </a:pPr>
+            <a:r>
+              <a:t>TuringBench</a:t>
+            </a:r>
+          </a:p>
+        </p:txBody>
+      </p:sp>
+      <p:sp>
+        <p:nvSpPr>
+          <p:cNvPr id="20" name="TextBox 19"/>
+          <p:cNvSpPr txBox="1"/>
+          <p:nvPr/>
+        </p:nvSpPr>
+        <p:spPr>
+          <a:xfrm>
+            <a:off x="8503920" y="4160520"/>
+            <a:ext cx="1188720" cy="365760"/>
+          </a:xfrm>
+          <a:prstGeom prst="rect">
+            <a:avLst/>
+          </a:prstGeom>
+          <a:noFill/>
+        </p:spPr>
+        <p:txBody>
+          <a:bodyPr wrap="square">
+            <a:spAutoFit/>
+          </a:bodyPr>
+          <a:lstStyle/>
+          <a:p>
+            <a:pPr algn="l">
+              <a:defRPr sz="1400" b="0">
+                <a:solidFill>
                   <a:srgbClr val="FFFFFF"/>
                 </a:solidFill>
                 <a:latin typeface="Calibri"/>
               </a:defRPr>
             </a:pPr>
             <a:r>
-              <a:t>0.9847</a:t>
-            </a:r>
-          </a:p>
-        </p:txBody>
-      </p:sp>
-      <p:sp>
-        <p:nvSpPr>
-          <p:cNvPr id="19" name="TextBox 18"/>
+              <a:t>0.9853</a:t>
+            </a:r>
+          </a:p>
+        </p:txBody>
+      </p:sp>
+      <p:sp>
+        <p:nvSpPr>
+          <p:cNvPr id="21" name="TextBox 20"/>
+          <p:cNvSpPr txBox="1"/>
+          <p:nvPr/>
+        </p:nvSpPr>
+        <p:spPr>
+          <a:xfrm>
+            <a:off x="9784080" y="4160520"/>
+            <a:ext cx="1188720" cy="365760"/>
+          </a:xfrm>
+          <a:prstGeom prst="rect">
+            <a:avLst/>
+          </a:prstGeom>
+          <a:noFill/>
+        </p:spPr>
+        <p:txBody>
+          <a:bodyPr wrap="square">
+            <a:spAutoFit/>
+          </a:bodyPr>
+          <a:lstStyle/>
+          <a:p>
+            <a:pPr algn="l">
+              <a:defRPr sz="1400" b="0">
+                <a:solidFill>
+                  <a:srgbClr val="4ECB71"/>
+                </a:solidFill>
+                <a:latin typeface="Calibri"/>
+              </a:defRPr>
+            </a:pPr>
+            <a:r>
+              <a:t>0.9812</a:t>
+            </a:r>
+          </a:p>
+        </p:txBody>
+      </p:sp>
+      <p:sp>
+        <p:nvSpPr>
+          <p:cNvPr id="22" name="TextBox 21"/>
+          <p:cNvSpPr txBox="1"/>
+          <p:nvPr/>
+        </p:nvSpPr>
+        <p:spPr>
+          <a:xfrm>
+            <a:off x="6400800" y="4754880"/>
+            <a:ext cx="2011680" cy="365760"/>
+          </a:xfrm>
+          <a:prstGeom prst="rect">
+            <a:avLst/>
+          </a:prstGeom>
+          <a:noFill/>
+        </p:spPr>
+        <p:txBody>
+          <a:bodyPr wrap="square">
+            <a:spAutoFit/>
+          </a:bodyPr>
+          <a:lstStyle/>
+          <a:p>
+            <a:pPr algn="l">
+              <a:defRPr sz="1400" b="0">
+                <a:solidFill>
+                  <a:srgbClr val="E0E0E0"/>
+                </a:solidFill>
+                <a:latin typeface="Calibri"/>
+              </a:defRPr>
+            </a:pPr>
+            <a:r>
+              <a:t>Pile</a:t>
+            </a:r>
+          </a:p>
+        </p:txBody>
+      </p:sp>
+      <p:sp>
+        <p:nvSpPr>
+          <p:cNvPr id="23" name="TextBox 22"/>
+          <p:cNvSpPr txBox="1"/>
+          <p:nvPr/>
+        </p:nvSpPr>
+        <p:spPr>
+          <a:xfrm>
+            <a:off x="8503920" y="4754880"/>
+            <a:ext cx="1188720" cy="365760"/>
+          </a:xfrm>
+          <a:prstGeom prst="rect">
+            <a:avLst/>
+          </a:prstGeom>
+          <a:noFill/>
+        </p:spPr>
+        <p:txBody>
+          <a:bodyPr wrap="square">
+            <a:spAutoFit/>
+          </a:bodyPr>
+          <a:lstStyle/>
+          <a:p>
+            <a:pPr algn="l">
+              <a:defRPr sz="1400" b="0">
+                <a:solidFill>
+                  <a:srgbClr val="FFFFFF"/>
+                </a:solidFill>
+                <a:latin typeface="Calibri"/>
+              </a:defRPr>
+            </a:pPr>
+            <a:r>
+              <a:t>0.9727</a:t>
+            </a:r>
+          </a:p>
+        </p:txBody>
+      </p:sp>
+      <p:sp>
+        <p:nvSpPr>
+          <p:cNvPr id="24" name="TextBox 23"/>
+          <p:cNvSpPr txBox="1"/>
+          <p:nvPr/>
+        </p:nvSpPr>
+        <p:spPr>
+          <a:xfrm>
+            <a:off x="9784080" y="4754880"/>
+            <a:ext cx="1188720" cy="365760"/>
+          </a:xfrm>
+          <a:prstGeom prst="rect">
+            <a:avLst/>
+          </a:prstGeom>
+          <a:noFill/>
+        </p:spPr>
+        <p:txBody>
+          <a:bodyPr wrap="square">
+            <a:spAutoFit/>
+          </a:bodyPr>
+          <a:lstStyle/>
+          <a:p>
+            <a:pPr algn="l">
+              <a:defRPr sz="1400" b="0">
+                <a:solidFill>
+                  <a:srgbClr val="FFFFFF"/>
+                </a:solidFill>
+                <a:latin typeface="Calibri"/>
+              </a:defRPr>
+            </a:pPr>
+            <a:r>
+              <a:t>0.9727</a:t>
+            </a:r>
+          </a:p>
+        </p:txBody>
+      </p:sp>
+      <p:sp>
+        <p:nvSpPr>
+          <p:cNvPr id="25" name="TextBox 24"/>
           <p:cNvSpPr txBox="1"/>
           <p:nvPr/>
         </p:nvSpPr>
@@ -9612,7 +9829,7 @@
       </p:sp>
       <p:sp>
         <p:nvSpPr>
-          <p:cNvPr id="20" name="TextBox 19"/>
+          <p:cNvPr id="26" name="TextBox 25"/>
           <p:cNvSpPr txBox="1"/>
           <p:nvPr/>
         </p:nvSpPr>
@@ -9641,14 +9858,14 @@
               </a:defRPr>
             </a:pPr>
             <a:r>
-              <a:t>drop 2 组 (无影响)</a:t>
-            </a:r>
-          </a:p>
-        </p:txBody>
-      </p:sp>
-      <p:sp>
-        <p:nvSpPr>
-          <p:cNvPr id="21" name="TextBox 20"/>
+              <a:t>drop 2组 (structure,perplexity)</a:t>
+            </a:r>
+          </a:p>
+        </p:txBody>
+      </p:sp>
+      <p:sp>
+        <p:nvSpPr>
+          <p:cNvPr id="27" name="TextBox 26"/>
           <p:cNvSpPr txBox="1"/>
           <p:nvPr/>
         </p:nvSpPr>
@@ -9677,14 +9894,14 @@
               </a:defRPr>
             </a:pPr>
             <a:r>
-              <a:t>drop 全部9组 → tok-only</a:t>
-            </a:r>
-          </a:p>
-        </p:txBody>
-      </p:sp>
-      <p:sp>
-        <p:nvSpPr>
-          <p:cNvPr id="22" name="TextBox 21"/>
+              <a:t>drop 0组</a:t>
+            </a:r>
+          </a:p>
+        </p:txBody>
+      </p:sp>
+      <p:sp>
+        <p:nvSpPr>
+          <p:cNvPr id="28" name="TextBox 27"/>
           <p:cNvSpPr txBox="1"/>
           <p:nvPr/>
         </p:nvSpPr>
@@ -9713,14 +9930,86 @@
               </a:defRPr>
             </a:pPr>
             <a:r>
-              <a:t>drop 0 组 (无影响)</a:t>
-            </a:r>
-          </a:p>
-        </p:txBody>
-      </p:sp>
-      <p:sp>
-        <p:nvSpPr>
-          <p:cNvPr id="23" name="TextBox 22"/>
+              <a:t>drop 1组 (perplexity)</a:t>
+            </a:r>
+          </a:p>
+        </p:txBody>
+      </p:sp>
+      <p:sp>
+        <p:nvSpPr>
+          <p:cNvPr id="29" name="TextBox 28"/>
+          <p:cNvSpPr txBox="1"/>
+          <p:nvPr/>
+        </p:nvSpPr>
+        <p:spPr>
+          <a:xfrm>
+            <a:off x="6400800" y="4434840"/>
+            <a:ext cx="5029200" cy="274320"/>
+          </a:xfrm>
+          <a:prstGeom prst="rect">
+            <a:avLst/>
+          </a:prstGeom>
+          <a:noFill/>
+        </p:spPr>
+        <p:txBody>
+          <a:bodyPr wrap="square">
+            <a:spAutoFit/>
+          </a:bodyPr>
+          <a:lstStyle/>
+          <a:p>
+            <a:pPr algn="l">
+              <a:defRPr sz="1100" b="0">
+                <a:solidFill>
+                  <a:srgbClr val="AAAAAA"/>
+                </a:solidFill>
+                <a:latin typeface="Calibri"/>
+              </a:defRPr>
+            </a:pPr>
+            <a:r>
+              <a:t>drop 3组 (readability,struct,emb)</a:t>
+            </a:r>
+          </a:p>
+        </p:txBody>
+      </p:sp>
+      <p:sp>
+        <p:nvSpPr>
+          <p:cNvPr id="30" name="TextBox 29"/>
+          <p:cNvSpPr txBox="1"/>
+          <p:nvPr/>
+        </p:nvSpPr>
+        <p:spPr>
+          <a:xfrm>
+            <a:off x="6400800" y="5029200"/>
+            <a:ext cx="5029200" cy="274320"/>
+          </a:xfrm>
+          <a:prstGeom prst="rect">
+            <a:avLst/>
+          </a:prstGeom>
+          <a:noFill/>
+        </p:spPr>
+        <p:txBody>
+          <a:bodyPr wrap="square">
+            <a:spAutoFit/>
+          </a:bodyPr>
+          <a:lstStyle/>
+          <a:p>
+            <a:pPr algn="l">
+              <a:defRPr sz="1100" b="0">
+                <a:solidFill>
+                  <a:srgbClr val="AAAAAA"/>
+                </a:solidFill>
+                <a:latin typeface="Calibri"/>
+              </a:defRPr>
+            </a:pPr>
+            <a:r>
+              <a:t>drop 0组</a:t>
+            </a:r>
+          </a:p>
+        </p:txBody>
+      </p:sp>
+      <p:sp>
+        <p:nvSpPr>
+          <p:cNvPr id="31" name="TextBox 30"/>
           <p:cNvSpPr txBox="1"/>
           <p:nvPr/>
         </p:nvSpPr>
@@ -9749,11 +10038,11 @@
               </a:defRPr>
             </a:pPr>
             <a:r>
-              <a:t>Auto-Filter 是"只赚不赔"策略: RAID/TuringBench 性能不变, SemEval AUC 从 0.84 恢复到 0.98</a:t>
+              <a:t>Auto-Filter 以组级 AUC &lt; 0.52 为门槛自动丢弃噪声特征组</a:t>
             </a:r>
             <a:br/>
             <a:r>
-              <a:t>已集成到项目 pipeline: src/auto_filter.py</a:t>
+              <a:t>关键发现: SemEval 上 model+token (0.9610) 远优于 all (0.8468) → 纯统计特征是噪声源</a:t>
             </a:r>
           </a:p>
         </p:txBody>
@@ -9793,7 +10082,7 @@
         <p:spPr>
           <a:xfrm>
             <a:off x="731520" y="365760"/>
-            <a:ext cx="9144000" cy="731520"/>
+            <a:ext cx="10972800" cy="731520"/>
           </a:xfrm>
           <a:prstGeom prst="rect">
             <a:avLst/>
@@ -9815,7 +10104,7 @@
               </a:defRPr>
             </a:pPr>
             <a:r>
-              <a:t>RAID vs HC3: 特征组消融对比</a:t>
+              <a:t>三层特征消融: 5 数据集全景</a:t>
             </a:r>
           </a:p>
         </p:txBody>
@@ -9829,7 +10118,7 @@
         <p:spPr>
           <a:xfrm>
             <a:off x="731520" y="1005840"/>
-            <a:ext cx="5486400" cy="38100"/>
+            <a:ext cx="7315200" cy="38100"/>
           </a:xfrm>
           <a:prstGeom prst="rect">
             <a:avLst/>
@@ -9863,30 +10152,54 @@
           </a:p>
         </p:txBody>
       </p:sp>
-      <p:sp>
-        <p:nvSpPr>
-          <p:cNvPr id="4" name="TextBox 3"/>
-          <p:cNvSpPr txBox="1"/>
-          <p:nvPr/>
-        </p:nvSpPr>
-        <p:spPr>
-          <a:xfrm>
-            <a:off x="914400" y="1371600"/>
-            <a:ext cx="2286000" cy="457200"/>
-          </a:xfrm>
-          <a:prstGeom prst="rect">
-            <a:avLst/>
-          </a:prstGeom>
-          <a:noFill/>
-        </p:spPr>
-        <p:txBody>
-          <a:bodyPr wrap="square">
-            <a:spAutoFit/>
-          </a:bodyPr>
-          <a:lstStyle/>
-          <a:p>
-            <a:pPr algn="l">
-              <a:defRPr sz="1800" b="1">
+      <p:pic>
+        <p:nvPicPr>
+          <p:cNvPr id="4" name="Picture 3" descr="three_layer_heatmap.png"/>
+          <p:cNvPicPr>
+            <a:picLocks noChangeAspect="1"/>
+          </p:cNvPicPr>
+          <p:nvPr/>
+        </p:nvPicPr>
+        <p:blipFill>
+          <a:blip r:embed="rId2"/>
+          <a:stretch>
+            <a:fillRect/>
+          </a:stretch>
+        </p:blipFill>
+        <p:spPr>
+          <a:xfrm>
+            <a:off x="274320" y="1188720"/>
+            <a:ext cx="6858000" cy="5029200"/>
+          </a:xfrm>
+          <a:prstGeom prst="rect">
+            <a:avLst/>
+          </a:prstGeom>
+        </p:spPr>
+      </p:pic>
+      <p:sp>
+        <p:nvSpPr>
+          <p:cNvPr id="5" name="TextBox 4"/>
+          <p:cNvSpPr txBox="1"/>
+          <p:nvPr/>
+        </p:nvSpPr>
+        <p:spPr>
+          <a:xfrm>
+            <a:off x="7498079" y="1280160"/>
+            <a:ext cx="4389120" cy="457200"/>
+          </a:xfrm>
+          <a:prstGeom prst="rect">
+            <a:avLst/>
+          </a:prstGeom>
+          <a:noFill/>
+        </p:spPr>
+        <p:txBody>
+          <a:bodyPr wrap="square">
+            <a:spAutoFit/>
+          </a:bodyPr>
+          <a:lstStyle/>
+          <a:p>
+            <a:pPr algn="l">
+              <a:defRPr sz="2000" b="1">
                 <a:solidFill>
                   <a:srgbClr val="00D2FF"/>
                 </a:solidFill>
@@ -9894,43 +10207,7 @@
               </a:defRPr>
             </a:pPr>
             <a:r>
-              <a:t>特征组</a:t>
-            </a:r>
-          </a:p>
-        </p:txBody>
-      </p:sp>
-      <p:sp>
-        <p:nvSpPr>
-          <p:cNvPr id="5" name="TextBox 4"/>
-          <p:cNvSpPr txBox="1"/>
-          <p:nvPr/>
-        </p:nvSpPr>
-        <p:spPr>
-          <a:xfrm>
-            <a:off x="4114800" y="1371600"/>
-            <a:ext cx="2286000" cy="457200"/>
-          </a:xfrm>
-          <a:prstGeom prst="rect">
-            <a:avLst/>
-          </a:prstGeom>
-          <a:noFill/>
-        </p:spPr>
-        <p:txBody>
-          <a:bodyPr wrap="square">
-            <a:spAutoFit/>
-          </a:bodyPr>
-          <a:lstStyle/>
-          <a:p>
-            <a:pPr algn="l">
-              <a:defRPr sz="1800" b="1">
-                <a:solidFill>
-                  <a:srgbClr val="00D2FF"/>
-                </a:solidFill>
-                <a:latin typeface="Calibri"/>
-              </a:defRPr>
-            </a:pPr>
-            <a:r>
-              <a:t>RAID AUC</a:t>
+              <a:t>核心发现</a:t>
             </a:r>
           </a:p>
         </p:txBody>
@@ -9943,966 +10220,245 @@
         </p:nvSpPr>
         <p:spPr>
           <a:xfrm>
-            <a:off x="6400800" y="1371600"/>
-            <a:ext cx="2286000" cy="457200"/>
-          </a:xfrm>
-          <a:prstGeom prst="rect">
-            <a:avLst/>
-          </a:prstGeom>
-          <a:noFill/>
-        </p:spPr>
-        <p:txBody>
-          <a:bodyPr wrap="square">
-            <a:spAutoFit/>
-          </a:bodyPr>
-          <a:lstStyle/>
-          <a:p>
-            <a:pPr algn="l">
-              <a:defRPr sz="1800" b="1">
-                <a:solidFill>
-                  <a:srgbClr val="00D2FF"/>
-                </a:solidFill>
-                <a:latin typeface="Calibri"/>
-              </a:defRPr>
-            </a:pPr>
-            <a:r>
-              <a:t>HC3 AUC</a:t>
-            </a:r>
-          </a:p>
-        </p:txBody>
-      </p:sp>
-      <p:sp>
-        <p:nvSpPr>
-          <p:cNvPr id="7" name="TextBox 6"/>
-          <p:cNvSpPr txBox="1"/>
-          <p:nvPr/>
-        </p:nvSpPr>
-        <p:spPr>
-          <a:xfrm>
-            <a:off x="8686800" y="1371600"/>
-            <a:ext cx="2286000" cy="457200"/>
-          </a:xfrm>
-          <a:prstGeom prst="rect">
-            <a:avLst/>
-          </a:prstGeom>
-          <a:noFill/>
-        </p:spPr>
-        <p:txBody>
-          <a:bodyPr wrap="square">
-            <a:spAutoFit/>
-          </a:bodyPr>
-          <a:lstStyle/>
-          <a:p>
-            <a:pPr algn="l">
-              <a:defRPr sz="1800" b="1">
-                <a:solidFill>
-                  <a:srgbClr val="00D2FF"/>
-                </a:solidFill>
-                <a:latin typeface="Calibri"/>
-              </a:defRPr>
-            </a:pPr>
-            <a:r>
-              <a:t>启示</a:t>
-            </a:r>
-          </a:p>
-        </p:txBody>
-      </p:sp>
-      <p:sp>
-        <p:nvSpPr>
-          <p:cNvPr id="8" name="TextBox 7"/>
-          <p:cNvSpPr txBox="1"/>
-          <p:nvPr/>
-        </p:nvSpPr>
-        <p:spPr>
-          <a:xfrm>
-            <a:off x="914400" y="2011680"/>
-            <a:ext cx="2743200" cy="457200"/>
-          </a:xfrm>
-          <a:prstGeom prst="rect">
-            <a:avLst/>
-          </a:prstGeom>
-          <a:noFill/>
-        </p:spPr>
-        <p:txBody>
-          <a:bodyPr wrap="square">
-            <a:spAutoFit/>
-          </a:bodyPr>
-          <a:lstStyle/>
-          <a:p>
-            <a:pPr algn="l">
-              <a:defRPr sz="1600" b="0">
-                <a:solidFill>
-                  <a:srgbClr val="FFFFFF"/>
-                </a:solidFill>
-                <a:latin typeface="Calibri"/>
-              </a:defRPr>
-            </a:pPr>
-            <a:r>
-              <a:t>basic_counts</a:t>
-            </a:r>
-          </a:p>
-        </p:txBody>
-      </p:sp>
-      <p:sp>
-        <p:nvSpPr>
-          <p:cNvPr id="9" name="TextBox 8"/>
-          <p:cNvSpPr txBox="1"/>
-          <p:nvPr/>
-        </p:nvSpPr>
-        <p:spPr>
-          <a:xfrm>
-            <a:off x="4114800" y="2011680"/>
-            <a:ext cx="1828800" cy="457200"/>
-          </a:xfrm>
-          <a:prstGeom prst="rect">
-            <a:avLst/>
-          </a:prstGeom>
-          <a:noFill/>
-        </p:spPr>
-        <p:txBody>
-          <a:bodyPr wrap="square">
-            <a:spAutoFit/>
-          </a:bodyPr>
-          <a:lstStyle/>
-          <a:p>
-            <a:pPr algn="l">
-              <a:defRPr sz="1600" b="0">
-                <a:solidFill>
-                  <a:srgbClr val="FFFFFF"/>
-                </a:solidFill>
-                <a:latin typeface="Calibri"/>
-              </a:defRPr>
-            </a:pPr>
-            <a:r>
-              <a:t>0.9700</a:t>
-            </a:r>
-          </a:p>
-        </p:txBody>
-      </p:sp>
-      <p:sp>
-        <p:nvSpPr>
-          <p:cNvPr id="10" name="TextBox 9"/>
-          <p:cNvSpPr txBox="1"/>
-          <p:nvPr/>
-        </p:nvSpPr>
-        <p:spPr>
-          <a:xfrm>
-            <a:off x="6400800" y="2011680"/>
-            <a:ext cx="1828800" cy="457200"/>
-          </a:xfrm>
-          <a:prstGeom prst="rect">
-            <a:avLst/>
-          </a:prstGeom>
-          <a:noFill/>
-        </p:spPr>
-        <p:txBody>
-          <a:bodyPr wrap="square">
-            <a:spAutoFit/>
-          </a:bodyPr>
-          <a:lstStyle/>
-          <a:p>
-            <a:pPr algn="l">
-              <a:defRPr sz="1600" b="0">
-                <a:solidFill>
-                  <a:srgbClr val="FFFFFF"/>
-                </a:solidFill>
-                <a:latin typeface="Calibri"/>
-              </a:defRPr>
-            </a:pPr>
-            <a:r>
-              <a:t>0.9204</a:t>
-            </a:r>
-          </a:p>
-        </p:txBody>
-      </p:sp>
-      <p:sp>
-        <p:nvSpPr>
-          <p:cNvPr id="11" name="TextBox 10"/>
-          <p:cNvSpPr txBox="1"/>
-          <p:nvPr/>
-        </p:nvSpPr>
-        <p:spPr>
-          <a:xfrm>
-            <a:off x="8686800" y="2011680"/>
-            <a:ext cx="2743200" cy="457200"/>
-          </a:xfrm>
-          <a:prstGeom prst="rect">
-            <a:avLst/>
-          </a:prstGeom>
-          <a:noFill/>
-        </p:spPr>
-        <p:txBody>
-          <a:bodyPr wrap="square">
-            <a:spAutoFit/>
-          </a:bodyPr>
-          <a:lstStyle/>
-          <a:p>
-            <a:pPr algn="l">
-              <a:defRPr sz="1600" b="0">
-                <a:solidFill>
-                  <a:srgbClr val="FFFFFF"/>
-                </a:solidFill>
-                <a:latin typeface="Calibri"/>
-              </a:defRPr>
-            </a:pPr>
-            <a:r>
-              <a:t>RAID 更强</a:t>
-            </a:r>
-          </a:p>
-        </p:txBody>
-      </p:sp>
-      <p:sp>
-        <p:nvSpPr>
-          <p:cNvPr id="12" name="TextBox 11"/>
-          <p:cNvSpPr txBox="1"/>
-          <p:nvPr/>
-        </p:nvSpPr>
-        <p:spPr>
-          <a:xfrm>
-            <a:off x="914400" y="2651760"/>
-            <a:ext cx="2743200" cy="457200"/>
-          </a:xfrm>
-          <a:prstGeom prst="rect">
-            <a:avLst/>
-          </a:prstGeom>
-          <a:noFill/>
-        </p:spPr>
-        <p:txBody>
-          <a:bodyPr wrap="square">
-            <a:spAutoFit/>
-          </a:bodyPr>
-          <a:lstStyle/>
-          <a:p>
-            <a:pPr algn="l">
-              <a:defRPr sz="1600" b="0">
-                <a:solidFill>
-                  <a:srgbClr val="FFFFFF"/>
-                </a:solidFill>
-                <a:latin typeface="Calibri"/>
-              </a:defRPr>
-            </a:pPr>
-            <a:r>
-              <a:t>averages</a:t>
-            </a:r>
-          </a:p>
-        </p:txBody>
-      </p:sp>
-      <p:sp>
-        <p:nvSpPr>
-          <p:cNvPr id="13" name="TextBox 12"/>
-          <p:cNvSpPr txBox="1"/>
-          <p:nvPr/>
-        </p:nvSpPr>
-        <p:spPr>
-          <a:xfrm>
-            <a:off x="4114800" y="2651760"/>
-            <a:ext cx="1828800" cy="457200"/>
-          </a:xfrm>
-          <a:prstGeom prst="rect">
-            <a:avLst/>
-          </a:prstGeom>
-          <a:noFill/>
-        </p:spPr>
-        <p:txBody>
-          <a:bodyPr wrap="square">
-            <a:spAutoFit/>
-          </a:bodyPr>
-          <a:lstStyle/>
-          <a:p>
-            <a:pPr algn="l">
-              <a:defRPr sz="1600" b="0">
-                <a:solidFill>
-                  <a:srgbClr val="FFFFFF"/>
-                </a:solidFill>
-                <a:latin typeface="Calibri"/>
-              </a:defRPr>
-            </a:pPr>
-            <a:r>
-              <a:t>0.9425</a:t>
-            </a:r>
-          </a:p>
-        </p:txBody>
-      </p:sp>
-      <p:sp>
-        <p:nvSpPr>
-          <p:cNvPr id="14" name="TextBox 13"/>
-          <p:cNvSpPr txBox="1"/>
-          <p:nvPr/>
-        </p:nvSpPr>
-        <p:spPr>
-          <a:xfrm>
-            <a:off x="6400800" y="2651760"/>
-            <a:ext cx="1828800" cy="457200"/>
-          </a:xfrm>
-          <a:prstGeom prst="rect">
-            <a:avLst/>
-          </a:prstGeom>
-          <a:noFill/>
-        </p:spPr>
-        <p:txBody>
-          <a:bodyPr wrap="square">
-            <a:spAutoFit/>
-          </a:bodyPr>
-          <a:lstStyle/>
-          <a:p>
-            <a:pPr algn="l">
-              <a:defRPr sz="1600" b="0">
-                <a:solidFill>
-                  <a:srgbClr val="FFFFFF"/>
-                </a:solidFill>
-                <a:latin typeface="Calibri"/>
-              </a:defRPr>
-            </a:pPr>
-            <a:r>
-              <a:t>0.9021</a:t>
-            </a:r>
-          </a:p>
-        </p:txBody>
-      </p:sp>
-      <p:sp>
-        <p:nvSpPr>
-          <p:cNvPr id="15" name="TextBox 14"/>
-          <p:cNvSpPr txBox="1"/>
-          <p:nvPr/>
-        </p:nvSpPr>
-        <p:spPr>
-          <a:xfrm>
-            <a:off x="8686800" y="2651760"/>
-            <a:ext cx="2743200" cy="457200"/>
-          </a:xfrm>
-          <a:prstGeom prst="rect">
-            <a:avLst/>
-          </a:prstGeom>
-          <a:noFill/>
-        </p:spPr>
-        <p:txBody>
-          <a:bodyPr wrap="square">
-            <a:spAutoFit/>
-          </a:bodyPr>
-          <a:lstStyle/>
-          <a:p>
-            <a:pPr algn="l">
-              <a:defRPr sz="1600" b="0">
-                <a:solidFill>
-                  <a:srgbClr val="FFFFFF"/>
-                </a:solidFill>
-                <a:latin typeface="Calibri"/>
-              </a:defRPr>
-            </a:pPr>
-            <a:r>
-              <a:t>RAID 更强</a:t>
-            </a:r>
-          </a:p>
-        </p:txBody>
-      </p:sp>
-      <p:sp>
-        <p:nvSpPr>
-          <p:cNvPr id="16" name="TextBox 15"/>
-          <p:cNvSpPr txBox="1"/>
-          <p:nvPr/>
-        </p:nvSpPr>
-        <p:spPr>
-          <a:xfrm>
-            <a:off x="914400" y="3291840"/>
-            <a:ext cx="2743200" cy="457200"/>
-          </a:xfrm>
-          <a:prstGeom prst="rect">
-            <a:avLst/>
-          </a:prstGeom>
-          <a:noFill/>
-        </p:spPr>
-        <p:txBody>
-          <a:bodyPr wrap="square">
-            <a:spAutoFit/>
-          </a:bodyPr>
-          <a:lstStyle/>
-          <a:p>
-            <a:pPr algn="l">
-              <a:defRPr sz="1600" b="0">
-                <a:solidFill>
-                  <a:srgbClr val="FFFFFF"/>
-                </a:solidFill>
-                <a:latin typeface="Calibri"/>
-              </a:defRPr>
-            </a:pPr>
-            <a:r>
-              <a:t>lexical_richness</a:t>
-            </a:r>
-          </a:p>
-        </p:txBody>
-      </p:sp>
-      <p:sp>
-        <p:nvSpPr>
-          <p:cNvPr id="17" name="TextBox 16"/>
-          <p:cNvSpPr txBox="1"/>
-          <p:nvPr/>
-        </p:nvSpPr>
-        <p:spPr>
-          <a:xfrm>
-            <a:off x="4114800" y="3291840"/>
-            <a:ext cx="1828800" cy="457200"/>
-          </a:xfrm>
-          <a:prstGeom prst="rect">
-            <a:avLst/>
-          </a:prstGeom>
-          <a:noFill/>
-        </p:spPr>
-        <p:txBody>
-          <a:bodyPr wrap="square">
-            <a:spAutoFit/>
-          </a:bodyPr>
-          <a:lstStyle/>
-          <a:p>
-            <a:pPr algn="l">
-              <a:defRPr sz="1600" b="0">
-                <a:solidFill>
-                  <a:srgbClr val="FFFFFF"/>
-                </a:solidFill>
-                <a:latin typeface="Calibri"/>
-              </a:defRPr>
-            </a:pPr>
-            <a:r>
-              <a:t>0.8861</a:t>
-            </a:r>
-          </a:p>
-        </p:txBody>
-      </p:sp>
-      <p:sp>
-        <p:nvSpPr>
-          <p:cNvPr id="18" name="TextBox 17"/>
-          <p:cNvSpPr txBox="1"/>
-          <p:nvPr/>
-        </p:nvSpPr>
-        <p:spPr>
-          <a:xfrm>
-            <a:off x="6400800" y="3291840"/>
-            <a:ext cx="1828800" cy="457200"/>
-          </a:xfrm>
-          <a:prstGeom prst="rect">
-            <a:avLst/>
-          </a:prstGeom>
-          <a:noFill/>
-        </p:spPr>
-        <p:txBody>
-          <a:bodyPr wrap="square">
-            <a:spAutoFit/>
-          </a:bodyPr>
-          <a:lstStyle/>
-          <a:p>
-            <a:pPr algn="l">
-              <a:defRPr sz="1600" b="0">
-                <a:solidFill>
-                  <a:srgbClr val="FFFFFF"/>
-                </a:solidFill>
-                <a:latin typeface="Calibri"/>
-              </a:defRPr>
-            </a:pPr>
-            <a:r>
-              <a:t>0.9367</a:t>
-            </a:r>
-          </a:p>
-        </p:txBody>
-      </p:sp>
-      <p:sp>
-        <p:nvSpPr>
-          <p:cNvPr id="19" name="TextBox 18"/>
-          <p:cNvSpPr txBox="1"/>
-          <p:nvPr/>
-        </p:nvSpPr>
-        <p:spPr>
-          <a:xfrm>
-            <a:off x="8686800" y="3291840"/>
-            <a:ext cx="2743200" cy="457200"/>
-          </a:xfrm>
-          <a:prstGeom prst="rect">
-            <a:avLst/>
-          </a:prstGeom>
-          <a:noFill/>
-        </p:spPr>
-        <p:txBody>
-          <a:bodyPr wrap="square">
-            <a:spAutoFit/>
-          </a:bodyPr>
-          <a:lstStyle/>
-          <a:p>
-            <a:pPr algn="l">
-              <a:defRPr sz="1600" b="0">
-                <a:solidFill>
-                  <a:srgbClr val="FFFFFF"/>
-                </a:solidFill>
-                <a:latin typeface="Calibri"/>
-              </a:defRPr>
-            </a:pPr>
-            <a:r>
-              <a:t>HC3 更强</a:t>
-            </a:r>
-          </a:p>
-        </p:txBody>
-      </p:sp>
-      <p:sp>
-        <p:nvSpPr>
-          <p:cNvPr id="20" name="TextBox 19"/>
-          <p:cNvSpPr txBox="1"/>
-          <p:nvPr/>
-        </p:nvSpPr>
-        <p:spPr>
-          <a:xfrm>
-            <a:off x="914400" y="3931920"/>
-            <a:ext cx="2743200" cy="457200"/>
-          </a:xfrm>
-          <a:prstGeom prst="rect">
-            <a:avLst/>
-          </a:prstGeom>
-          <a:noFill/>
-        </p:spPr>
-        <p:txBody>
-          <a:bodyPr wrap="square">
-            <a:spAutoFit/>
-          </a:bodyPr>
-          <a:lstStyle/>
-          <a:p>
-            <a:pPr algn="l">
-              <a:defRPr sz="1600" b="0">
-                <a:solidFill>
-                  <a:srgbClr val="FFFFFF"/>
-                </a:solidFill>
-                <a:latin typeface="Calibri"/>
-              </a:defRPr>
-            </a:pPr>
-            <a:r>
-              <a:t>readability</a:t>
-            </a:r>
-          </a:p>
-        </p:txBody>
-      </p:sp>
-      <p:sp>
-        <p:nvSpPr>
-          <p:cNvPr id="21" name="TextBox 20"/>
-          <p:cNvSpPr txBox="1"/>
-          <p:nvPr/>
-        </p:nvSpPr>
-        <p:spPr>
-          <a:xfrm>
-            <a:off x="4114800" y="3931920"/>
-            <a:ext cx="1828800" cy="457200"/>
-          </a:xfrm>
-          <a:prstGeom prst="rect">
-            <a:avLst/>
-          </a:prstGeom>
-          <a:noFill/>
-        </p:spPr>
-        <p:txBody>
-          <a:bodyPr wrap="square">
-            <a:spAutoFit/>
-          </a:bodyPr>
-          <a:lstStyle/>
-          <a:p>
-            <a:pPr algn="l">
-              <a:defRPr sz="1600" b="0">
-                <a:solidFill>
-                  <a:srgbClr val="FFFFFF"/>
-                </a:solidFill>
-                <a:latin typeface="Calibri"/>
-              </a:defRPr>
-            </a:pPr>
-            <a:r>
-              <a:t>0.8500</a:t>
-            </a:r>
-          </a:p>
-        </p:txBody>
-      </p:sp>
-      <p:sp>
-        <p:nvSpPr>
-          <p:cNvPr id="22" name="TextBox 21"/>
-          <p:cNvSpPr txBox="1"/>
-          <p:nvPr/>
-        </p:nvSpPr>
-        <p:spPr>
-          <a:xfrm>
-            <a:off x="6400800" y="3931920"/>
-            <a:ext cx="1828800" cy="457200"/>
-          </a:xfrm>
-          <a:prstGeom prst="rect">
-            <a:avLst/>
-          </a:prstGeom>
-          <a:noFill/>
-        </p:spPr>
-        <p:txBody>
-          <a:bodyPr wrap="square">
-            <a:spAutoFit/>
-          </a:bodyPr>
-          <a:lstStyle/>
-          <a:p>
-            <a:pPr algn="l">
-              <a:defRPr sz="1600" b="0">
-                <a:solidFill>
-                  <a:srgbClr val="FFFFFF"/>
-                </a:solidFill>
-                <a:latin typeface="Calibri"/>
-              </a:defRPr>
-            </a:pPr>
-            <a:r>
-              <a:t>0.9741</a:t>
-            </a:r>
-          </a:p>
-        </p:txBody>
-      </p:sp>
-      <p:sp>
-        <p:nvSpPr>
-          <p:cNvPr id="23" name="TextBox 22"/>
-          <p:cNvSpPr txBox="1"/>
-          <p:nvPr/>
-        </p:nvSpPr>
-        <p:spPr>
-          <a:xfrm>
-            <a:off x="8686800" y="3931920"/>
-            <a:ext cx="2743200" cy="457200"/>
-          </a:xfrm>
-          <a:prstGeom prst="rect">
-            <a:avLst/>
-          </a:prstGeom>
-          <a:noFill/>
-        </p:spPr>
-        <p:txBody>
-          <a:bodyPr wrap="square">
-            <a:spAutoFit/>
-          </a:bodyPr>
-          <a:lstStyle/>
-          <a:p>
-            <a:pPr algn="l">
-              <a:defRPr sz="1600" b="0">
-                <a:solidFill>
-                  <a:srgbClr val="FFFFFF"/>
-                </a:solidFill>
-                <a:latin typeface="Calibri"/>
-              </a:defRPr>
-            </a:pPr>
-            <a:r>
-              <a:t>HC3 远优</a:t>
-            </a:r>
-          </a:p>
-        </p:txBody>
-      </p:sp>
-      <p:sp>
-        <p:nvSpPr>
-          <p:cNvPr id="24" name="TextBox 23"/>
-          <p:cNvSpPr txBox="1"/>
-          <p:nvPr/>
-        </p:nvSpPr>
-        <p:spPr>
-          <a:xfrm>
-            <a:off x="914400" y="4572000"/>
-            <a:ext cx="2743200" cy="457200"/>
-          </a:xfrm>
-          <a:prstGeom prst="rect">
-            <a:avLst/>
-          </a:prstGeom>
-          <a:noFill/>
-        </p:spPr>
-        <p:txBody>
-          <a:bodyPr wrap="square">
-            <a:spAutoFit/>
-          </a:bodyPr>
-          <a:lstStyle/>
-          <a:p>
-            <a:pPr algn="l">
-              <a:defRPr sz="1600" b="0">
-                <a:solidFill>
-                  <a:srgbClr val="FF6B6B"/>
-                </a:solidFill>
-                <a:latin typeface="Calibri"/>
-              </a:defRPr>
-            </a:pPr>
-            <a:r>
-              <a:t>perplexity</a:t>
-            </a:r>
-          </a:p>
-        </p:txBody>
-      </p:sp>
-      <p:sp>
-        <p:nvSpPr>
-          <p:cNvPr id="25" name="TextBox 24"/>
-          <p:cNvSpPr txBox="1"/>
-          <p:nvPr/>
-        </p:nvSpPr>
-        <p:spPr>
-          <a:xfrm>
-            <a:off x="4114800" y="4572000"/>
-            <a:ext cx="1828800" cy="457200"/>
-          </a:xfrm>
-          <a:prstGeom prst="rect">
-            <a:avLst/>
-          </a:prstGeom>
-          <a:noFill/>
-        </p:spPr>
-        <p:txBody>
-          <a:bodyPr wrap="square">
-            <a:spAutoFit/>
-          </a:bodyPr>
-          <a:lstStyle/>
-          <a:p>
-            <a:pPr algn="l">
-              <a:defRPr sz="1600" b="0">
-                <a:solidFill>
-                  <a:srgbClr val="FF6B6B"/>
-                </a:solidFill>
-                <a:latin typeface="Calibri"/>
-              </a:defRPr>
-            </a:pPr>
-            <a:r>
-              <a:t>0.4920</a:t>
-            </a:r>
-          </a:p>
-        </p:txBody>
-      </p:sp>
-      <p:sp>
-        <p:nvSpPr>
-          <p:cNvPr id="26" name="TextBox 25"/>
-          <p:cNvSpPr txBox="1"/>
-          <p:nvPr/>
-        </p:nvSpPr>
-        <p:spPr>
-          <a:xfrm>
-            <a:off x="6400800" y="4572000"/>
-            <a:ext cx="1828800" cy="457200"/>
-          </a:xfrm>
-          <a:prstGeom prst="rect">
-            <a:avLst/>
-          </a:prstGeom>
-          <a:noFill/>
-        </p:spPr>
-        <p:txBody>
-          <a:bodyPr wrap="square">
-            <a:spAutoFit/>
-          </a:bodyPr>
-          <a:lstStyle/>
-          <a:p>
-            <a:pPr algn="l">
-              <a:defRPr sz="1600" b="0">
-                <a:solidFill>
-                  <a:srgbClr val="FF6B6B"/>
-                </a:solidFill>
-                <a:latin typeface="Calibri"/>
-              </a:defRPr>
-            </a:pPr>
-            <a:r>
-              <a:t>0.9912</a:t>
-            </a:r>
-          </a:p>
-        </p:txBody>
-      </p:sp>
-      <p:sp>
-        <p:nvSpPr>
-          <p:cNvPr id="27" name="TextBox 26"/>
-          <p:cNvSpPr txBox="1"/>
-          <p:nvPr/>
-        </p:nvSpPr>
-        <p:spPr>
-          <a:xfrm>
-            <a:off x="8686800" y="4572000"/>
-            <a:ext cx="2743200" cy="457200"/>
-          </a:xfrm>
-          <a:prstGeom prst="rect">
-            <a:avLst/>
-          </a:prstGeom>
-          <a:noFill/>
-        </p:spPr>
-        <p:txBody>
-          <a:bodyPr wrap="square">
-            <a:spAutoFit/>
-          </a:bodyPr>
-          <a:lstStyle/>
-          <a:p>
-            <a:pPr algn="l">
-              <a:defRPr sz="1600" b="0">
-                <a:solidFill>
-                  <a:srgbClr val="FF6B6B"/>
-                </a:solidFill>
-                <a:latin typeface="Calibri"/>
-              </a:defRPr>
-            </a:pPr>
-            <a:r>
-              <a:t>完全反转!</a:t>
-            </a:r>
-          </a:p>
-        </p:txBody>
-      </p:sp>
-      <p:sp>
-        <p:nvSpPr>
-          <p:cNvPr id="28" name="TextBox 27"/>
-          <p:cNvSpPr txBox="1"/>
-          <p:nvPr/>
-        </p:nvSpPr>
-        <p:spPr>
-          <a:xfrm>
-            <a:off x="914400" y="5212080"/>
-            <a:ext cx="2743200" cy="457200"/>
-          </a:xfrm>
-          <a:prstGeom prst="rect">
-            <a:avLst/>
-          </a:prstGeom>
-          <a:noFill/>
-        </p:spPr>
-        <p:txBody>
-          <a:bodyPr wrap="square">
-            <a:spAutoFit/>
-          </a:bodyPr>
-          <a:lstStyle/>
-          <a:p>
-            <a:pPr algn="l">
-              <a:defRPr sz="1600" b="0">
-                <a:solidFill>
-                  <a:srgbClr val="FFFFFF"/>
-                </a:solidFill>
-                <a:latin typeface="Calibri"/>
-              </a:defRPr>
-            </a:pPr>
-            <a:r>
-              <a:t>embedding_pca</a:t>
-            </a:r>
-          </a:p>
-        </p:txBody>
-      </p:sp>
-      <p:sp>
-        <p:nvSpPr>
-          <p:cNvPr id="29" name="TextBox 28"/>
-          <p:cNvSpPr txBox="1"/>
-          <p:nvPr/>
-        </p:nvSpPr>
-        <p:spPr>
-          <a:xfrm>
-            <a:off x="4114800" y="5212080"/>
-            <a:ext cx="1828800" cy="457200"/>
-          </a:xfrm>
-          <a:prstGeom prst="rect">
-            <a:avLst/>
-          </a:prstGeom>
-          <a:noFill/>
-        </p:spPr>
-        <p:txBody>
-          <a:bodyPr wrap="square">
-            <a:spAutoFit/>
-          </a:bodyPr>
-          <a:lstStyle/>
-          <a:p>
-            <a:pPr algn="l">
-              <a:defRPr sz="1600" b="0">
-                <a:solidFill>
-                  <a:srgbClr val="FFFFFF"/>
-                </a:solidFill>
-                <a:latin typeface="Calibri"/>
-              </a:defRPr>
-            </a:pPr>
-            <a:r>
-              <a:t>0.9357</a:t>
-            </a:r>
-          </a:p>
-        </p:txBody>
-      </p:sp>
-      <p:sp>
-        <p:nvSpPr>
-          <p:cNvPr id="30" name="TextBox 29"/>
-          <p:cNvSpPr txBox="1"/>
-          <p:nvPr/>
-        </p:nvSpPr>
-        <p:spPr>
-          <a:xfrm>
-            <a:off x="6400800" y="5212080"/>
-            <a:ext cx="1828800" cy="457200"/>
-          </a:xfrm>
-          <a:prstGeom prst="rect">
-            <a:avLst/>
-          </a:prstGeom>
-          <a:noFill/>
-        </p:spPr>
-        <p:txBody>
-          <a:bodyPr wrap="square">
-            <a:spAutoFit/>
-          </a:bodyPr>
-          <a:lstStyle/>
-          <a:p>
-            <a:pPr algn="l">
-              <a:defRPr sz="1600" b="0">
-                <a:solidFill>
-                  <a:srgbClr val="FFFFFF"/>
-                </a:solidFill>
-                <a:latin typeface="Calibri"/>
-              </a:defRPr>
-            </a:pPr>
-            <a:r>
-              <a:t>0.8972</a:t>
-            </a:r>
-          </a:p>
-        </p:txBody>
-      </p:sp>
-      <p:sp>
-        <p:nvSpPr>
-          <p:cNvPr id="31" name="TextBox 30"/>
-          <p:cNvSpPr txBox="1"/>
-          <p:nvPr/>
-        </p:nvSpPr>
-        <p:spPr>
-          <a:xfrm>
-            <a:off x="8686800" y="5212080"/>
-            <a:ext cx="2743200" cy="457200"/>
-          </a:xfrm>
-          <a:prstGeom prst="rect">
-            <a:avLst/>
-          </a:prstGeom>
-          <a:noFill/>
-        </p:spPr>
-        <p:txBody>
-          <a:bodyPr wrap="square">
-            <a:spAutoFit/>
-          </a:bodyPr>
-          <a:lstStyle/>
-          <a:p>
-            <a:pPr algn="l">
-              <a:defRPr sz="1600" b="0">
-                <a:solidFill>
-                  <a:srgbClr val="FFFFFF"/>
-                </a:solidFill>
-                <a:latin typeface="Calibri"/>
-              </a:defRPr>
-            </a:pPr>
-            <a:r>
-              <a:t>接近</a:t>
-            </a:r>
-          </a:p>
-        </p:txBody>
-      </p:sp>
-      <p:sp>
-        <p:nvSpPr>
-          <p:cNvPr id="32" name="TextBox 31"/>
-          <p:cNvSpPr txBox="1"/>
-          <p:nvPr/>
-        </p:nvSpPr>
-        <p:spPr>
-          <a:xfrm>
-            <a:off x="731520" y="5760720"/>
-            <a:ext cx="10515600" cy="731520"/>
-          </a:xfrm>
-          <a:prstGeom prst="rect">
-            <a:avLst/>
-          </a:prstGeom>
-          <a:noFill/>
-        </p:spPr>
-        <p:txBody>
-          <a:bodyPr wrap="square">
-            <a:spAutoFit/>
-          </a:bodyPr>
-          <a:lstStyle/>
-          <a:p>
-            <a:pPr algn="ctr">
-              <a:defRPr sz="1600" b="0">
-                <a:solidFill>
-                  <a:srgbClr val="00D2FF"/>
-                </a:solidFill>
-                <a:latin typeface="Calibri"/>
-              </a:defRPr>
-            </a:pPr>
-            <a:r>
-              <a:t>核心启示: 多模型检测不能依赖单一语言模型的困惑度 — 需要模型无关的统计特征作为稳定基线</a:t>
+            <a:off x="7498079" y="1828800"/>
+            <a:ext cx="4389120" cy="4572000"/>
+          </a:xfrm>
+          <a:prstGeom prst="rect">
+            <a:avLst/>
+          </a:prstGeom>
+          <a:noFill/>
+        </p:spPr>
+        <p:txBody>
+          <a:bodyPr wrap="square">
+            <a:spAutoFit/>
+          </a:bodyPr>
+          <a:lstStyle/>
+          <a:p>
+            <a:pPr>
+              <a:spcAft>
+                <a:spcPts val="780"/>
+              </a:spcAft>
+              <a:defRPr sz="1300">
+                <a:solidFill>
+                  <a:srgbClr val="E0E0E0"/>
+                </a:solidFill>
+                <a:latin typeface="Calibri"/>
+              </a:defRPr>
+            </a:pPr>
+            <a:r>
+              <a:t>RAID: stat (0.994) + token (0.990)</a:t>
+            </a:r>
+          </a:p>
+          <a:p>
+            <a:pPr>
+              <a:spcAft>
+                <a:spcPts val="780"/>
+              </a:spcAft>
+              <a:defRPr sz="1300">
+                <a:solidFill>
+                  <a:srgbClr val="E0E0E0"/>
+                </a:solidFill>
+                <a:latin typeface="Calibri"/>
+              </a:defRPr>
+            </a:pPr>
+            <a:r>
+              <a:t>  → 两层互补, all=0.999</a:t>
+            </a:r>
+          </a:p>
+          <a:p>
+            <a:pPr>
+              <a:spcAft>
+                <a:spcPts val="780"/>
+              </a:spcAft>
+              <a:defRPr sz="1300">
+                <a:solidFill>
+                  <a:srgbClr val="E0E0E0"/>
+                </a:solidFill>
+                <a:latin typeface="Calibri"/>
+              </a:defRPr>
+            </a:pPr>
+          </a:p>
+          <a:p>
+            <a:pPr>
+              <a:spcAft>
+                <a:spcPts val="780"/>
+              </a:spcAft>
+              <a:defRPr sz="1300">
+                <a:solidFill>
+                  <a:srgbClr val="E0E0E0"/>
+                </a:solidFill>
+                <a:latin typeface="Calibri"/>
+              </a:defRPr>
+            </a:pPr>
+            <a:r>
+              <a:t>SemEval: 只有 token 有效 (0.976)</a:t>
+            </a:r>
+          </a:p>
+          <a:p>
+            <a:pPr>
+              <a:spcAft>
+                <a:spcPts val="780"/>
+              </a:spcAft>
+              <a:defRPr sz="1300">
+                <a:solidFill>
+                  <a:srgbClr val="E0E0E0"/>
+                </a:solidFill>
+                <a:latin typeface="Calibri"/>
+              </a:defRPr>
+            </a:pPr>
+            <a:r>
+              <a:t>  stat/model 均 ~0.51 (纯噪声)</a:t>
+            </a:r>
+          </a:p>
+          <a:p>
+            <a:pPr>
+              <a:spcAft>
+                <a:spcPts val="780"/>
+              </a:spcAft>
+              <a:defRPr sz="1300">
+                <a:solidFill>
+                  <a:srgbClr val="E0E0E0"/>
+                </a:solidFill>
+                <a:latin typeface="Calibri"/>
+              </a:defRPr>
+            </a:pPr>
+            <a:r>
+              <a:t>  model+token=0.961 &gt; all=0.847</a:t>
+            </a:r>
+          </a:p>
+          <a:p>
+            <a:pPr>
+              <a:spcAft>
+                <a:spcPts val="780"/>
+              </a:spcAft>
+              <a:defRPr sz="1300">
+                <a:solidFill>
+                  <a:srgbClr val="E0E0E0"/>
+                </a:solidFill>
+                <a:latin typeface="Calibri"/>
+              </a:defRPr>
+            </a:pPr>
+            <a:r>
+              <a:t>  → 纯统计特征是噪声源!</a:t>
+            </a:r>
+          </a:p>
+          <a:p>
+            <a:pPr>
+              <a:spcAft>
+                <a:spcPts val="780"/>
+              </a:spcAft>
+              <a:defRPr sz="1300">
+                <a:solidFill>
+                  <a:srgbClr val="E0E0E0"/>
+                </a:solidFill>
+                <a:latin typeface="Calibri"/>
+              </a:defRPr>
+            </a:pPr>
+          </a:p>
+          <a:p>
+            <a:pPr>
+              <a:spcAft>
+                <a:spcPts val="780"/>
+              </a:spcAft>
+              <a:defRPr sz="1300">
+                <a:solidFill>
+                  <a:srgbClr val="E0E0E0"/>
+                </a:solidFill>
+                <a:latin typeface="Calibri"/>
+              </a:defRPr>
+            </a:pPr>
+            <a:r>
+              <a:t>TuringBench: model 最强 (0.975)</a:t>
+            </a:r>
+          </a:p>
+          <a:p>
+            <a:pPr>
+              <a:spcAft>
+                <a:spcPts val="780"/>
+              </a:spcAft>
+              <a:defRPr sz="1300">
+                <a:solidFill>
+                  <a:srgbClr val="E0E0E0"/>
+                </a:solidFill>
+                <a:latin typeface="Calibri"/>
+              </a:defRPr>
+            </a:pPr>
+            <a:r>
+              <a:t>  stat=0.67, token=0.52</a:t>
+            </a:r>
+          </a:p>
+          <a:p>
+            <a:pPr>
+              <a:spcAft>
+                <a:spcPts val="780"/>
+              </a:spcAft>
+              <a:defRPr sz="1300">
+                <a:solidFill>
+                  <a:srgbClr val="E0E0E0"/>
+                </a:solidFill>
+                <a:latin typeface="Calibri"/>
+              </a:defRPr>
+            </a:pPr>
+            <a:r>
+              <a:t>  → BERT embedding 捕捉老 AI 风格</a:t>
+            </a:r>
+          </a:p>
+          <a:p>
+            <a:pPr>
+              <a:spcAft>
+                <a:spcPts val="780"/>
+              </a:spcAft>
+              <a:defRPr sz="1300">
+                <a:solidFill>
+                  <a:srgbClr val="E0E0E0"/>
+                </a:solidFill>
+                <a:latin typeface="Calibri"/>
+              </a:defRPr>
+            </a:pPr>
+          </a:p>
+          <a:p>
+            <a:pPr>
+              <a:spcAft>
+                <a:spcPts val="780"/>
+              </a:spcAft>
+              <a:defRPr sz="1300">
+                <a:solidFill>
+                  <a:srgbClr val="E0E0E0"/>
+                </a:solidFill>
+                <a:latin typeface="Calibri"/>
+              </a:defRPr>
+            </a:pPr>
+            <a:r>
+              <a:t>HC3: stat+model 已饱和 (0.999)</a:t>
+            </a:r>
+          </a:p>
+          <a:p>
+            <a:pPr>
+              <a:spcAft>
+                <a:spcPts val="780"/>
+              </a:spcAft>
+              <a:defRPr sz="1300">
+                <a:solidFill>
+                  <a:srgbClr val="E0E0E0"/>
+                </a:solidFill>
+                <a:latin typeface="Calibri"/>
+              </a:defRPr>
+            </a:pPr>
+          </a:p>
+          <a:p>
+            <a:pPr>
+              <a:spcAft>
+                <a:spcPts val="780"/>
+              </a:spcAft>
+              <a:defRPr sz="1300">
+                <a:solidFill>
+                  <a:srgbClr val="E0E0E0"/>
+                </a:solidFill>
+                <a:latin typeface="Calibri"/>
+              </a:defRPr>
+            </a:pPr>
+            <a:r>
+              <a:t>Pile: stat 主导 (0.962)</a:t>
             </a:r>
           </a:p>
         </p:txBody>
@@ -10956,7 +10512,7 @@
           <a:lstStyle/>
           <a:p>
             <a:pPr algn="l">
-              <a:defRPr sz="3600" b="1">
+              <a:defRPr sz="3200" b="1">
                 <a:solidFill>
                   <a:srgbClr val="00D2FF"/>
                 </a:solidFill>
@@ -10964,7 +10520,7 @@
               </a:defRPr>
             </a:pPr>
             <a:r>
-              <a:t>结论</a:t>
+              <a:t>RAID vs HC3: 特征组消融对比</a:t>
             </a:r>
           </a:p>
         </p:txBody>
@@ -10978,7 +10534,7 @@
         <p:spPr>
           <a:xfrm>
             <a:off x="731520" y="1005840"/>
-            <a:ext cx="3657600" cy="38100"/>
+            <a:ext cx="5486400" cy="38100"/>
           </a:xfrm>
           <a:prstGeom prst="rect">
             <a:avLst/>
@@ -11020,229 +10576,1038 @@
         </p:nvSpPr>
         <p:spPr>
           <a:xfrm>
-            <a:off x="731520" y="1371600"/>
-            <a:ext cx="10058400" cy="5029200"/>
-          </a:xfrm>
-          <a:prstGeom prst="rect">
-            <a:avLst/>
-          </a:prstGeom>
-          <a:noFill/>
-        </p:spPr>
-        <p:txBody>
-          <a:bodyPr wrap="square">
-            <a:spAutoFit/>
-          </a:bodyPr>
-          <a:lstStyle/>
-          <a:p>
-            <a:pPr>
-              <a:spcAft>
-                <a:spcPts val="720"/>
-              </a:spcAft>
-              <a:defRPr sz="1800">
-                <a:solidFill>
-                  <a:srgbClr val="E0E0E0"/>
-                </a:solidFill>
-                <a:latin typeface="Calibri"/>
-              </a:defRPr>
-            </a:pPr>
-            <a:r>
-              <a:t>1. XGBoost + 120 维组合特征在 RAID 上达到 AUC 0.9992</a:t>
-            </a:r>
-          </a:p>
-          <a:p>
-            <a:pPr>
-              <a:spcAft>
-                <a:spcPts val="720"/>
-              </a:spcAft>
-              <a:defRPr sz="1800">
-                <a:solidFill>
-                  <a:srgbClr val="E0E0E0"/>
-                </a:solidFill>
-                <a:latin typeface="Calibri"/>
-              </a:defRPr>
-            </a:pPr>
-            <a:r>
-              <a:t>    完全可解释，超越零样本方法 Fast-DetectGPT (0.7815)</a:t>
-            </a:r>
-          </a:p>
-          <a:p>
-            <a:pPr>
-              <a:spcAft>
-                <a:spcPts val="720"/>
-              </a:spcAft>
-              <a:defRPr sz="1800">
-                <a:solidFill>
-                  <a:srgbClr val="E0E0E0"/>
-                </a:solidFill>
-                <a:latin typeface="Calibri"/>
-              </a:defRPr>
-            </a:pPr>
-          </a:p>
-          <a:p>
-            <a:pPr>
-              <a:spcAft>
-                <a:spcPts val="720"/>
-              </a:spcAft>
-              <a:defRPr sz="1800">
-                <a:solidFill>
-                  <a:srgbClr val="E0E0E0"/>
-                </a:solidFill>
-                <a:latin typeface="Calibri"/>
-              </a:defRPr>
-            </a:pPr>
-            <a:r>
-              <a:t>2. 两类特征视角正交，互补覆盖盲区</a:t>
-            </a:r>
-          </a:p>
-          <a:p>
-            <a:pPr>
-              <a:spcAft>
-                <a:spcPts val="720"/>
-              </a:spcAft>
-              <a:defRPr sz="1800">
-                <a:solidFill>
-                  <a:srgbClr val="E0E0E0"/>
-                </a:solidFill>
-                <a:latin typeface="Calibri"/>
-              </a:defRPr>
-            </a:pPr>
-            <a:r>
-              <a:t>    手工特征看"文本外表"，Token 特征看"AI 内在"</a:t>
-            </a:r>
-          </a:p>
-          <a:p>
-            <a:pPr>
-              <a:spcAft>
-                <a:spcPts val="720"/>
-              </a:spcAft>
-              <a:defRPr sz="1800">
-                <a:solidFill>
-                  <a:srgbClr val="E0E0E0"/>
-                </a:solidFill>
-                <a:latin typeface="Calibri"/>
-              </a:defRPr>
-            </a:pPr>
-          </a:p>
-          <a:p>
-            <a:pPr>
-              <a:spcAft>
-                <a:spcPts val="720"/>
-              </a:spcAft>
-              <a:defRPr sz="1800">
-                <a:solidFill>
-                  <a:srgbClr val="E0E0E0"/>
-                </a:solidFill>
-                <a:latin typeface="Calibri"/>
-              </a:defRPr>
-            </a:pPr>
-            <a:r>
-              <a:t>3. GPT-2 困惑度的 Paradox 是重要发现</a:t>
-            </a:r>
-          </a:p>
-          <a:p>
-            <a:pPr>
-              <a:spcAft>
-                <a:spcPts val="720"/>
-              </a:spcAft>
-              <a:defRPr sz="1800">
-                <a:solidFill>
-                  <a:srgbClr val="E0E0E0"/>
-                </a:solidFill>
-                <a:latin typeface="Calibri"/>
-              </a:defRPr>
-            </a:pPr>
-            <a:r>
-              <a:t>    HC3 最强 (0.99) → RAID 完全失效 (0.49)</a:t>
-            </a:r>
-          </a:p>
-          <a:p>
-            <a:pPr>
-              <a:spcAft>
-                <a:spcPts val="720"/>
-              </a:spcAft>
-              <a:defRPr sz="1800">
-                <a:solidFill>
-                  <a:srgbClr val="E0E0E0"/>
-                </a:solidFill>
-                <a:latin typeface="Calibri"/>
-              </a:defRPr>
-            </a:pPr>
-          </a:p>
-          <a:p>
-            <a:pPr>
-              <a:spcAft>
-                <a:spcPts val="720"/>
-              </a:spcAft>
-              <a:defRPr sz="1800">
-                <a:solidFill>
-                  <a:srgbClr val="E0E0E0"/>
-                </a:solidFill>
-                <a:latin typeface="Calibri"/>
-              </a:defRPr>
-            </a:pPr>
-            <a:r>
-              <a:t>4. 统计特征对 10/11 种对抗攻击天然鲁棒</a:t>
-            </a:r>
-          </a:p>
-          <a:p>
-            <a:pPr>
-              <a:spcAft>
-                <a:spcPts val="720"/>
-              </a:spcAft>
-              <a:defRPr sz="1800">
-                <a:solidFill>
-                  <a:srgbClr val="E0E0E0"/>
-                </a:solidFill>
-                <a:latin typeface="Calibri"/>
-              </a:defRPr>
-            </a:pPr>
-            <a:r>
-              <a:t>    只有释义攻击能显著降低检测效果</a:t>
-            </a:r>
-          </a:p>
-          <a:p>
-            <a:pPr>
-              <a:spcAft>
-                <a:spcPts val="720"/>
-              </a:spcAft>
-              <a:defRPr sz="1800">
-                <a:solidFill>
-                  <a:srgbClr val="E0E0E0"/>
-                </a:solidFill>
-                <a:latin typeface="Calibri"/>
-              </a:defRPr>
-            </a:pPr>
-          </a:p>
-          <a:p>
-            <a:pPr>
-              <a:spcAft>
-                <a:spcPts val="720"/>
-              </a:spcAft>
-              <a:defRPr sz="1800">
-                <a:solidFill>
-                  <a:srgbClr val="E0E0E0"/>
-                </a:solidFill>
-                <a:latin typeface="Calibri"/>
-              </a:defRPr>
-            </a:pPr>
-            <a:r>
-              <a:t>5. Token 概率特征有"时代窗口"</a:t>
-            </a:r>
-          </a:p>
-          <a:p>
-            <a:pPr>
-              <a:spcAft>
-                <a:spcPts val="720"/>
-              </a:spcAft>
-              <a:defRPr sz="1800">
-                <a:solidFill>
-                  <a:srgbClr val="E0E0E0"/>
-                </a:solidFill>
-                <a:latin typeface="Calibri"/>
-              </a:defRPr>
-            </a:pPr>
-            <a:r>
-              <a:t>    观察者模型需要与目标生成器同代</a:t>
+            <a:off x="914400" y="1371600"/>
+            <a:ext cx="2286000" cy="457200"/>
+          </a:xfrm>
+          <a:prstGeom prst="rect">
+            <a:avLst/>
+          </a:prstGeom>
+          <a:noFill/>
+        </p:spPr>
+        <p:txBody>
+          <a:bodyPr wrap="square">
+            <a:spAutoFit/>
+          </a:bodyPr>
+          <a:lstStyle/>
+          <a:p>
+            <a:pPr algn="l">
+              <a:defRPr sz="1800" b="1">
+                <a:solidFill>
+                  <a:srgbClr val="00D2FF"/>
+                </a:solidFill>
+                <a:latin typeface="Calibri"/>
+              </a:defRPr>
+            </a:pPr>
+            <a:r>
+              <a:t>特征组</a:t>
+            </a:r>
+          </a:p>
+        </p:txBody>
+      </p:sp>
+      <p:sp>
+        <p:nvSpPr>
+          <p:cNvPr id="5" name="TextBox 4"/>
+          <p:cNvSpPr txBox="1"/>
+          <p:nvPr/>
+        </p:nvSpPr>
+        <p:spPr>
+          <a:xfrm>
+            <a:off x="4114800" y="1371600"/>
+            <a:ext cx="2286000" cy="457200"/>
+          </a:xfrm>
+          <a:prstGeom prst="rect">
+            <a:avLst/>
+          </a:prstGeom>
+          <a:noFill/>
+        </p:spPr>
+        <p:txBody>
+          <a:bodyPr wrap="square">
+            <a:spAutoFit/>
+          </a:bodyPr>
+          <a:lstStyle/>
+          <a:p>
+            <a:pPr algn="l">
+              <a:defRPr sz="1800" b="1">
+                <a:solidFill>
+                  <a:srgbClr val="00D2FF"/>
+                </a:solidFill>
+                <a:latin typeface="Calibri"/>
+              </a:defRPr>
+            </a:pPr>
+            <a:r>
+              <a:t>RAID AUC</a:t>
+            </a:r>
+          </a:p>
+        </p:txBody>
+      </p:sp>
+      <p:sp>
+        <p:nvSpPr>
+          <p:cNvPr id="6" name="TextBox 5"/>
+          <p:cNvSpPr txBox="1"/>
+          <p:nvPr/>
+        </p:nvSpPr>
+        <p:spPr>
+          <a:xfrm>
+            <a:off x="6400800" y="1371600"/>
+            <a:ext cx="2286000" cy="457200"/>
+          </a:xfrm>
+          <a:prstGeom prst="rect">
+            <a:avLst/>
+          </a:prstGeom>
+          <a:noFill/>
+        </p:spPr>
+        <p:txBody>
+          <a:bodyPr wrap="square">
+            <a:spAutoFit/>
+          </a:bodyPr>
+          <a:lstStyle/>
+          <a:p>
+            <a:pPr algn="l">
+              <a:defRPr sz="1800" b="1">
+                <a:solidFill>
+                  <a:srgbClr val="00D2FF"/>
+                </a:solidFill>
+                <a:latin typeface="Calibri"/>
+              </a:defRPr>
+            </a:pPr>
+            <a:r>
+              <a:t>HC3 AUC</a:t>
+            </a:r>
+          </a:p>
+        </p:txBody>
+      </p:sp>
+      <p:sp>
+        <p:nvSpPr>
+          <p:cNvPr id="7" name="TextBox 6"/>
+          <p:cNvSpPr txBox="1"/>
+          <p:nvPr/>
+        </p:nvSpPr>
+        <p:spPr>
+          <a:xfrm>
+            <a:off x="8686800" y="1371600"/>
+            <a:ext cx="2286000" cy="457200"/>
+          </a:xfrm>
+          <a:prstGeom prst="rect">
+            <a:avLst/>
+          </a:prstGeom>
+          <a:noFill/>
+        </p:spPr>
+        <p:txBody>
+          <a:bodyPr wrap="square">
+            <a:spAutoFit/>
+          </a:bodyPr>
+          <a:lstStyle/>
+          <a:p>
+            <a:pPr algn="l">
+              <a:defRPr sz="1800" b="1">
+                <a:solidFill>
+                  <a:srgbClr val="00D2FF"/>
+                </a:solidFill>
+                <a:latin typeface="Calibri"/>
+              </a:defRPr>
+            </a:pPr>
+            <a:r>
+              <a:t>启示</a:t>
+            </a:r>
+          </a:p>
+        </p:txBody>
+      </p:sp>
+      <p:sp>
+        <p:nvSpPr>
+          <p:cNvPr id="8" name="TextBox 7"/>
+          <p:cNvSpPr txBox="1"/>
+          <p:nvPr/>
+        </p:nvSpPr>
+        <p:spPr>
+          <a:xfrm>
+            <a:off x="914400" y="2011680"/>
+            <a:ext cx="2743200" cy="457200"/>
+          </a:xfrm>
+          <a:prstGeom prst="rect">
+            <a:avLst/>
+          </a:prstGeom>
+          <a:noFill/>
+        </p:spPr>
+        <p:txBody>
+          <a:bodyPr wrap="square">
+            <a:spAutoFit/>
+          </a:bodyPr>
+          <a:lstStyle/>
+          <a:p>
+            <a:pPr algn="l">
+              <a:defRPr sz="1600" b="0">
+                <a:solidFill>
+                  <a:srgbClr val="FFFFFF"/>
+                </a:solidFill>
+                <a:latin typeface="Calibri"/>
+              </a:defRPr>
+            </a:pPr>
+            <a:r>
+              <a:t>basic_counts</a:t>
+            </a:r>
+          </a:p>
+        </p:txBody>
+      </p:sp>
+      <p:sp>
+        <p:nvSpPr>
+          <p:cNvPr id="9" name="TextBox 8"/>
+          <p:cNvSpPr txBox="1"/>
+          <p:nvPr/>
+        </p:nvSpPr>
+        <p:spPr>
+          <a:xfrm>
+            <a:off x="4114800" y="2011680"/>
+            <a:ext cx="1828800" cy="457200"/>
+          </a:xfrm>
+          <a:prstGeom prst="rect">
+            <a:avLst/>
+          </a:prstGeom>
+          <a:noFill/>
+        </p:spPr>
+        <p:txBody>
+          <a:bodyPr wrap="square">
+            <a:spAutoFit/>
+          </a:bodyPr>
+          <a:lstStyle/>
+          <a:p>
+            <a:pPr algn="l">
+              <a:defRPr sz="1600" b="0">
+                <a:solidFill>
+                  <a:srgbClr val="FFFFFF"/>
+                </a:solidFill>
+                <a:latin typeface="Calibri"/>
+              </a:defRPr>
+            </a:pPr>
+            <a:r>
+              <a:t>0.9700</a:t>
+            </a:r>
+          </a:p>
+        </p:txBody>
+      </p:sp>
+      <p:sp>
+        <p:nvSpPr>
+          <p:cNvPr id="10" name="TextBox 9"/>
+          <p:cNvSpPr txBox="1"/>
+          <p:nvPr/>
+        </p:nvSpPr>
+        <p:spPr>
+          <a:xfrm>
+            <a:off x="6400800" y="2011680"/>
+            <a:ext cx="1828800" cy="457200"/>
+          </a:xfrm>
+          <a:prstGeom prst="rect">
+            <a:avLst/>
+          </a:prstGeom>
+          <a:noFill/>
+        </p:spPr>
+        <p:txBody>
+          <a:bodyPr wrap="square">
+            <a:spAutoFit/>
+          </a:bodyPr>
+          <a:lstStyle/>
+          <a:p>
+            <a:pPr algn="l">
+              <a:defRPr sz="1600" b="0">
+                <a:solidFill>
+                  <a:srgbClr val="FFFFFF"/>
+                </a:solidFill>
+                <a:latin typeface="Calibri"/>
+              </a:defRPr>
+            </a:pPr>
+            <a:r>
+              <a:t>0.9204</a:t>
+            </a:r>
+          </a:p>
+        </p:txBody>
+      </p:sp>
+      <p:sp>
+        <p:nvSpPr>
+          <p:cNvPr id="11" name="TextBox 10"/>
+          <p:cNvSpPr txBox="1"/>
+          <p:nvPr/>
+        </p:nvSpPr>
+        <p:spPr>
+          <a:xfrm>
+            <a:off x="8686800" y="2011680"/>
+            <a:ext cx="2743200" cy="457200"/>
+          </a:xfrm>
+          <a:prstGeom prst="rect">
+            <a:avLst/>
+          </a:prstGeom>
+          <a:noFill/>
+        </p:spPr>
+        <p:txBody>
+          <a:bodyPr wrap="square">
+            <a:spAutoFit/>
+          </a:bodyPr>
+          <a:lstStyle/>
+          <a:p>
+            <a:pPr algn="l">
+              <a:defRPr sz="1600" b="0">
+                <a:solidFill>
+                  <a:srgbClr val="FFFFFF"/>
+                </a:solidFill>
+                <a:latin typeface="Calibri"/>
+              </a:defRPr>
+            </a:pPr>
+            <a:r>
+              <a:t>RAID 更强</a:t>
+            </a:r>
+          </a:p>
+        </p:txBody>
+      </p:sp>
+      <p:sp>
+        <p:nvSpPr>
+          <p:cNvPr id="12" name="TextBox 11"/>
+          <p:cNvSpPr txBox="1"/>
+          <p:nvPr/>
+        </p:nvSpPr>
+        <p:spPr>
+          <a:xfrm>
+            <a:off x="914400" y="2651760"/>
+            <a:ext cx="2743200" cy="457200"/>
+          </a:xfrm>
+          <a:prstGeom prst="rect">
+            <a:avLst/>
+          </a:prstGeom>
+          <a:noFill/>
+        </p:spPr>
+        <p:txBody>
+          <a:bodyPr wrap="square">
+            <a:spAutoFit/>
+          </a:bodyPr>
+          <a:lstStyle/>
+          <a:p>
+            <a:pPr algn="l">
+              <a:defRPr sz="1600" b="0">
+                <a:solidFill>
+                  <a:srgbClr val="FFFFFF"/>
+                </a:solidFill>
+                <a:latin typeface="Calibri"/>
+              </a:defRPr>
+            </a:pPr>
+            <a:r>
+              <a:t>averages</a:t>
+            </a:r>
+          </a:p>
+        </p:txBody>
+      </p:sp>
+      <p:sp>
+        <p:nvSpPr>
+          <p:cNvPr id="13" name="TextBox 12"/>
+          <p:cNvSpPr txBox="1"/>
+          <p:nvPr/>
+        </p:nvSpPr>
+        <p:spPr>
+          <a:xfrm>
+            <a:off x="4114800" y="2651760"/>
+            <a:ext cx="1828800" cy="457200"/>
+          </a:xfrm>
+          <a:prstGeom prst="rect">
+            <a:avLst/>
+          </a:prstGeom>
+          <a:noFill/>
+        </p:spPr>
+        <p:txBody>
+          <a:bodyPr wrap="square">
+            <a:spAutoFit/>
+          </a:bodyPr>
+          <a:lstStyle/>
+          <a:p>
+            <a:pPr algn="l">
+              <a:defRPr sz="1600" b="0">
+                <a:solidFill>
+                  <a:srgbClr val="FFFFFF"/>
+                </a:solidFill>
+                <a:latin typeface="Calibri"/>
+              </a:defRPr>
+            </a:pPr>
+            <a:r>
+              <a:t>0.9425</a:t>
+            </a:r>
+          </a:p>
+        </p:txBody>
+      </p:sp>
+      <p:sp>
+        <p:nvSpPr>
+          <p:cNvPr id="14" name="TextBox 13"/>
+          <p:cNvSpPr txBox="1"/>
+          <p:nvPr/>
+        </p:nvSpPr>
+        <p:spPr>
+          <a:xfrm>
+            <a:off x="6400800" y="2651760"/>
+            <a:ext cx="1828800" cy="457200"/>
+          </a:xfrm>
+          <a:prstGeom prst="rect">
+            <a:avLst/>
+          </a:prstGeom>
+          <a:noFill/>
+        </p:spPr>
+        <p:txBody>
+          <a:bodyPr wrap="square">
+            <a:spAutoFit/>
+          </a:bodyPr>
+          <a:lstStyle/>
+          <a:p>
+            <a:pPr algn="l">
+              <a:defRPr sz="1600" b="0">
+                <a:solidFill>
+                  <a:srgbClr val="FFFFFF"/>
+                </a:solidFill>
+                <a:latin typeface="Calibri"/>
+              </a:defRPr>
+            </a:pPr>
+            <a:r>
+              <a:t>0.9021</a:t>
+            </a:r>
+          </a:p>
+        </p:txBody>
+      </p:sp>
+      <p:sp>
+        <p:nvSpPr>
+          <p:cNvPr id="15" name="TextBox 14"/>
+          <p:cNvSpPr txBox="1"/>
+          <p:nvPr/>
+        </p:nvSpPr>
+        <p:spPr>
+          <a:xfrm>
+            <a:off x="8686800" y="2651760"/>
+            <a:ext cx="2743200" cy="457200"/>
+          </a:xfrm>
+          <a:prstGeom prst="rect">
+            <a:avLst/>
+          </a:prstGeom>
+          <a:noFill/>
+        </p:spPr>
+        <p:txBody>
+          <a:bodyPr wrap="square">
+            <a:spAutoFit/>
+          </a:bodyPr>
+          <a:lstStyle/>
+          <a:p>
+            <a:pPr algn="l">
+              <a:defRPr sz="1600" b="0">
+                <a:solidFill>
+                  <a:srgbClr val="FFFFFF"/>
+                </a:solidFill>
+                <a:latin typeface="Calibri"/>
+              </a:defRPr>
+            </a:pPr>
+            <a:r>
+              <a:t>RAID 更强</a:t>
+            </a:r>
+          </a:p>
+        </p:txBody>
+      </p:sp>
+      <p:sp>
+        <p:nvSpPr>
+          <p:cNvPr id="16" name="TextBox 15"/>
+          <p:cNvSpPr txBox="1"/>
+          <p:nvPr/>
+        </p:nvSpPr>
+        <p:spPr>
+          <a:xfrm>
+            <a:off x="914400" y="3291840"/>
+            <a:ext cx="2743200" cy="457200"/>
+          </a:xfrm>
+          <a:prstGeom prst="rect">
+            <a:avLst/>
+          </a:prstGeom>
+          <a:noFill/>
+        </p:spPr>
+        <p:txBody>
+          <a:bodyPr wrap="square">
+            <a:spAutoFit/>
+          </a:bodyPr>
+          <a:lstStyle/>
+          <a:p>
+            <a:pPr algn="l">
+              <a:defRPr sz="1600" b="0">
+                <a:solidFill>
+                  <a:srgbClr val="FFFFFF"/>
+                </a:solidFill>
+                <a:latin typeface="Calibri"/>
+              </a:defRPr>
+            </a:pPr>
+            <a:r>
+              <a:t>lexical_richness</a:t>
+            </a:r>
+          </a:p>
+        </p:txBody>
+      </p:sp>
+      <p:sp>
+        <p:nvSpPr>
+          <p:cNvPr id="17" name="TextBox 16"/>
+          <p:cNvSpPr txBox="1"/>
+          <p:nvPr/>
+        </p:nvSpPr>
+        <p:spPr>
+          <a:xfrm>
+            <a:off x="4114800" y="3291840"/>
+            <a:ext cx="1828800" cy="457200"/>
+          </a:xfrm>
+          <a:prstGeom prst="rect">
+            <a:avLst/>
+          </a:prstGeom>
+          <a:noFill/>
+        </p:spPr>
+        <p:txBody>
+          <a:bodyPr wrap="square">
+            <a:spAutoFit/>
+          </a:bodyPr>
+          <a:lstStyle/>
+          <a:p>
+            <a:pPr algn="l">
+              <a:defRPr sz="1600" b="0">
+                <a:solidFill>
+                  <a:srgbClr val="FFFFFF"/>
+                </a:solidFill>
+                <a:latin typeface="Calibri"/>
+              </a:defRPr>
+            </a:pPr>
+            <a:r>
+              <a:t>0.8861</a:t>
+            </a:r>
+          </a:p>
+        </p:txBody>
+      </p:sp>
+      <p:sp>
+        <p:nvSpPr>
+          <p:cNvPr id="18" name="TextBox 17"/>
+          <p:cNvSpPr txBox="1"/>
+          <p:nvPr/>
+        </p:nvSpPr>
+        <p:spPr>
+          <a:xfrm>
+            <a:off x="6400800" y="3291840"/>
+            <a:ext cx="1828800" cy="457200"/>
+          </a:xfrm>
+          <a:prstGeom prst="rect">
+            <a:avLst/>
+          </a:prstGeom>
+          <a:noFill/>
+        </p:spPr>
+        <p:txBody>
+          <a:bodyPr wrap="square">
+            <a:spAutoFit/>
+          </a:bodyPr>
+          <a:lstStyle/>
+          <a:p>
+            <a:pPr algn="l">
+              <a:defRPr sz="1600" b="0">
+                <a:solidFill>
+                  <a:srgbClr val="FFFFFF"/>
+                </a:solidFill>
+                <a:latin typeface="Calibri"/>
+              </a:defRPr>
+            </a:pPr>
+            <a:r>
+              <a:t>0.9367</a:t>
+            </a:r>
+          </a:p>
+        </p:txBody>
+      </p:sp>
+      <p:sp>
+        <p:nvSpPr>
+          <p:cNvPr id="19" name="TextBox 18"/>
+          <p:cNvSpPr txBox="1"/>
+          <p:nvPr/>
+        </p:nvSpPr>
+        <p:spPr>
+          <a:xfrm>
+            <a:off x="8686800" y="3291840"/>
+            <a:ext cx="2743200" cy="457200"/>
+          </a:xfrm>
+          <a:prstGeom prst="rect">
+            <a:avLst/>
+          </a:prstGeom>
+          <a:noFill/>
+        </p:spPr>
+        <p:txBody>
+          <a:bodyPr wrap="square">
+            <a:spAutoFit/>
+          </a:bodyPr>
+          <a:lstStyle/>
+          <a:p>
+            <a:pPr algn="l">
+              <a:defRPr sz="1600" b="0">
+                <a:solidFill>
+                  <a:srgbClr val="FFFFFF"/>
+                </a:solidFill>
+                <a:latin typeface="Calibri"/>
+              </a:defRPr>
+            </a:pPr>
+            <a:r>
+              <a:t>HC3 更强</a:t>
+            </a:r>
+          </a:p>
+        </p:txBody>
+      </p:sp>
+      <p:sp>
+        <p:nvSpPr>
+          <p:cNvPr id="20" name="TextBox 19"/>
+          <p:cNvSpPr txBox="1"/>
+          <p:nvPr/>
+        </p:nvSpPr>
+        <p:spPr>
+          <a:xfrm>
+            <a:off x="914400" y="3931920"/>
+            <a:ext cx="2743200" cy="457200"/>
+          </a:xfrm>
+          <a:prstGeom prst="rect">
+            <a:avLst/>
+          </a:prstGeom>
+          <a:noFill/>
+        </p:spPr>
+        <p:txBody>
+          <a:bodyPr wrap="square">
+            <a:spAutoFit/>
+          </a:bodyPr>
+          <a:lstStyle/>
+          <a:p>
+            <a:pPr algn="l">
+              <a:defRPr sz="1600" b="0">
+                <a:solidFill>
+                  <a:srgbClr val="FFFFFF"/>
+                </a:solidFill>
+                <a:latin typeface="Calibri"/>
+              </a:defRPr>
+            </a:pPr>
+            <a:r>
+              <a:t>readability</a:t>
+            </a:r>
+          </a:p>
+        </p:txBody>
+      </p:sp>
+      <p:sp>
+        <p:nvSpPr>
+          <p:cNvPr id="21" name="TextBox 20"/>
+          <p:cNvSpPr txBox="1"/>
+          <p:nvPr/>
+        </p:nvSpPr>
+        <p:spPr>
+          <a:xfrm>
+            <a:off x="4114800" y="3931920"/>
+            <a:ext cx="1828800" cy="457200"/>
+          </a:xfrm>
+          <a:prstGeom prst="rect">
+            <a:avLst/>
+          </a:prstGeom>
+          <a:noFill/>
+        </p:spPr>
+        <p:txBody>
+          <a:bodyPr wrap="square">
+            <a:spAutoFit/>
+          </a:bodyPr>
+          <a:lstStyle/>
+          <a:p>
+            <a:pPr algn="l">
+              <a:defRPr sz="1600" b="0">
+                <a:solidFill>
+                  <a:srgbClr val="FFFFFF"/>
+                </a:solidFill>
+                <a:latin typeface="Calibri"/>
+              </a:defRPr>
+            </a:pPr>
+            <a:r>
+              <a:t>0.8500</a:t>
+            </a:r>
+          </a:p>
+        </p:txBody>
+      </p:sp>
+      <p:sp>
+        <p:nvSpPr>
+          <p:cNvPr id="22" name="TextBox 21"/>
+          <p:cNvSpPr txBox="1"/>
+          <p:nvPr/>
+        </p:nvSpPr>
+        <p:spPr>
+          <a:xfrm>
+            <a:off x="6400800" y="3931920"/>
+            <a:ext cx="1828800" cy="457200"/>
+          </a:xfrm>
+          <a:prstGeom prst="rect">
+            <a:avLst/>
+          </a:prstGeom>
+          <a:noFill/>
+        </p:spPr>
+        <p:txBody>
+          <a:bodyPr wrap="square">
+            <a:spAutoFit/>
+          </a:bodyPr>
+          <a:lstStyle/>
+          <a:p>
+            <a:pPr algn="l">
+              <a:defRPr sz="1600" b="0">
+                <a:solidFill>
+                  <a:srgbClr val="FFFFFF"/>
+                </a:solidFill>
+                <a:latin typeface="Calibri"/>
+              </a:defRPr>
+            </a:pPr>
+            <a:r>
+              <a:t>0.9741</a:t>
+            </a:r>
+          </a:p>
+        </p:txBody>
+      </p:sp>
+      <p:sp>
+        <p:nvSpPr>
+          <p:cNvPr id="23" name="TextBox 22"/>
+          <p:cNvSpPr txBox="1"/>
+          <p:nvPr/>
+        </p:nvSpPr>
+        <p:spPr>
+          <a:xfrm>
+            <a:off x="8686800" y="3931920"/>
+            <a:ext cx="2743200" cy="457200"/>
+          </a:xfrm>
+          <a:prstGeom prst="rect">
+            <a:avLst/>
+          </a:prstGeom>
+          <a:noFill/>
+        </p:spPr>
+        <p:txBody>
+          <a:bodyPr wrap="square">
+            <a:spAutoFit/>
+          </a:bodyPr>
+          <a:lstStyle/>
+          <a:p>
+            <a:pPr algn="l">
+              <a:defRPr sz="1600" b="0">
+                <a:solidFill>
+                  <a:srgbClr val="FFFFFF"/>
+                </a:solidFill>
+                <a:latin typeface="Calibri"/>
+              </a:defRPr>
+            </a:pPr>
+            <a:r>
+              <a:t>HC3 远优</a:t>
+            </a:r>
+          </a:p>
+        </p:txBody>
+      </p:sp>
+      <p:sp>
+        <p:nvSpPr>
+          <p:cNvPr id="24" name="TextBox 23"/>
+          <p:cNvSpPr txBox="1"/>
+          <p:nvPr/>
+        </p:nvSpPr>
+        <p:spPr>
+          <a:xfrm>
+            <a:off x="914400" y="4572000"/>
+            <a:ext cx="2743200" cy="457200"/>
+          </a:xfrm>
+          <a:prstGeom prst="rect">
+            <a:avLst/>
+          </a:prstGeom>
+          <a:noFill/>
+        </p:spPr>
+        <p:txBody>
+          <a:bodyPr wrap="square">
+            <a:spAutoFit/>
+          </a:bodyPr>
+          <a:lstStyle/>
+          <a:p>
+            <a:pPr algn="l">
+              <a:defRPr sz="1600" b="0">
+                <a:solidFill>
+                  <a:srgbClr val="FF6B6B"/>
+                </a:solidFill>
+                <a:latin typeface="Calibri"/>
+              </a:defRPr>
+            </a:pPr>
+            <a:r>
+              <a:t>perplexity</a:t>
+            </a:r>
+          </a:p>
+        </p:txBody>
+      </p:sp>
+      <p:sp>
+        <p:nvSpPr>
+          <p:cNvPr id="25" name="TextBox 24"/>
+          <p:cNvSpPr txBox="1"/>
+          <p:nvPr/>
+        </p:nvSpPr>
+        <p:spPr>
+          <a:xfrm>
+            <a:off x="4114800" y="4572000"/>
+            <a:ext cx="1828800" cy="457200"/>
+          </a:xfrm>
+          <a:prstGeom prst="rect">
+            <a:avLst/>
+          </a:prstGeom>
+          <a:noFill/>
+        </p:spPr>
+        <p:txBody>
+          <a:bodyPr wrap="square">
+            <a:spAutoFit/>
+          </a:bodyPr>
+          <a:lstStyle/>
+          <a:p>
+            <a:pPr algn="l">
+              <a:defRPr sz="1600" b="0">
+                <a:solidFill>
+                  <a:srgbClr val="FF6B6B"/>
+                </a:solidFill>
+                <a:latin typeface="Calibri"/>
+              </a:defRPr>
+            </a:pPr>
+            <a:r>
+              <a:t>0.4920</a:t>
+            </a:r>
+          </a:p>
+        </p:txBody>
+      </p:sp>
+      <p:sp>
+        <p:nvSpPr>
+          <p:cNvPr id="26" name="TextBox 25"/>
+          <p:cNvSpPr txBox="1"/>
+          <p:nvPr/>
+        </p:nvSpPr>
+        <p:spPr>
+          <a:xfrm>
+            <a:off x="6400800" y="4572000"/>
+            <a:ext cx="1828800" cy="457200"/>
+          </a:xfrm>
+          <a:prstGeom prst="rect">
+            <a:avLst/>
+          </a:prstGeom>
+          <a:noFill/>
+        </p:spPr>
+        <p:txBody>
+          <a:bodyPr wrap="square">
+            <a:spAutoFit/>
+          </a:bodyPr>
+          <a:lstStyle/>
+          <a:p>
+            <a:pPr algn="l">
+              <a:defRPr sz="1600" b="0">
+                <a:solidFill>
+                  <a:srgbClr val="FF6B6B"/>
+                </a:solidFill>
+                <a:latin typeface="Calibri"/>
+              </a:defRPr>
+            </a:pPr>
+            <a:r>
+              <a:t>0.9912</a:t>
+            </a:r>
+          </a:p>
+        </p:txBody>
+      </p:sp>
+      <p:sp>
+        <p:nvSpPr>
+          <p:cNvPr id="27" name="TextBox 26"/>
+          <p:cNvSpPr txBox="1"/>
+          <p:nvPr/>
+        </p:nvSpPr>
+        <p:spPr>
+          <a:xfrm>
+            <a:off x="8686800" y="4572000"/>
+            <a:ext cx="2743200" cy="457200"/>
+          </a:xfrm>
+          <a:prstGeom prst="rect">
+            <a:avLst/>
+          </a:prstGeom>
+          <a:noFill/>
+        </p:spPr>
+        <p:txBody>
+          <a:bodyPr wrap="square">
+            <a:spAutoFit/>
+          </a:bodyPr>
+          <a:lstStyle/>
+          <a:p>
+            <a:pPr algn="l">
+              <a:defRPr sz="1600" b="0">
+                <a:solidFill>
+                  <a:srgbClr val="FF6B6B"/>
+                </a:solidFill>
+                <a:latin typeface="Calibri"/>
+              </a:defRPr>
+            </a:pPr>
+            <a:r>
+              <a:t>完全反转!</a:t>
+            </a:r>
+          </a:p>
+        </p:txBody>
+      </p:sp>
+      <p:sp>
+        <p:nvSpPr>
+          <p:cNvPr id="28" name="TextBox 27"/>
+          <p:cNvSpPr txBox="1"/>
+          <p:nvPr/>
+        </p:nvSpPr>
+        <p:spPr>
+          <a:xfrm>
+            <a:off x="914400" y="5212080"/>
+            <a:ext cx="2743200" cy="457200"/>
+          </a:xfrm>
+          <a:prstGeom prst="rect">
+            <a:avLst/>
+          </a:prstGeom>
+          <a:noFill/>
+        </p:spPr>
+        <p:txBody>
+          <a:bodyPr wrap="square">
+            <a:spAutoFit/>
+          </a:bodyPr>
+          <a:lstStyle/>
+          <a:p>
+            <a:pPr algn="l">
+              <a:defRPr sz="1600" b="0">
+                <a:solidFill>
+                  <a:srgbClr val="FFFFFF"/>
+                </a:solidFill>
+                <a:latin typeface="Calibri"/>
+              </a:defRPr>
+            </a:pPr>
+            <a:r>
+              <a:t>embedding_pca</a:t>
+            </a:r>
+          </a:p>
+        </p:txBody>
+      </p:sp>
+      <p:sp>
+        <p:nvSpPr>
+          <p:cNvPr id="29" name="TextBox 28"/>
+          <p:cNvSpPr txBox="1"/>
+          <p:nvPr/>
+        </p:nvSpPr>
+        <p:spPr>
+          <a:xfrm>
+            <a:off x="4114800" y="5212080"/>
+            <a:ext cx="1828800" cy="457200"/>
+          </a:xfrm>
+          <a:prstGeom prst="rect">
+            <a:avLst/>
+          </a:prstGeom>
+          <a:noFill/>
+        </p:spPr>
+        <p:txBody>
+          <a:bodyPr wrap="square">
+            <a:spAutoFit/>
+          </a:bodyPr>
+          <a:lstStyle/>
+          <a:p>
+            <a:pPr algn="l">
+              <a:defRPr sz="1600" b="0">
+                <a:solidFill>
+                  <a:srgbClr val="FFFFFF"/>
+                </a:solidFill>
+                <a:latin typeface="Calibri"/>
+              </a:defRPr>
+            </a:pPr>
+            <a:r>
+              <a:t>0.9357</a:t>
+            </a:r>
+          </a:p>
+        </p:txBody>
+      </p:sp>
+      <p:sp>
+        <p:nvSpPr>
+          <p:cNvPr id="30" name="TextBox 29"/>
+          <p:cNvSpPr txBox="1"/>
+          <p:nvPr/>
+        </p:nvSpPr>
+        <p:spPr>
+          <a:xfrm>
+            <a:off x="6400800" y="5212080"/>
+            <a:ext cx="1828800" cy="457200"/>
+          </a:xfrm>
+          <a:prstGeom prst="rect">
+            <a:avLst/>
+          </a:prstGeom>
+          <a:noFill/>
+        </p:spPr>
+        <p:txBody>
+          <a:bodyPr wrap="square">
+            <a:spAutoFit/>
+          </a:bodyPr>
+          <a:lstStyle/>
+          <a:p>
+            <a:pPr algn="l">
+              <a:defRPr sz="1600" b="0">
+                <a:solidFill>
+                  <a:srgbClr val="FFFFFF"/>
+                </a:solidFill>
+                <a:latin typeface="Calibri"/>
+              </a:defRPr>
+            </a:pPr>
+            <a:r>
+              <a:t>0.8972</a:t>
+            </a:r>
+          </a:p>
+        </p:txBody>
+      </p:sp>
+      <p:sp>
+        <p:nvSpPr>
+          <p:cNvPr id="31" name="TextBox 30"/>
+          <p:cNvSpPr txBox="1"/>
+          <p:nvPr/>
+        </p:nvSpPr>
+        <p:spPr>
+          <a:xfrm>
+            <a:off x="8686800" y="5212080"/>
+            <a:ext cx="2743200" cy="457200"/>
+          </a:xfrm>
+          <a:prstGeom prst="rect">
+            <a:avLst/>
+          </a:prstGeom>
+          <a:noFill/>
+        </p:spPr>
+        <p:txBody>
+          <a:bodyPr wrap="square">
+            <a:spAutoFit/>
+          </a:bodyPr>
+          <a:lstStyle/>
+          <a:p>
+            <a:pPr algn="l">
+              <a:defRPr sz="1600" b="0">
+                <a:solidFill>
+                  <a:srgbClr val="FFFFFF"/>
+                </a:solidFill>
+                <a:latin typeface="Calibri"/>
+              </a:defRPr>
+            </a:pPr>
+            <a:r>
+              <a:t>接近</a:t>
+            </a:r>
+          </a:p>
+        </p:txBody>
+      </p:sp>
+      <p:sp>
+        <p:nvSpPr>
+          <p:cNvPr id="32" name="TextBox 31"/>
+          <p:cNvSpPr txBox="1"/>
+          <p:nvPr/>
+        </p:nvSpPr>
+        <p:spPr>
+          <a:xfrm>
+            <a:off x="731520" y="5760720"/>
+            <a:ext cx="10515600" cy="731520"/>
+          </a:xfrm>
+          <a:prstGeom prst="rect">
+            <a:avLst/>
+          </a:prstGeom>
+          <a:noFill/>
+        </p:spPr>
+        <p:txBody>
+          <a:bodyPr wrap="square">
+            <a:spAutoFit/>
+          </a:bodyPr>
+          <a:lstStyle/>
+          <a:p>
+            <a:pPr algn="ctr">
+              <a:defRPr sz="1600" b="0">
+                <a:solidFill>
+                  <a:srgbClr val="00D2FF"/>
+                </a:solidFill>
+                <a:latin typeface="Calibri"/>
+              </a:defRPr>
+            </a:pPr>
+            <a:r>
+              <a:t>核心启示: 多模型检测不能依赖单一语言模型的困惑度 — 需要模型无关的统计特征作为稳定基线</a:t>
             </a:r>
           </a:p>
         </p:txBody>
@@ -11304,7 +11669,7 @@
               </a:defRPr>
             </a:pPr>
             <a:r>
-              <a:t>未来方向与部署建议</a:t>
+              <a:t>结论</a:t>
             </a:r>
           </a:p>
         </p:txBody>
@@ -11361,311 +11726,244 @@
         <p:spPr>
           <a:xfrm>
             <a:off x="731520" y="1371600"/>
-            <a:ext cx="5029200" cy="548640"/>
-          </a:xfrm>
-          <a:prstGeom prst="rect">
-            <a:avLst/>
-          </a:prstGeom>
-          <a:noFill/>
-        </p:spPr>
-        <p:txBody>
-          <a:bodyPr wrap="square">
-            <a:spAutoFit/>
-          </a:bodyPr>
-          <a:lstStyle/>
-          <a:p>
-            <a:pPr algn="l">
-              <a:defRPr sz="2200" b="1">
-                <a:solidFill>
-                  <a:srgbClr val="4ECB71"/>
-                </a:solidFill>
-                <a:latin typeface="Calibri"/>
-              </a:defRPr>
-            </a:pPr>
-            <a:r>
-              <a:t>未来工作</a:t>
-            </a:r>
-          </a:p>
-        </p:txBody>
-      </p:sp>
-      <p:sp>
-        <p:nvSpPr>
-          <p:cNvPr id="5" name="TextBox 4"/>
-          <p:cNvSpPr txBox="1"/>
-          <p:nvPr/>
-        </p:nvSpPr>
-        <p:spPr>
-          <a:xfrm>
-            <a:off x="731520" y="2011680"/>
-            <a:ext cx="5029200" cy="2743200"/>
-          </a:xfrm>
-          <a:prstGeom prst="rect">
-            <a:avLst/>
-          </a:prstGeom>
-          <a:noFill/>
-        </p:spPr>
-        <p:txBody>
-          <a:bodyPr wrap="square">
-            <a:spAutoFit/>
-          </a:bodyPr>
-          <a:lstStyle/>
-          <a:p>
-            <a:pPr>
-              <a:spcAft>
-                <a:spcPts val="960"/>
-              </a:spcAft>
-              <a:defRPr sz="1600">
-                <a:solidFill>
-                  <a:srgbClr val="E0E0E0"/>
-                </a:solidFill>
-                <a:latin typeface="Calibri"/>
-              </a:defRPr>
-            </a:pPr>
-            <a:r>
-              <a:t>引入语义相似度特征防御释义攻击</a:t>
-            </a:r>
-          </a:p>
-          <a:p>
-            <a:pPr>
-              <a:spcAft>
-                <a:spcPts val="960"/>
-              </a:spcAft>
-              <a:defRPr sz="1600">
-                <a:solidFill>
-                  <a:srgbClr val="E0E0E0"/>
-                </a:solidFill>
-                <a:latin typeface="Calibri"/>
-              </a:defRPr>
-            </a:pPr>
-            <a:r>
-              <a:t>多观察者模型集成 (Mistral + Qwen + Llama)</a:t>
-            </a:r>
-          </a:p>
-          <a:p>
-            <a:pPr>
-              <a:spcAft>
-                <a:spcPts val="960"/>
-              </a:spcAft>
-              <a:defRPr sz="1600">
-                <a:solidFill>
-                  <a:srgbClr val="E0E0E0"/>
-                </a:solidFill>
-                <a:latin typeface="Calibri"/>
-              </a:defRPr>
-            </a:pPr>
-            <a:r>
-              <a:t>动态特征选择: 根据文本领域自动调整</a:t>
-            </a:r>
-          </a:p>
-          <a:p>
-            <a:pPr>
-              <a:spcAft>
-                <a:spcPts val="960"/>
-              </a:spcAft>
-              <a:defRPr sz="1600">
-                <a:solidFill>
-                  <a:srgbClr val="E0E0E0"/>
-                </a:solidFill>
-                <a:latin typeface="Calibri"/>
-              </a:defRPr>
-            </a:pPr>
-            <a:r>
-              <a:t>探索更多 token 统计: burstiness, curvature</a:t>
-            </a:r>
-          </a:p>
-          <a:p>
-            <a:pPr>
-              <a:spcAft>
-                <a:spcPts val="960"/>
-              </a:spcAft>
-              <a:defRPr sz="1600">
-                <a:solidFill>
-                  <a:srgbClr val="E0E0E0"/>
-                </a:solidFill>
-                <a:latin typeface="Calibri"/>
-              </a:defRPr>
-            </a:pPr>
-            <a:r>
-              <a:t>在 SemEval/TuringBench 全量数据验证</a:t>
-            </a:r>
-          </a:p>
-        </p:txBody>
-      </p:sp>
-      <p:sp>
-        <p:nvSpPr>
-          <p:cNvPr id="6" name="TextBox 5"/>
-          <p:cNvSpPr txBox="1"/>
-          <p:nvPr/>
-        </p:nvSpPr>
-        <p:spPr>
-          <a:xfrm>
-            <a:off x="6400800" y="1371600"/>
-            <a:ext cx="5029200" cy="548640"/>
-          </a:xfrm>
-          <a:prstGeom prst="rect">
-            <a:avLst/>
-          </a:prstGeom>
-          <a:noFill/>
-        </p:spPr>
-        <p:txBody>
-          <a:bodyPr wrap="square">
-            <a:spAutoFit/>
-          </a:bodyPr>
-          <a:lstStyle/>
-          <a:p>
-            <a:pPr algn="l">
-              <a:defRPr sz="2200" b="1">
-                <a:solidFill>
-                  <a:srgbClr val="FF6B6B"/>
-                </a:solidFill>
-                <a:latin typeface="Calibri"/>
-              </a:defRPr>
-            </a:pPr>
-            <a:r>
-              <a:t>部署建议</a:t>
-            </a:r>
-          </a:p>
-        </p:txBody>
-      </p:sp>
-      <p:sp>
-        <p:nvSpPr>
-          <p:cNvPr id="7" name="TextBox 6"/>
-          <p:cNvSpPr txBox="1"/>
-          <p:nvPr/>
-        </p:nvSpPr>
-        <p:spPr>
-          <a:xfrm>
-            <a:off x="6400800" y="2011680"/>
-            <a:ext cx="5029200" cy="2743200"/>
-          </a:xfrm>
-          <a:prstGeom prst="rect">
-            <a:avLst/>
-          </a:prstGeom>
-          <a:noFill/>
-        </p:spPr>
-        <p:txBody>
-          <a:bodyPr wrap="square">
-            <a:spAutoFit/>
-          </a:bodyPr>
-          <a:lstStyle/>
-          <a:p>
-            <a:pPr>
-              <a:spcAft>
-                <a:spcPts val="960"/>
-              </a:spcAft>
-              <a:defRPr sz="1600">
-                <a:solidFill>
-                  <a:srgbClr val="E0E0E0"/>
-                </a:solidFill>
-                <a:latin typeface="Calibri"/>
-              </a:defRPr>
-            </a:pPr>
-            <a:r>
-              <a:t>以模型无关的手工特征作为稳定基线</a:t>
-            </a:r>
-          </a:p>
-          <a:p>
-            <a:pPr>
-              <a:spcAft>
-                <a:spcPts val="960"/>
-              </a:spcAft>
-              <a:defRPr sz="1600">
-                <a:solidFill>
-                  <a:srgbClr val="E0E0E0"/>
-                </a:solidFill>
-                <a:latin typeface="Calibri"/>
-              </a:defRPr>
-            </a:pPr>
-            <a:r>
-              <a:t>辅以同代 LLM token 特征覆盖新生成器</a:t>
-            </a:r>
-          </a:p>
-          <a:p>
-            <a:pPr>
-              <a:spcAft>
-                <a:spcPts val="960"/>
-              </a:spcAft>
-              <a:defRPr sz="1600">
-                <a:solidFill>
-                  <a:srgbClr val="E0E0E0"/>
-                </a:solidFill>
-                <a:latin typeface="Calibri"/>
-              </a:defRPr>
-            </a:pPr>
-            <a:r>
-              <a:t>观察者模型需要定期更新 (半年一次)</a:t>
-            </a:r>
-          </a:p>
-          <a:p>
-            <a:pPr>
-              <a:spcAft>
-                <a:spcPts val="960"/>
-              </a:spcAft>
-              <a:defRPr sz="1600">
-                <a:solidFill>
-                  <a:srgbClr val="E0E0E0"/>
-                </a:solidFill>
-                <a:latin typeface="Calibri"/>
-              </a:defRPr>
-            </a:pPr>
-            <a:r>
-              <a:t>跨域部署需注意领域差异 (诗歌 vs 新闻)</a:t>
-            </a:r>
-          </a:p>
-          <a:p>
-            <a:pPr>
-              <a:spcAft>
-                <a:spcPts val="960"/>
-              </a:spcAft>
-              <a:defRPr sz="1600">
-                <a:solidFill>
-                  <a:srgbClr val="E0E0E0"/>
-                </a:solidFill>
-                <a:latin typeface="Calibri"/>
-              </a:defRPr>
-            </a:pPr>
-            <a:r>
-              <a:t>提供 SHAP 解释以增强用户信任</a:t>
-            </a:r>
-          </a:p>
-        </p:txBody>
-      </p:sp>
-      <p:sp>
-        <p:nvSpPr>
-          <p:cNvPr id="8" name="TextBox 7"/>
-          <p:cNvSpPr txBox="1"/>
-          <p:nvPr/>
-        </p:nvSpPr>
-        <p:spPr>
-          <a:xfrm>
-            <a:off x="731520" y="5029200"/>
-            <a:ext cx="10515600" cy="1097280"/>
-          </a:xfrm>
-          <a:prstGeom prst="rect">
-            <a:avLst/>
-          </a:prstGeom>
-          <a:noFill/>
-        </p:spPr>
-        <p:txBody>
-          <a:bodyPr wrap="square">
-            <a:spAutoFit/>
-          </a:bodyPr>
-          <a:lstStyle/>
-          <a:p>
-            <a:pPr algn="ctr">
-              <a:defRPr sz="2000" b="0">
-                <a:solidFill>
-                  <a:srgbClr val="00D2FF"/>
-                </a:solidFill>
-                <a:latin typeface="Calibri"/>
-              </a:defRPr>
-            </a:pPr>
-            <a:r>
-              <a:t>"手工特征看文本的外表，Token 概率特征看文本在 AI 眼中的内在。</a:t>
-            </a:r>
-            <a:br/>
-            <a:r>
-              <a:t>当一个视角被欺骗时，另一个视角往往能看穿。这就是 120 维组合的力量。"</a:t>
+            <a:ext cx="10058400" cy="5029200"/>
+          </a:xfrm>
+          <a:prstGeom prst="rect">
+            <a:avLst/>
+          </a:prstGeom>
+          <a:noFill/>
+        </p:spPr>
+        <p:txBody>
+          <a:bodyPr wrap="square">
+            <a:spAutoFit/>
+          </a:bodyPr>
+          <a:lstStyle/>
+          <a:p>
+            <a:pPr>
+              <a:spcAft>
+                <a:spcPts val="720"/>
+              </a:spcAft>
+              <a:defRPr sz="1800">
+                <a:solidFill>
+                  <a:srgbClr val="E0E0E0"/>
+                </a:solidFill>
+                <a:latin typeface="Calibri"/>
+              </a:defRPr>
+            </a:pPr>
+            <a:r>
+              <a:t>1. 三层 118 维特征体系在 RAID 上达 AUC 0.9992</a:t>
+            </a:r>
+          </a:p>
+          <a:p>
+            <a:pPr>
+              <a:spcAft>
+                <a:spcPts val="720"/>
+              </a:spcAft>
+              <a:defRPr sz="1800">
+                <a:solidFill>
+                  <a:srgbClr val="E0E0E0"/>
+                </a:solidFill>
+                <a:latin typeface="Calibri"/>
+              </a:defRPr>
+            </a:pPr>
+            <a:r>
+              <a:t>    纯统计 + 模型衍生 + Token 概率, 完全可解释</a:t>
+            </a:r>
+          </a:p>
+          <a:p>
+            <a:pPr>
+              <a:spcAft>
+                <a:spcPts val="720"/>
+              </a:spcAft>
+              <a:defRPr sz="1800">
+                <a:solidFill>
+                  <a:srgbClr val="E0E0E0"/>
+                </a:solidFill>
+                <a:latin typeface="Calibri"/>
+              </a:defRPr>
+            </a:pPr>
+          </a:p>
+          <a:p>
+            <a:pPr>
+              <a:spcAft>
+                <a:spcPts val="720"/>
+              </a:spcAft>
+              <a:defRPr sz="1800">
+                <a:solidFill>
+                  <a:srgbClr val="E0E0E0"/>
+                </a:solidFill>
+                <a:latin typeface="Calibri"/>
+              </a:defRPr>
+            </a:pPr>
+            <a:r>
+              <a:t>2. 不同层在不同场景各有"保质期"</a:t>
+            </a:r>
+          </a:p>
+          <a:p>
+            <a:pPr>
+              <a:spcAft>
+                <a:spcPts val="720"/>
+              </a:spcAft>
+              <a:defRPr sz="1800">
+                <a:solidFill>
+                  <a:srgbClr val="E0E0E0"/>
+                </a:solidFill>
+                <a:latin typeface="Calibri"/>
+              </a:defRPr>
+            </a:pPr>
+            <a:r>
+              <a:t>    纯统计: 老 AI 强, 新 AI 失效 (SemEval ~0.52)</a:t>
+            </a:r>
+          </a:p>
+          <a:p>
+            <a:pPr>
+              <a:spcAft>
+                <a:spcPts val="720"/>
+              </a:spcAft>
+              <a:defRPr sz="1800">
+                <a:solidFill>
+                  <a:srgbClr val="E0E0E0"/>
+                </a:solidFill>
+                <a:latin typeface="Calibri"/>
+              </a:defRPr>
+            </a:pPr>
+            <a:r>
+              <a:t>    模型衍生: 依赖参考模型, 跨系失效 (RAID perplexity 0.49)</a:t>
+            </a:r>
+          </a:p>
+          <a:p>
+            <a:pPr>
+              <a:spcAft>
+                <a:spcPts val="720"/>
+              </a:spcAft>
+              <a:defRPr sz="1800">
+                <a:solidFill>
+                  <a:srgbClr val="E0E0E0"/>
+                </a:solidFill>
+                <a:latin typeface="Calibri"/>
+              </a:defRPr>
+            </a:pPr>
+            <a:r>
+              <a:t>    Token: 只认同代 AI (TuringBench ~0.52)</a:t>
+            </a:r>
+          </a:p>
+          <a:p>
+            <a:pPr>
+              <a:spcAft>
+                <a:spcPts val="720"/>
+              </a:spcAft>
+              <a:defRPr sz="1800">
+                <a:solidFill>
+                  <a:srgbClr val="E0E0E0"/>
+                </a:solidFill>
+                <a:latin typeface="Calibri"/>
+              </a:defRPr>
+            </a:pPr>
+          </a:p>
+          <a:p>
+            <a:pPr>
+              <a:spcAft>
+                <a:spcPts val="720"/>
+              </a:spcAft>
+              <a:defRPr sz="1800">
+                <a:solidFill>
+                  <a:srgbClr val="E0E0E0"/>
+                </a:solidFill>
+                <a:latin typeface="Calibri"/>
+              </a:defRPr>
+            </a:pPr>
+            <a:r>
+              <a:t>3. 互补效果取决于信号强度</a:t>
+            </a:r>
+          </a:p>
+          <a:p>
+            <a:pPr>
+              <a:spcAft>
+                <a:spcPts val="720"/>
+              </a:spcAft>
+              <a:defRPr sz="1800">
+                <a:solidFill>
+                  <a:srgbClr val="E0E0E0"/>
+                </a:solidFill>
+                <a:latin typeface="Calibri"/>
+              </a:defRPr>
+            </a:pPr>
+            <a:r>
+              <a:t>    RAID: stat+token → AUC +0.005 (两侧有信号)</a:t>
+            </a:r>
+          </a:p>
+          <a:p>
+            <a:pPr>
+              <a:spcAft>
+                <a:spcPts val="720"/>
+              </a:spcAft>
+              <a:defRPr sz="1800">
+                <a:solidFill>
+                  <a:srgbClr val="E0E0E0"/>
+                </a:solidFill>
+                <a:latin typeface="Calibri"/>
+              </a:defRPr>
+            </a:pPr>
+            <a:r>
+              <a:t>    SemEval: model+token (0.961) &gt; all (0.847)</a:t>
+            </a:r>
+          </a:p>
+          <a:p>
+            <a:pPr>
+              <a:spcAft>
+                <a:spcPts val="720"/>
+              </a:spcAft>
+              <a:defRPr sz="1800">
+                <a:solidFill>
+                  <a:srgbClr val="E0E0E0"/>
+                </a:solidFill>
+                <a:latin typeface="Calibri"/>
+              </a:defRPr>
+            </a:pPr>
+          </a:p>
+          <a:p>
+            <a:pPr>
+              <a:spcAft>
+                <a:spcPts val="720"/>
+              </a:spcAft>
+              <a:defRPr sz="1800">
+                <a:solidFill>
+                  <a:srgbClr val="E0E0E0"/>
+                </a:solidFill>
+                <a:latin typeface="Calibri"/>
+              </a:defRPr>
+            </a:pPr>
+            <a:r>
+              <a:t>4. 统计特征对 10/11 种对抗攻击天然鲁棒</a:t>
+            </a:r>
+          </a:p>
+          <a:p>
+            <a:pPr>
+              <a:spcAft>
+                <a:spcPts val="720"/>
+              </a:spcAft>
+              <a:defRPr sz="1800">
+                <a:solidFill>
+                  <a:srgbClr val="E0E0E0"/>
+                </a:solidFill>
+                <a:latin typeface="Calibri"/>
+              </a:defRPr>
+            </a:pPr>
+          </a:p>
+          <a:p>
+            <a:pPr>
+              <a:spcAft>
+                <a:spcPts val="720"/>
+              </a:spcAft>
+              <a:defRPr sz="1800">
+                <a:solidFill>
+                  <a:srgbClr val="E0E0E0"/>
+                </a:solidFill>
+                <a:latin typeface="Calibri"/>
+              </a:defRPr>
+            </a:pPr>
+            <a:r>
+              <a:t>5. Auto-Filter 基于组级 AUC 自动检测噪声</a:t>
             </a:r>
           </a:p>
         </p:txBody>
@@ -11679,6 +11977,429 @@
 </file>
 
 <file path=ppt/slides/slide24.xml><?xml version="1.0" encoding="utf-8"?>
+<p:sld xmlns:a="http://schemas.openxmlformats.org/drawingml/2006/main" xmlns:p="http://schemas.openxmlformats.org/presentationml/2006/main" xmlns:r="http://schemas.openxmlformats.org/officeDocument/2006/relationships">
+  <p:cSld>
+    <p:bg>
+      <p:bgPr>
+        <a:solidFill>
+          <a:srgbClr val="1A1A2E"/>
+        </a:solidFill>
+        <a:effectLst/>
+      </p:bgPr>
+    </p:bg>
+    <p:spTree>
+      <p:nvGrpSpPr>
+        <p:cNvPr id="1" name=""/>
+        <p:cNvGrpSpPr/>
+        <p:nvPr/>
+      </p:nvGrpSpPr>
+      <p:grpSpPr/>
+      <p:sp>
+        <p:nvSpPr>
+          <p:cNvPr id="2" name="TextBox 1"/>
+          <p:cNvSpPr txBox="1"/>
+          <p:nvPr/>
+        </p:nvSpPr>
+        <p:spPr>
+          <a:xfrm>
+            <a:off x="731520" y="365760"/>
+            <a:ext cx="9144000" cy="731520"/>
+          </a:xfrm>
+          <a:prstGeom prst="rect">
+            <a:avLst/>
+          </a:prstGeom>
+          <a:noFill/>
+        </p:spPr>
+        <p:txBody>
+          <a:bodyPr wrap="square">
+            <a:spAutoFit/>
+          </a:bodyPr>
+          <a:lstStyle/>
+          <a:p>
+            <a:pPr algn="l">
+              <a:defRPr sz="3600" b="1">
+                <a:solidFill>
+                  <a:srgbClr val="00D2FF"/>
+                </a:solidFill>
+                <a:latin typeface="Calibri"/>
+              </a:defRPr>
+            </a:pPr>
+            <a:r>
+              <a:t>未来方向与部署建议</a:t>
+            </a:r>
+          </a:p>
+        </p:txBody>
+      </p:sp>
+      <p:sp>
+        <p:nvSpPr>
+          <p:cNvPr id="3" name="Rectangle 2"/>
+          <p:cNvSpPr/>
+          <p:nvPr/>
+        </p:nvSpPr>
+        <p:spPr>
+          <a:xfrm>
+            <a:off x="731520" y="1005840"/>
+            <a:ext cx="3657600" cy="38100"/>
+          </a:xfrm>
+          <a:prstGeom prst="rect">
+            <a:avLst/>
+          </a:prstGeom>
+          <a:solidFill>
+            <a:srgbClr val="00D2FF"/>
+          </a:solidFill>
+          <a:ln>
+            <a:noFill/>
+          </a:ln>
+        </p:spPr>
+        <p:style>
+          <a:lnRef idx="1">
+            <a:schemeClr val="accent1"/>
+          </a:lnRef>
+          <a:fillRef idx="3">
+            <a:schemeClr val="accent1"/>
+          </a:fillRef>
+          <a:effectRef idx="2">
+            <a:schemeClr val="accent1"/>
+          </a:effectRef>
+          <a:fontRef idx="minor">
+            <a:schemeClr val="lt1"/>
+          </a:fontRef>
+        </p:style>
+        <p:txBody>
+          <a:bodyPr rtlCol="0" anchor="ctr"/>
+          <a:lstStyle/>
+          <a:p>
+            <a:pPr algn="ctr"/>
+          </a:p>
+        </p:txBody>
+      </p:sp>
+      <p:sp>
+        <p:nvSpPr>
+          <p:cNvPr id="4" name="TextBox 3"/>
+          <p:cNvSpPr txBox="1"/>
+          <p:nvPr/>
+        </p:nvSpPr>
+        <p:spPr>
+          <a:xfrm>
+            <a:off x="731520" y="1371600"/>
+            <a:ext cx="5029200" cy="548640"/>
+          </a:xfrm>
+          <a:prstGeom prst="rect">
+            <a:avLst/>
+          </a:prstGeom>
+          <a:noFill/>
+        </p:spPr>
+        <p:txBody>
+          <a:bodyPr wrap="square">
+            <a:spAutoFit/>
+          </a:bodyPr>
+          <a:lstStyle/>
+          <a:p>
+            <a:pPr algn="l">
+              <a:defRPr sz="2200" b="1">
+                <a:solidFill>
+                  <a:srgbClr val="4ECB71"/>
+                </a:solidFill>
+                <a:latin typeface="Calibri"/>
+              </a:defRPr>
+            </a:pPr>
+            <a:r>
+              <a:t>未来工作</a:t>
+            </a:r>
+          </a:p>
+        </p:txBody>
+      </p:sp>
+      <p:sp>
+        <p:nvSpPr>
+          <p:cNvPr id="5" name="TextBox 4"/>
+          <p:cNvSpPr txBox="1"/>
+          <p:nvPr/>
+        </p:nvSpPr>
+        <p:spPr>
+          <a:xfrm>
+            <a:off x="731520" y="2011680"/>
+            <a:ext cx="5029200" cy="2743200"/>
+          </a:xfrm>
+          <a:prstGeom prst="rect">
+            <a:avLst/>
+          </a:prstGeom>
+          <a:noFill/>
+        </p:spPr>
+        <p:txBody>
+          <a:bodyPr wrap="square">
+            <a:spAutoFit/>
+          </a:bodyPr>
+          <a:lstStyle/>
+          <a:p>
+            <a:pPr>
+              <a:spcAft>
+                <a:spcPts val="960"/>
+              </a:spcAft>
+              <a:defRPr sz="1600">
+                <a:solidFill>
+                  <a:srgbClr val="E0E0E0"/>
+                </a:solidFill>
+                <a:latin typeface="Calibri"/>
+              </a:defRPr>
+            </a:pPr>
+            <a:r>
+              <a:t>引入语义相似度特征防御释义攻击</a:t>
+            </a:r>
+          </a:p>
+          <a:p>
+            <a:pPr>
+              <a:spcAft>
+                <a:spcPts val="960"/>
+              </a:spcAft>
+              <a:defRPr sz="1600">
+                <a:solidFill>
+                  <a:srgbClr val="E0E0E0"/>
+                </a:solidFill>
+                <a:latin typeface="Calibri"/>
+              </a:defRPr>
+            </a:pPr>
+            <a:r>
+              <a:t>多观察者模型集成 (Mistral + Qwen + Llama)</a:t>
+            </a:r>
+          </a:p>
+          <a:p>
+            <a:pPr>
+              <a:spcAft>
+                <a:spcPts val="960"/>
+              </a:spcAft>
+              <a:defRPr sz="1600">
+                <a:solidFill>
+                  <a:srgbClr val="E0E0E0"/>
+                </a:solidFill>
+                <a:latin typeface="Calibri"/>
+              </a:defRPr>
+            </a:pPr>
+            <a:r>
+              <a:t>动态特征选择: 根据文本领域自动调整</a:t>
+            </a:r>
+          </a:p>
+          <a:p>
+            <a:pPr>
+              <a:spcAft>
+                <a:spcPts val="960"/>
+              </a:spcAft>
+              <a:defRPr sz="1600">
+                <a:solidFill>
+                  <a:srgbClr val="E0E0E0"/>
+                </a:solidFill>
+                <a:latin typeface="Calibri"/>
+              </a:defRPr>
+            </a:pPr>
+            <a:r>
+              <a:t>探索更多 token 统计: burstiness, curvature</a:t>
+            </a:r>
+          </a:p>
+          <a:p>
+            <a:pPr>
+              <a:spcAft>
+                <a:spcPts val="960"/>
+              </a:spcAft>
+              <a:defRPr sz="1600">
+                <a:solidFill>
+                  <a:srgbClr val="E0E0E0"/>
+                </a:solidFill>
+                <a:latin typeface="Calibri"/>
+              </a:defRPr>
+            </a:pPr>
+            <a:r>
+              <a:t>在 SemEval/TuringBench 全量数据验证</a:t>
+            </a:r>
+          </a:p>
+        </p:txBody>
+      </p:sp>
+      <p:sp>
+        <p:nvSpPr>
+          <p:cNvPr id="6" name="TextBox 5"/>
+          <p:cNvSpPr txBox="1"/>
+          <p:nvPr/>
+        </p:nvSpPr>
+        <p:spPr>
+          <a:xfrm>
+            <a:off x="6400800" y="1371600"/>
+            <a:ext cx="5029200" cy="548640"/>
+          </a:xfrm>
+          <a:prstGeom prst="rect">
+            <a:avLst/>
+          </a:prstGeom>
+          <a:noFill/>
+        </p:spPr>
+        <p:txBody>
+          <a:bodyPr wrap="square">
+            <a:spAutoFit/>
+          </a:bodyPr>
+          <a:lstStyle/>
+          <a:p>
+            <a:pPr algn="l">
+              <a:defRPr sz="2200" b="1">
+                <a:solidFill>
+                  <a:srgbClr val="FF6B6B"/>
+                </a:solidFill>
+                <a:latin typeface="Calibri"/>
+              </a:defRPr>
+            </a:pPr>
+            <a:r>
+              <a:t>部署建议</a:t>
+            </a:r>
+          </a:p>
+        </p:txBody>
+      </p:sp>
+      <p:sp>
+        <p:nvSpPr>
+          <p:cNvPr id="7" name="TextBox 6"/>
+          <p:cNvSpPr txBox="1"/>
+          <p:nvPr/>
+        </p:nvSpPr>
+        <p:spPr>
+          <a:xfrm>
+            <a:off x="6400800" y="2011680"/>
+            <a:ext cx="5029200" cy="2743200"/>
+          </a:xfrm>
+          <a:prstGeom prst="rect">
+            <a:avLst/>
+          </a:prstGeom>
+          <a:noFill/>
+        </p:spPr>
+        <p:txBody>
+          <a:bodyPr wrap="square">
+            <a:spAutoFit/>
+          </a:bodyPr>
+          <a:lstStyle/>
+          <a:p>
+            <a:pPr>
+              <a:spcAft>
+                <a:spcPts val="960"/>
+              </a:spcAft>
+              <a:defRPr sz="1600">
+                <a:solidFill>
+                  <a:srgbClr val="E0E0E0"/>
+                </a:solidFill>
+                <a:latin typeface="Calibri"/>
+              </a:defRPr>
+            </a:pPr>
+            <a:r>
+              <a:t>以模型无关的手工特征作为稳定基线</a:t>
+            </a:r>
+          </a:p>
+          <a:p>
+            <a:pPr>
+              <a:spcAft>
+                <a:spcPts val="960"/>
+              </a:spcAft>
+              <a:defRPr sz="1600">
+                <a:solidFill>
+                  <a:srgbClr val="E0E0E0"/>
+                </a:solidFill>
+                <a:latin typeface="Calibri"/>
+              </a:defRPr>
+            </a:pPr>
+            <a:r>
+              <a:t>辅以同代 LLM token 特征覆盖新生成器</a:t>
+            </a:r>
+          </a:p>
+          <a:p>
+            <a:pPr>
+              <a:spcAft>
+                <a:spcPts val="960"/>
+              </a:spcAft>
+              <a:defRPr sz="1600">
+                <a:solidFill>
+                  <a:srgbClr val="E0E0E0"/>
+                </a:solidFill>
+                <a:latin typeface="Calibri"/>
+              </a:defRPr>
+            </a:pPr>
+            <a:r>
+              <a:t>观察者模型需要定期更新 (半年一次)</a:t>
+            </a:r>
+          </a:p>
+          <a:p>
+            <a:pPr>
+              <a:spcAft>
+                <a:spcPts val="960"/>
+              </a:spcAft>
+              <a:defRPr sz="1600">
+                <a:solidFill>
+                  <a:srgbClr val="E0E0E0"/>
+                </a:solidFill>
+                <a:latin typeface="Calibri"/>
+              </a:defRPr>
+            </a:pPr>
+            <a:r>
+              <a:t>跨域部署需注意领域差异 (诗歌 vs 新闻)</a:t>
+            </a:r>
+          </a:p>
+          <a:p>
+            <a:pPr>
+              <a:spcAft>
+                <a:spcPts val="960"/>
+              </a:spcAft>
+              <a:defRPr sz="1600">
+                <a:solidFill>
+                  <a:srgbClr val="E0E0E0"/>
+                </a:solidFill>
+                <a:latin typeface="Calibri"/>
+              </a:defRPr>
+            </a:pPr>
+            <a:r>
+              <a:t>提供 SHAP 解释以增强用户信任</a:t>
+            </a:r>
+          </a:p>
+        </p:txBody>
+      </p:sp>
+      <p:sp>
+        <p:nvSpPr>
+          <p:cNvPr id="8" name="TextBox 7"/>
+          <p:cNvSpPr txBox="1"/>
+          <p:nvPr/>
+        </p:nvSpPr>
+        <p:spPr>
+          <a:xfrm>
+            <a:off x="731520" y="5029200"/>
+            <a:ext cx="10515600" cy="1097280"/>
+          </a:xfrm>
+          <a:prstGeom prst="rect">
+            <a:avLst/>
+          </a:prstGeom>
+          <a:noFill/>
+        </p:spPr>
+        <p:txBody>
+          <a:bodyPr wrap="square">
+            <a:spAutoFit/>
+          </a:bodyPr>
+          <a:lstStyle/>
+          <a:p>
+            <a:pPr algn="ctr">
+              <a:defRPr sz="2000" b="0">
+                <a:solidFill>
+                  <a:srgbClr val="00D2FF"/>
+                </a:solidFill>
+                <a:latin typeface="Calibri"/>
+              </a:defRPr>
+            </a:pPr>
+            <a:r>
+              <a:t>"手工特征看文本的外表，Token 概率特征看文本在 AI 眼中的内在。</a:t>
+            </a:r>
+            <a:br/>
+            <a:r>
+              <a:t>当一个视角被欺骗时，另一个视角往往能看穿。这就是 120 维组合的力量。"</a:t>
+            </a:r>
+          </a:p>
+        </p:txBody>
+      </p:sp>
+    </p:spTree>
+  </p:cSld>
+  <p:clrMapOvr>
+    <a:masterClrMapping/>
+  </p:clrMapOvr>
+</p:sld>
+</file>
+
+<file path=ppt/slides/slide25.xml><?xml version="1.0" encoding="utf-8"?>
 <p:sld xmlns:a="http://schemas.openxmlformats.org/drawingml/2006/main" xmlns:p="http://schemas.openxmlformats.org/presentationml/2006/main" xmlns:r="http://schemas.openxmlformats.org/officeDocument/2006/relationships">
   <p:cSld>
     <p:bg>

</xml_diff>

<commit_message>
Refactor to two-layer taxonomy (Model-Free vs Model-Based)
Replace three-layer classification with cleaner two-layer split:
- Layer 1: Model-Free (~36d) - pure text statistics
- Layer 2: Model-Based (82d) - BERT/GPT-2/Mistral sub-groups
Update ablation experiment, PPT, ACM report, and notebook accordingly.

Co-Authored-By: Claude Opus 4.6 <noreply@anthropic.com>
</commit_message>
<xml_diff>
--- a/reports/AIGC_Detection_Presentation.pptx
+++ b/reports/AIGC_Detection_Presentation.pptx
@@ -10104,7 +10104,7 @@
               </a:defRPr>
             </a:pPr>
             <a:r>
-              <a:t>三层特征消融: 5 数据集全景</a:t>
+              <a:t>两层消融 + Model-Based Sub-group 分析</a:t>
             </a:r>
           </a:p>
         </p:txBody>
@@ -10236,229 +10236,229 @@
           <a:p>
             <a:pPr>
               <a:spcAft>
-                <a:spcPts val="780"/>
-              </a:spcAft>
-              <a:defRPr sz="1300">
-                <a:solidFill>
-                  <a:srgbClr val="E0E0E0"/>
-                </a:solidFill>
-                <a:latin typeface="Calibri"/>
-              </a:defRPr>
-            </a:pPr>
-            <a:r>
-              <a:t>RAID: stat (0.994) + token (0.990)</a:t>
-            </a:r>
-          </a:p>
-          <a:p>
-            <a:pPr>
-              <a:spcAft>
-                <a:spcPts val="780"/>
-              </a:spcAft>
-              <a:defRPr sz="1300">
-                <a:solidFill>
-                  <a:srgbClr val="E0E0E0"/>
-                </a:solidFill>
-                <a:latin typeface="Calibri"/>
-              </a:defRPr>
-            </a:pPr>
-            <a:r>
-              <a:t>  → 两层互补, all=0.999</a:t>
-            </a:r>
-          </a:p>
-          <a:p>
-            <a:pPr>
-              <a:spcAft>
-                <a:spcPts val="780"/>
-              </a:spcAft>
-              <a:defRPr sz="1300">
-                <a:solidFill>
-                  <a:srgbClr val="E0E0E0"/>
-                </a:solidFill>
-                <a:latin typeface="Calibri"/>
-              </a:defRPr>
-            </a:pPr>
-          </a:p>
-          <a:p>
-            <a:pPr>
-              <a:spcAft>
-                <a:spcPts val="780"/>
-              </a:spcAft>
-              <a:defRPr sz="1300">
-                <a:solidFill>
-                  <a:srgbClr val="E0E0E0"/>
-                </a:solidFill>
-                <a:latin typeface="Calibri"/>
-              </a:defRPr>
-            </a:pPr>
-            <a:r>
-              <a:t>SemEval: 只有 token 有效 (0.976)</a:t>
-            </a:r>
-          </a:p>
-          <a:p>
-            <a:pPr>
-              <a:spcAft>
-                <a:spcPts val="780"/>
-              </a:spcAft>
-              <a:defRPr sz="1300">
-                <a:solidFill>
-                  <a:srgbClr val="E0E0E0"/>
-                </a:solidFill>
-                <a:latin typeface="Calibri"/>
-              </a:defRPr>
-            </a:pPr>
-            <a:r>
-              <a:t>  stat/model 均 ~0.51 (纯噪声)</a:t>
-            </a:r>
-          </a:p>
-          <a:p>
-            <a:pPr>
-              <a:spcAft>
-                <a:spcPts val="780"/>
-              </a:spcAft>
-              <a:defRPr sz="1300">
-                <a:solidFill>
-                  <a:srgbClr val="E0E0E0"/>
-                </a:solidFill>
-                <a:latin typeface="Calibri"/>
-              </a:defRPr>
-            </a:pPr>
-            <a:r>
-              <a:t>  model+token=0.961 &gt; all=0.847</a:t>
-            </a:r>
-          </a:p>
-          <a:p>
-            <a:pPr>
-              <a:spcAft>
-                <a:spcPts val="780"/>
-              </a:spcAft>
-              <a:defRPr sz="1300">
-                <a:solidFill>
-                  <a:srgbClr val="E0E0E0"/>
-                </a:solidFill>
-                <a:latin typeface="Calibri"/>
-              </a:defRPr>
-            </a:pPr>
-            <a:r>
-              <a:t>  → 纯统计特征是噪声源!</a:t>
-            </a:r>
-          </a:p>
-          <a:p>
-            <a:pPr>
-              <a:spcAft>
-                <a:spcPts val="780"/>
-              </a:spcAft>
-              <a:defRPr sz="1300">
-                <a:solidFill>
-                  <a:srgbClr val="E0E0E0"/>
-                </a:solidFill>
-                <a:latin typeface="Calibri"/>
-              </a:defRPr>
-            </a:pPr>
-          </a:p>
-          <a:p>
-            <a:pPr>
-              <a:spcAft>
-                <a:spcPts val="780"/>
-              </a:spcAft>
-              <a:defRPr sz="1300">
-                <a:solidFill>
-                  <a:srgbClr val="E0E0E0"/>
-                </a:solidFill>
-                <a:latin typeface="Calibri"/>
-              </a:defRPr>
-            </a:pPr>
-            <a:r>
-              <a:t>TuringBench: model 最强 (0.975)</a:t>
-            </a:r>
-          </a:p>
-          <a:p>
-            <a:pPr>
-              <a:spcAft>
-                <a:spcPts val="780"/>
-              </a:spcAft>
-              <a:defRPr sz="1300">
-                <a:solidFill>
-                  <a:srgbClr val="E0E0E0"/>
-                </a:solidFill>
-                <a:latin typeface="Calibri"/>
-              </a:defRPr>
-            </a:pPr>
-            <a:r>
-              <a:t>  stat=0.67, token=0.52</a:t>
-            </a:r>
-          </a:p>
-          <a:p>
-            <a:pPr>
-              <a:spcAft>
-                <a:spcPts val="780"/>
-              </a:spcAft>
-              <a:defRPr sz="1300">
-                <a:solidFill>
-                  <a:srgbClr val="E0E0E0"/>
-                </a:solidFill>
-                <a:latin typeface="Calibri"/>
-              </a:defRPr>
-            </a:pPr>
-            <a:r>
-              <a:t>  → BERT embedding 捕捉老 AI 风格</a:t>
-            </a:r>
-          </a:p>
-          <a:p>
-            <a:pPr>
-              <a:spcAft>
-                <a:spcPts val="780"/>
-              </a:spcAft>
-              <a:defRPr sz="1300">
-                <a:solidFill>
-                  <a:srgbClr val="E0E0E0"/>
-                </a:solidFill>
-                <a:latin typeface="Calibri"/>
-              </a:defRPr>
-            </a:pPr>
-          </a:p>
-          <a:p>
-            <a:pPr>
-              <a:spcAft>
-                <a:spcPts val="780"/>
-              </a:spcAft>
-              <a:defRPr sz="1300">
-                <a:solidFill>
-                  <a:srgbClr val="E0E0E0"/>
-                </a:solidFill>
-                <a:latin typeface="Calibri"/>
-              </a:defRPr>
-            </a:pPr>
-            <a:r>
-              <a:t>HC3: stat+model 已饱和 (0.999)</a:t>
-            </a:r>
-          </a:p>
-          <a:p>
-            <a:pPr>
-              <a:spcAft>
-                <a:spcPts val="780"/>
-              </a:spcAft>
-              <a:defRPr sz="1300">
-                <a:solidFill>
-                  <a:srgbClr val="E0E0E0"/>
-                </a:solidFill>
-                <a:latin typeface="Calibri"/>
-              </a:defRPr>
-            </a:pPr>
-          </a:p>
-          <a:p>
-            <a:pPr>
-              <a:spcAft>
-                <a:spcPts val="780"/>
-              </a:spcAft>
-              <a:defRPr sz="1300">
-                <a:solidFill>
-                  <a:srgbClr val="E0E0E0"/>
-                </a:solidFill>
-                <a:latin typeface="Calibri"/>
-              </a:defRPr>
-            </a:pPr>
-            <a:r>
-              <a:t>Pile: stat 主导 (0.962)</a:t>
+                <a:spcPts val="719"/>
+              </a:spcAft>
+              <a:defRPr sz="1200">
+                <a:solidFill>
+                  <a:srgbClr val="E0E0E0"/>
+                </a:solidFill>
+                <a:latin typeface="Calibri"/>
+              </a:defRPr>
+            </a:pPr>
+            <a:r>
+              <a:t>Model-Based 三个 sub-group</a:t>
+            </a:r>
+          </a:p>
+          <a:p>
+            <a:pPr>
+              <a:spcAft>
+                <a:spcPts val="719"/>
+              </a:spcAft>
+              <a:defRPr sz="1200">
+                <a:solidFill>
+                  <a:srgbClr val="E0E0E0"/>
+                </a:solidFill>
+                <a:latin typeface="Calibri"/>
+              </a:defRPr>
+            </a:pPr>
+            <a:r>
+              <a:t>行为完全不同:</a:t>
+            </a:r>
+          </a:p>
+          <a:p>
+            <a:pPr>
+              <a:spcAft>
+                <a:spcPts val="719"/>
+              </a:spcAft>
+              <a:defRPr sz="1200">
+                <a:solidFill>
+                  <a:srgbClr val="E0E0E0"/>
+                </a:solidFill>
+                <a:latin typeface="Calibri"/>
+              </a:defRPr>
+            </a:pPr>
+          </a:p>
+          <a:p>
+            <a:pPr>
+              <a:spcAft>
+                <a:spcPts val="719"/>
+              </a:spcAft>
+              <a:defRPr sz="1200">
+                <a:solidFill>
+                  <a:srgbClr val="E0E0E0"/>
+                </a:solidFill>
+                <a:latin typeface="Calibri"/>
+              </a:defRPr>
+            </a:pPr>
+            <a:r>
+              <a:t>BERT-emb: HC3/Pile 有效,</a:t>
+            </a:r>
+          </a:p>
+          <a:p>
+            <a:pPr>
+              <a:spcAft>
+                <a:spcPts val="719"/>
+              </a:spcAft>
+              <a:defRPr sz="1200">
+                <a:solidFill>
+                  <a:srgbClr val="E0E0E0"/>
+                </a:solidFill>
+                <a:latin typeface="Calibri"/>
+              </a:defRPr>
+            </a:pPr>
+            <a:r>
+              <a:t>  SemEval/TB 失效</a:t>
+            </a:r>
+          </a:p>
+          <a:p>
+            <a:pPr>
+              <a:spcAft>
+                <a:spcPts val="719"/>
+              </a:spcAft>
+              <a:defRPr sz="1200">
+                <a:solidFill>
+                  <a:srgbClr val="E0E0E0"/>
+                </a:solidFill>
+                <a:latin typeface="Calibri"/>
+              </a:defRPr>
+            </a:pPr>
+          </a:p>
+          <a:p>
+            <a:pPr>
+              <a:spcAft>
+                <a:spcPts val="719"/>
+              </a:spcAft>
+              <a:defRPr sz="1200">
+                <a:solidFill>
+                  <a:srgbClr val="E0E0E0"/>
+                </a:solidFill>
+                <a:latin typeface="Calibri"/>
+              </a:defRPr>
+            </a:pPr>
+            <a:r>
+              <a:t>GPT2-ppl: HC3=0.99, TB=0.97</a:t>
+            </a:r>
+          </a:p>
+          <a:p>
+            <a:pPr>
+              <a:spcAft>
+                <a:spcPts val="719"/>
+              </a:spcAft>
+              <a:defRPr sz="1200">
+                <a:solidFill>
+                  <a:srgbClr val="E0E0E0"/>
+                </a:solidFill>
+                <a:latin typeface="Calibri"/>
+              </a:defRPr>
+            </a:pPr>
+            <a:r>
+              <a:t>  但 RAID=0.49 (Perplexity Paradox)</a:t>
+            </a:r>
+          </a:p>
+          <a:p>
+            <a:pPr>
+              <a:spcAft>
+                <a:spcPts val="719"/>
+              </a:spcAft>
+              <a:defRPr sz="1200">
+                <a:solidFill>
+                  <a:srgbClr val="E0E0E0"/>
+                </a:solidFill>
+                <a:latin typeface="Calibri"/>
+              </a:defRPr>
+            </a:pPr>
+          </a:p>
+          <a:p>
+            <a:pPr>
+              <a:spcAft>
+                <a:spcPts val="719"/>
+              </a:spcAft>
+              <a:defRPr sz="1200">
+                <a:solidFill>
+                  <a:srgbClr val="E0E0E0"/>
+                </a:solidFill>
+                <a:latin typeface="Calibri"/>
+              </a:defRPr>
+            </a:pPr>
+            <a:r>
+              <a:t>Mistral-token: RAID=0.99,</a:t>
+            </a:r>
+          </a:p>
+          <a:p>
+            <a:pPr>
+              <a:spcAft>
+                <a:spcPts val="719"/>
+              </a:spcAft>
+              <a:defRPr sz="1200">
+                <a:solidFill>
+                  <a:srgbClr val="E0E0E0"/>
+                </a:solidFill>
+                <a:latin typeface="Calibri"/>
+              </a:defRPr>
+            </a:pPr>
+            <a:r>
+              <a:t>  SemEval=0.98</a:t>
+            </a:r>
+          </a:p>
+          <a:p>
+            <a:pPr>
+              <a:spcAft>
+                <a:spcPts val="719"/>
+              </a:spcAft>
+              <a:defRPr sz="1200">
+                <a:solidFill>
+                  <a:srgbClr val="E0E0E0"/>
+                </a:solidFill>
+                <a:latin typeface="Calibri"/>
+              </a:defRPr>
+            </a:pPr>
+            <a:r>
+              <a:t>  但 HC3/TB/Pile ≈ 0.50</a:t>
+            </a:r>
+          </a:p>
+          <a:p>
+            <a:pPr>
+              <a:spcAft>
+                <a:spcPts val="719"/>
+              </a:spcAft>
+              <a:defRPr sz="1200">
+                <a:solidFill>
+                  <a:srgbClr val="E0E0E0"/>
+                </a:solidFill>
+                <a:latin typeface="Calibri"/>
+              </a:defRPr>
+            </a:pPr>
+          </a:p>
+          <a:p>
+            <a:pPr>
+              <a:spcAft>
+                <a:spcPts val="719"/>
+              </a:spcAft>
+              <a:defRPr sz="1200">
+                <a:solidFill>
+                  <a:srgbClr val="E0E0E0"/>
+                </a:solidFill>
+                <a:latin typeface="Calibri"/>
+              </a:defRPr>
+            </a:pPr>
+            <a:r>
+              <a:t>→ 每个参考模型都有自己的</a:t>
+            </a:r>
+          </a:p>
+          <a:p>
+            <a:pPr>
+              <a:spcAft>
+                <a:spcPts val="719"/>
+              </a:spcAft>
+              <a:defRPr sz="1200">
+                <a:solidFill>
+                  <a:srgbClr val="E0E0E0"/>
+                </a:solidFill>
+                <a:latin typeface="Calibri"/>
+              </a:defRPr>
+            </a:pPr>
+            <a:r>
+              <a:t>  "有效期", 取决于目标 AI 的时代</a:t>
             </a:r>
           </a:p>
         </p:txBody>
@@ -11751,7 +11751,7 @@
               </a:defRPr>
             </a:pPr>
             <a:r>
-              <a:t>1. 三层 118 维特征体系在 RAID 上达 AUC 0.9992</a:t>
+              <a:t>1. 两层 118 维特征体系在 RAID 上达 AUC 0.9992</a:t>
             </a:r>
           </a:p>
           <a:p>
@@ -11767,7 +11767,7 @@
               </a:defRPr>
             </a:pPr>
             <a:r>
-              <a:t>    纯统计 + 模型衍生 + Token 概率, 完全可解释</a:t>
+              <a:t>    Model-Free (36维) + Model-Based (82维), 完全可解释</a:t>
             </a:r>
           </a:p>
           <a:p>
@@ -11796,7 +11796,7 @@
               </a:defRPr>
             </a:pPr>
             <a:r>
-              <a:t>2. 不同层在不同场景各有"保质期"</a:t>
+              <a:t>2. Model-Based 内部三个 sub-group 各有"有效期"</a:t>
             </a:r>
           </a:p>
           <a:p>
@@ -11812,7 +11812,7 @@
               </a:defRPr>
             </a:pPr>
             <a:r>
-              <a:t>    纯统计: 老 AI 强, 新 AI 失效 (SemEval ~0.52)</a:t>
+              <a:t>    BERT-emb: 通用语义特征, HC3/Pile 有效</a:t>
             </a:r>
           </a:p>
           <a:p>
@@ -11828,7 +11828,7 @@
               </a:defRPr>
             </a:pPr>
             <a:r>
-              <a:t>    模型衍生: 依赖参考模型, 跨系失效 (RAID perplexity 0.49)</a:t>
+              <a:t>    GPT2-ppl: 只认 GPT 家族 (HC3=0.99, RAID=0.49)</a:t>
             </a:r>
           </a:p>
           <a:p>
@@ -11844,7 +11844,7 @@
               </a:defRPr>
             </a:pPr>
             <a:r>
-              <a:t>    Token: 只认同代 AI (TuringBench ~0.52)</a:t>
+              <a:t>    Mistral-token: 只认同代 AI (SemEval=0.98, TB=0.52)</a:t>
             </a:r>
           </a:p>
           <a:p>
@@ -11873,7 +11873,7 @@
               </a:defRPr>
             </a:pPr>
             <a:r>
-              <a:t>3. 互补效果取决于信号强度</a:t>
+              <a:t>3. Model-Free 对老 AI 有效 (RAID=0.994)</a:t>
             </a:r>
           </a:p>
           <a:p>
@@ -11889,7 +11889,7 @@
               </a:defRPr>
             </a:pPr>
             <a:r>
-              <a:t>    RAID: stat+token → AUC +0.005 (两侧有信号)</a:t>
+              <a:t>    但新 AI 已在统计上逼近人类 (SemEval=0.52)</a:t>
             </a:r>
           </a:p>
           <a:p>
@@ -11904,9 +11904,6 @@
                 <a:latin typeface="Calibri"/>
               </a:defRPr>
             </a:pPr>
-            <a:r>
-              <a:t>    SemEval: model+token (0.961) &gt; all (0.847)</a:t>
-            </a:r>
           </a:p>
           <a:p>
             <a:pPr>
@@ -11920,6 +11917,9 @@
                 <a:latin typeface="Calibri"/>
               </a:defRPr>
             </a:pPr>
+            <a:r>
+              <a:t>4. 盲目合并会更差 (噪声稀释)</a:t>
+            </a:r>
           </a:p>
           <a:p>
             <a:pPr>
@@ -11934,7 +11934,7 @@
               </a:defRPr>
             </a:pPr>
             <a:r>
-              <a:t>4. 统计特征对 10/11 种对抗攻击天然鲁棒</a:t>
+              <a:t>    SemEval: model-based=0.961 &gt; all=0.847</a:t>
             </a:r>
           </a:p>
           <a:p>
@@ -11963,7 +11963,7 @@
               </a:defRPr>
             </a:pPr>
             <a:r>
-              <a:t>5. Auto-Filter 基于组级 AUC 自动检测噪声</a:t>
+              <a:t>5. Auto-Filter 自动检测并丢弃噪声特征组</a:t>
             </a:r>
           </a:p>
         </p:txBody>
@@ -13486,7 +13486,7 @@
               </a:defRPr>
             </a:pPr>
             <a:r>
-              <a:t>方法概览：三层 120 维特征体系 + XGBoost</a:t>
+              <a:t>方法概览：两层 118 维特征体系 + XGBoost</a:t>
             </a:r>
           </a:p>
         </p:txBody>
@@ -13542,22 +13542,22 @@
         </p:nvSpPr>
         <p:spPr>
           <a:xfrm>
-            <a:off x="274320" y="1280160"/>
-            <a:ext cx="3474720" cy="457200"/>
-          </a:xfrm>
-          <a:prstGeom prst="rect">
-            <a:avLst/>
-          </a:prstGeom>
-          <a:noFill/>
-        </p:spPr>
-        <p:txBody>
-          <a:bodyPr wrap="square">
-            <a:spAutoFit/>
-          </a:bodyPr>
-          <a:lstStyle/>
-          <a:p>
-            <a:pPr algn="l">
-              <a:defRPr sz="1800" b="1">
+            <a:off x="457200" y="1280160"/>
+            <a:ext cx="5029200" cy="457200"/>
+          </a:xfrm>
+          <a:prstGeom prst="rect">
+            <a:avLst/>
+          </a:prstGeom>
+          <a:noFill/>
+        </p:spPr>
+        <p:txBody>
+          <a:bodyPr wrap="square">
+            <a:spAutoFit/>
+          </a:bodyPr>
+          <a:lstStyle/>
+          <a:p>
+            <a:pPr algn="l">
+              <a:defRPr sz="2000" b="1">
                 <a:solidFill>
                   <a:srgbClr val="FF6B6B"/>
                 </a:solidFill>
@@ -13565,7 +13565,7 @@
               </a:defRPr>
             </a:pPr>
             <a:r>
-              <a:t>Layer 1: 纯统计特征 (~36维)</a:t>
+              <a:t>Layer 1: Model-Free (~36维)</a:t>
             </a:r>
           </a:p>
         </p:txBody>
@@ -13578,25 +13578,61 @@
         </p:nvSpPr>
         <p:spPr>
           <a:xfrm>
-            <a:off x="274320" y="1737360"/>
-            <a:ext cx="3474720" cy="2926080"/>
-          </a:xfrm>
-          <a:prstGeom prst="rect">
-            <a:avLst/>
-          </a:prstGeom>
-          <a:noFill/>
-        </p:spPr>
-        <p:txBody>
-          <a:bodyPr wrap="square">
-            <a:spAutoFit/>
-          </a:bodyPr>
-          <a:lstStyle/>
-          <a:p>
-            <a:pPr>
-              <a:spcAft>
-                <a:spcPts val="719"/>
-              </a:spcAft>
-              <a:defRPr sz="1200">
+            <a:off x="457200" y="1737360"/>
+            <a:ext cx="5029200" cy="365760"/>
+          </a:xfrm>
+          <a:prstGeom prst="rect">
+            <a:avLst/>
+          </a:prstGeom>
+          <a:noFill/>
+        </p:spPr>
+        <p:txBody>
+          <a:bodyPr wrap="square">
+            <a:spAutoFit/>
+          </a:bodyPr>
+          <a:lstStyle/>
+          <a:p>
+            <a:pPr algn="l">
+              <a:defRPr sz="1400" b="0">
+                <a:solidFill>
+                  <a:srgbClr val="AAAAAA"/>
+                </a:solidFill>
+                <a:latin typeface="Calibri"/>
+              </a:defRPr>
+            </a:pPr>
+            <a:r>
+              <a:t>不依赖任何神经网络, 纯文本统计</a:t>
+            </a:r>
+          </a:p>
+        </p:txBody>
+      </p:sp>
+      <p:sp>
+        <p:nvSpPr>
+          <p:cNvPr id="6" name="TextBox 5"/>
+          <p:cNvSpPr txBox="1"/>
+          <p:nvPr/>
+        </p:nvSpPr>
+        <p:spPr>
+          <a:xfrm>
+            <a:off x="457200" y="2103120"/>
+            <a:ext cx="5029200" cy="2743200"/>
+          </a:xfrm>
+          <a:prstGeom prst="rect">
+            <a:avLst/>
+          </a:prstGeom>
+          <a:noFill/>
+        </p:spPr>
+        <p:txBody>
+          <a:bodyPr wrap="square">
+            <a:spAutoFit/>
+          </a:bodyPr>
+          <a:lstStyle/>
+          <a:p>
+            <a:pPr>
+              <a:spcAft>
+                <a:spcPts val="780"/>
+              </a:spcAft>
+              <a:defRPr sz="1300">
                 <a:solidFill>
                   <a:srgbClr val="E0E0E0"/>
                 </a:solidFill>
@@ -13610,9 +13646,9 @@
           <a:p>
             <a:pPr>
               <a:spcAft>
-                <a:spcPts val="719"/>
-              </a:spcAft>
-              <a:defRPr sz="1200">
+                <a:spcPts val="780"/>
+              </a:spcAft>
+              <a:defRPr sz="1300">
                 <a:solidFill>
                   <a:srgbClr val="E0E0E0"/>
                 </a:solidFill>
@@ -13626,9 +13662,9 @@
           <a:p>
             <a:pPr>
               <a:spcAft>
-                <a:spcPts val="719"/>
-              </a:spcAft>
-              <a:defRPr sz="1200">
+                <a:spcPts val="780"/>
+              </a:spcAft>
+              <a:defRPr sz="1300">
                 <a:solidFill>
                   <a:srgbClr val="E0E0E0"/>
                 </a:solidFill>
@@ -13642,57 +13678,57 @@
           <a:p>
             <a:pPr>
               <a:spcAft>
-                <a:spcPts val="719"/>
-              </a:spcAft>
-              <a:defRPr sz="1200">
-                <a:solidFill>
-                  <a:srgbClr val="E0E0E0"/>
-                </a:solidFill>
-                <a:latin typeface="Calibri"/>
-              </a:defRPr>
-            </a:pPr>
-            <a:r>
-              <a:t>lexical_richness (7): TTR, Hapax...</a:t>
-            </a:r>
-          </a:p>
-          <a:p>
-            <a:pPr>
-              <a:spcAft>
-                <a:spcPts val="719"/>
-              </a:spcAft>
-              <a:defRPr sz="1200">
-                <a:solidFill>
-                  <a:srgbClr val="E0E0E0"/>
-                </a:solidFill>
-                <a:latin typeface="Calibri"/>
-              </a:defRPr>
-            </a:pPr>
-            <a:r>
-              <a:t>punctuation (11): 标点 + 大写/数字比</a:t>
-            </a:r>
-          </a:p>
-          <a:p>
-            <a:pPr>
-              <a:spcAft>
-                <a:spcPts val="719"/>
-              </a:spcAft>
-              <a:defRPr sz="1200">
-                <a:solidFill>
-                  <a:srgbClr val="E0E0E0"/>
-                </a:solidFill>
-                <a:latin typeface="Calibri"/>
-              </a:defRPr>
-            </a:pPr>
-            <a:r>
-              <a:t>readability (7): Flesch, SMOG...</a:t>
-            </a:r>
-          </a:p>
-          <a:p>
-            <a:pPr>
-              <a:spcAft>
-                <a:spcPts val="719"/>
-              </a:spcAft>
-              <a:defRPr sz="1200">
+                <a:spcPts val="780"/>
+              </a:spcAft>
+              <a:defRPr sz="1300">
+                <a:solidFill>
+                  <a:srgbClr val="E0E0E0"/>
+                </a:solidFill>
+                <a:latin typeface="Calibri"/>
+              </a:defRPr>
+            </a:pPr>
+            <a:r>
+              <a:t>lexical_richness (7): TTR, Hapax, Yule's K...</a:t>
+            </a:r>
+          </a:p>
+          <a:p>
+            <a:pPr>
+              <a:spcAft>
+                <a:spcPts val="780"/>
+              </a:spcAft>
+              <a:defRPr sz="1300">
+                <a:solidFill>
+                  <a:srgbClr val="E0E0E0"/>
+                </a:solidFill>
+                <a:latin typeface="Calibri"/>
+              </a:defRPr>
+            </a:pPr>
+            <a:r>
+              <a:t>punctuation (11): 标点使用率 + 大写/数字比</a:t>
+            </a:r>
+          </a:p>
+          <a:p>
+            <a:pPr>
+              <a:spcAft>
+                <a:spcPts val="780"/>
+              </a:spcAft>
+              <a:defRPr sz="1300">
+                <a:solidFill>
+                  <a:srgbClr val="E0E0E0"/>
+                </a:solidFill>
+                <a:latin typeface="Calibri"/>
+              </a:defRPr>
+            </a:pPr>
+            <a:r>
+              <a:t>readability (7): Flesch, Gunning Fog, SMOG...</a:t>
+            </a:r>
+          </a:p>
+          <a:p>
+            <a:pPr>
+              <a:spcAft>
+                <a:spcPts val="780"/>
+              </a:spcAft>
+              <a:defRPr sz="1300">
                 <a:solidFill>
                   <a:srgbClr val="E0E0E0"/>
                 </a:solidFill>
@@ -13703,71 +13739,6 @@
               <a:t>structure (1): 短句比例</a:t>
             </a:r>
           </a:p>
-          <a:p>
-            <a:pPr>
-              <a:spcAft>
-                <a:spcPts val="719"/>
-              </a:spcAft>
-              <a:defRPr sz="1200">
-                <a:solidFill>
-                  <a:srgbClr val="E0E0E0"/>
-                </a:solidFill>
-                <a:latin typeface="Calibri"/>
-              </a:defRPr>
-            </a:pPr>
-          </a:p>
-          <a:p>
-            <a:pPr>
-              <a:spcAft>
-                <a:spcPts val="719"/>
-              </a:spcAft>
-              <a:defRPr sz="1200">
-                <a:solidFill>
-                  <a:srgbClr val="E0E0E0"/>
-                </a:solidFill>
-                <a:latin typeface="Calibri"/>
-              </a:defRPr>
-            </a:pPr>
-            <a:r>
-              <a:t>不依赖任何神经网络, 纯公式计算</a:t>
-            </a:r>
-          </a:p>
-        </p:txBody>
-      </p:sp>
-      <p:sp>
-        <p:nvSpPr>
-          <p:cNvPr id="6" name="TextBox 5"/>
-          <p:cNvSpPr txBox="1"/>
-          <p:nvPr/>
-        </p:nvSpPr>
-        <p:spPr>
-          <a:xfrm>
-            <a:off x="4114800" y="1280160"/>
-            <a:ext cx="3657600" cy="457200"/>
-          </a:xfrm>
-          <a:prstGeom prst="rect">
-            <a:avLst/>
-          </a:prstGeom>
-          <a:noFill/>
-        </p:spPr>
-        <p:txBody>
-          <a:bodyPr wrap="square">
-            <a:spAutoFit/>
-          </a:bodyPr>
-          <a:lstStyle/>
-          <a:p>
-            <a:pPr algn="l">
-              <a:defRPr sz="1800" b="1">
-                <a:solidFill>
-                  <a:srgbClr val="FFA500"/>
-                </a:solidFill>
-                <a:latin typeface="Calibri"/>
-              </a:defRPr>
-            </a:pPr>
-            <a:r>
-              <a:t>Layer 2: 模型衍生特征 (52维)</a:t>
-            </a:r>
-          </a:p>
         </p:txBody>
       </p:sp>
       <p:sp>
@@ -13778,25 +13749,97 @@
         </p:nvSpPr>
         <p:spPr>
           <a:xfrm>
-            <a:off x="4114800" y="1737360"/>
-            <a:ext cx="3657600" cy="2926080"/>
-          </a:xfrm>
-          <a:prstGeom prst="rect">
-            <a:avLst/>
-          </a:prstGeom>
-          <a:noFill/>
-        </p:spPr>
-        <p:txBody>
-          <a:bodyPr wrap="square">
-            <a:spAutoFit/>
-          </a:bodyPr>
-          <a:lstStyle/>
-          <a:p>
-            <a:pPr>
-              <a:spcAft>
-                <a:spcPts val="719"/>
-              </a:spcAft>
-              <a:defRPr sz="1200">
+            <a:off x="6400800" y="1280160"/>
+            <a:ext cx="5303520" cy="457200"/>
+          </a:xfrm>
+          <a:prstGeom prst="rect">
+            <a:avLst/>
+          </a:prstGeom>
+          <a:noFill/>
+        </p:spPr>
+        <p:txBody>
+          <a:bodyPr wrap="square">
+            <a:spAutoFit/>
+          </a:bodyPr>
+          <a:lstStyle/>
+          <a:p>
+            <a:pPr algn="l">
+              <a:defRPr sz="2000" b="1">
+                <a:solidFill>
+                  <a:srgbClr val="4ECB71"/>
+                </a:solidFill>
+                <a:latin typeface="Calibri"/>
+              </a:defRPr>
+            </a:pPr>
+            <a:r>
+              <a:t>Layer 2: Model-Based (82维)</a:t>
+            </a:r>
+          </a:p>
+        </p:txBody>
+      </p:sp>
+      <p:sp>
+        <p:nvSpPr>
+          <p:cNvPr id="8" name="TextBox 7"/>
+          <p:cNvSpPr txBox="1"/>
+          <p:nvPr/>
+        </p:nvSpPr>
+        <p:spPr>
+          <a:xfrm>
+            <a:off x="6400800" y="1737360"/>
+            <a:ext cx="5303520" cy="365760"/>
+          </a:xfrm>
+          <a:prstGeom prst="rect">
+            <a:avLst/>
+          </a:prstGeom>
+          <a:noFill/>
+        </p:spPr>
+        <p:txBody>
+          <a:bodyPr wrap="square">
+            <a:spAutoFit/>
+          </a:bodyPr>
+          <a:lstStyle/>
+          <a:p>
+            <a:pPr algn="l">
+              <a:defRPr sz="1400" b="0">
+                <a:solidFill>
+                  <a:srgbClr val="AAAAAA"/>
+                </a:solidFill>
+                <a:latin typeface="Calibri"/>
+              </a:defRPr>
+            </a:pPr>
+            <a:r>
+              <a:t>需要预训练模型推理, 不同参考模型有不同"有效期"</a:t>
+            </a:r>
+          </a:p>
+        </p:txBody>
+      </p:sp>
+      <p:sp>
+        <p:nvSpPr>
+          <p:cNvPr id="9" name="TextBox 8"/>
+          <p:cNvSpPr txBox="1"/>
+          <p:nvPr/>
+        </p:nvSpPr>
+        <p:spPr>
+          <a:xfrm>
+            <a:off x="6400800" y="2103120"/>
+            <a:ext cx="5303520" cy="2743200"/>
+          </a:xfrm>
+          <a:prstGeom prst="rect">
+            <a:avLst/>
+          </a:prstGeom>
+          <a:noFill/>
+        </p:spPr>
+        <p:txBody>
+          <a:bodyPr wrap="square">
+            <a:spAutoFit/>
+          </a:bodyPr>
+          <a:lstStyle/>
+          <a:p>
+            <a:pPr>
+              <a:spcAft>
+                <a:spcPts val="780"/>
+              </a:spcAft>
+              <a:defRPr sz="1300">
                 <a:solidFill>
                   <a:srgbClr val="E0E0E0"/>
                 </a:solidFill>
@@ -13810,54 +13853,38 @@
           <a:p>
             <a:pPr>
               <a:spcAft>
-                <a:spcPts val="719"/>
-              </a:spcAft>
-              <a:defRPr sz="1200">
-                <a:solidFill>
-                  <a:srgbClr val="E0E0E0"/>
-                </a:solidFill>
-                <a:latin typeface="Calibri"/>
-              </a:defRPr>
-            </a:pPr>
-            <a:r>
-              <a:t>  将文本映射到语义空间</a:t>
-            </a:r>
-          </a:p>
-          <a:p>
-            <a:pPr>
-              <a:spcAft>
-                <a:spcPts val="719"/>
-              </a:spcAft>
-              <a:defRPr sz="1200">
-                <a:solidFill>
-                  <a:srgbClr val="E0E0E0"/>
-                </a:solidFill>
-                <a:latin typeface="Calibri"/>
-              </a:defRPr>
-            </a:pPr>
-            <a:r>
-              <a:t>  AI 文本语义分布更集中</a:t>
-            </a:r>
-          </a:p>
-          <a:p>
-            <a:pPr>
-              <a:spcAft>
-                <a:spcPts val="719"/>
-              </a:spcAft>
-              <a:defRPr sz="1200">
-                <a:solidFill>
-                  <a:srgbClr val="E0E0E0"/>
-                </a:solidFill>
-                <a:latin typeface="Calibri"/>
-              </a:defRPr>
-            </a:pPr>
-          </a:p>
-          <a:p>
-            <a:pPr>
-              <a:spcAft>
-                <a:spcPts val="719"/>
-              </a:spcAft>
-              <a:defRPr sz="1200">
+                <a:spcPts val="780"/>
+              </a:spcAft>
+              <a:defRPr sz="1300">
+                <a:solidFill>
+                  <a:srgbClr val="E0E0E0"/>
+                </a:solidFill>
+                <a:latin typeface="Calibri"/>
+              </a:defRPr>
+            </a:pPr>
+            <a:r>
+              <a:t>  语义空间分布, 捕捉风格差异</a:t>
+            </a:r>
+          </a:p>
+          <a:p>
+            <a:pPr>
+              <a:spcAft>
+                <a:spcPts val="780"/>
+              </a:spcAft>
+              <a:defRPr sz="1300">
+                <a:solidFill>
+                  <a:srgbClr val="E0E0E0"/>
+                </a:solidFill>
+                <a:latin typeface="Calibri"/>
+              </a:defRPr>
+            </a:pPr>
+          </a:p>
+          <a:p>
+            <a:pPr>
+              <a:spcAft>
+                <a:spcPts val="780"/>
+              </a:spcAft>
+              <a:defRPr sz="1300">
                 <a:solidFill>
                   <a:srgbClr val="E0E0E0"/>
                 </a:solidFill>
@@ -13871,278 +13898,78 @@
           <a:p>
             <a:pPr>
               <a:spcAft>
-                <a:spcPts val="719"/>
-              </a:spcAft>
-              <a:defRPr sz="1200">
-                <a:solidFill>
-                  <a:srgbClr val="E0E0E0"/>
-                </a:solidFill>
-                <a:latin typeface="Calibri"/>
-              </a:defRPr>
-            </a:pPr>
-            <a:r>
-              <a:t>  文本级别的困惑度汇总</a:t>
-            </a:r>
-          </a:p>
-          <a:p>
-            <a:pPr>
-              <a:spcAft>
-                <a:spcPts val="719"/>
-              </a:spcAft>
-              <a:defRPr sz="1200">
-                <a:solidFill>
-                  <a:srgbClr val="E0E0E0"/>
-                </a:solidFill>
-                <a:latin typeface="Calibri"/>
-              </a:defRPr>
-            </a:pPr>
-            <a:r>
-              <a:t>  HC3 最强特征 (AUC 0.99)</a:t>
-            </a:r>
-          </a:p>
-          <a:p>
-            <a:pPr>
-              <a:spcAft>
-                <a:spcPts val="719"/>
-              </a:spcAft>
-              <a:defRPr sz="1200">
-                <a:solidFill>
-                  <a:srgbClr val="E0E0E0"/>
-                </a:solidFill>
-                <a:latin typeface="Calibri"/>
-              </a:defRPr>
-            </a:pPr>
-            <a:r>
-              <a:t>  RAID 完全失效 (AUC 0.49)</a:t>
-            </a:r>
-          </a:p>
-          <a:p>
-            <a:pPr>
-              <a:spcAft>
-                <a:spcPts val="719"/>
-              </a:spcAft>
-              <a:defRPr sz="1200">
-                <a:solidFill>
-                  <a:srgbClr val="E0E0E0"/>
-                </a:solidFill>
-                <a:latin typeface="Calibri"/>
-              </a:defRPr>
-            </a:pPr>
-            <a:r>
-              <a:t>  → 模型依赖性是其本质属性</a:t>
-            </a:r>
-          </a:p>
-        </p:txBody>
-      </p:sp>
-      <p:sp>
-        <p:nvSpPr>
-          <p:cNvPr id="8" name="TextBox 7"/>
-          <p:cNvSpPr txBox="1"/>
-          <p:nvPr/>
-        </p:nvSpPr>
-        <p:spPr>
-          <a:xfrm>
-            <a:off x="8046720" y="1280160"/>
-            <a:ext cx="3840480" cy="457200"/>
-          </a:xfrm>
-          <a:prstGeom prst="rect">
-            <a:avLst/>
-          </a:prstGeom>
-          <a:noFill/>
-        </p:spPr>
-        <p:txBody>
-          <a:bodyPr wrap="square">
-            <a:spAutoFit/>
-          </a:bodyPr>
-          <a:lstStyle/>
-          <a:p>
-            <a:pPr algn="l">
-              <a:defRPr sz="1800" b="1">
-                <a:solidFill>
-                  <a:srgbClr val="4ECB71"/>
-                </a:solidFill>
-                <a:latin typeface="Calibri"/>
-              </a:defRPr>
-            </a:pPr>
-            <a:r>
-              <a:t>Layer 3: Token 概率特征 (30维)</a:t>
-            </a:r>
-          </a:p>
-        </p:txBody>
-      </p:sp>
-      <p:sp>
-        <p:nvSpPr>
-          <p:cNvPr id="9" name="TextBox 8"/>
-          <p:cNvSpPr txBox="1"/>
-          <p:nvPr/>
-        </p:nvSpPr>
-        <p:spPr>
-          <a:xfrm>
-            <a:off x="8046720" y="1737360"/>
-            <a:ext cx="3840480" cy="2926080"/>
-          </a:xfrm>
-          <a:prstGeom prst="rect">
-            <a:avLst/>
-          </a:prstGeom>
-          <a:noFill/>
-        </p:spPr>
-        <p:txBody>
-          <a:bodyPr wrap="square">
-            <a:spAutoFit/>
-          </a:bodyPr>
-          <a:lstStyle/>
-          <a:p>
-            <a:pPr>
-              <a:spcAft>
-                <a:spcPts val="719"/>
-              </a:spcAft>
-              <a:defRPr sz="1200">
-                <a:solidFill>
-                  <a:srgbClr val="E0E0E0"/>
-                </a:solidFill>
-                <a:latin typeface="Calibri"/>
-              </a:defRPr>
-            </a:pPr>
-            <a:r>
-              <a:t>观察者: Mistral-7B-Instruct</a:t>
-            </a:r>
-          </a:p>
-          <a:p>
-            <a:pPr>
-              <a:spcAft>
-                <a:spcPts val="719"/>
-              </a:spcAft>
-              <a:defRPr sz="1200">
-                <a:solidFill>
-                  <a:srgbClr val="E0E0E0"/>
-                </a:solidFill>
-                <a:latin typeface="Calibri"/>
-              </a:defRPr>
-            </a:pPr>
-          </a:p>
-          <a:p>
-            <a:pPr>
-              <a:spcAft>
-                <a:spcPts val="719"/>
-              </a:spcAft>
-              <a:defRPr sz="1200">
-                <a:solidFill>
-                  <a:srgbClr val="E0E0E0"/>
-                </a:solidFill>
-                <a:latin typeface="Calibri"/>
-              </a:defRPr>
-            </a:pPr>
-            <a:r>
-              <a:t>Log-prob (10): mean, std, min,</a:t>
-            </a:r>
-          </a:p>
-          <a:p>
-            <a:pPr>
-              <a:spcAft>
-                <a:spcPts val="719"/>
-              </a:spcAft>
-              <a:defRPr sz="1200">
-                <a:solidFill>
-                  <a:srgbClr val="E0E0E0"/>
-                </a:solidFill>
-                <a:latin typeface="Calibri"/>
-              </a:defRPr>
-            </a:pPr>
-            <a:r>
-              <a:t>  max, median, q10, q90, skew...</a:t>
-            </a:r>
-          </a:p>
-          <a:p>
-            <a:pPr>
-              <a:spcAft>
-                <a:spcPts val="719"/>
-              </a:spcAft>
-              <a:defRPr sz="1200">
-                <a:solidFill>
-                  <a:srgbClr val="E0E0E0"/>
-                </a:solidFill>
-                <a:latin typeface="Calibri"/>
-              </a:defRPr>
-            </a:pPr>
-            <a:r>
-              <a:t>Rank (8): mean, std, median,</a:t>
-            </a:r>
-          </a:p>
-          <a:p>
-            <a:pPr>
-              <a:spcAft>
-                <a:spcPts val="719"/>
-              </a:spcAft>
-              <a:defRPr sz="1200">
-                <a:solidFill>
-                  <a:srgbClr val="E0E0E0"/>
-                </a:solidFill>
-                <a:latin typeface="Calibri"/>
-              </a:defRPr>
-            </a:pPr>
-            <a:r>
-              <a:t>  top-1/5/10/100 fraction</a:t>
-            </a:r>
-          </a:p>
-          <a:p>
-            <a:pPr>
-              <a:spcAft>
-                <a:spcPts val="719"/>
-              </a:spcAft>
-              <a:defRPr sz="1200">
-                <a:solidFill>
-                  <a:srgbClr val="E0E0E0"/>
-                </a:solidFill>
-                <a:latin typeface="Calibri"/>
-              </a:defRPr>
-            </a:pPr>
-            <a:r>
-              <a:t>Entropy (6): mean, std, min,</a:t>
-            </a:r>
-          </a:p>
-          <a:p>
-            <a:pPr>
-              <a:spcAft>
-                <a:spcPts val="719"/>
-              </a:spcAft>
-              <a:defRPr sz="1200">
-                <a:solidFill>
-                  <a:srgbClr val="E0E0E0"/>
-                </a:solidFill>
-                <a:latin typeface="Calibri"/>
-              </a:defRPr>
-            </a:pPr>
-            <a:r>
-              <a:t>  max, median, skew</a:t>
-            </a:r>
-          </a:p>
-          <a:p>
-            <a:pPr>
-              <a:spcAft>
-                <a:spcPts val="719"/>
-              </a:spcAft>
-              <a:defRPr sz="1200">
-                <a:solidFill>
-                  <a:srgbClr val="E0E0E0"/>
-                </a:solidFill>
-                <a:latin typeface="Calibri"/>
-              </a:defRPr>
-            </a:pPr>
-          </a:p>
-          <a:p>
-            <a:pPr>
-              <a:spcAft>
-                <a:spcPts val="719"/>
-              </a:spcAft>
-              <a:defRPr sz="1200">
-                <a:solidFill>
-                  <a:srgbClr val="E0E0E0"/>
-                </a:solidFill>
-                <a:latin typeface="Calibri"/>
-              </a:defRPr>
-            </a:pPr>
-            <a:r>
-              <a:t>逐 token 粒度, 看 AI 的"选词指纹"</a:t>
+                <a:spcPts val="780"/>
+              </a:spcAft>
+              <a:defRPr sz="1300">
+                <a:solidFill>
+                  <a:srgbClr val="E0E0E0"/>
+                </a:solidFill>
+                <a:latin typeface="Calibri"/>
+              </a:defRPr>
+            </a:pPr>
+            <a:r>
+              <a:t>  文本级困惑度, 检测"GPT家族"</a:t>
+            </a:r>
+          </a:p>
+          <a:p>
+            <a:pPr>
+              <a:spcAft>
+                <a:spcPts val="780"/>
+              </a:spcAft>
+              <a:defRPr sz="1300">
+                <a:solidFill>
+                  <a:srgbClr val="E0E0E0"/>
+                </a:solidFill>
+                <a:latin typeface="Calibri"/>
+              </a:defRPr>
+            </a:pPr>
+          </a:p>
+          <a:p>
+            <a:pPr>
+              <a:spcAft>
+                <a:spcPts val="780"/>
+              </a:spcAft>
+              <a:defRPr sz="1300">
+                <a:solidFill>
+                  <a:srgbClr val="E0E0E0"/>
+                </a:solidFill>
+                <a:latin typeface="Calibri"/>
+              </a:defRPr>
+            </a:pPr>
+            <a:r>
+              <a:t>Mistral-7B token 概率 (30维)</a:t>
+            </a:r>
+          </a:p>
+          <a:p>
+            <a:pPr>
+              <a:spcAft>
+                <a:spcPts val="780"/>
+              </a:spcAft>
+              <a:defRPr sz="1300">
+                <a:solidFill>
+                  <a:srgbClr val="E0E0E0"/>
+                </a:solidFill>
+                <a:latin typeface="Calibri"/>
+              </a:defRPr>
+            </a:pPr>
+            <a:r>
+              <a:t>  逐 token log-prob / rank / entropy</a:t>
+            </a:r>
+          </a:p>
+          <a:p>
+            <a:pPr>
+              <a:spcAft>
+                <a:spcPts val="780"/>
+              </a:spcAft>
+              <a:defRPr sz="1300">
+                <a:solidFill>
+                  <a:srgbClr val="E0E0E0"/>
+                </a:solidFill>
+                <a:latin typeface="Calibri"/>
+              </a:defRPr>
+            </a:pPr>
+            <a:r>
+              <a:t>  检测同代 AI 的"选词指纹"</a:t>
             </a:r>
           </a:p>
         </p:txBody>
@@ -14178,7 +14005,7 @@
               </a:defRPr>
             </a:pPr>
             <a:r>
-              <a:t>纯统计 (36维)  +  模型衍生 (52维)  +  Token级 (30维)  =  118维 (去重后)</a:t>
+              <a:t>Model-Free (36维)  +  Model-Based (82维)  =  118维 (去重后)</a:t>
             </a:r>
           </a:p>
         </p:txBody>
@@ -14250,7 +14077,7 @@
               </a:defRPr>
             </a:pPr>
             <a:r>
-              <a:t>三层特征从不同粒度和视角刻画文本: 表面统计 → 语义嵌入 → Token 概率</a:t>
+              <a:t>核心理念：Model-Free 看文本的外表, Model-Based 的三个参考模型各自捕捉不同时代 AI 的内在</a:t>
             </a:r>
           </a:p>
         </p:txBody>

</xml_diff>

<commit_message>
Refocus PPT narrative on shelf-life story, remove Auto-Filter slide
Replace Auto-Filter dedicated slide with "Feature Shelf Life Summary"
showing effective/ineffective ranges per feature layer and deployment
strategies. Update method overview and conclusion accordingly.

Co-Authored-By: Claude Opus 4.6 <noreply@anthropic.com>
</commit_message>
<xml_diff>
--- a/reports/AIGC_Detection_Presentation.pptx
+++ b/reports/AIGC_Detection_Presentation.pptx
@@ -8526,7 +8526,7 @@
               </a:defRPr>
             </a:pPr>
             <a:r>
-              <a:t>启示: 生产系统需要特征选择/门控 — 先评估各特征组信号强度，动态决定使用哪些特征</a:t>
+              <a:t>启示: Model-Free 特征的"有效期"已过 — 新 AI 在统计上逼近人类, 需要同代参考模型的 token 特征来检测</a:t>
             </a:r>
           </a:p>
         </p:txBody>
@@ -8894,7 +8894,7 @@
               </a:defRPr>
             </a:pPr>
             <a:r>
-              <a:t>解决方案: Auto-Filter 噪声特征自动过滤</a:t>
+              <a:t>特征"有效期"总结：按目标选参考模型</a:t>
             </a:r>
           </a:p>
         </p:txBody>
@@ -8951,7 +8951,7 @@
         <p:spPr>
           <a:xfrm>
             <a:off x="731520" y="1280160"/>
-            <a:ext cx="5029200" cy="548640"/>
+            <a:ext cx="5486400" cy="548640"/>
           </a:xfrm>
           <a:prstGeom prst="rect">
             <a:avLst/>
@@ -8973,7 +8973,7 @@
               </a:defRPr>
             </a:pPr>
             <a:r>
-              <a:t>机制: 组级信号强度检测</a:t>
+              <a:t>各特征层的有效范围</a:t>
             </a:r>
           </a:p>
         </p:txBody>
@@ -8987,125 +8987,29 @@
         <p:spPr>
           <a:xfrm>
             <a:off x="731520" y="1828800"/>
-            <a:ext cx="5029200" cy="2286000"/>
-          </a:xfrm>
-          <a:prstGeom prst="rect">
-            <a:avLst/>
-          </a:prstGeom>
-          <a:noFill/>
-        </p:spPr>
-        <p:txBody>
-          <a:bodyPr wrap="square">
-            <a:spAutoFit/>
-          </a:bodyPr>
-          <a:lstStyle/>
-          <a:p>
-            <a:pPr>
-              <a:spcAft>
-                <a:spcPts val="900"/>
-              </a:spcAft>
-              <a:defRPr sz="1500">
-                <a:solidFill>
-                  <a:srgbClr val="E0E0E0"/>
-                </a:solidFill>
-                <a:latin typeface="Calibri"/>
-              </a:defRPr>
-            </a:pPr>
-            <a:r>
-              <a:t>对每组特征计算平均单特征 AUC</a:t>
-            </a:r>
-          </a:p>
-          <a:p>
-            <a:pPr>
-              <a:spcAft>
-                <a:spcPts val="900"/>
-              </a:spcAft>
-              <a:defRPr sz="1500">
-                <a:solidFill>
-                  <a:srgbClr val="E0E0E0"/>
-                </a:solidFill>
-                <a:latin typeface="Calibri"/>
-              </a:defRPr>
-            </a:pPr>
-            <a:r>
-              <a:t>  avg_AUC = mean(max(AUC_i, 1-AUC_i))</a:t>
-            </a:r>
-          </a:p>
-          <a:p>
-            <a:pPr>
-              <a:spcAft>
-                <a:spcPts val="900"/>
-              </a:spcAft>
-              <a:defRPr sz="1500">
-                <a:solidFill>
-                  <a:srgbClr val="E0E0E0"/>
-                </a:solidFill>
-                <a:latin typeface="Calibri"/>
-              </a:defRPr>
-            </a:pPr>
-            <a:r>
-              <a:t>丢弃 avg AUC &lt; 0.52 的组 (近随机)</a:t>
-            </a:r>
-          </a:p>
-          <a:p>
-            <a:pPr>
-              <a:spcAft>
-                <a:spcPts val="900"/>
-              </a:spcAft>
-              <a:defRPr sz="1500">
-                <a:solidFill>
-                  <a:srgbClr val="E0E0E0"/>
-                </a:solidFill>
-                <a:latin typeface="Calibri"/>
-              </a:defRPr>
-            </a:pPr>
-            <a:r>
-              <a:t>余下特征 + 30 token → 组合训练</a:t>
-            </a:r>
-          </a:p>
-          <a:p>
-            <a:pPr>
-              <a:spcAft>
-                <a:spcPts val="900"/>
-              </a:spcAft>
-              <a:defRPr sz="1500">
-                <a:solidFill>
-                  <a:srgbClr val="E0E0E0"/>
-                </a:solidFill>
-                <a:latin typeface="Calibri"/>
-              </a:defRPr>
-            </a:pPr>
-          </a:p>
-          <a:p>
-            <a:pPr>
-              <a:spcAft>
-                <a:spcPts val="900"/>
-              </a:spcAft>
-              <a:defRPr sz="1500">
-                <a:solidFill>
-                  <a:srgbClr val="E0E0E0"/>
-                </a:solidFill>
-                <a:latin typeface="Calibri"/>
-              </a:defRPr>
-            </a:pPr>
-            <a:r>
-              <a:t>只用训练集评估 → 不泄露测试信息</a:t>
-            </a:r>
-          </a:p>
-          <a:p>
-            <a:pPr>
-              <a:spcAft>
-                <a:spcPts val="900"/>
-              </a:spcAft>
-              <a:defRPr sz="1500">
-                <a:solidFill>
-                  <a:srgbClr val="E0E0E0"/>
-                </a:solidFill>
-                <a:latin typeface="Calibri"/>
-              </a:defRPr>
-            </a:pPr>
-            <a:r>
-              <a:t>O(n·p) 开销 → 几秒完成</a:t>
+            <a:ext cx="2286000" cy="365760"/>
+          </a:xfrm>
+          <a:prstGeom prst="rect">
+            <a:avLst/>
+          </a:prstGeom>
+          <a:noFill/>
+        </p:spPr>
+        <p:txBody>
+          <a:bodyPr wrap="square">
+            <a:spAutoFit/>
+          </a:bodyPr>
+          <a:lstStyle/>
+          <a:p>
+            <a:pPr algn="l">
+              <a:defRPr sz="1600" b="1">
+                <a:solidFill>
+                  <a:srgbClr val="00D2FF"/>
+                </a:solidFill>
+                <a:latin typeface="Calibri"/>
+              </a:defRPr>
+            </a:pPr>
+            <a:r>
+              <a:t>特征层</a:t>
             </a:r>
           </a:p>
         </p:txBody>
@@ -9118,22 +9022,526 @@
         </p:nvSpPr>
         <p:spPr>
           <a:xfrm>
-            <a:off x="6400800" y="1280160"/>
-            <a:ext cx="5029200" cy="548640"/>
-          </a:xfrm>
-          <a:prstGeom prst="rect">
-            <a:avLst/>
-          </a:prstGeom>
-          <a:noFill/>
-        </p:spPr>
-        <p:txBody>
-          <a:bodyPr wrap="square">
-            <a:spAutoFit/>
-          </a:bodyPr>
-          <a:lstStyle/>
-          <a:p>
-            <a:pPr algn="l">
-              <a:defRPr sz="2000" b="1">
+            <a:off x="3200400" y="1828800"/>
+            <a:ext cx="2743200" cy="365760"/>
+          </a:xfrm>
+          <a:prstGeom prst="rect">
+            <a:avLst/>
+          </a:prstGeom>
+          <a:noFill/>
+        </p:spPr>
+        <p:txBody>
+          <a:bodyPr wrap="square">
+            <a:spAutoFit/>
+          </a:bodyPr>
+          <a:lstStyle/>
+          <a:p>
+            <a:pPr algn="l">
+              <a:defRPr sz="1600" b="1">
+                <a:solidFill>
+                  <a:srgbClr val="00D2FF"/>
+                </a:solidFill>
+                <a:latin typeface="Calibri"/>
+              </a:defRPr>
+            </a:pPr>
+            <a:r>
+              <a:t>有效目标</a:t>
+            </a:r>
+          </a:p>
+        </p:txBody>
+      </p:sp>
+      <p:sp>
+        <p:nvSpPr>
+          <p:cNvPr id="7" name="TextBox 6"/>
+          <p:cNvSpPr txBox="1"/>
+          <p:nvPr/>
+        </p:nvSpPr>
+        <p:spPr>
+          <a:xfrm>
+            <a:off x="6217920" y="1828800"/>
+            <a:ext cx="2743200" cy="365760"/>
+          </a:xfrm>
+          <a:prstGeom prst="rect">
+            <a:avLst/>
+          </a:prstGeom>
+          <a:noFill/>
+        </p:spPr>
+        <p:txBody>
+          <a:bodyPr wrap="square">
+            <a:spAutoFit/>
+          </a:bodyPr>
+          <a:lstStyle/>
+          <a:p>
+            <a:pPr algn="l">
+              <a:defRPr sz="1600" b="1">
+                <a:solidFill>
+                  <a:srgbClr val="00D2FF"/>
+                </a:solidFill>
+                <a:latin typeface="Calibri"/>
+              </a:defRPr>
+            </a:pPr>
+            <a:r>
+              <a:t>失效目标</a:t>
+            </a:r>
+          </a:p>
+        </p:txBody>
+      </p:sp>
+      <p:sp>
+        <p:nvSpPr>
+          <p:cNvPr id="8" name="TextBox 7"/>
+          <p:cNvSpPr txBox="1"/>
+          <p:nvPr/>
+        </p:nvSpPr>
+        <p:spPr>
+          <a:xfrm>
+            <a:off x="731520" y="2377440"/>
+            <a:ext cx="2286000" cy="457200"/>
+          </a:xfrm>
+          <a:prstGeom prst="rect">
+            <a:avLst/>
+          </a:prstGeom>
+          <a:noFill/>
+        </p:spPr>
+        <p:txBody>
+          <a:bodyPr wrap="square">
+            <a:spAutoFit/>
+          </a:bodyPr>
+          <a:lstStyle/>
+          <a:p>
+            <a:pPr algn="l">
+              <a:defRPr sz="1400" b="1">
+                <a:solidFill>
+                  <a:srgbClr val="E0E0E0"/>
+                </a:solidFill>
+                <a:latin typeface="Calibri"/>
+              </a:defRPr>
+            </a:pPr>
+            <a:r>
+              <a:t>Model-Free (36d)</a:t>
+            </a:r>
+          </a:p>
+        </p:txBody>
+      </p:sp>
+      <p:sp>
+        <p:nvSpPr>
+          <p:cNvPr id="9" name="TextBox 8"/>
+          <p:cNvSpPr txBox="1"/>
+          <p:nvPr/>
+        </p:nvSpPr>
+        <p:spPr>
+          <a:xfrm>
+            <a:off x="3200400" y="2377440"/>
+            <a:ext cx="2743200" cy="457200"/>
+          </a:xfrm>
+          <a:prstGeom prst="rect">
+            <a:avLst/>
+          </a:prstGeom>
+          <a:noFill/>
+        </p:spPr>
+        <p:txBody>
+          <a:bodyPr wrap="square">
+            <a:spAutoFit/>
+          </a:bodyPr>
+          <a:lstStyle/>
+          <a:p>
+            <a:pPr algn="l">
+              <a:defRPr sz="1300" b="0">
+                <a:solidFill>
+                  <a:srgbClr val="4ECB71"/>
+                </a:solidFill>
+                <a:latin typeface="Calibri"/>
+              </a:defRPr>
+            </a:pPr>
+            <a:r>
+              <a:t>老 AI (RAID=0.994)</a:t>
+            </a:r>
+          </a:p>
+        </p:txBody>
+      </p:sp>
+      <p:sp>
+        <p:nvSpPr>
+          <p:cNvPr id="10" name="TextBox 9"/>
+          <p:cNvSpPr txBox="1"/>
+          <p:nvPr/>
+        </p:nvSpPr>
+        <p:spPr>
+          <a:xfrm>
+            <a:off x="6217920" y="2377440"/>
+            <a:ext cx="2743200" cy="457200"/>
+          </a:xfrm>
+          <a:prstGeom prst="rect">
+            <a:avLst/>
+          </a:prstGeom>
+          <a:noFill/>
+        </p:spPr>
+        <p:txBody>
+          <a:bodyPr wrap="square">
+            <a:spAutoFit/>
+          </a:bodyPr>
+          <a:lstStyle/>
+          <a:p>
+            <a:pPr algn="l">
+              <a:defRPr sz="1300" b="0">
+                <a:solidFill>
+                  <a:srgbClr val="FF6B6B"/>
+                </a:solidFill>
+                <a:latin typeface="Calibri"/>
+              </a:defRPr>
+            </a:pPr>
+            <a:r>
+              <a:t>新 AI (SemEval=0.52)</a:t>
+            </a:r>
+          </a:p>
+        </p:txBody>
+      </p:sp>
+      <p:sp>
+        <p:nvSpPr>
+          <p:cNvPr id="11" name="TextBox 10"/>
+          <p:cNvSpPr txBox="1"/>
+          <p:nvPr/>
+        </p:nvSpPr>
+        <p:spPr>
+          <a:xfrm>
+            <a:off x="731520" y="3063240"/>
+            <a:ext cx="2286000" cy="457200"/>
+          </a:xfrm>
+          <a:prstGeom prst="rect">
+            <a:avLst/>
+          </a:prstGeom>
+          <a:noFill/>
+        </p:spPr>
+        <p:txBody>
+          <a:bodyPr wrap="square">
+            <a:spAutoFit/>
+          </a:bodyPr>
+          <a:lstStyle/>
+          <a:p>
+            <a:pPr algn="l">
+              <a:defRPr sz="1400" b="1">
+                <a:solidFill>
+                  <a:srgbClr val="E0E0E0"/>
+                </a:solidFill>
+                <a:latin typeface="Calibri"/>
+              </a:defRPr>
+            </a:pPr>
+            <a:r>
+              <a:t>BERT-emb (50d)</a:t>
+            </a:r>
+          </a:p>
+        </p:txBody>
+      </p:sp>
+      <p:sp>
+        <p:nvSpPr>
+          <p:cNvPr id="12" name="TextBox 11"/>
+          <p:cNvSpPr txBox="1"/>
+          <p:nvPr/>
+        </p:nvSpPr>
+        <p:spPr>
+          <a:xfrm>
+            <a:off x="3200400" y="3063240"/>
+            <a:ext cx="2743200" cy="457200"/>
+          </a:xfrm>
+          <a:prstGeom prst="rect">
+            <a:avLst/>
+          </a:prstGeom>
+          <a:noFill/>
+        </p:spPr>
+        <p:txBody>
+          <a:bodyPr wrap="square">
+            <a:spAutoFit/>
+          </a:bodyPr>
+          <a:lstStyle/>
+          <a:p>
+            <a:pPr algn="l">
+              <a:defRPr sz="1300" b="0">
+                <a:solidFill>
+                  <a:srgbClr val="4ECB71"/>
+                </a:solidFill>
+                <a:latin typeface="Calibri"/>
+              </a:defRPr>
+            </a:pPr>
+            <a:r>
+              <a:t>HC3=0.88, Pile=0.90</a:t>
+            </a:r>
+          </a:p>
+        </p:txBody>
+      </p:sp>
+      <p:sp>
+        <p:nvSpPr>
+          <p:cNvPr id="13" name="TextBox 12"/>
+          <p:cNvSpPr txBox="1"/>
+          <p:nvPr/>
+        </p:nvSpPr>
+        <p:spPr>
+          <a:xfrm>
+            <a:off x="6217920" y="3063240"/>
+            <a:ext cx="2743200" cy="457200"/>
+          </a:xfrm>
+          <a:prstGeom prst="rect">
+            <a:avLst/>
+          </a:prstGeom>
+          <a:noFill/>
+        </p:spPr>
+        <p:txBody>
+          <a:bodyPr wrap="square">
+            <a:spAutoFit/>
+          </a:bodyPr>
+          <a:lstStyle/>
+          <a:p>
+            <a:pPr algn="l">
+              <a:defRPr sz="1300" b="0">
+                <a:solidFill>
+                  <a:srgbClr val="FF6B6B"/>
+                </a:solidFill>
+                <a:latin typeface="Calibri"/>
+              </a:defRPr>
+            </a:pPr>
+            <a:r>
+              <a:t>SemEval=0.50, TB=0.54</a:t>
+            </a:r>
+          </a:p>
+        </p:txBody>
+      </p:sp>
+      <p:sp>
+        <p:nvSpPr>
+          <p:cNvPr id="14" name="TextBox 13"/>
+          <p:cNvSpPr txBox="1"/>
+          <p:nvPr/>
+        </p:nvSpPr>
+        <p:spPr>
+          <a:xfrm>
+            <a:off x="731520" y="3749039"/>
+            <a:ext cx="2286000" cy="457200"/>
+          </a:xfrm>
+          <a:prstGeom prst="rect">
+            <a:avLst/>
+          </a:prstGeom>
+          <a:noFill/>
+        </p:spPr>
+        <p:txBody>
+          <a:bodyPr wrap="square">
+            <a:spAutoFit/>
+          </a:bodyPr>
+          <a:lstStyle/>
+          <a:p>
+            <a:pPr algn="l">
+              <a:defRPr sz="1400" b="1">
+                <a:solidFill>
+                  <a:srgbClr val="FF6B6B"/>
+                </a:solidFill>
+                <a:latin typeface="Calibri"/>
+              </a:defRPr>
+            </a:pPr>
+            <a:r>
+              <a:t>GPT2-ppl (2d)</a:t>
+            </a:r>
+          </a:p>
+        </p:txBody>
+      </p:sp>
+      <p:sp>
+        <p:nvSpPr>
+          <p:cNvPr id="15" name="TextBox 14"/>
+          <p:cNvSpPr txBox="1"/>
+          <p:nvPr/>
+        </p:nvSpPr>
+        <p:spPr>
+          <a:xfrm>
+            <a:off x="3200400" y="3749039"/>
+            <a:ext cx="2743200" cy="457200"/>
+          </a:xfrm>
+          <a:prstGeom prst="rect">
+            <a:avLst/>
+          </a:prstGeom>
+          <a:noFill/>
+        </p:spPr>
+        <p:txBody>
+          <a:bodyPr wrap="square">
+            <a:spAutoFit/>
+          </a:bodyPr>
+          <a:lstStyle/>
+          <a:p>
+            <a:pPr algn="l">
+              <a:defRPr sz="1300" b="0">
+                <a:solidFill>
+                  <a:srgbClr val="4ECB71"/>
+                </a:solidFill>
+                <a:latin typeface="Calibri"/>
+              </a:defRPr>
+            </a:pPr>
+            <a:r>
+              <a:t>GPT系: HC3=0.99, TB=0.97</a:t>
+            </a:r>
+          </a:p>
+        </p:txBody>
+      </p:sp>
+      <p:sp>
+        <p:nvSpPr>
+          <p:cNvPr id="16" name="TextBox 15"/>
+          <p:cNvSpPr txBox="1"/>
+          <p:nvPr/>
+        </p:nvSpPr>
+        <p:spPr>
+          <a:xfrm>
+            <a:off x="6217920" y="3749039"/>
+            <a:ext cx="2743200" cy="457200"/>
+          </a:xfrm>
+          <a:prstGeom prst="rect">
+            <a:avLst/>
+          </a:prstGeom>
+          <a:noFill/>
+        </p:spPr>
+        <p:txBody>
+          <a:bodyPr wrap="square">
+            <a:spAutoFit/>
+          </a:bodyPr>
+          <a:lstStyle/>
+          <a:p>
+            <a:pPr algn="l">
+              <a:defRPr sz="1300" b="0">
+                <a:solidFill>
+                  <a:srgbClr val="FF6B6B"/>
+                </a:solidFill>
+                <a:latin typeface="Calibri"/>
+              </a:defRPr>
+            </a:pPr>
+            <a:r>
+              <a:t>非GPT: RAID=0.49</a:t>
+            </a:r>
+          </a:p>
+        </p:txBody>
+      </p:sp>
+      <p:sp>
+        <p:nvSpPr>
+          <p:cNvPr id="17" name="TextBox 16"/>
+          <p:cNvSpPr txBox="1"/>
+          <p:nvPr/>
+        </p:nvSpPr>
+        <p:spPr>
+          <a:xfrm>
+            <a:off x="731520" y="4434840"/>
+            <a:ext cx="2286000" cy="457200"/>
+          </a:xfrm>
+          <a:prstGeom prst="rect">
+            <a:avLst/>
+          </a:prstGeom>
+          <a:noFill/>
+        </p:spPr>
+        <p:txBody>
+          <a:bodyPr wrap="square">
+            <a:spAutoFit/>
+          </a:bodyPr>
+          <a:lstStyle/>
+          <a:p>
+            <a:pPr algn="l">
+              <a:defRPr sz="1400" b="1">
+                <a:solidFill>
+                  <a:srgbClr val="4ECB71"/>
+                </a:solidFill>
+                <a:latin typeface="Calibri"/>
+              </a:defRPr>
+            </a:pPr>
+            <a:r>
+              <a:t>Mistral-token (30d)</a:t>
+            </a:r>
+          </a:p>
+        </p:txBody>
+      </p:sp>
+      <p:sp>
+        <p:nvSpPr>
+          <p:cNvPr id="18" name="TextBox 17"/>
+          <p:cNvSpPr txBox="1"/>
+          <p:nvPr/>
+        </p:nvSpPr>
+        <p:spPr>
+          <a:xfrm>
+            <a:off x="3200400" y="4434840"/>
+            <a:ext cx="2743200" cy="457200"/>
+          </a:xfrm>
+          <a:prstGeom prst="rect">
+            <a:avLst/>
+          </a:prstGeom>
+          <a:noFill/>
+        </p:spPr>
+        <p:txBody>
+          <a:bodyPr wrap="square">
+            <a:spAutoFit/>
+          </a:bodyPr>
+          <a:lstStyle/>
+          <a:p>
+            <a:pPr algn="l">
+              <a:defRPr sz="1300" b="0">
+                <a:solidFill>
+                  <a:srgbClr val="4ECB71"/>
+                </a:solidFill>
+                <a:latin typeface="Calibri"/>
+              </a:defRPr>
+            </a:pPr>
+            <a:r>
+              <a:t>同代: RAID=0.99, SE=0.98</a:t>
+            </a:r>
+          </a:p>
+        </p:txBody>
+      </p:sp>
+      <p:sp>
+        <p:nvSpPr>
+          <p:cNvPr id="19" name="TextBox 18"/>
+          <p:cNvSpPr txBox="1"/>
+          <p:nvPr/>
+        </p:nvSpPr>
+        <p:spPr>
+          <a:xfrm>
+            <a:off x="6217920" y="4434840"/>
+            <a:ext cx="2743200" cy="457200"/>
+          </a:xfrm>
+          <a:prstGeom prst="rect">
+            <a:avLst/>
+          </a:prstGeom>
+          <a:noFill/>
+        </p:spPr>
+        <p:txBody>
+          <a:bodyPr wrap="square">
+            <a:spAutoFit/>
+          </a:bodyPr>
+          <a:lstStyle/>
+          <a:p>
+            <a:pPr algn="l">
+              <a:defRPr sz="1300" b="0">
+                <a:solidFill>
+                  <a:srgbClr val="FF6B6B"/>
+                </a:solidFill>
+                <a:latin typeface="Calibri"/>
+              </a:defRPr>
+            </a:pPr>
+            <a:r>
+              <a:t>老AI: HC3=0.50, TB=0.52</a:t>
+            </a:r>
+          </a:p>
+        </p:txBody>
+      </p:sp>
+      <p:sp>
+        <p:nvSpPr>
+          <p:cNvPr id="20" name="TextBox 19"/>
+          <p:cNvSpPr txBox="1"/>
+          <p:nvPr/>
+        </p:nvSpPr>
+        <p:spPr>
+          <a:xfrm>
+            <a:off x="731520" y="4846320"/>
+            <a:ext cx="10972800" cy="548640"/>
+          </a:xfrm>
+          <a:prstGeom prst="rect">
+            <a:avLst/>
+          </a:prstGeom>
+          <a:noFill/>
+        </p:spPr>
+        <p:txBody>
+          <a:bodyPr wrap="square">
+            <a:spAutoFit/>
+          </a:bodyPr>
+          <a:lstStyle/>
+          <a:p>
+            <a:pPr algn="ctr">
+              <a:defRPr sz="1800" b="1">
                 <a:solidFill>
                   <a:srgbClr val="FFFFFF"/>
                 </a:solidFill>
@@ -9141,35 +9549,35 @@
               </a:defRPr>
             </a:pPr>
             <a:r>
-              <a:t>跨数据集 Auto-Filter 结果</a:t>
-            </a:r>
-          </a:p>
-        </p:txBody>
-      </p:sp>
-      <p:sp>
-        <p:nvSpPr>
-          <p:cNvPr id="7" name="TextBox 6"/>
-          <p:cNvSpPr txBox="1"/>
-          <p:nvPr/>
-        </p:nvSpPr>
-        <p:spPr>
-          <a:xfrm>
-            <a:off x="6400800" y="1828800"/>
-            <a:ext cx="2011680" cy="365760"/>
-          </a:xfrm>
-          <a:prstGeom prst="rect">
-            <a:avLst/>
-          </a:prstGeom>
-          <a:noFill/>
-        </p:spPr>
-        <p:txBody>
-          <a:bodyPr wrap="square">
-            <a:spAutoFit/>
-          </a:bodyPr>
-          <a:lstStyle/>
-          <a:p>
-            <a:pPr algn="l">
-              <a:defRPr sz="1500" b="1">
+              <a:t>部署策略：先判断目标 AI 的时代，再选合适的特征层</a:t>
+            </a:r>
+          </a:p>
+        </p:txBody>
+      </p:sp>
+      <p:sp>
+        <p:nvSpPr>
+          <p:cNvPr id="21" name="TextBox 20"/>
+          <p:cNvSpPr txBox="1"/>
+          <p:nvPr/>
+        </p:nvSpPr>
+        <p:spPr>
+          <a:xfrm>
+            <a:off x="731520" y="5303520"/>
+            <a:ext cx="3474720" cy="274320"/>
+          </a:xfrm>
+          <a:prstGeom prst="rect">
+            <a:avLst/>
+          </a:prstGeom>
+          <a:noFill/>
+        </p:spPr>
+        <p:txBody>
+          <a:bodyPr wrap="square">
+            <a:spAutoFit/>
+          </a:bodyPr>
+          <a:lstStyle/>
+          <a:p>
+            <a:pPr algn="l">
+              <a:defRPr sz="1300" b="1">
                 <a:solidFill>
                   <a:srgbClr val="00D2FF"/>
                 </a:solidFill>
@@ -9177,35 +9585,107 @@
               </a:defRPr>
             </a:pPr>
             <a:r>
-              <a:t>Dataset</a:t>
-            </a:r>
-          </a:p>
-        </p:txBody>
-      </p:sp>
-      <p:sp>
-        <p:nvSpPr>
-          <p:cNvPr id="8" name="TextBox 7"/>
-          <p:cNvSpPr txBox="1"/>
-          <p:nvPr/>
-        </p:nvSpPr>
-        <p:spPr>
-          <a:xfrm>
-            <a:off x="8503920" y="1828800"/>
-            <a:ext cx="1188720" cy="365760"/>
-          </a:xfrm>
-          <a:prstGeom prst="rect">
-            <a:avLst/>
-          </a:prstGeom>
-          <a:noFill/>
-        </p:spPr>
-        <p:txBody>
-          <a:bodyPr wrap="square">
-            <a:spAutoFit/>
-          </a:bodyPr>
-          <a:lstStyle/>
-          <a:p>
-            <a:pPr algn="l">
-              <a:defRPr sz="1500" b="1">
+              <a:t>检测 GPT 系 (ChatGPT)</a:t>
+            </a:r>
+          </a:p>
+        </p:txBody>
+      </p:sp>
+      <p:sp>
+        <p:nvSpPr>
+          <p:cNvPr id="22" name="TextBox 21"/>
+          <p:cNvSpPr txBox="1"/>
+          <p:nvPr/>
+        </p:nvSpPr>
+        <p:spPr>
+          <a:xfrm>
+            <a:off x="731520" y="5577840"/>
+            <a:ext cx="3474720" cy="274320"/>
+          </a:xfrm>
+          <a:prstGeom prst="rect">
+            <a:avLst/>
+          </a:prstGeom>
+          <a:noFill/>
+        </p:spPr>
+        <p:txBody>
+          <a:bodyPr wrap="square">
+            <a:spAutoFit/>
+          </a:bodyPr>
+          <a:lstStyle/>
+          <a:p>
+            <a:pPr algn="l">
+              <a:defRPr sz="1200" b="0">
+                <a:solidFill>
+                  <a:srgbClr val="E0E0E0"/>
+                </a:solidFill>
+                <a:latin typeface="Calibri"/>
+              </a:defRPr>
+            </a:pPr>
+            <a:r>
+              <a:t>Model-Free + GPT2-ppl</a:t>
+            </a:r>
+          </a:p>
+        </p:txBody>
+      </p:sp>
+      <p:sp>
+        <p:nvSpPr>
+          <p:cNvPr id="23" name="TextBox 22"/>
+          <p:cNvSpPr txBox="1"/>
+          <p:nvPr/>
+        </p:nvSpPr>
+        <p:spPr>
+          <a:xfrm>
+            <a:off x="731520" y="5852160"/>
+            <a:ext cx="3474720" cy="274320"/>
+          </a:xfrm>
+          <a:prstGeom prst="rect">
+            <a:avLst/>
+          </a:prstGeom>
+          <a:noFill/>
+        </p:spPr>
+        <p:txBody>
+          <a:bodyPr wrap="square">
+            <a:spAutoFit/>
+          </a:bodyPr>
+          <a:lstStyle/>
+          <a:p>
+            <a:pPr algn="l">
+              <a:defRPr sz="1200" b="0">
+                <a:solidFill>
+                  <a:srgbClr val="4ECB71"/>
+                </a:solidFill>
+                <a:latin typeface="Calibri"/>
+              </a:defRPr>
+            </a:pPr>
+            <a:r>
+              <a:t>HC3: AUC 1.000</a:t>
+            </a:r>
+          </a:p>
+        </p:txBody>
+      </p:sp>
+      <p:sp>
+        <p:nvSpPr>
+          <p:cNvPr id="24" name="TextBox 23"/>
+          <p:cNvSpPr txBox="1"/>
+          <p:nvPr/>
+        </p:nvSpPr>
+        <p:spPr>
+          <a:xfrm>
+            <a:off x="4480559" y="5303520"/>
+            <a:ext cx="3474720" cy="274320"/>
+          </a:xfrm>
+          <a:prstGeom prst="rect">
+            <a:avLst/>
+          </a:prstGeom>
+          <a:noFill/>
+        </p:spPr>
+        <p:txBody>
+          <a:bodyPr wrap="square">
+            <a:spAutoFit/>
+          </a:bodyPr>
+          <a:lstStyle/>
+          <a:p>
+            <a:pPr algn="l">
+              <a:defRPr sz="1300" b="1">
                 <a:solidFill>
                   <a:srgbClr val="00D2FF"/>
                 </a:solidFill>
@@ -9213,35 +9693,107 @@
               </a:defRPr>
             </a:pPr>
             <a:r>
-              <a:t>Before</a:t>
-            </a:r>
-          </a:p>
-        </p:txBody>
-      </p:sp>
-      <p:sp>
-        <p:nvSpPr>
-          <p:cNvPr id="9" name="TextBox 8"/>
-          <p:cNvSpPr txBox="1"/>
-          <p:nvPr/>
-        </p:nvSpPr>
-        <p:spPr>
-          <a:xfrm>
-            <a:off x="9784080" y="1828800"/>
-            <a:ext cx="1188720" cy="365760"/>
-          </a:xfrm>
-          <a:prstGeom prst="rect">
-            <a:avLst/>
-          </a:prstGeom>
-          <a:noFill/>
-        </p:spPr>
-        <p:txBody>
-          <a:bodyPr wrap="square">
-            <a:spAutoFit/>
-          </a:bodyPr>
-          <a:lstStyle/>
-          <a:p>
-            <a:pPr algn="l">
-              <a:defRPr sz="1500" b="1">
+              <a:t>检测同代新 AI (GPT-4/Claude)</a:t>
+            </a:r>
+          </a:p>
+        </p:txBody>
+      </p:sp>
+      <p:sp>
+        <p:nvSpPr>
+          <p:cNvPr id="25" name="TextBox 24"/>
+          <p:cNvSpPr txBox="1"/>
+          <p:nvPr/>
+        </p:nvSpPr>
+        <p:spPr>
+          <a:xfrm>
+            <a:off x="4480559" y="5577840"/>
+            <a:ext cx="3474720" cy="274320"/>
+          </a:xfrm>
+          <a:prstGeom prst="rect">
+            <a:avLst/>
+          </a:prstGeom>
+          <a:noFill/>
+        </p:spPr>
+        <p:txBody>
+          <a:bodyPr wrap="square">
+            <a:spAutoFit/>
+          </a:bodyPr>
+          <a:lstStyle/>
+          <a:p>
+            <a:pPr algn="l">
+              <a:defRPr sz="1200" b="0">
+                <a:solidFill>
+                  <a:srgbClr val="E0E0E0"/>
+                </a:solidFill>
+                <a:latin typeface="Calibri"/>
+              </a:defRPr>
+            </a:pPr>
+            <a:r>
+              <a:t>Model-Free + Mistral-token</a:t>
+            </a:r>
+          </a:p>
+        </p:txBody>
+      </p:sp>
+      <p:sp>
+        <p:nvSpPr>
+          <p:cNvPr id="26" name="TextBox 25"/>
+          <p:cNvSpPr txBox="1"/>
+          <p:nvPr/>
+        </p:nvSpPr>
+        <p:spPr>
+          <a:xfrm>
+            <a:off x="4480559" y="5852160"/>
+            <a:ext cx="3474720" cy="274320"/>
+          </a:xfrm>
+          <a:prstGeom prst="rect">
+            <a:avLst/>
+          </a:prstGeom>
+          <a:noFill/>
+        </p:spPr>
+        <p:txBody>
+          <a:bodyPr wrap="square">
+            <a:spAutoFit/>
+          </a:bodyPr>
+          <a:lstStyle/>
+          <a:p>
+            <a:pPr algn="l">
+              <a:defRPr sz="1200" b="0">
+                <a:solidFill>
+                  <a:srgbClr val="4ECB71"/>
+                </a:solidFill>
+                <a:latin typeface="Calibri"/>
+              </a:defRPr>
+            </a:pPr>
+            <a:r>
+              <a:t>RAID: AUC 0.999</a:t>
+            </a:r>
+          </a:p>
+        </p:txBody>
+      </p:sp>
+      <p:sp>
+        <p:nvSpPr>
+          <p:cNvPr id="27" name="TextBox 26"/>
+          <p:cNvSpPr txBox="1"/>
+          <p:nvPr/>
+        </p:nvSpPr>
+        <p:spPr>
+          <a:xfrm>
+            <a:off x="8229600" y="5303520"/>
+            <a:ext cx="3474720" cy="274320"/>
+          </a:xfrm>
+          <a:prstGeom prst="rect">
+            <a:avLst/>
+          </a:prstGeom>
+          <a:noFill/>
+        </p:spPr>
+        <p:txBody>
+          <a:bodyPr wrap="square">
+            <a:spAutoFit/>
+          </a:bodyPr>
+          <a:lstStyle/>
+          <a:p>
+            <a:pPr algn="l">
+              <a:defRPr sz="1300" b="1">
                 <a:solidFill>
                   <a:srgbClr val="00D2FF"/>
                 </a:solidFill>
@@ -9249,107 +9801,71 @@
               </a:defRPr>
             </a:pPr>
             <a:r>
-              <a:t>After</a:t>
-            </a:r>
-          </a:p>
-        </p:txBody>
-      </p:sp>
-      <p:sp>
-        <p:nvSpPr>
-          <p:cNvPr id="10" name="TextBox 9"/>
-          <p:cNvSpPr txBox="1"/>
-          <p:nvPr/>
-        </p:nvSpPr>
-        <p:spPr>
-          <a:xfrm>
-            <a:off x="6400800" y="2377440"/>
-            <a:ext cx="2011680" cy="365760"/>
-          </a:xfrm>
-          <a:prstGeom prst="rect">
-            <a:avLst/>
-          </a:prstGeom>
-          <a:noFill/>
-        </p:spPr>
-        <p:txBody>
-          <a:bodyPr wrap="square">
-            <a:spAutoFit/>
-          </a:bodyPr>
-          <a:lstStyle/>
-          <a:p>
-            <a:pPr algn="l">
-              <a:defRPr sz="1400" b="0">
-                <a:solidFill>
-                  <a:srgbClr val="E0E0E0"/>
-                </a:solidFill>
-                <a:latin typeface="Calibri"/>
-              </a:defRPr>
-            </a:pPr>
-            <a:r>
-              <a:t>RAID</a:t>
-            </a:r>
-          </a:p>
-        </p:txBody>
-      </p:sp>
-      <p:sp>
-        <p:nvSpPr>
-          <p:cNvPr id="11" name="TextBox 10"/>
-          <p:cNvSpPr txBox="1"/>
-          <p:nvPr/>
-        </p:nvSpPr>
-        <p:spPr>
-          <a:xfrm>
-            <a:off x="8503920" y="2377440"/>
-            <a:ext cx="1188720" cy="365760"/>
-          </a:xfrm>
-          <a:prstGeom prst="rect">
-            <a:avLst/>
-          </a:prstGeom>
-          <a:noFill/>
-        </p:spPr>
-        <p:txBody>
-          <a:bodyPr wrap="square">
-            <a:spAutoFit/>
-          </a:bodyPr>
-          <a:lstStyle/>
-          <a:p>
-            <a:pPr algn="l">
-              <a:defRPr sz="1400" b="0">
-                <a:solidFill>
-                  <a:srgbClr val="FFFFFF"/>
-                </a:solidFill>
-                <a:latin typeface="Calibri"/>
-              </a:defRPr>
-            </a:pPr>
-            <a:r>
-              <a:t>0.9991</a:t>
-            </a:r>
-          </a:p>
-        </p:txBody>
-      </p:sp>
-      <p:sp>
-        <p:nvSpPr>
-          <p:cNvPr id="12" name="TextBox 11"/>
-          <p:cNvSpPr txBox="1"/>
-          <p:nvPr/>
-        </p:nvSpPr>
-        <p:spPr>
-          <a:xfrm>
-            <a:off x="9784080" y="2377440"/>
-            <a:ext cx="1188720" cy="365760"/>
-          </a:xfrm>
-          <a:prstGeom prst="rect">
-            <a:avLst/>
-          </a:prstGeom>
-          <a:noFill/>
-        </p:spPr>
-        <p:txBody>
-          <a:bodyPr wrap="square">
-            <a:spAutoFit/>
-          </a:bodyPr>
-          <a:lstStyle/>
-          <a:p>
-            <a:pPr algn="l">
-              <a:defRPr sz="1400" b="0">
+              <a:t>未知目标 / 混合场景</a:t>
+            </a:r>
+          </a:p>
+        </p:txBody>
+      </p:sp>
+      <p:sp>
+        <p:nvSpPr>
+          <p:cNvPr id="28" name="TextBox 27"/>
+          <p:cNvSpPr txBox="1"/>
+          <p:nvPr/>
+        </p:nvSpPr>
+        <p:spPr>
+          <a:xfrm>
+            <a:off x="8229600" y="5577840"/>
+            <a:ext cx="3474720" cy="274320"/>
+          </a:xfrm>
+          <a:prstGeom prst="rect">
+            <a:avLst/>
+          </a:prstGeom>
+          <a:noFill/>
+        </p:spPr>
+        <p:txBody>
+          <a:bodyPr wrap="square">
+            <a:spAutoFit/>
+          </a:bodyPr>
+          <a:lstStyle/>
+          <a:p>
+            <a:pPr algn="l">
+              <a:defRPr sz="1200" b="0">
+                <a:solidFill>
+                  <a:srgbClr val="E0E0E0"/>
+                </a:solidFill>
+                <a:latin typeface="Calibri"/>
+              </a:defRPr>
+            </a:pPr>
+            <a:r>
+              <a:t>全部 118 维 + 组级信号检测</a:t>
+            </a:r>
+          </a:p>
+        </p:txBody>
+      </p:sp>
+      <p:sp>
+        <p:nvSpPr>
+          <p:cNvPr id="29" name="TextBox 28"/>
+          <p:cNvSpPr txBox="1"/>
+          <p:nvPr/>
+        </p:nvSpPr>
+        <p:spPr>
+          <a:xfrm>
+            <a:off x="8229600" y="5852160"/>
+            <a:ext cx="3474720" cy="274320"/>
+          </a:xfrm>
+          <a:prstGeom prst="rect">
+            <a:avLst/>
+          </a:prstGeom>
+          <a:noFill/>
+        </p:spPr>
+        <p:txBody>
+          <a:bodyPr wrap="square">
+            <a:spAutoFit/>
+          </a:bodyPr>
+          <a:lstStyle/>
+          <a:p>
+            <a:pPr algn="l">
+              <a:defRPr sz="1200" b="0">
                 <a:solidFill>
                   <a:srgbClr val="4ECB71"/>
                 </a:solidFill>
@@ -9357,692 +9873,7 @@
               </a:defRPr>
             </a:pPr>
             <a:r>
-              <a:t>0.9992</a:t>
-            </a:r>
-          </a:p>
-        </p:txBody>
-      </p:sp>
-      <p:sp>
-        <p:nvSpPr>
-          <p:cNvPr id="13" name="TextBox 12"/>
-          <p:cNvSpPr txBox="1"/>
-          <p:nvPr/>
-        </p:nvSpPr>
-        <p:spPr>
-          <a:xfrm>
-            <a:off x="6400800" y="2971800"/>
-            <a:ext cx="2011680" cy="365760"/>
-          </a:xfrm>
-          <a:prstGeom prst="rect">
-            <a:avLst/>
-          </a:prstGeom>
-          <a:noFill/>
-        </p:spPr>
-        <p:txBody>
-          <a:bodyPr wrap="square">
-            <a:spAutoFit/>
-          </a:bodyPr>
-          <a:lstStyle/>
-          <a:p>
-            <a:pPr algn="l">
-              <a:defRPr sz="1400" b="0">
-                <a:solidFill>
-                  <a:srgbClr val="E0E0E0"/>
-                </a:solidFill>
-                <a:latin typeface="Calibri"/>
-              </a:defRPr>
-            </a:pPr>
-            <a:r>
-              <a:t>HC3</a:t>
-            </a:r>
-          </a:p>
-        </p:txBody>
-      </p:sp>
-      <p:sp>
-        <p:nvSpPr>
-          <p:cNvPr id="14" name="TextBox 13"/>
-          <p:cNvSpPr txBox="1"/>
-          <p:nvPr/>
-        </p:nvSpPr>
-        <p:spPr>
-          <a:xfrm>
-            <a:off x="8503920" y="2971800"/>
-            <a:ext cx="1188720" cy="365760"/>
-          </a:xfrm>
-          <a:prstGeom prst="rect">
-            <a:avLst/>
-          </a:prstGeom>
-          <a:noFill/>
-        </p:spPr>
-        <p:txBody>
-          <a:bodyPr wrap="square">
-            <a:spAutoFit/>
-          </a:bodyPr>
-          <a:lstStyle/>
-          <a:p>
-            <a:pPr algn="l">
-              <a:defRPr sz="1400" b="0">
-                <a:solidFill>
-                  <a:srgbClr val="FFFFFF"/>
-                </a:solidFill>
-                <a:latin typeface="Calibri"/>
-              </a:defRPr>
-            </a:pPr>
-            <a:r>
-              <a:t>0.9995</a:t>
-            </a:r>
-          </a:p>
-        </p:txBody>
-      </p:sp>
-      <p:sp>
-        <p:nvSpPr>
-          <p:cNvPr id="15" name="TextBox 14"/>
-          <p:cNvSpPr txBox="1"/>
-          <p:nvPr/>
-        </p:nvSpPr>
-        <p:spPr>
-          <a:xfrm>
-            <a:off x="9784080" y="2971800"/>
-            <a:ext cx="1188720" cy="365760"/>
-          </a:xfrm>
-          <a:prstGeom prst="rect">
-            <a:avLst/>
-          </a:prstGeom>
-          <a:noFill/>
-        </p:spPr>
-        <p:txBody>
-          <a:bodyPr wrap="square">
-            <a:spAutoFit/>
-          </a:bodyPr>
-          <a:lstStyle/>
-          <a:p>
-            <a:pPr algn="l">
-              <a:defRPr sz="1400" b="0">
-                <a:solidFill>
-                  <a:srgbClr val="4ECB71"/>
-                </a:solidFill>
-                <a:latin typeface="Calibri"/>
-              </a:defRPr>
-            </a:pPr>
-            <a:r>
-              <a:t>0.9996</a:t>
-            </a:r>
-          </a:p>
-        </p:txBody>
-      </p:sp>
-      <p:sp>
-        <p:nvSpPr>
-          <p:cNvPr id="16" name="TextBox 15"/>
-          <p:cNvSpPr txBox="1"/>
-          <p:nvPr/>
-        </p:nvSpPr>
-        <p:spPr>
-          <a:xfrm>
-            <a:off x="6400800" y="3566160"/>
-            <a:ext cx="2011680" cy="365760"/>
-          </a:xfrm>
-          <a:prstGeom prst="rect">
-            <a:avLst/>
-          </a:prstGeom>
-          <a:noFill/>
-        </p:spPr>
-        <p:txBody>
-          <a:bodyPr wrap="square">
-            <a:spAutoFit/>
-          </a:bodyPr>
-          <a:lstStyle/>
-          <a:p>
-            <a:pPr algn="l">
-              <a:defRPr sz="1400" b="0">
-                <a:solidFill>
-                  <a:srgbClr val="FF6B6B"/>
-                </a:solidFill>
-                <a:latin typeface="Calibri"/>
-              </a:defRPr>
-            </a:pPr>
-            <a:r>
-              <a:t>SemEval</a:t>
-            </a:r>
-          </a:p>
-        </p:txBody>
-      </p:sp>
-      <p:sp>
-        <p:nvSpPr>
-          <p:cNvPr id="17" name="TextBox 16"/>
-          <p:cNvSpPr txBox="1"/>
-          <p:nvPr/>
-        </p:nvSpPr>
-        <p:spPr>
-          <a:xfrm>
-            <a:off x="8503920" y="3566160"/>
-            <a:ext cx="1188720" cy="365760"/>
-          </a:xfrm>
-          <a:prstGeom prst="rect">
-            <a:avLst/>
-          </a:prstGeom>
-          <a:noFill/>
-        </p:spPr>
-        <p:txBody>
-          <a:bodyPr wrap="square">
-            <a:spAutoFit/>
-          </a:bodyPr>
-          <a:lstStyle/>
-          <a:p>
-            <a:pPr algn="l">
-              <a:defRPr sz="1400" b="0">
-                <a:solidFill>
-                  <a:srgbClr val="FFFFFF"/>
-                </a:solidFill>
-                <a:latin typeface="Calibri"/>
-              </a:defRPr>
-            </a:pPr>
-            <a:r>
-              <a:t>0.8468</a:t>
-            </a:r>
-          </a:p>
-        </p:txBody>
-      </p:sp>
-      <p:sp>
-        <p:nvSpPr>
-          <p:cNvPr id="18" name="TextBox 17"/>
-          <p:cNvSpPr txBox="1"/>
-          <p:nvPr/>
-        </p:nvSpPr>
-        <p:spPr>
-          <a:xfrm>
-            <a:off x="9784080" y="3566160"/>
-            <a:ext cx="1188720" cy="365760"/>
-          </a:xfrm>
-          <a:prstGeom prst="rect">
-            <a:avLst/>
-          </a:prstGeom>
-          <a:noFill/>
-        </p:spPr>
-        <p:txBody>
-          <a:bodyPr wrap="square">
-            <a:spAutoFit/>
-          </a:bodyPr>
-          <a:lstStyle/>
-          <a:p>
-            <a:pPr algn="l">
-              <a:defRPr sz="1400" b="0">
-                <a:solidFill>
-                  <a:srgbClr val="4ECB71"/>
-                </a:solidFill>
-                <a:latin typeface="Calibri"/>
-              </a:defRPr>
-            </a:pPr>
-            <a:r>
-              <a:t>0.8371</a:t>
-            </a:r>
-          </a:p>
-        </p:txBody>
-      </p:sp>
-      <p:sp>
-        <p:nvSpPr>
-          <p:cNvPr id="19" name="TextBox 18"/>
-          <p:cNvSpPr txBox="1"/>
-          <p:nvPr/>
-        </p:nvSpPr>
-        <p:spPr>
-          <a:xfrm>
-            <a:off x="6400800" y="4160520"/>
-            <a:ext cx="2011680" cy="365760"/>
-          </a:xfrm>
-          <a:prstGeom prst="rect">
-            <a:avLst/>
-          </a:prstGeom>
-          <a:noFill/>
-        </p:spPr>
-        <p:txBody>
-          <a:bodyPr wrap="square">
-            <a:spAutoFit/>
-          </a:bodyPr>
-          <a:lstStyle/>
-          <a:p>
-            <a:pPr algn="l">
-              <a:defRPr sz="1400" b="0">
-                <a:solidFill>
-                  <a:srgbClr val="FF6B6B"/>
-                </a:solidFill>
-                <a:latin typeface="Calibri"/>
-              </a:defRPr>
-            </a:pPr>
-            <a:r>
-              <a:t>TuringBench</a:t>
-            </a:r>
-          </a:p>
-        </p:txBody>
-      </p:sp>
-      <p:sp>
-        <p:nvSpPr>
-          <p:cNvPr id="20" name="TextBox 19"/>
-          <p:cNvSpPr txBox="1"/>
-          <p:nvPr/>
-        </p:nvSpPr>
-        <p:spPr>
-          <a:xfrm>
-            <a:off x="8503920" y="4160520"/>
-            <a:ext cx="1188720" cy="365760"/>
-          </a:xfrm>
-          <a:prstGeom prst="rect">
-            <a:avLst/>
-          </a:prstGeom>
-          <a:noFill/>
-        </p:spPr>
-        <p:txBody>
-          <a:bodyPr wrap="square">
-            <a:spAutoFit/>
-          </a:bodyPr>
-          <a:lstStyle/>
-          <a:p>
-            <a:pPr algn="l">
-              <a:defRPr sz="1400" b="0">
-                <a:solidFill>
-                  <a:srgbClr val="FFFFFF"/>
-                </a:solidFill>
-                <a:latin typeface="Calibri"/>
-              </a:defRPr>
-            </a:pPr>
-            <a:r>
-              <a:t>0.9853</a:t>
-            </a:r>
-          </a:p>
-        </p:txBody>
-      </p:sp>
-      <p:sp>
-        <p:nvSpPr>
-          <p:cNvPr id="21" name="TextBox 20"/>
-          <p:cNvSpPr txBox="1"/>
-          <p:nvPr/>
-        </p:nvSpPr>
-        <p:spPr>
-          <a:xfrm>
-            <a:off x="9784080" y="4160520"/>
-            <a:ext cx="1188720" cy="365760"/>
-          </a:xfrm>
-          <a:prstGeom prst="rect">
-            <a:avLst/>
-          </a:prstGeom>
-          <a:noFill/>
-        </p:spPr>
-        <p:txBody>
-          <a:bodyPr wrap="square">
-            <a:spAutoFit/>
-          </a:bodyPr>
-          <a:lstStyle/>
-          <a:p>
-            <a:pPr algn="l">
-              <a:defRPr sz="1400" b="0">
-                <a:solidFill>
-                  <a:srgbClr val="4ECB71"/>
-                </a:solidFill>
-                <a:latin typeface="Calibri"/>
-              </a:defRPr>
-            </a:pPr>
-            <a:r>
-              <a:t>0.9812</a:t>
-            </a:r>
-          </a:p>
-        </p:txBody>
-      </p:sp>
-      <p:sp>
-        <p:nvSpPr>
-          <p:cNvPr id="22" name="TextBox 21"/>
-          <p:cNvSpPr txBox="1"/>
-          <p:nvPr/>
-        </p:nvSpPr>
-        <p:spPr>
-          <a:xfrm>
-            <a:off x="6400800" y="4754880"/>
-            <a:ext cx="2011680" cy="365760"/>
-          </a:xfrm>
-          <a:prstGeom prst="rect">
-            <a:avLst/>
-          </a:prstGeom>
-          <a:noFill/>
-        </p:spPr>
-        <p:txBody>
-          <a:bodyPr wrap="square">
-            <a:spAutoFit/>
-          </a:bodyPr>
-          <a:lstStyle/>
-          <a:p>
-            <a:pPr algn="l">
-              <a:defRPr sz="1400" b="0">
-                <a:solidFill>
-                  <a:srgbClr val="E0E0E0"/>
-                </a:solidFill>
-                <a:latin typeface="Calibri"/>
-              </a:defRPr>
-            </a:pPr>
-            <a:r>
-              <a:t>Pile</a:t>
-            </a:r>
-          </a:p>
-        </p:txBody>
-      </p:sp>
-      <p:sp>
-        <p:nvSpPr>
-          <p:cNvPr id="23" name="TextBox 22"/>
-          <p:cNvSpPr txBox="1"/>
-          <p:nvPr/>
-        </p:nvSpPr>
-        <p:spPr>
-          <a:xfrm>
-            <a:off x="8503920" y="4754880"/>
-            <a:ext cx="1188720" cy="365760"/>
-          </a:xfrm>
-          <a:prstGeom prst="rect">
-            <a:avLst/>
-          </a:prstGeom>
-          <a:noFill/>
-        </p:spPr>
-        <p:txBody>
-          <a:bodyPr wrap="square">
-            <a:spAutoFit/>
-          </a:bodyPr>
-          <a:lstStyle/>
-          <a:p>
-            <a:pPr algn="l">
-              <a:defRPr sz="1400" b="0">
-                <a:solidFill>
-                  <a:srgbClr val="FFFFFF"/>
-                </a:solidFill>
-                <a:latin typeface="Calibri"/>
-              </a:defRPr>
-            </a:pPr>
-            <a:r>
-              <a:t>0.9727</a:t>
-            </a:r>
-          </a:p>
-        </p:txBody>
-      </p:sp>
-      <p:sp>
-        <p:nvSpPr>
-          <p:cNvPr id="24" name="TextBox 23"/>
-          <p:cNvSpPr txBox="1"/>
-          <p:nvPr/>
-        </p:nvSpPr>
-        <p:spPr>
-          <a:xfrm>
-            <a:off x="9784080" y="4754880"/>
-            <a:ext cx="1188720" cy="365760"/>
-          </a:xfrm>
-          <a:prstGeom prst="rect">
-            <a:avLst/>
-          </a:prstGeom>
-          <a:noFill/>
-        </p:spPr>
-        <p:txBody>
-          <a:bodyPr wrap="square">
-            <a:spAutoFit/>
-          </a:bodyPr>
-          <a:lstStyle/>
-          <a:p>
-            <a:pPr algn="l">
-              <a:defRPr sz="1400" b="0">
-                <a:solidFill>
-                  <a:srgbClr val="FFFFFF"/>
-                </a:solidFill>
-                <a:latin typeface="Calibri"/>
-              </a:defRPr>
-            </a:pPr>
-            <a:r>
-              <a:t>0.9727</a:t>
-            </a:r>
-          </a:p>
-        </p:txBody>
-      </p:sp>
-      <p:sp>
-        <p:nvSpPr>
-          <p:cNvPr id="25" name="TextBox 24"/>
-          <p:cNvSpPr txBox="1"/>
-          <p:nvPr/>
-        </p:nvSpPr>
-        <p:spPr>
-          <a:xfrm>
-            <a:off x="6400800" y="4389120"/>
-            <a:ext cx="5029200" cy="365760"/>
-          </a:xfrm>
-          <a:prstGeom prst="rect">
-            <a:avLst/>
-          </a:prstGeom>
-          <a:noFill/>
-        </p:spPr>
-        <p:txBody>
-          <a:bodyPr wrap="square">
-            <a:spAutoFit/>
-          </a:bodyPr>
-          <a:lstStyle/>
-          <a:p>
-            <a:pPr algn="l">
-              <a:defRPr sz="1200" b="0">
-                <a:solidFill>
-                  <a:srgbClr val="AAAAAA"/>
-                </a:solidFill>
-                <a:latin typeface="Calibri"/>
-              </a:defRPr>
-            </a:pPr>
-          </a:p>
-        </p:txBody>
-      </p:sp>
-      <p:sp>
-        <p:nvSpPr>
-          <p:cNvPr id="26" name="TextBox 25"/>
-          <p:cNvSpPr txBox="1"/>
-          <p:nvPr/>
-        </p:nvSpPr>
-        <p:spPr>
-          <a:xfrm>
-            <a:off x="6400800" y="2651760"/>
-            <a:ext cx="5029200" cy="274320"/>
-          </a:xfrm>
-          <a:prstGeom prst="rect">
-            <a:avLst/>
-          </a:prstGeom>
-          <a:noFill/>
-        </p:spPr>
-        <p:txBody>
-          <a:bodyPr wrap="square">
-            <a:spAutoFit/>
-          </a:bodyPr>
-          <a:lstStyle/>
-          <a:p>
-            <a:pPr algn="l">
-              <a:defRPr sz="1100" b="0">
-                <a:solidFill>
-                  <a:srgbClr val="AAAAAA"/>
-                </a:solidFill>
-                <a:latin typeface="Calibri"/>
-              </a:defRPr>
-            </a:pPr>
-            <a:r>
-              <a:t>drop 2组 (structure,perplexity)</a:t>
-            </a:r>
-          </a:p>
-        </p:txBody>
-      </p:sp>
-      <p:sp>
-        <p:nvSpPr>
-          <p:cNvPr id="27" name="TextBox 26"/>
-          <p:cNvSpPr txBox="1"/>
-          <p:nvPr/>
-        </p:nvSpPr>
-        <p:spPr>
-          <a:xfrm>
-            <a:off x="6400800" y="3246120"/>
-            <a:ext cx="5029200" cy="274320"/>
-          </a:xfrm>
-          <a:prstGeom prst="rect">
-            <a:avLst/>
-          </a:prstGeom>
-          <a:noFill/>
-        </p:spPr>
-        <p:txBody>
-          <a:bodyPr wrap="square">
-            <a:spAutoFit/>
-          </a:bodyPr>
-          <a:lstStyle/>
-          <a:p>
-            <a:pPr algn="l">
-              <a:defRPr sz="1100" b="0">
-                <a:solidFill>
-                  <a:srgbClr val="AAAAAA"/>
-                </a:solidFill>
-                <a:latin typeface="Calibri"/>
-              </a:defRPr>
-            </a:pPr>
-            <a:r>
-              <a:t>drop 0组</a:t>
-            </a:r>
-          </a:p>
-        </p:txBody>
-      </p:sp>
-      <p:sp>
-        <p:nvSpPr>
-          <p:cNvPr id="28" name="TextBox 27"/>
-          <p:cNvSpPr txBox="1"/>
-          <p:nvPr/>
-        </p:nvSpPr>
-        <p:spPr>
-          <a:xfrm>
-            <a:off x="6400800" y="3840480"/>
-            <a:ext cx="5029200" cy="274320"/>
-          </a:xfrm>
-          <a:prstGeom prst="rect">
-            <a:avLst/>
-          </a:prstGeom>
-          <a:noFill/>
-        </p:spPr>
-        <p:txBody>
-          <a:bodyPr wrap="square">
-            <a:spAutoFit/>
-          </a:bodyPr>
-          <a:lstStyle/>
-          <a:p>
-            <a:pPr algn="l">
-              <a:defRPr sz="1100" b="0">
-                <a:solidFill>
-                  <a:srgbClr val="AAAAAA"/>
-                </a:solidFill>
-                <a:latin typeface="Calibri"/>
-              </a:defRPr>
-            </a:pPr>
-            <a:r>
-              <a:t>drop 1组 (perplexity)</a:t>
-            </a:r>
-          </a:p>
-        </p:txBody>
-      </p:sp>
-      <p:sp>
-        <p:nvSpPr>
-          <p:cNvPr id="29" name="TextBox 28"/>
-          <p:cNvSpPr txBox="1"/>
-          <p:nvPr/>
-        </p:nvSpPr>
-        <p:spPr>
-          <a:xfrm>
-            <a:off x="6400800" y="4434840"/>
-            <a:ext cx="5029200" cy="274320"/>
-          </a:xfrm>
-          <a:prstGeom prst="rect">
-            <a:avLst/>
-          </a:prstGeom>
-          <a:noFill/>
-        </p:spPr>
-        <p:txBody>
-          <a:bodyPr wrap="square">
-            <a:spAutoFit/>
-          </a:bodyPr>
-          <a:lstStyle/>
-          <a:p>
-            <a:pPr algn="l">
-              <a:defRPr sz="1100" b="0">
-                <a:solidFill>
-                  <a:srgbClr val="AAAAAA"/>
-                </a:solidFill>
-                <a:latin typeface="Calibri"/>
-              </a:defRPr>
-            </a:pPr>
-            <a:r>
-              <a:t>drop 3组 (readability,struct,emb)</a:t>
-            </a:r>
-          </a:p>
-        </p:txBody>
-      </p:sp>
-      <p:sp>
-        <p:nvSpPr>
-          <p:cNvPr id="30" name="TextBox 29"/>
-          <p:cNvSpPr txBox="1"/>
-          <p:nvPr/>
-        </p:nvSpPr>
-        <p:spPr>
-          <a:xfrm>
-            <a:off x="6400800" y="5029200"/>
-            <a:ext cx="5029200" cy="274320"/>
-          </a:xfrm>
-          <a:prstGeom prst="rect">
-            <a:avLst/>
-          </a:prstGeom>
-          <a:noFill/>
-        </p:spPr>
-        <p:txBody>
-          <a:bodyPr wrap="square">
-            <a:spAutoFit/>
-          </a:bodyPr>
-          <a:lstStyle/>
-          <a:p>
-            <a:pPr algn="l">
-              <a:defRPr sz="1100" b="0">
-                <a:solidFill>
-                  <a:srgbClr val="AAAAAA"/>
-                </a:solidFill>
-                <a:latin typeface="Calibri"/>
-              </a:defRPr>
-            </a:pPr>
-            <a:r>
-              <a:t>drop 0组</a:t>
-            </a:r>
-          </a:p>
-        </p:txBody>
-      </p:sp>
-      <p:sp>
-        <p:nvSpPr>
-          <p:cNvPr id="31" name="TextBox 30"/>
-          <p:cNvSpPr txBox="1"/>
-          <p:nvPr/>
-        </p:nvSpPr>
-        <p:spPr>
-          <a:xfrm>
-            <a:off x="731520" y="5029200"/>
-            <a:ext cx="10972800" cy="731520"/>
-          </a:xfrm>
-          <a:prstGeom prst="rect">
-            <a:avLst/>
-          </a:prstGeom>
-          <a:noFill/>
-        </p:spPr>
-        <p:txBody>
-          <a:bodyPr wrap="square">
-            <a:spAutoFit/>
-          </a:bodyPr>
-          <a:lstStyle/>
-          <a:p>
-            <a:pPr algn="ctr">
-              <a:defRPr sz="1600" b="0">
-                <a:solidFill>
-                  <a:srgbClr val="00D2FF"/>
-                </a:solidFill>
-                <a:latin typeface="Calibri"/>
-              </a:defRPr>
-            </a:pPr>
-            <a:r>
-              <a:t>Auto-Filter 以组级 AUC &lt; 0.52 为门槛自动丢弃噪声特征组</a:t>
-            </a:r>
-            <a:br/>
-            <a:r>
-              <a:t>关键发现: SemEval 上 model+token (0.9610) 远优于 all (0.8468) → 纯统计特征是噪声源</a:t>
+              <a:t>按需丢弃噪声组</a:t>
             </a:r>
           </a:p>
         </p:txBody>
@@ -11963,7 +11794,23 @@
               </a:defRPr>
             </a:pPr>
             <a:r>
-              <a:t>5. Auto-Filter 自动检测并丢弃噪声特征组</a:t>
+              <a:t>5. 部署策略: 按目标 AI 时代选择合适的参考模型</a:t>
+            </a:r>
+          </a:p>
+          <a:p>
+            <a:pPr>
+              <a:spcAft>
+                <a:spcPts val="720"/>
+              </a:spcAft>
+              <a:defRPr sz="1800">
+                <a:solidFill>
+                  <a:srgbClr val="E0E0E0"/>
+                </a:solidFill>
+                <a:latin typeface="Calibri"/>
+              </a:defRPr>
+            </a:pPr>
+            <a:r>
+              <a:t>    没有"万能特征", 观察者模型需定期更新</a:t>
             </a:r>
           </a:p>
         </p:txBody>
@@ -14041,7 +13888,7 @@
               </a:defRPr>
             </a:pPr>
             <a:r>
-              <a:t>→  Auto-Filter (丢噪声组)  →  XGBoost (500 trees, depth 8)  →  SHAP 可解释分析</a:t>
+              <a:t>→  XGBoost (500 trees, depth 8)  →  SHAP 可解释分析</a:t>
             </a:r>
           </a:p>
         </p:txBody>

</xml_diff>

<commit_message>
Enhance PPT: enrich problem slide with RAID heatmap & method comparison, add project implementation steps to method overview slide
Slide 2: Replace class_distribution with RAID model×domain heatmap,
add challenge cards and method comparison table (DL vs zero-shot vs ours).
Slide 4: Add two-step implementation guide (feature engineering +
model building with correlation analysis and SHAP attribution).

Co-Authored-By: Claude Opus 4.6 <noreply@anthropic.com>
</commit_message>
<xml_diff>
--- a/reports/AIGC_Detection_Presentation.pptx
+++ b/reports/AIGC_Detection_Presentation.pptx
@@ -8644,25 +8644,22 @@
         </p:nvSpPr>
         <p:spPr>
           <a:xfrm>
-            <a:off x="731520" y="1371600"/>
-            <a:ext cx="5029200" cy="4572000"/>
-          </a:xfrm>
-          <a:prstGeom prst="rect">
-            <a:avLst/>
-          </a:prstGeom>
-          <a:noFill/>
-        </p:spPr>
-        <p:txBody>
-          <a:bodyPr wrap="square">
-            <a:spAutoFit/>
-          </a:bodyPr>
-          <a:lstStyle/>
-          <a:p>
-            <a:pPr>
-              <a:spcAft>
-                <a:spcPts val="1080"/>
-              </a:spcAft>
-              <a:defRPr sz="1800">
+            <a:off x="731520" y="1188720"/>
+            <a:ext cx="5486400" cy="457200"/>
+          </a:xfrm>
+          <a:prstGeom prst="rect">
+            <a:avLst/>
+          </a:prstGeom>
+          <a:noFill/>
+        </p:spPr>
+        <p:txBody>
+          <a:bodyPr wrap="square">
+            <a:spAutoFit/>
+          </a:bodyPr>
+          <a:lstStyle/>
+          <a:p>
+            <a:pPr algn="l">
+              <a:defRPr sz="2000" b="1">
                 <a:solidFill>
                   <a:srgbClr val="FFFFFF"/>
                 </a:solidFill>
@@ -8673,25 +8670,870 @@
               <a:t>核心任务：区分人类文本 vs AI 生成文本 (二分类)</a:t>
             </a:r>
           </a:p>
-          <a:p>
-            <a:pPr>
-              <a:spcAft>
-                <a:spcPts val="1080"/>
-              </a:spcAft>
-              <a:defRPr sz="1800">
+        </p:txBody>
+      </p:sp>
+      <p:sp>
+        <p:nvSpPr>
+          <p:cNvPr id="5" name="Rounded Rectangle 4"/>
+          <p:cNvSpPr/>
+          <p:nvPr/>
+        </p:nvSpPr>
+        <p:spPr>
+          <a:xfrm>
+            <a:off x="731520" y="1828800"/>
+            <a:ext cx="1280160" cy="1463040"/>
+          </a:xfrm>
+          <a:prstGeom prst="roundRect">
+            <a:avLst/>
+          </a:prstGeom>
+          <a:solidFill>
+            <a:srgbClr val="202848"/>
+          </a:solidFill>
+          <a:ln w="25400">
+            <a:solidFill>
+              <a:srgbClr val="FF6B6B"/>
+            </a:solidFill>
+          </a:ln>
+        </p:spPr>
+        <p:style>
+          <a:lnRef idx="1">
+            <a:schemeClr val="accent1"/>
+          </a:lnRef>
+          <a:fillRef idx="3">
+            <a:schemeClr val="accent1"/>
+          </a:fillRef>
+          <a:effectRef idx="2">
+            <a:schemeClr val="accent1"/>
+          </a:effectRef>
+          <a:fontRef idx="minor">
+            <a:schemeClr val="lt1"/>
+          </a:fontRef>
+        </p:style>
+        <p:txBody>
+          <a:bodyPr rtlCol="0" anchor="ctr"/>
+          <a:lstStyle/>
+          <a:p>
+            <a:pPr algn="ctr"/>
+          </a:p>
+        </p:txBody>
+      </p:sp>
+      <p:sp>
+        <p:nvSpPr>
+          <p:cNvPr id="6" name="TextBox 5"/>
+          <p:cNvSpPr txBox="1"/>
+          <p:nvPr/>
+        </p:nvSpPr>
+        <p:spPr>
+          <a:xfrm>
+            <a:off x="822960" y="1874519"/>
+            <a:ext cx="1097280" cy="365760"/>
+          </a:xfrm>
+          <a:prstGeom prst="rect">
+            <a:avLst/>
+          </a:prstGeom>
+          <a:noFill/>
+        </p:spPr>
+        <p:txBody>
+          <a:bodyPr wrap="square">
+            <a:spAutoFit/>
+          </a:bodyPr>
+          <a:lstStyle/>
+          <a:p>
+            <a:pPr algn="ctr">
+              <a:defRPr sz="1400" b="1">
+                <a:solidFill>
+                  <a:srgbClr val="FF6B6B"/>
+                </a:solidFill>
+                <a:latin typeface="Calibri"/>
+              </a:defRPr>
+            </a:pPr>
+            <a:r>
+              <a:t>多模型</a:t>
+            </a:r>
+          </a:p>
+        </p:txBody>
+      </p:sp>
+      <p:sp>
+        <p:nvSpPr>
+          <p:cNvPr id="7" name="TextBox 6"/>
+          <p:cNvSpPr txBox="1"/>
+          <p:nvPr/>
+        </p:nvSpPr>
+        <p:spPr>
+          <a:xfrm>
+            <a:off x="822960" y="2240280"/>
+            <a:ext cx="1097280" cy="914400"/>
+          </a:xfrm>
+          <a:prstGeom prst="rect">
+            <a:avLst/>
+          </a:prstGeom>
+          <a:noFill/>
+        </p:spPr>
+        <p:txBody>
+          <a:bodyPr wrap="square">
+            <a:spAutoFit/>
+          </a:bodyPr>
+          <a:lstStyle/>
+          <a:p>
+            <a:pPr algn="ctr">
+              <a:defRPr sz="1100" b="0">
+                <a:solidFill>
+                  <a:srgbClr val="E0E0E0"/>
+                </a:solidFill>
+                <a:latin typeface="Calibri"/>
+              </a:defRPr>
+            </a:pPr>
+            <a:r>
+              <a:t>11+ 种生成器</a:t>
+            </a:r>
+            <a:br/>
+            <a:r>
+              <a:t>GPT-2 → GPT-4</a:t>
+            </a:r>
+          </a:p>
+        </p:txBody>
+      </p:sp>
+      <p:sp>
+        <p:nvSpPr>
+          <p:cNvPr id="8" name="Rounded Rectangle 7"/>
+          <p:cNvSpPr/>
+          <p:nvPr/>
+        </p:nvSpPr>
+        <p:spPr>
+          <a:xfrm>
+            <a:off x="2148840" y="1828800"/>
+            <a:ext cx="1280160" cy="1463040"/>
+          </a:xfrm>
+          <a:prstGeom prst="roundRect">
+            <a:avLst/>
+          </a:prstGeom>
+          <a:solidFill>
+            <a:srgbClr val="202848"/>
+          </a:solidFill>
+          <a:ln w="25400">
+            <a:solidFill>
+              <a:srgbClr val="00D2FF"/>
+            </a:solidFill>
+          </a:ln>
+        </p:spPr>
+        <p:style>
+          <a:lnRef idx="1">
+            <a:schemeClr val="accent1"/>
+          </a:lnRef>
+          <a:fillRef idx="3">
+            <a:schemeClr val="accent1"/>
+          </a:fillRef>
+          <a:effectRef idx="2">
+            <a:schemeClr val="accent1"/>
+          </a:effectRef>
+          <a:fontRef idx="minor">
+            <a:schemeClr val="lt1"/>
+          </a:fontRef>
+        </p:style>
+        <p:txBody>
+          <a:bodyPr rtlCol="0" anchor="ctr"/>
+          <a:lstStyle/>
+          <a:p>
+            <a:pPr algn="ctr"/>
+          </a:p>
+        </p:txBody>
+      </p:sp>
+      <p:sp>
+        <p:nvSpPr>
+          <p:cNvPr id="9" name="TextBox 8"/>
+          <p:cNvSpPr txBox="1"/>
+          <p:nvPr/>
+        </p:nvSpPr>
+        <p:spPr>
+          <a:xfrm>
+            <a:off x="2240280" y="1874519"/>
+            <a:ext cx="1097280" cy="365760"/>
+          </a:xfrm>
+          <a:prstGeom prst="rect">
+            <a:avLst/>
+          </a:prstGeom>
+          <a:noFill/>
+        </p:spPr>
+        <p:txBody>
+          <a:bodyPr wrap="square">
+            <a:spAutoFit/>
+          </a:bodyPr>
+          <a:lstStyle/>
+          <a:p>
+            <a:pPr algn="ctr">
+              <a:defRPr sz="1400" b="1">
+                <a:solidFill>
+                  <a:srgbClr val="00D2FF"/>
+                </a:solidFill>
+                <a:latin typeface="Calibri"/>
+              </a:defRPr>
+            </a:pPr>
+            <a:r>
+              <a:t>多领域</a:t>
+            </a:r>
+          </a:p>
+        </p:txBody>
+      </p:sp>
+      <p:sp>
+        <p:nvSpPr>
+          <p:cNvPr id="10" name="TextBox 9"/>
+          <p:cNvSpPr txBox="1"/>
+          <p:nvPr/>
+        </p:nvSpPr>
+        <p:spPr>
+          <a:xfrm>
+            <a:off x="2240280" y="2240280"/>
+            <a:ext cx="1097280" cy="914400"/>
+          </a:xfrm>
+          <a:prstGeom prst="rect">
+            <a:avLst/>
+          </a:prstGeom>
+          <a:noFill/>
+        </p:spPr>
+        <p:txBody>
+          <a:bodyPr wrap="square">
+            <a:spAutoFit/>
+          </a:bodyPr>
+          <a:lstStyle/>
+          <a:p>
+            <a:pPr algn="ctr">
+              <a:defRPr sz="1100" b="0">
+                <a:solidFill>
+                  <a:srgbClr val="E0E0E0"/>
+                </a:solidFill>
+                <a:latin typeface="Calibri"/>
+              </a:defRPr>
+            </a:pPr>
+            <a:r>
+              <a:t>新闻/诗歌/摘要</a:t>
+            </a:r>
+            <a:br/>
+            <a:r>
+              <a:t>领域差异大</a:t>
+            </a:r>
+          </a:p>
+        </p:txBody>
+      </p:sp>
+      <p:sp>
+        <p:nvSpPr>
+          <p:cNvPr id="11" name="Rounded Rectangle 10"/>
+          <p:cNvSpPr/>
+          <p:nvPr/>
+        </p:nvSpPr>
+        <p:spPr>
+          <a:xfrm>
+            <a:off x="3566160" y="1828800"/>
+            <a:ext cx="1280160" cy="1463040"/>
+          </a:xfrm>
+          <a:prstGeom prst="roundRect">
+            <a:avLst/>
+          </a:prstGeom>
+          <a:solidFill>
+            <a:srgbClr val="202848"/>
+          </a:solidFill>
+          <a:ln w="25400">
+            <a:solidFill>
+              <a:srgbClr val="FFA500"/>
+            </a:solidFill>
+          </a:ln>
+        </p:spPr>
+        <p:style>
+          <a:lnRef idx="1">
+            <a:schemeClr val="accent1"/>
+          </a:lnRef>
+          <a:fillRef idx="3">
+            <a:schemeClr val="accent1"/>
+          </a:fillRef>
+          <a:effectRef idx="2">
+            <a:schemeClr val="accent1"/>
+          </a:effectRef>
+          <a:fontRef idx="minor">
+            <a:schemeClr val="lt1"/>
+          </a:fontRef>
+        </p:style>
+        <p:txBody>
+          <a:bodyPr rtlCol="0" anchor="ctr"/>
+          <a:lstStyle/>
+          <a:p>
+            <a:pPr algn="ctr"/>
+          </a:p>
+        </p:txBody>
+      </p:sp>
+      <p:sp>
+        <p:nvSpPr>
+          <p:cNvPr id="12" name="TextBox 11"/>
+          <p:cNvSpPr txBox="1"/>
+          <p:nvPr/>
+        </p:nvSpPr>
+        <p:spPr>
+          <a:xfrm>
+            <a:off x="3657600" y="1874519"/>
+            <a:ext cx="1097280" cy="365760"/>
+          </a:xfrm>
+          <a:prstGeom prst="rect">
+            <a:avLst/>
+          </a:prstGeom>
+          <a:noFill/>
+        </p:spPr>
+        <p:txBody>
+          <a:bodyPr wrap="square">
+            <a:spAutoFit/>
+          </a:bodyPr>
+          <a:lstStyle/>
+          <a:p>
+            <a:pPr algn="ctr">
+              <a:defRPr sz="1400" b="1">
+                <a:solidFill>
+                  <a:srgbClr val="FFA500"/>
+                </a:solidFill>
+                <a:latin typeface="Calibri"/>
+              </a:defRPr>
+            </a:pPr>
+            <a:r>
+              <a:t>对抗攻击</a:t>
+            </a:r>
+          </a:p>
+        </p:txBody>
+      </p:sp>
+      <p:sp>
+        <p:nvSpPr>
+          <p:cNvPr id="13" name="TextBox 12"/>
+          <p:cNvSpPr txBox="1"/>
+          <p:nvPr/>
+        </p:nvSpPr>
+        <p:spPr>
+          <a:xfrm>
+            <a:off x="3657600" y="2240280"/>
+            <a:ext cx="1097280" cy="914400"/>
+          </a:xfrm>
+          <a:prstGeom prst="rect">
+            <a:avLst/>
+          </a:prstGeom>
+          <a:noFill/>
+        </p:spPr>
+        <p:txBody>
+          <a:bodyPr wrap="square">
+            <a:spAutoFit/>
+          </a:bodyPr>
+          <a:lstStyle/>
+          <a:p>
+            <a:pPr algn="ctr">
+              <a:defRPr sz="1100" b="0">
+                <a:solidFill>
+                  <a:srgbClr val="E0E0E0"/>
+                </a:solidFill>
+                <a:latin typeface="Calibri"/>
+              </a:defRPr>
+            </a:pPr>
+            <a:r>
+              <a:t>释义/同义词替换</a:t>
+            </a:r>
+            <a:br/>
+            <a:r>
+              <a:t>11 种规避手段</a:t>
+            </a:r>
+          </a:p>
+        </p:txBody>
+      </p:sp>
+      <p:sp>
+        <p:nvSpPr>
+          <p:cNvPr id="14" name="Rounded Rectangle 13"/>
+          <p:cNvSpPr/>
+          <p:nvPr/>
+        </p:nvSpPr>
+        <p:spPr>
+          <a:xfrm>
+            <a:off x="4983480" y="1828800"/>
+            <a:ext cx="1280160" cy="1463040"/>
+          </a:xfrm>
+          <a:prstGeom prst="roundRect">
+            <a:avLst/>
+          </a:prstGeom>
+          <a:solidFill>
+            <a:srgbClr val="202848"/>
+          </a:solidFill>
+          <a:ln w="25400">
+            <a:solidFill>
+              <a:srgbClr val="4ECB71"/>
+            </a:solidFill>
+          </a:ln>
+        </p:spPr>
+        <p:style>
+          <a:lnRef idx="1">
+            <a:schemeClr val="accent1"/>
+          </a:lnRef>
+          <a:fillRef idx="3">
+            <a:schemeClr val="accent1"/>
+          </a:fillRef>
+          <a:effectRef idx="2">
+            <a:schemeClr val="accent1"/>
+          </a:effectRef>
+          <a:fontRef idx="minor">
+            <a:schemeClr val="lt1"/>
+          </a:fontRef>
+        </p:style>
+        <p:txBody>
+          <a:bodyPr rtlCol="0" anchor="ctr"/>
+          <a:lstStyle/>
+          <a:p>
+            <a:pPr algn="ctr"/>
+          </a:p>
+        </p:txBody>
+      </p:sp>
+      <p:sp>
+        <p:nvSpPr>
+          <p:cNvPr id="15" name="TextBox 14"/>
+          <p:cNvSpPr txBox="1"/>
+          <p:nvPr/>
+        </p:nvSpPr>
+        <p:spPr>
+          <a:xfrm>
+            <a:off x="5074920" y="1874519"/>
+            <a:ext cx="1097280" cy="365760"/>
+          </a:xfrm>
+          <a:prstGeom prst="rect">
+            <a:avLst/>
+          </a:prstGeom>
+          <a:noFill/>
+        </p:spPr>
+        <p:txBody>
+          <a:bodyPr wrap="square">
+            <a:spAutoFit/>
+          </a:bodyPr>
+          <a:lstStyle/>
+          <a:p>
+            <a:pPr algn="ctr">
+              <a:defRPr sz="1400" b="1">
+                <a:solidFill>
+                  <a:srgbClr val="4ECB71"/>
+                </a:solidFill>
+                <a:latin typeface="Calibri"/>
+              </a:defRPr>
+            </a:pPr>
+            <a:r>
+              <a:t>可解释性</a:t>
+            </a:r>
+          </a:p>
+        </p:txBody>
+      </p:sp>
+      <p:sp>
+        <p:nvSpPr>
+          <p:cNvPr id="16" name="TextBox 15"/>
+          <p:cNvSpPr txBox="1"/>
+          <p:nvPr/>
+        </p:nvSpPr>
+        <p:spPr>
+          <a:xfrm>
+            <a:off x="5074920" y="2240280"/>
+            <a:ext cx="1097280" cy="914400"/>
+          </a:xfrm>
+          <a:prstGeom prst="rect">
+            <a:avLst/>
+          </a:prstGeom>
+          <a:noFill/>
+        </p:spPr>
+        <p:txBody>
+          <a:bodyPr wrap="square">
+            <a:spAutoFit/>
+          </a:bodyPr>
+          <a:lstStyle/>
+          <a:p>
+            <a:pPr algn="ctr">
+              <a:defRPr sz="1100" b="0">
+                <a:solidFill>
+                  <a:srgbClr val="E0E0E0"/>
+                </a:solidFill>
+                <a:latin typeface="Calibri"/>
+              </a:defRPr>
+            </a:pPr>
+            <a:r>
+              <a:t>不只要判定</a:t>
+            </a:r>
+            <a:br/>
+            <a:r>
+              <a:t>要说明为什么</a:t>
+            </a:r>
+          </a:p>
+        </p:txBody>
+      </p:sp>
+      <p:sp>
+        <p:nvSpPr>
+          <p:cNvPr id="17" name="TextBox 16"/>
+          <p:cNvSpPr txBox="1"/>
+          <p:nvPr/>
+        </p:nvSpPr>
+        <p:spPr>
+          <a:xfrm>
+            <a:off x="731520" y="3566160"/>
+            <a:ext cx="5486400" cy="457200"/>
+          </a:xfrm>
+          <a:prstGeom prst="rect">
+            <a:avLst/>
+          </a:prstGeom>
+          <a:noFill/>
+        </p:spPr>
+        <p:txBody>
+          <a:bodyPr wrap="square">
+            <a:spAutoFit/>
+          </a:bodyPr>
+          <a:lstStyle/>
+          <a:p>
+            <a:pPr algn="l">
+              <a:defRPr sz="1800" b="1">
+                <a:solidFill>
+                  <a:srgbClr val="00D2FF"/>
+                </a:solidFill>
+                <a:latin typeface="Calibri"/>
+              </a:defRPr>
+            </a:pPr>
+            <a:r>
+              <a:t>现有方法 vs 我们的方法</a:t>
+            </a:r>
+          </a:p>
+        </p:txBody>
+      </p:sp>
+      <p:sp>
+        <p:nvSpPr>
+          <p:cNvPr id="18" name="TextBox 17"/>
+          <p:cNvSpPr txBox="1"/>
+          <p:nvPr/>
+        </p:nvSpPr>
+        <p:spPr>
+          <a:xfrm>
+            <a:off x="731520" y="4023360"/>
+            <a:ext cx="1828800" cy="274320"/>
+          </a:xfrm>
+          <a:prstGeom prst="rect">
+            <a:avLst/>
+          </a:prstGeom>
+          <a:noFill/>
+        </p:spPr>
+        <p:txBody>
+          <a:bodyPr wrap="square">
+            <a:spAutoFit/>
+          </a:bodyPr>
+          <a:lstStyle/>
+          <a:p>
+            <a:pPr algn="l">
+              <a:defRPr sz="1300" b="1">
+                <a:solidFill>
+                  <a:srgbClr val="AAAAAA"/>
+                </a:solidFill>
+                <a:latin typeface="Calibri"/>
+              </a:defRPr>
+            </a:pPr>
+          </a:p>
+        </p:txBody>
+      </p:sp>
+      <p:sp>
+        <p:nvSpPr>
+          <p:cNvPr id="19" name="TextBox 18"/>
+          <p:cNvSpPr txBox="1"/>
+          <p:nvPr/>
+        </p:nvSpPr>
+        <p:spPr>
+          <a:xfrm>
+            <a:off x="2560320" y="4023360"/>
+            <a:ext cx="1828800" cy="274320"/>
+          </a:xfrm>
+          <a:prstGeom prst="rect">
+            <a:avLst/>
+          </a:prstGeom>
+          <a:noFill/>
+        </p:spPr>
+        <p:txBody>
+          <a:bodyPr wrap="square">
+            <a:spAutoFit/>
+          </a:bodyPr>
+          <a:lstStyle/>
+          <a:p>
+            <a:pPr algn="l">
+              <a:defRPr sz="1300" b="1">
+                <a:solidFill>
+                  <a:srgbClr val="AAAAAA"/>
+                </a:solidFill>
+                <a:latin typeface="Calibri"/>
+              </a:defRPr>
+            </a:pPr>
+            <a:r>
+              <a:t>深度学习黑盒</a:t>
+            </a:r>
+          </a:p>
+        </p:txBody>
+      </p:sp>
+      <p:sp>
+        <p:nvSpPr>
+          <p:cNvPr id="20" name="TextBox 19"/>
+          <p:cNvSpPr txBox="1"/>
+          <p:nvPr/>
+        </p:nvSpPr>
+        <p:spPr>
+          <a:xfrm>
+            <a:off x="4389120" y="4023360"/>
+            <a:ext cx="1828800" cy="274320"/>
+          </a:xfrm>
+          <a:prstGeom prst="rect">
+            <a:avLst/>
+          </a:prstGeom>
+          <a:noFill/>
+        </p:spPr>
+        <p:txBody>
+          <a:bodyPr wrap="square">
+            <a:spAutoFit/>
+          </a:bodyPr>
+          <a:lstStyle/>
+          <a:p>
+            <a:pPr algn="l">
+              <a:defRPr sz="1300" b="1">
+                <a:solidFill>
+                  <a:srgbClr val="AAAAAA"/>
+                </a:solidFill>
+                <a:latin typeface="Calibri"/>
+              </a:defRPr>
+            </a:pPr>
+            <a:r>
+              <a:t>零样本方法</a:t>
+            </a:r>
+          </a:p>
+        </p:txBody>
+      </p:sp>
+      <p:sp>
+        <p:nvSpPr>
+          <p:cNvPr id="21" name="TextBox 20"/>
+          <p:cNvSpPr txBox="1"/>
+          <p:nvPr/>
+        </p:nvSpPr>
+        <p:spPr>
+          <a:xfrm>
+            <a:off x="731520" y="4023360"/>
+            <a:ext cx="1828800" cy="274320"/>
+          </a:xfrm>
+          <a:prstGeom prst="rect">
+            <a:avLst/>
+          </a:prstGeom>
+          <a:noFill/>
+        </p:spPr>
+        <p:txBody>
+          <a:bodyPr wrap="square">
+            <a:spAutoFit/>
+          </a:bodyPr>
+          <a:lstStyle/>
+          <a:p>
+            <a:pPr algn="l">
+              <a:defRPr sz="1300" b="0">
+                <a:solidFill>
+                  <a:srgbClr val="AAAAAA"/>
+                </a:solidFill>
+                <a:latin typeface="Calibri"/>
+              </a:defRPr>
+            </a:pPr>
+          </a:p>
+        </p:txBody>
+      </p:sp>
+      <p:sp>
+        <p:nvSpPr>
+          <p:cNvPr id="22" name="TextBox 21"/>
+          <p:cNvSpPr txBox="1"/>
+          <p:nvPr/>
+        </p:nvSpPr>
+        <p:spPr>
+          <a:xfrm>
+            <a:off x="6217920" y="4023360"/>
+            <a:ext cx="1828800" cy="274320"/>
+          </a:xfrm>
+          <a:prstGeom prst="rect">
+            <a:avLst/>
+          </a:prstGeom>
+          <a:noFill/>
+        </p:spPr>
+        <p:txBody>
+          <a:bodyPr wrap="square">
+            <a:spAutoFit/>
+          </a:bodyPr>
+          <a:lstStyle/>
+          <a:p>
+            <a:pPr algn="l">
+              <a:defRPr sz="1300" b="1">
+                <a:solidFill>
+                  <a:srgbClr val="4ECB71"/>
+                </a:solidFill>
+                <a:latin typeface="Calibri"/>
+              </a:defRPr>
+            </a:pPr>
+            <a:r>
+              <a:t>我们 (XGBoost)</a:t>
+            </a:r>
+          </a:p>
+        </p:txBody>
+      </p:sp>
+      <p:sp>
+        <p:nvSpPr>
+          <p:cNvPr id="23" name="TextBox 22"/>
+          <p:cNvSpPr txBox="1"/>
+          <p:nvPr/>
+        </p:nvSpPr>
+        <p:spPr>
+          <a:xfrm>
+            <a:off x="731520" y="4389120"/>
+            <a:ext cx="1828800" cy="274320"/>
+          </a:xfrm>
+          <a:prstGeom prst="rect">
+            <a:avLst/>
+          </a:prstGeom>
+          <a:noFill/>
+        </p:spPr>
+        <p:txBody>
+          <a:bodyPr wrap="square">
+            <a:spAutoFit/>
+          </a:bodyPr>
+          <a:lstStyle/>
+          <a:p>
+            <a:pPr algn="l">
+              <a:defRPr sz="1200" b="1">
                 <a:solidFill>
                   <a:srgbClr val="FFFFFF"/>
                 </a:solidFill>
                 <a:latin typeface="Calibri"/>
               </a:defRPr>
             </a:pPr>
-          </a:p>
-          <a:p>
-            <a:pPr>
-              <a:spcAft>
-                <a:spcPts val="1080"/>
-              </a:spcAft>
-              <a:defRPr sz="1800">
+            <a:r>
+              <a:t>可解释性</a:t>
+            </a:r>
+          </a:p>
+        </p:txBody>
+      </p:sp>
+      <p:sp>
+        <p:nvSpPr>
+          <p:cNvPr id="24" name="TextBox 23"/>
+          <p:cNvSpPr txBox="1"/>
+          <p:nvPr/>
+        </p:nvSpPr>
+        <p:spPr>
+          <a:xfrm>
+            <a:off x="2560320" y="4389120"/>
+            <a:ext cx="1828800" cy="274320"/>
+          </a:xfrm>
+          <a:prstGeom prst="rect">
+            <a:avLst/>
+          </a:prstGeom>
+          <a:noFill/>
+        </p:spPr>
+        <p:txBody>
+          <a:bodyPr wrap="square">
+            <a:spAutoFit/>
+          </a:bodyPr>
+          <a:lstStyle/>
+          <a:p>
+            <a:pPr algn="l">
+              <a:defRPr sz="1200" b="0">
+                <a:solidFill>
+                  <a:srgbClr val="FF6B6B"/>
+                </a:solidFill>
+                <a:latin typeface="Calibri"/>
+              </a:defRPr>
+            </a:pPr>
+            <a:r>
+              <a:t>黑盒</a:t>
+            </a:r>
+          </a:p>
+        </p:txBody>
+      </p:sp>
+      <p:sp>
+        <p:nvSpPr>
+          <p:cNvPr id="25" name="TextBox 24"/>
+          <p:cNvSpPr txBox="1"/>
+          <p:nvPr/>
+        </p:nvSpPr>
+        <p:spPr>
+          <a:xfrm>
+            <a:off x="4389120" y="4389120"/>
+            <a:ext cx="1828800" cy="274320"/>
+          </a:xfrm>
+          <a:prstGeom prst="rect">
+            <a:avLst/>
+          </a:prstGeom>
+          <a:noFill/>
+        </p:spPr>
+        <p:txBody>
+          <a:bodyPr wrap="square">
+            <a:spAutoFit/>
+          </a:bodyPr>
+          <a:lstStyle/>
+          <a:p>
+            <a:pPr algn="l">
+              <a:defRPr sz="1200" b="0">
+                <a:solidFill>
+                  <a:srgbClr val="FF6B6B"/>
+                </a:solidFill>
+                <a:latin typeface="Calibri"/>
+              </a:defRPr>
+            </a:pPr>
+            <a:r>
+              <a:t>部分</a:t>
+            </a:r>
+          </a:p>
+        </p:txBody>
+      </p:sp>
+      <p:sp>
+        <p:nvSpPr>
+          <p:cNvPr id="26" name="TextBox 25"/>
+          <p:cNvSpPr txBox="1"/>
+          <p:nvPr/>
+        </p:nvSpPr>
+        <p:spPr>
+          <a:xfrm>
+            <a:off x="6217920" y="4389120"/>
+            <a:ext cx="1828800" cy="274320"/>
+          </a:xfrm>
+          <a:prstGeom prst="rect">
+            <a:avLst/>
+          </a:prstGeom>
+          <a:noFill/>
+        </p:spPr>
+        <p:txBody>
+          <a:bodyPr wrap="square">
+            <a:spAutoFit/>
+          </a:bodyPr>
+          <a:lstStyle/>
+          <a:p>
+            <a:pPr algn="l">
+              <a:defRPr sz="1200" b="0">
+                <a:solidFill>
+                  <a:srgbClr val="4ECB71"/>
+                </a:solidFill>
+                <a:latin typeface="Calibri"/>
+              </a:defRPr>
+            </a:pPr>
+            <a:r>
+              <a:t>完全可解释</a:t>
+            </a:r>
+          </a:p>
+        </p:txBody>
+      </p:sp>
+      <p:sp>
+        <p:nvSpPr>
+          <p:cNvPr id="27" name="TextBox 26"/>
+          <p:cNvSpPr txBox="1"/>
+          <p:nvPr/>
+        </p:nvSpPr>
+        <p:spPr>
+          <a:xfrm>
+            <a:off x="731520" y="4800600"/>
+            <a:ext cx="1828800" cy="274320"/>
+          </a:xfrm>
+          <a:prstGeom prst="rect">
+            <a:avLst/>
+          </a:prstGeom>
+          <a:noFill/>
+        </p:spPr>
+        <p:txBody>
+          <a:bodyPr wrap="square">
+            <a:spAutoFit/>
+          </a:bodyPr>
+          <a:lstStyle/>
+          <a:p>
+            <a:pPr algn="l">
+              <a:defRPr sz="1200" b="1">
                 <a:solidFill>
                   <a:srgbClr val="FFFFFF"/>
                 </a:solidFill>
@@ -8699,15 +9541,143 @@
               </a:defRPr>
             </a:pPr>
             <a:r>
-              <a:t>挑战 1: 多模型 — 11+ 种 AI 生成器，特征各异</a:t>
-            </a:r>
-          </a:p>
-          <a:p>
-            <a:pPr>
-              <a:spcAft>
-                <a:spcPts val="1080"/>
-              </a:spcAft>
-              <a:defRPr sz="1800">
+              <a:t>AUC</a:t>
+            </a:r>
+          </a:p>
+        </p:txBody>
+      </p:sp>
+      <p:sp>
+        <p:nvSpPr>
+          <p:cNvPr id="28" name="TextBox 27"/>
+          <p:cNvSpPr txBox="1"/>
+          <p:nvPr/>
+        </p:nvSpPr>
+        <p:spPr>
+          <a:xfrm>
+            <a:off x="2560320" y="4800600"/>
+            <a:ext cx="1828800" cy="274320"/>
+          </a:xfrm>
+          <a:prstGeom prst="rect">
+            <a:avLst/>
+          </a:prstGeom>
+          <a:noFill/>
+        </p:spPr>
+        <p:txBody>
+          <a:bodyPr wrap="square">
+            <a:spAutoFit/>
+          </a:bodyPr>
+          <a:lstStyle/>
+          <a:p>
+            <a:pPr algn="l">
+              <a:defRPr sz="1200" b="0">
+                <a:solidFill>
+                  <a:srgbClr val="FF6B6B"/>
+                </a:solidFill>
+                <a:latin typeface="Calibri"/>
+              </a:defRPr>
+            </a:pPr>
+            <a:r>
+              <a:t>~0.98</a:t>
+            </a:r>
+          </a:p>
+        </p:txBody>
+      </p:sp>
+      <p:sp>
+        <p:nvSpPr>
+          <p:cNvPr id="29" name="TextBox 28"/>
+          <p:cNvSpPr txBox="1"/>
+          <p:nvPr/>
+        </p:nvSpPr>
+        <p:spPr>
+          <a:xfrm>
+            <a:off x="4389120" y="4800600"/>
+            <a:ext cx="1828800" cy="274320"/>
+          </a:xfrm>
+          <a:prstGeom prst="rect">
+            <a:avLst/>
+          </a:prstGeom>
+          <a:noFill/>
+        </p:spPr>
+        <p:txBody>
+          <a:bodyPr wrap="square">
+            <a:spAutoFit/>
+          </a:bodyPr>
+          <a:lstStyle/>
+          <a:p>
+            <a:pPr algn="l">
+              <a:defRPr sz="1200" b="0">
+                <a:solidFill>
+                  <a:srgbClr val="FF6B6B"/>
+                </a:solidFill>
+                <a:latin typeface="Calibri"/>
+              </a:defRPr>
+            </a:pPr>
+            <a:r>
+              <a:t>0.78</a:t>
+            </a:r>
+          </a:p>
+        </p:txBody>
+      </p:sp>
+      <p:sp>
+        <p:nvSpPr>
+          <p:cNvPr id="30" name="TextBox 29"/>
+          <p:cNvSpPr txBox="1"/>
+          <p:nvPr/>
+        </p:nvSpPr>
+        <p:spPr>
+          <a:xfrm>
+            <a:off x="6217920" y="4800600"/>
+            <a:ext cx="1828800" cy="274320"/>
+          </a:xfrm>
+          <a:prstGeom prst="rect">
+            <a:avLst/>
+          </a:prstGeom>
+          <a:noFill/>
+        </p:spPr>
+        <p:txBody>
+          <a:bodyPr wrap="square">
+            <a:spAutoFit/>
+          </a:bodyPr>
+          <a:lstStyle/>
+          <a:p>
+            <a:pPr algn="l">
+              <a:defRPr sz="1200" b="0">
+                <a:solidFill>
+                  <a:srgbClr val="4ECB71"/>
+                </a:solidFill>
+                <a:latin typeface="Calibri"/>
+              </a:defRPr>
+            </a:pPr>
+            <a:r>
+              <a:t>0.999</a:t>
+            </a:r>
+          </a:p>
+        </p:txBody>
+      </p:sp>
+      <p:sp>
+        <p:nvSpPr>
+          <p:cNvPr id="31" name="TextBox 30"/>
+          <p:cNvSpPr txBox="1"/>
+          <p:nvPr/>
+        </p:nvSpPr>
+        <p:spPr>
+          <a:xfrm>
+            <a:off x="731520" y="5212080"/>
+            <a:ext cx="1828800" cy="274320"/>
+          </a:xfrm>
+          <a:prstGeom prst="rect">
+            <a:avLst/>
+          </a:prstGeom>
+          <a:noFill/>
+        </p:spPr>
+        <p:txBody>
+          <a:bodyPr wrap="square">
+            <a:spAutoFit/>
+          </a:bodyPr>
+          <a:lstStyle/>
+          <a:p>
+            <a:pPr algn="l">
+              <a:defRPr sz="1200" b="1">
                 <a:solidFill>
                   <a:srgbClr val="FFFFFF"/>
                 </a:solidFill>
@@ -8715,15 +9685,143 @@
               </a:defRPr>
             </a:pPr>
             <a:r>
-              <a:t>挑战 2: 多领域 — 新闻、诗歌、学术摘要等差异大</a:t>
-            </a:r>
-          </a:p>
-          <a:p>
-            <a:pPr>
-              <a:spcAft>
-                <a:spcPts val="1080"/>
-              </a:spcAft>
-              <a:defRPr sz="1800">
+              <a:t>速度</a:t>
+            </a:r>
+          </a:p>
+        </p:txBody>
+      </p:sp>
+      <p:sp>
+        <p:nvSpPr>
+          <p:cNvPr id="32" name="TextBox 31"/>
+          <p:cNvSpPr txBox="1"/>
+          <p:nvPr/>
+        </p:nvSpPr>
+        <p:spPr>
+          <a:xfrm>
+            <a:off x="2560320" y="5212080"/>
+            <a:ext cx="1828800" cy="274320"/>
+          </a:xfrm>
+          <a:prstGeom prst="rect">
+            <a:avLst/>
+          </a:prstGeom>
+          <a:noFill/>
+        </p:spPr>
+        <p:txBody>
+          <a:bodyPr wrap="square">
+            <a:spAutoFit/>
+          </a:bodyPr>
+          <a:lstStyle/>
+          <a:p>
+            <a:pPr algn="l">
+              <a:defRPr sz="1200" b="0">
+                <a:solidFill>
+                  <a:srgbClr val="FF6B6B"/>
+                </a:solidFill>
+                <a:latin typeface="Calibri"/>
+              </a:defRPr>
+            </a:pPr>
+            <a:r>
+              <a:t>慢 (GPU)</a:t>
+            </a:r>
+          </a:p>
+        </p:txBody>
+      </p:sp>
+      <p:sp>
+        <p:nvSpPr>
+          <p:cNvPr id="33" name="TextBox 32"/>
+          <p:cNvSpPr txBox="1"/>
+          <p:nvPr/>
+        </p:nvSpPr>
+        <p:spPr>
+          <a:xfrm>
+            <a:off x="4389120" y="5212080"/>
+            <a:ext cx="1828800" cy="274320"/>
+          </a:xfrm>
+          <a:prstGeom prst="rect">
+            <a:avLst/>
+          </a:prstGeom>
+          <a:noFill/>
+        </p:spPr>
+        <p:txBody>
+          <a:bodyPr wrap="square">
+            <a:spAutoFit/>
+          </a:bodyPr>
+          <a:lstStyle/>
+          <a:p>
+            <a:pPr algn="l">
+              <a:defRPr sz="1200" b="0">
+                <a:solidFill>
+                  <a:srgbClr val="FF6B6B"/>
+                </a:solidFill>
+                <a:latin typeface="Calibri"/>
+              </a:defRPr>
+            </a:pPr>
+            <a:r>
+              <a:t>慢 (GPU)</a:t>
+            </a:r>
+          </a:p>
+        </p:txBody>
+      </p:sp>
+      <p:sp>
+        <p:nvSpPr>
+          <p:cNvPr id="34" name="TextBox 33"/>
+          <p:cNvSpPr txBox="1"/>
+          <p:nvPr/>
+        </p:nvSpPr>
+        <p:spPr>
+          <a:xfrm>
+            <a:off x="6217920" y="5212080"/>
+            <a:ext cx="1828800" cy="274320"/>
+          </a:xfrm>
+          <a:prstGeom prst="rect">
+            <a:avLst/>
+          </a:prstGeom>
+          <a:noFill/>
+        </p:spPr>
+        <p:txBody>
+          <a:bodyPr wrap="square">
+            <a:spAutoFit/>
+          </a:bodyPr>
+          <a:lstStyle/>
+          <a:p>
+            <a:pPr algn="l">
+              <a:defRPr sz="1200" b="0">
+                <a:solidFill>
+                  <a:srgbClr val="4ECB71"/>
+                </a:solidFill>
+                <a:latin typeface="Calibri"/>
+              </a:defRPr>
+            </a:pPr>
+            <a:r>
+              <a:t>快 (CPU)</a:t>
+            </a:r>
+          </a:p>
+        </p:txBody>
+      </p:sp>
+      <p:sp>
+        <p:nvSpPr>
+          <p:cNvPr id="35" name="TextBox 34"/>
+          <p:cNvSpPr txBox="1"/>
+          <p:nvPr/>
+        </p:nvSpPr>
+        <p:spPr>
+          <a:xfrm>
+            <a:off x="731520" y="5623560"/>
+            <a:ext cx="1828800" cy="274320"/>
+          </a:xfrm>
+          <a:prstGeom prst="rect">
+            <a:avLst/>
+          </a:prstGeom>
+          <a:noFill/>
+        </p:spPr>
+        <p:txBody>
+          <a:bodyPr wrap="square">
+            <a:spAutoFit/>
+          </a:bodyPr>
+          <a:lstStyle/>
+          <a:p>
+            <a:pPr algn="l">
+              <a:defRPr sz="1200" b="1">
                 <a:solidFill>
                   <a:srgbClr val="FFFFFF"/>
                 </a:solidFill>
@@ -8731,91 +9829,122 @@
               </a:defRPr>
             </a:pPr>
             <a:r>
-              <a:t>挑战 3: 对抗攻击 — 释义、同义词替换等规避手段</a:t>
-            </a:r>
-          </a:p>
-          <a:p>
-            <a:pPr>
-              <a:spcAft>
-                <a:spcPts val="1080"/>
-              </a:spcAft>
-              <a:defRPr sz="1800">
-                <a:solidFill>
-                  <a:srgbClr val="FFFFFF"/>
-                </a:solidFill>
-                <a:latin typeface="Calibri"/>
-              </a:defRPr>
-            </a:pPr>
-            <a:r>
-              <a:t>挑战 4: 可解释性 — 不能只给判定，要说明为什么</a:t>
-            </a:r>
-          </a:p>
-          <a:p>
-            <a:pPr>
-              <a:spcAft>
-                <a:spcPts val="1080"/>
-              </a:spcAft>
-              <a:defRPr sz="1800">
-                <a:solidFill>
-                  <a:srgbClr val="FFFFFF"/>
-                </a:solidFill>
-                <a:latin typeface="Calibri"/>
-              </a:defRPr>
-            </a:pPr>
-          </a:p>
-          <a:p>
-            <a:pPr>
-              <a:spcAft>
-                <a:spcPts val="1080"/>
-              </a:spcAft>
-              <a:defRPr sz="1800">
-                <a:solidFill>
-                  <a:srgbClr val="FFFFFF"/>
-                </a:solidFill>
-                <a:latin typeface="Calibri"/>
-              </a:defRPr>
-            </a:pPr>
-            <a:r>
-              <a:t>我们的目标：</a:t>
-            </a:r>
-          </a:p>
-          <a:p>
-            <a:pPr>
-              <a:spcAft>
-                <a:spcPts val="1080"/>
-              </a:spcAft>
-              <a:defRPr sz="1800">
-                <a:solidFill>
-                  <a:srgbClr val="FFFFFF"/>
-                </a:solidFill>
-                <a:latin typeface="Calibri"/>
-              </a:defRPr>
-            </a:pPr>
-            <a:r>
-              <a:t>  用可解释的统计特征 + 轻量机器学习</a:t>
-            </a:r>
-          </a:p>
-          <a:p>
-            <a:pPr>
-              <a:spcAft>
-                <a:spcPts val="1080"/>
-              </a:spcAft>
-              <a:defRPr sz="1800">
-                <a:solidFill>
-                  <a:srgbClr val="FFFFFF"/>
-                </a:solidFill>
-                <a:latin typeface="Calibri"/>
-              </a:defRPr>
-            </a:pPr>
-            <a:r>
-              <a:t>  替代不可解释的深度学习黑盒</a:t>
+              <a:t>泛化性</a:t>
+            </a:r>
+          </a:p>
+        </p:txBody>
+      </p:sp>
+      <p:sp>
+        <p:nvSpPr>
+          <p:cNvPr id="36" name="TextBox 35"/>
+          <p:cNvSpPr txBox="1"/>
+          <p:nvPr/>
+        </p:nvSpPr>
+        <p:spPr>
+          <a:xfrm>
+            <a:off x="2560320" y="5623560"/>
+            <a:ext cx="1828800" cy="274320"/>
+          </a:xfrm>
+          <a:prstGeom prst="rect">
+            <a:avLst/>
+          </a:prstGeom>
+          <a:noFill/>
+        </p:spPr>
+        <p:txBody>
+          <a:bodyPr wrap="square">
+            <a:spAutoFit/>
+          </a:bodyPr>
+          <a:lstStyle/>
+          <a:p>
+            <a:pPr algn="l">
+              <a:defRPr sz="1200" b="0">
+                <a:solidFill>
+                  <a:srgbClr val="FF6B6B"/>
+                </a:solidFill>
+                <a:latin typeface="Calibri"/>
+              </a:defRPr>
+            </a:pPr>
+            <a:r>
+              <a:t>需重训练</a:t>
+            </a:r>
+          </a:p>
+        </p:txBody>
+      </p:sp>
+      <p:sp>
+        <p:nvSpPr>
+          <p:cNvPr id="37" name="TextBox 36"/>
+          <p:cNvSpPr txBox="1"/>
+          <p:nvPr/>
+        </p:nvSpPr>
+        <p:spPr>
+          <a:xfrm>
+            <a:off x="4389120" y="5623560"/>
+            <a:ext cx="1828800" cy="274320"/>
+          </a:xfrm>
+          <a:prstGeom prst="rect">
+            <a:avLst/>
+          </a:prstGeom>
+          <a:noFill/>
+        </p:spPr>
+        <p:txBody>
+          <a:bodyPr wrap="square">
+            <a:spAutoFit/>
+          </a:bodyPr>
+          <a:lstStyle/>
+          <a:p>
+            <a:pPr algn="l">
+              <a:defRPr sz="1200" b="0">
+                <a:solidFill>
+                  <a:srgbClr val="FF6B6B"/>
+                </a:solidFill>
+                <a:latin typeface="Calibri"/>
+              </a:defRPr>
+            </a:pPr>
+            <a:r>
+              <a:t>不稳定</a:t>
+            </a:r>
+          </a:p>
+        </p:txBody>
+      </p:sp>
+      <p:sp>
+        <p:nvSpPr>
+          <p:cNvPr id="38" name="TextBox 37"/>
+          <p:cNvSpPr txBox="1"/>
+          <p:nvPr/>
+        </p:nvSpPr>
+        <p:spPr>
+          <a:xfrm>
+            <a:off x="6217920" y="5623560"/>
+            <a:ext cx="1828800" cy="274320"/>
+          </a:xfrm>
+          <a:prstGeom prst="rect">
+            <a:avLst/>
+          </a:prstGeom>
+          <a:noFill/>
+        </p:spPr>
+        <p:txBody>
+          <a:bodyPr wrap="square">
+            <a:spAutoFit/>
+          </a:bodyPr>
+          <a:lstStyle/>
+          <a:p>
+            <a:pPr algn="l">
+              <a:defRPr sz="1200" b="0">
+                <a:solidFill>
+                  <a:srgbClr val="4ECB71"/>
+                </a:solidFill>
+                <a:latin typeface="Calibri"/>
+              </a:defRPr>
+            </a:pPr>
+            <a:r>
+              <a:t>特征组合灵活</a:t>
             </a:r>
           </a:p>
         </p:txBody>
       </p:sp>
       <p:pic>
         <p:nvPicPr>
-          <p:cNvPr id="5" name="Picture 4" descr="class_distribution.png"/>
+          <p:cNvPr id="39" name="Picture 38" descr="raid_model_domain_heatmap.png"/>
           <p:cNvPicPr>
             <a:picLocks noChangeAspect="1"/>
           </p:cNvPicPr>
@@ -8829,14 +9958,122 @@
         </p:blipFill>
         <p:spPr>
           <a:xfrm>
-            <a:off x="6858000" y="1371600"/>
-            <a:ext cx="4572000" cy="3429000"/>
+            <a:off x="6858000" y="1188720"/>
+            <a:ext cx="5029200" cy="2743200"/>
           </a:xfrm>
           <a:prstGeom prst="rect">
             <a:avLst/>
           </a:prstGeom>
         </p:spPr>
       </p:pic>
+      <p:sp>
+        <p:nvSpPr>
+          <p:cNvPr id="40" name="TextBox 39"/>
+          <p:cNvSpPr txBox="1"/>
+          <p:nvPr/>
+        </p:nvSpPr>
+        <p:spPr>
+          <a:xfrm>
+            <a:off x="6858000" y="4023360"/>
+            <a:ext cx="5029200" cy="365760"/>
+          </a:xfrm>
+          <a:prstGeom prst="rect">
+            <a:avLst/>
+          </a:prstGeom>
+          <a:noFill/>
+        </p:spPr>
+        <p:txBody>
+          <a:bodyPr wrap="square">
+            <a:spAutoFit/>
+          </a:bodyPr>
+          <a:lstStyle/>
+          <a:p>
+            <a:pPr algn="ctr">
+              <a:defRPr sz="1400" b="1">
+                <a:solidFill>
+                  <a:srgbClr val="00D2FF"/>
+                </a:solidFill>
+                <a:latin typeface="Calibri"/>
+              </a:defRPr>
+            </a:pPr>
+            <a:r>
+              <a:t>RAID: 11 生成器 × 8 领域</a:t>
+            </a:r>
+          </a:p>
+        </p:txBody>
+      </p:sp>
+      <p:sp>
+        <p:nvSpPr>
+          <p:cNvPr id="41" name="TextBox 40"/>
+          <p:cNvSpPr txBox="1"/>
+          <p:nvPr/>
+        </p:nvSpPr>
+        <p:spPr>
+          <a:xfrm>
+            <a:off x="6858000" y="4389120"/>
+            <a:ext cx="5029200" cy="365760"/>
+          </a:xfrm>
+          <a:prstGeom prst="rect">
+            <a:avLst/>
+          </a:prstGeom>
+          <a:noFill/>
+        </p:spPr>
+        <p:txBody>
+          <a:bodyPr wrap="square">
+            <a:spAutoFit/>
+          </a:bodyPr>
+          <a:lstStyle/>
+          <a:p>
+            <a:pPr algn="ctr">
+              <a:defRPr sz="1200" b="0">
+                <a:solidFill>
+                  <a:srgbClr val="AAAAAA"/>
+                </a:solidFill>
+                <a:latin typeface="Calibri"/>
+              </a:defRPr>
+            </a:pPr>
+            <a:r>
+              <a:t>从 GPT-2 到 GPT-4, 覆盖全代际</a:t>
+            </a:r>
+          </a:p>
+        </p:txBody>
+      </p:sp>
+      <p:sp>
+        <p:nvSpPr>
+          <p:cNvPr id="42" name="TextBox 41"/>
+          <p:cNvSpPr txBox="1"/>
+          <p:nvPr/>
+        </p:nvSpPr>
+        <p:spPr>
+          <a:xfrm>
+            <a:off x="731520" y="6035040"/>
+            <a:ext cx="10972800" cy="457200"/>
+          </a:xfrm>
+          <a:prstGeom prst="rect">
+            <a:avLst/>
+          </a:prstGeom>
+          <a:noFill/>
+        </p:spPr>
+        <p:txBody>
+          <a:bodyPr wrap="square">
+            <a:spAutoFit/>
+          </a:bodyPr>
+          <a:lstStyle/>
+          <a:p>
+            <a:pPr algn="ctr">
+              <a:defRPr sz="1600" b="0">
+                <a:solidFill>
+                  <a:srgbClr val="00D2FF"/>
+                </a:solidFill>
+                <a:latin typeface="Calibri"/>
+              </a:defRPr>
+            </a:pPr>
+            <a:r>
+              <a:t>我们的目标：用 118 维可解释特征 + XGBoost, 在 RAID 上超越零样本方法, 并揭示特征的"有效期"规律</a:t>
+            </a:r>
+          </a:p>
+        </p:txBody>
+      </p:sp>
     </p:spTree>
   </p:cSld>
   <p:clrMapOvr>
@@ -13829,8 +15066,8 @@
         </p:nvSpPr>
         <p:spPr>
           <a:xfrm>
-            <a:off x="457200" y="4846320"/>
-            <a:ext cx="10972800" cy="457200"/>
+            <a:off x="457200" y="4572000"/>
+            <a:ext cx="10972800" cy="365760"/>
           </a:xfrm>
           <a:prstGeom prst="rect">
             <a:avLst/>
@@ -13844,7 +15081,7 @@
           <a:lstStyle/>
           <a:p>
             <a:pPr algn="ctr">
-              <a:defRPr sz="1800" b="1">
+              <a:defRPr sz="1700" b="1">
                 <a:solidFill>
                   <a:srgbClr val="FFFFFF"/>
                 </a:solidFill>
@@ -13852,44 +15089,53 @@
               </a:defRPr>
             </a:pPr>
             <a:r>
-              <a:t>Model-Free (36维)  +  Model-Based (82维)  =  118维 (去重后)</a:t>
-            </a:r>
-          </a:p>
-        </p:txBody>
-      </p:sp>
-      <p:sp>
-        <p:nvSpPr>
-          <p:cNvPr id="11" name="TextBox 10"/>
-          <p:cNvSpPr txBox="1"/>
-          <p:nvPr/>
-        </p:nvSpPr>
-        <p:spPr>
-          <a:xfrm>
-            <a:off x="1828800" y="5303520"/>
-            <a:ext cx="8229600" cy="548640"/>
-          </a:xfrm>
-          <a:prstGeom prst="rect">
-            <a:avLst/>
-          </a:prstGeom>
-          <a:noFill/>
-        </p:spPr>
-        <p:txBody>
-          <a:bodyPr wrap="square">
-            <a:spAutoFit/>
-          </a:bodyPr>
-          <a:lstStyle/>
-          <a:p>
-            <a:pPr algn="ctr">
-              <a:defRPr sz="1800" b="1">
-                <a:solidFill>
-                  <a:srgbClr val="FFFFFF"/>
-                </a:solidFill>
-                <a:latin typeface="Calibri"/>
-              </a:defRPr>
-            </a:pPr>
-            <a:r>
-              <a:t>→  XGBoost (500 trees, depth 8)  →  SHAP 可解释分析</a:t>
-            </a:r>
+              <a:t>Model-Free (36维)  +  Model-Based (82维)  =  118维 → XGBoost → SHAP</a:t>
+            </a:r>
+          </a:p>
+        </p:txBody>
+      </p:sp>
+      <p:sp>
+        <p:nvSpPr>
+          <p:cNvPr id="11" name="Rounded Rectangle 10"/>
+          <p:cNvSpPr/>
+          <p:nvPr/>
+        </p:nvSpPr>
+        <p:spPr>
+          <a:xfrm>
+            <a:off x="457200" y="5029200"/>
+            <a:ext cx="5486400" cy="1371600"/>
+          </a:xfrm>
+          <a:prstGeom prst="roundRect">
+            <a:avLst/>
+          </a:prstGeom>
+          <a:solidFill>
+            <a:srgbClr val="202848"/>
+          </a:solidFill>
+          <a:ln w="19050">
+            <a:solidFill>
+              <a:srgbClr val="FF6B6B"/>
+            </a:solidFill>
+          </a:ln>
+        </p:spPr>
+        <p:style>
+          <a:lnRef idx="1">
+            <a:schemeClr val="accent1"/>
+          </a:lnRef>
+          <a:fillRef idx="3">
+            <a:schemeClr val="accent1"/>
+          </a:fillRef>
+          <a:effectRef idx="2">
+            <a:schemeClr val="accent1"/>
+          </a:effectRef>
+          <a:fontRef idx="minor">
+            <a:schemeClr val="lt1"/>
+          </a:fontRef>
+        </p:style>
+        <p:txBody>
+          <a:bodyPr rtlCol="0" anchor="ctr"/>
+          <a:lstStyle/>
+          <a:p>
+            <a:pPr algn="ctr"/>
           </a:p>
         </p:txBody>
       </p:sp>
@@ -13901,30 +15147,253 @@
         </p:nvSpPr>
         <p:spPr>
           <a:xfrm>
-            <a:off x="731520" y="5943600"/>
-            <a:ext cx="10058400" cy="457200"/>
-          </a:xfrm>
-          <a:prstGeom prst="rect">
-            <a:avLst/>
-          </a:prstGeom>
-          <a:noFill/>
-        </p:spPr>
-        <p:txBody>
-          <a:bodyPr wrap="square">
-            <a:spAutoFit/>
-          </a:bodyPr>
-          <a:lstStyle/>
-          <a:p>
-            <a:pPr algn="ctr">
-              <a:defRPr sz="1600" b="0">
-                <a:solidFill>
-                  <a:srgbClr val="00D2FF"/>
-                </a:solidFill>
-                <a:latin typeface="Calibri"/>
-              </a:defRPr>
-            </a:pPr>
-            <a:r>
-              <a:t>核心理念：Model-Free 看文本的外表, Model-Based 的三个参考模型各自捕捉不同时代 AI 的内在</a:t>
+            <a:off x="640080" y="5029200"/>
+            <a:ext cx="5120640" cy="320040"/>
+          </a:xfrm>
+          <a:prstGeom prst="rect">
+            <a:avLst/>
+          </a:prstGeom>
+          <a:noFill/>
+        </p:spPr>
+        <p:txBody>
+          <a:bodyPr wrap="square">
+            <a:spAutoFit/>
+          </a:bodyPr>
+          <a:lstStyle/>
+          <a:p>
+            <a:pPr algn="l">
+              <a:defRPr sz="1400" b="1">
+                <a:solidFill>
+                  <a:srgbClr val="FF6B6B"/>
+                </a:solidFill>
+                <a:latin typeface="Calibri"/>
+              </a:defRPr>
+            </a:pPr>
+            <a:r>
+              <a:t>Step 1: 多维度特征工程</a:t>
+            </a:r>
+          </a:p>
+        </p:txBody>
+      </p:sp>
+      <p:sp>
+        <p:nvSpPr>
+          <p:cNvPr id="13" name="TextBox 12"/>
+          <p:cNvSpPr txBox="1"/>
+          <p:nvPr/>
+        </p:nvSpPr>
+        <p:spPr>
+          <a:xfrm>
+            <a:off x="640080" y="5349240"/>
+            <a:ext cx="5120640" cy="1005840"/>
+          </a:xfrm>
+          <a:prstGeom prst="rect">
+            <a:avLst/>
+          </a:prstGeom>
+          <a:noFill/>
+        </p:spPr>
+        <p:txBody>
+          <a:bodyPr wrap="square">
+            <a:spAutoFit/>
+          </a:bodyPr>
+          <a:lstStyle/>
+          <a:p>
+            <a:pPr>
+              <a:spcAft>
+                <a:spcPts val="600"/>
+              </a:spcAft>
+              <a:defRPr sz="1000">
+                <a:solidFill>
+                  <a:srgbClr val="E0E0E0"/>
+                </a:solidFill>
+                <a:latin typeface="Calibri"/>
+              </a:defRPr>
+            </a:pPr>
+            <a:r>
+              <a:t>词汇丰富度: TTR, Hapax ratio, Yule's K (AI 用词重复)</a:t>
+            </a:r>
+          </a:p>
+          <a:p>
+            <a:pPr>
+              <a:spcAft>
+                <a:spcPts val="600"/>
+              </a:spcAft>
+              <a:defRPr sz="1000">
+                <a:solidFill>
+                  <a:srgbClr val="E0E0E0"/>
+                </a:solidFill>
+                <a:latin typeface="Calibri"/>
+              </a:defRPr>
+            </a:pPr>
+            <a:r>
+              <a:t>可读性评分: Flesch-Kincaid, Gunning Fog (AI 偏好中等难度)</a:t>
+            </a:r>
+          </a:p>
+          <a:p>
+            <a:pPr>
+              <a:spcAft>
+                <a:spcPts val="600"/>
+              </a:spcAft>
+              <a:defRPr sz="1000">
+                <a:solidFill>
+                  <a:srgbClr val="E0E0E0"/>
+                </a:solidFill>
+                <a:latin typeface="Calibri"/>
+              </a:defRPr>
+            </a:pPr>
+            <a:r>
+              <a:t>行文模式: 段落结构规则性、句长波动 (AI 缺乏节奏变化)</a:t>
+            </a:r>
+          </a:p>
+        </p:txBody>
+      </p:sp>
+      <p:sp>
+        <p:nvSpPr>
+          <p:cNvPr id="14" name="Rounded Rectangle 13"/>
+          <p:cNvSpPr/>
+          <p:nvPr/>
+        </p:nvSpPr>
+        <p:spPr>
+          <a:xfrm>
+            <a:off x="6217920" y="5029200"/>
+            <a:ext cx="5486400" cy="1371600"/>
+          </a:xfrm>
+          <a:prstGeom prst="roundRect">
+            <a:avLst/>
+          </a:prstGeom>
+          <a:solidFill>
+            <a:srgbClr val="202848"/>
+          </a:solidFill>
+          <a:ln w="19050">
+            <a:solidFill>
+              <a:srgbClr val="4ECB71"/>
+            </a:solidFill>
+          </a:ln>
+        </p:spPr>
+        <p:style>
+          <a:lnRef idx="1">
+            <a:schemeClr val="accent1"/>
+          </a:lnRef>
+          <a:fillRef idx="3">
+            <a:schemeClr val="accent1"/>
+          </a:fillRef>
+          <a:effectRef idx="2">
+            <a:schemeClr val="accent1"/>
+          </a:effectRef>
+          <a:fontRef idx="minor">
+            <a:schemeClr val="lt1"/>
+          </a:fontRef>
+        </p:style>
+        <p:txBody>
+          <a:bodyPr rtlCol="0" anchor="ctr"/>
+          <a:lstStyle/>
+          <a:p>
+            <a:pPr algn="ctr"/>
+          </a:p>
+        </p:txBody>
+      </p:sp>
+      <p:sp>
+        <p:nvSpPr>
+          <p:cNvPr id="15" name="TextBox 14"/>
+          <p:cNvSpPr txBox="1"/>
+          <p:nvPr/>
+        </p:nvSpPr>
+        <p:spPr>
+          <a:xfrm>
+            <a:off x="6400800" y="5029200"/>
+            <a:ext cx="5120640" cy="320040"/>
+          </a:xfrm>
+          <a:prstGeom prst="rect">
+            <a:avLst/>
+          </a:prstGeom>
+          <a:noFill/>
+        </p:spPr>
+        <p:txBody>
+          <a:bodyPr wrap="square">
+            <a:spAutoFit/>
+          </a:bodyPr>
+          <a:lstStyle/>
+          <a:p>
+            <a:pPr algn="l">
+              <a:defRPr sz="1400" b="1">
+                <a:solidFill>
+                  <a:srgbClr val="4ECB71"/>
+                </a:solidFill>
+                <a:latin typeface="Calibri"/>
+              </a:defRPr>
+            </a:pPr>
+            <a:r>
+              <a:t>Step 2: 模型构建与特征筛选</a:t>
+            </a:r>
+          </a:p>
+        </p:txBody>
+      </p:sp>
+      <p:sp>
+        <p:nvSpPr>
+          <p:cNvPr id="16" name="TextBox 15"/>
+          <p:cNvSpPr txBox="1"/>
+          <p:nvPr/>
+        </p:nvSpPr>
+        <p:spPr>
+          <a:xfrm>
+            <a:off x="6400800" y="5349240"/>
+            <a:ext cx="5120640" cy="1005840"/>
+          </a:xfrm>
+          <a:prstGeom prst="rect">
+            <a:avLst/>
+          </a:prstGeom>
+          <a:noFill/>
+        </p:spPr>
+        <p:txBody>
+          <a:bodyPr wrap="square">
+            <a:spAutoFit/>
+          </a:bodyPr>
+          <a:lstStyle/>
+          <a:p>
+            <a:pPr>
+              <a:spcAft>
+                <a:spcPts val="600"/>
+              </a:spcAft>
+              <a:defRPr sz="1000">
+                <a:solidFill>
+                  <a:srgbClr val="E0E0E0"/>
+                </a:solidFill>
+                <a:latin typeface="Calibri"/>
+              </a:defRPr>
+            </a:pPr>
+            <a:r>
+              <a:t>XGBoost / Random Forest / LR 对比, 选最优分类器</a:t>
+            </a:r>
+          </a:p>
+          <a:p>
+            <a:pPr>
+              <a:spcAft>
+                <a:spcPts val="600"/>
+              </a:spcAft>
+              <a:defRPr sz="1000">
+                <a:solidFill>
+                  <a:srgbClr val="E0E0E0"/>
+                </a:solidFill>
+                <a:latin typeface="Calibri"/>
+              </a:defRPr>
+            </a:pPr>
+            <a:r>
+              <a:t>相关性分析 + 消融实验剔除冗余特征</a:t>
+            </a:r>
+          </a:p>
+          <a:p>
+            <a:pPr>
+              <a:spcAft>
+                <a:spcPts val="600"/>
+              </a:spcAft>
+              <a:defRPr sz="1000">
+                <a:solidFill>
+                  <a:srgbClr val="E0E0E0"/>
+                </a:solidFill>
+                <a:latin typeface="Calibri"/>
+              </a:defRPr>
+            </a:pPr>
+            <a:r>
+              <a:t>SHAP 归因分析验证每个特征的贡献与可解释性</a:t>
             </a:r>
           </a:p>
         </p:txBody>

</xml_diff>

<commit_message>
Fix PPT: update 120→118 dimensions throughout, fix text overflow
- Regenerate raid_final_comparison.png with 118 labels
- Fix results text width and font size to prevent overflow
- SHAP slide title: 120维→118维
- All other 120 references updated to 118

Co-Authored-By: Claude Opus 4.6 <noreply@anthropic.com>
</commit_message>
<xml_diff>
--- a/reports/AIGC_Detection_Presentation.pptx
+++ b/reports/AIGC_Detection_Presentation.pptx
@@ -3879,7 +3879,7 @@
               </a:defRPr>
             </a:pPr>
             <a:r>
-              <a:t>SHAP 可解释性分析 (120 维)</a:t>
+              <a:t>SHAP 可解释性分析 (118 维)</a:t>
             </a:r>
           </a:p>
         </p:txBody>
@@ -5932,7 +5932,7 @@
               </a:defRPr>
             </a:pPr>
             <a:r>
-              <a:t>不同生成器有不同的"特征指纹" — 120 维在 Cohere/ChatGPT 上提升最大</a:t>
+              <a:t>不同生成器有不同的"特征指纹" — 118 维在 Cohere/ChatGPT 上提升最大</a:t>
             </a:r>
           </a:p>
         </p:txBody>
@@ -6507,7 +6507,7 @@
               </a:defRPr>
             </a:pPr>
             <a:r>
-              <a:t>120-mix</a:t>
+              <a:t>118-mix</a:t>
             </a:r>
           </a:p>
         </p:txBody>
@@ -7695,7 +7695,7 @@
               </a:defRPr>
             </a:pPr>
             <a:r>
-              <a:t>核心规律: 120 组合只在两侧特征都有信号时互补增强 (RAID)</a:t>
+              <a:t>核心规律: 118 组合只在两侧特征都有信号时互补增强 (RAID)</a:t>
             </a:r>
             <a:br/>
             <a:r>
@@ -8060,7 +8060,7 @@
               </a:defRPr>
             </a:pPr>
             <a:r>
-              <a:t>120 维模型中 42.7% importance → 噪声特征</a:t>
+              <a:t>118 维模型中 42.7% importance → 噪声特征</a:t>
             </a:r>
           </a:p>
           <a:p>
@@ -13470,7 +13470,7 @@
             </a:r>
             <a:br/>
             <a:r>
-              <a:t>当一个视角被欺骗时，另一个视角往往能看穿。这就是 120 维组合的力量。"</a:t>
+              <a:t>当一个视角被欺骗时，另一个视角往往能看穿。这就是 118 维组合的力量。"</a:t>
             </a:r>
           </a:p>
         </p:txBody>
@@ -17674,7 +17674,7 @@
         <p:spPr>
           <a:xfrm>
             <a:off x="457200" y="1371600"/>
-            <a:ext cx="5943600" cy="2931695"/>
+            <a:ext cx="5943600" cy="2929775"/>
           </a:xfrm>
           <a:prstGeom prst="rect">
             <a:avLst/>
@@ -17726,149 +17726,149 @@
         <p:spPr>
           <a:xfrm>
             <a:off x="6858000" y="2103120"/>
-            <a:ext cx="4572000" cy="4114800"/>
-          </a:xfrm>
-          <a:prstGeom prst="rect">
-            <a:avLst/>
-          </a:prstGeom>
-          <a:noFill/>
-        </p:spPr>
-        <p:txBody>
-          <a:bodyPr wrap="square">
-            <a:spAutoFit/>
-          </a:bodyPr>
-          <a:lstStyle/>
-          <a:p>
-            <a:pPr>
-              <a:spcAft>
-                <a:spcPts val="960"/>
-              </a:spcAft>
-              <a:defRPr sz="1600">
-                <a:solidFill>
-                  <a:srgbClr val="E0E0E0"/>
-                </a:solidFill>
-                <a:latin typeface="Calibri"/>
-              </a:defRPr>
-            </a:pPr>
-            <a:r>
-              <a:t>XGBoost (120 组合):  AUC 0.9992</a:t>
-            </a:r>
-          </a:p>
-          <a:p>
-            <a:pPr>
-              <a:spcAft>
-                <a:spcPts val="960"/>
-              </a:spcAft>
-              <a:defRPr sz="1600">
-                <a:solidFill>
-                  <a:srgbClr val="E0E0E0"/>
-                </a:solidFill>
-                <a:latin typeface="Calibri"/>
-              </a:defRPr>
-            </a:pPr>
-            <a:r>
-              <a:t>XGBoost (90 手工):   AUC 0.9951</a:t>
-            </a:r>
-          </a:p>
-          <a:p>
-            <a:pPr>
-              <a:spcAft>
-                <a:spcPts val="960"/>
-              </a:spcAft>
-              <a:defRPr sz="1600">
-                <a:solidFill>
-                  <a:srgbClr val="E0E0E0"/>
-                </a:solidFill>
-                <a:latin typeface="Calibri"/>
-              </a:defRPr>
-            </a:pPr>
-            <a:r>
-              <a:t>XGBoost (30 Token):  AUC 0.9900</a:t>
-            </a:r>
-          </a:p>
-          <a:p>
-            <a:pPr>
-              <a:spcAft>
-                <a:spcPts val="960"/>
-              </a:spcAft>
-              <a:defRPr sz="1600">
-                <a:solidFill>
-                  <a:srgbClr val="E0E0E0"/>
-                </a:solidFill>
-                <a:latin typeface="Calibri"/>
-              </a:defRPr>
-            </a:pPr>
-            <a:r>
-              <a:t>Random Forest (90):  AUC 0.9923</a:t>
-            </a:r>
-          </a:p>
-          <a:p>
-            <a:pPr>
-              <a:spcAft>
-                <a:spcPts val="960"/>
-              </a:spcAft>
-              <a:defRPr sz="1600">
-                <a:solidFill>
-                  <a:srgbClr val="E0E0E0"/>
-                </a:solidFill>
-                <a:latin typeface="Calibri"/>
-              </a:defRPr>
-            </a:pPr>
-            <a:r>
-              <a:t>LR (90):             AUC 0.9653</a:t>
-            </a:r>
-          </a:p>
-          <a:p>
-            <a:pPr>
-              <a:spcAft>
-                <a:spcPts val="960"/>
-              </a:spcAft>
-              <a:defRPr sz="1600">
-                <a:solidFill>
-                  <a:srgbClr val="E0E0E0"/>
-                </a:solidFill>
-                <a:latin typeface="Calibri"/>
-              </a:defRPr>
-            </a:pPr>
-            <a:r>
-              <a:t>Fast-DetectGPT:      AUC 0.7815</a:t>
-            </a:r>
-          </a:p>
-          <a:p>
-            <a:pPr>
-              <a:spcAft>
-                <a:spcPts val="960"/>
-              </a:spcAft>
-              <a:defRPr sz="1600">
-                <a:solidFill>
-                  <a:srgbClr val="E0E0E0"/>
-                </a:solidFill>
-                <a:latin typeface="Calibri"/>
-              </a:defRPr>
-            </a:pPr>
-          </a:p>
-          <a:p>
-            <a:pPr>
-              <a:spcAft>
-                <a:spcPts val="960"/>
-              </a:spcAft>
-              <a:defRPr sz="1600">
-                <a:solidFill>
-                  <a:srgbClr val="E0E0E0"/>
-                </a:solidFill>
-                <a:latin typeface="Calibri"/>
-              </a:defRPr>
-            </a:pPr>
-            <a:r>
-              <a:t>120 组合 vs 90 手工:</a:t>
-            </a:r>
-          </a:p>
-          <a:p>
-            <a:pPr>
-              <a:spcAft>
-                <a:spcPts val="960"/>
-              </a:spcAft>
-              <a:defRPr sz="1600">
+            <a:ext cx="5029200" cy="4114800"/>
+          </a:xfrm>
+          <a:prstGeom prst="rect">
+            <a:avLst/>
+          </a:prstGeom>
+          <a:noFill/>
+        </p:spPr>
+        <p:txBody>
+          <a:bodyPr wrap="square">
+            <a:spAutoFit/>
+          </a:bodyPr>
+          <a:lstStyle/>
+          <a:p>
+            <a:pPr>
+              <a:spcAft>
+                <a:spcPts val="900"/>
+              </a:spcAft>
+              <a:defRPr sz="1500">
+                <a:solidFill>
+                  <a:srgbClr val="E0E0E0"/>
+                </a:solidFill>
+                <a:latin typeface="Calibri"/>
+              </a:defRPr>
+            </a:pPr>
+            <a:r>
+              <a:t>XGBoost (118 组合):  AUC 0.9992</a:t>
+            </a:r>
+          </a:p>
+          <a:p>
+            <a:pPr>
+              <a:spcAft>
+                <a:spcPts val="900"/>
+              </a:spcAft>
+              <a:defRPr sz="1500">
+                <a:solidFill>
+                  <a:srgbClr val="E0E0E0"/>
+                </a:solidFill>
+                <a:latin typeface="Calibri"/>
+              </a:defRPr>
+            </a:pPr>
+            <a:r>
+              <a:t>XGBoost (88 手工):    AUC 0.9951</a:t>
+            </a:r>
+          </a:p>
+          <a:p>
+            <a:pPr>
+              <a:spcAft>
+                <a:spcPts val="900"/>
+              </a:spcAft>
+              <a:defRPr sz="1500">
+                <a:solidFill>
+                  <a:srgbClr val="E0E0E0"/>
+                </a:solidFill>
+                <a:latin typeface="Calibri"/>
+              </a:defRPr>
+            </a:pPr>
+            <a:r>
+              <a:t>XGBoost (30 Token):   AUC 0.9900</a:t>
+            </a:r>
+          </a:p>
+          <a:p>
+            <a:pPr>
+              <a:spcAft>
+                <a:spcPts val="900"/>
+              </a:spcAft>
+              <a:defRPr sz="1500">
+                <a:solidFill>
+                  <a:srgbClr val="E0E0E0"/>
+                </a:solidFill>
+                <a:latin typeface="Calibri"/>
+              </a:defRPr>
+            </a:pPr>
+            <a:r>
+              <a:t>Random Forest (88):   AUC 0.9923</a:t>
+            </a:r>
+          </a:p>
+          <a:p>
+            <a:pPr>
+              <a:spcAft>
+                <a:spcPts val="900"/>
+              </a:spcAft>
+              <a:defRPr sz="1500">
+                <a:solidFill>
+                  <a:srgbClr val="E0E0E0"/>
+                </a:solidFill>
+                <a:latin typeface="Calibri"/>
+              </a:defRPr>
+            </a:pPr>
+            <a:r>
+              <a:t>LR (88):                   AUC 0.9653</a:t>
+            </a:r>
+          </a:p>
+          <a:p>
+            <a:pPr>
+              <a:spcAft>
+                <a:spcPts val="900"/>
+              </a:spcAft>
+              <a:defRPr sz="1500">
+                <a:solidFill>
+                  <a:srgbClr val="E0E0E0"/>
+                </a:solidFill>
+                <a:latin typeface="Calibri"/>
+              </a:defRPr>
+            </a:pPr>
+            <a:r>
+              <a:t>Fast-DetectGPT:         AUC 0.7815</a:t>
+            </a:r>
+          </a:p>
+          <a:p>
+            <a:pPr>
+              <a:spcAft>
+                <a:spcPts val="900"/>
+              </a:spcAft>
+              <a:defRPr sz="1500">
+                <a:solidFill>
+                  <a:srgbClr val="E0E0E0"/>
+                </a:solidFill>
+                <a:latin typeface="Calibri"/>
+              </a:defRPr>
+            </a:pPr>
+          </a:p>
+          <a:p>
+            <a:pPr>
+              <a:spcAft>
+                <a:spcPts val="900"/>
+              </a:spcAft>
+              <a:defRPr sz="1500">
+                <a:solidFill>
+                  <a:srgbClr val="E0E0E0"/>
+                </a:solidFill>
+                <a:latin typeface="Calibri"/>
+              </a:defRPr>
+            </a:pPr>
+            <a:r>
+              <a:t>118 组合 vs 88 手工:</a:t>
+            </a:r>
+          </a:p>
+          <a:p>
+            <a:pPr>
+              <a:spcAft>
+                <a:spcPts val="900"/>
+              </a:spcAft>
+              <a:defRPr sz="1500">
                 <a:solidFill>
                   <a:srgbClr val="E0E0E0"/>
                 </a:solidFill>
@@ -17882,22 +17882,22 @@
           <a:p>
             <a:pPr>
               <a:spcAft>
-                <a:spcPts val="960"/>
-              </a:spcAft>
-              <a:defRPr sz="1600">
-                <a:solidFill>
-                  <a:srgbClr val="E0E0E0"/>
-                </a:solidFill>
-                <a:latin typeface="Calibri"/>
-              </a:defRPr>
-            </a:pPr>
-          </a:p>
-          <a:p>
-            <a:pPr>
-              <a:spcAft>
-                <a:spcPts val="960"/>
-              </a:spcAft>
-              <a:defRPr sz="1600">
+                <a:spcPts val="900"/>
+              </a:spcAft>
+              <a:defRPr sz="1500">
+                <a:solidFill>
+                  <a:srgbClr val="E0E0E0"/>
+                </a:solidFill>
+                <a:latin typeface="Calibri"/>
+              </a:defRPr>
+            </a:pPr>
+          </a:p>
+          <a:p>
+            <a:pPr>
+              <a:spcAft>
+                <a:spcPts val="900"/>
+              </a:spcAft>
+              <a:defRPr sz="1500">
                 <a:solidFill>
                   <a:srgbClr val="E0E0E0"/>
                 </a:solidFill>

</xml_diff>

<commit_message>
Regenerate PPT with updated 118-dimension figures
Co-Authored-By: Claude Opus 4.6 <noreply@anthropic.com>
</commit_message>
<xml_diff>
--- a/reports/AIGC_Detection_Presentation.pptx
+++ b/reports/AIGC_Detection_Presentation.pptx
@@ -3944,7 +3944,7 @@
         <p:spPr>
           <a:xfrm>
             <a:off x="274320" y="1188720"/>
-            <a:ext cx="5486400" cy="9363269"/>
+            <a:ext cx="5486400" cy="9336179"/>
           </a:xfrm>
           <a:prstGeom prst="rect">
             <a:avLst/>
@@ -5894,7 +5894,7 @@
         <p:spPr>
           <a:xfrm>
             <a:off x="6217920" y="1188720"/>
-            <a:ext cx="5669280" cy="3370923"/>
+            <a:ext cx="5669280" cy="3377036"/>
           </a:xfrm>
           <a:prstGeom prst="rect">
             <a:avLst/>

</xml_diff>

<commit_message>
Fix remaining 90-feat → 88-feat labels in cross-dataset slides
Co-Authored-By: Claude Opus 4.6 <noreply@anthropic.com>
</commit_message>
<xml_diff>
--- a/reports/AIGC_Detection_Presentation.pptx
+++ b/reports/AIGC_Detection_Presentation.pptx
@@ -10435,7 +10435,7 @@
               </a:defRPr>
             </a:pPr>
             <a:r>
-              <a:t>为什么 90-feat 在 SemEval 上失效?</a:t>
+              <a:t>为什么 88-feat 在 SemEval 上失效?</a:t>
             </a:r>
           </a:p>
         </p:txBody>
@@ -10797,7 +10797,7 @@
               </a:defRPr>
             </a:pPr>
             <a:r>
-              <a:t>逐步加入 90-feat 的效果 (越多噪声越差):</a:t>
+              <a:t>逐步加入 88-feat 的效果 (越多噪声越差):</a:t>
             </a:r>
           </a:p>
         </p:txBody>
@@ -10905,7 +10905,7 @@
               </a:defRPr>
             </a:pPr>
             <a:r>
-              <a:t>+ top5 90-feat (35维)</a:t>
+              <a:t>+ top5 88-feat (35维)</a:t>
             </a:r>
           </a:p>
         </p:txBody>
@@ -10977,7 +10977,7 @@
               </a:defRPr>
             </a:pPr>
             <a:r>
-              <a:t>+ top10 90-feat (40维)</a:t>
+              <a:t>+ top10 88-feat (40维)</a:t>
             </a:r>
           </a:p>
         </p:txBody>

</xml_diff>

<commit_message>
Split single-feature AUC into Model-Free (36d) + Token (30d) Top 10
- Model-Free chart excludes emb_pca and perplexity features
- New token feature AUC chart (raid_token_feature_auc.png)
- Slide 6 shows both side by side

Co-Authored-By: Claude Opus 4.6 <noreply@anthropic.com>
</commit_message>
<xml_diff>
--- a/reports/AIGC_Detection_Presentation.pptx
+++ b/reports/AIGC_Detection_Presentation.pptx
@@ -3441,7 +3441,7 @@
       </p:pic>
       <p:pic>
         <p:nvPicPr>
-          <p:cNvPr id="5" name="Picture 4" descr="raid_single_feature_dist.png"/>
+          <p:cNvPr id="5" name="Picture 4" descr="raid_token_feature_auc.png"/>
           <p:cNvPicPr>
             <a:picLocks noChangeAspect="1"/>
           </p:cNvPicPr>
@@ -3456,7 +3456,7 @@
         <p:spPr>
           <a:xfrm>
             <a:off x="6217920" y="1188720"/>
-            <a:ext cx="5669280" cy="3622239"/>
+            <a:ext cx="5669280" cy="3370923"/>
           </a:xfrm>
           <a:prstGeom prst="rect">
             <a:avLst/>
@@ -3471,7 +3471,79 @@
         </p:nvSpPr>
         <p:spPr>
           <a:xfrm>
-            <a:off x="731520" y="6035040"/>
+            <a:off x="274320" y="5303520"/>
+            <a:ext cx="5943600" cy="365760"/>
+          </a:xfrm>
+          <a:prstGeom prst="rect">
+            <a:avLst/>
+          </a:prstGeom>
+          <a:noFill/>
+        </p:spPr>
+        <p:txBody>
+          <a:bodyPr wrap="square">
+            <a:spAutoFit/>
+          </a:bodyPr>
+          <a:lstStyle/>
+          <a:p>
+            <a:pPr algn="ctr">
+              <a:defRPr sz="1400" b="0">
+                <a:solidFill>
+                  <a:srgbClr val="4ECB71"/>
+                </a:solidFill>
+                <a:latin typeface="Calibri"/>
+              </a:defRPr>
+            </a:pPr>
+            <a:r>
+              <a:t>Model-Free (36d): 段落结构最强</a:t>
+            </a:r>
+          </a:p>
+        </p:txBody>
+      </p:sp>
+      <p:sp>
+        <p:nvSpPr>
+          <p:cNvPr id="7" name="TextBox 6"/>
+          <p:cNvSpPr txBox="1"/>
+          <p:nvPr/>
+        </p:nvSpPr>
+        <p:spPr>
+          <a:xfrm>
+            <a:off x="6217920" y="5303520"/>
+            <a:ext cx="5669280" cy="365760"/>
+          </a:xfrm>
+          <a:prstGeom prst="rect">
+            <a:avLst/>
+          </a:prstGeom>
+          <a:noFill/>
+        </p:spPr>
+        <p:txBody>
+          <a:bodyPr wrap="square">
+            <a:spAutoFit/>
+          </a:bodyPr>
+          <a:lstStyle/>
+          <a:p>
+            <a:pPr algn="ctr">
+              <a:defRPr sz="1400" b="0">
+                <a:solidFill>
+                  <a:srgbClr val="FF6B6B"/>
+                </a:solidFill>
+                <a:latin typeface="Calibri"/>
+              </a:defRPr>
+            </a:pPr>
+            <a:r>
+              <a:t>Token (30d): 概率分布特征普遍 &gt;0.77</a:t>
+            </a:r>
+          </a:p>
+        </p:txBody>
+      </p:sp>
+      <p:sp>
+        <p:nvSpPr>
+          <p:cNvPr id="8" name="TextBox 7"/>
+          <p:cNvSpPr txBox="1"/>
+          <p:nvPr/>
+        </p:nvSpPr>
+        <p:spPr>
+          <a:xfrm>
+            <a:off x="731520" y="5852160"/>
             <a:ext cx="10058400" cy="457200"/>
           </a:xfrm>
           <a:prstGeom prst="rect">
@@ -3494,7 +3566,7 @@
               </a:defRPr>
             </a:pPr>
             <a:r>
-              <a:t>words_per_paragraph (AUC 0.89) 是最强单特征 — AI 倾向于生成规则的段落结构</a:t>
+              <a:t>Model-Free 最强特征 AUC=0.89 (段落结构), Token 最强 AUC=0.85 (概率波动) — 两类视角互补</a:t>
             </a:r>
           </a:p>
         </p:txBody>

</xml_diff>